<commit_message>
docs: unify QA activity conditions and cross-review presentation decks
</commit_message>
<xml_diff>
--- a/docs/presentations_files/quality-attributes/VIA-quality-attributes.pptx
+++ b/docs/presentations_files/quality-attributes/VIA-quality-attributes.pptx
@@ -2,14 +2,15 @@
 <file path=ppt/presentation.xml><?xml version="1.0" encoding="utf-8"?>
 <p:presentation xmlns:p="http://schemas.openxmlformats.org/presentationml/2006/main">
   <p:sldMasterIdLst>
-    <p:sldMasterId xmlns:r="http://schemas.openxmlformats.org/officeDocument/2006/relationships" id="2147483648" r:id="R9b19b2511c344ab7"/>
+    <p:sldMasterId xmlns:r="http://schemas.openxmlformats.org/officeDocument/2006/relationships" id="2147483648" r:id="R8b69c28d660e44a6"/>
   </p:sldMasterIdLst>
   <p:notesMasterIdLst>
-    <p:notesMasterId xmlns:r="http://schemas.openxmlformats.org/officeDocument/2006/relationships" r:id="Rdadffbb602d34743"/>
+    <p:notesMasterId xmlns:r="http://schemas.openxmlformats.org/officeDocument/2006/relationships" r:id="R1ba9329fd0304527"/>
   </p:notesMasterIdLst>
   <p:sldIdLst>
-    <p:sldId xmlns:r="http://schemas.openxmlformats.org/officeDocument/2006/relationships" id="256" r:id="Rcc4ae133cd934d31"/>
-    <p:sldId xmlns:r="http://schemas.openxmlformats.org/officeDocument/2006/relationships" id="257" r:id="R5c1a50768c4a4229"/>
+    <p:sldId xmlns:r="http://schemas.openxmlformats.org/officeDocument/2006/relationships" id="256" r:id="Rbe31113c8ae04b7b"/>
+    <p:sldId xmlns:r="http://schemas.openxmlformats.org/officeDocument/2006/relationships" id="257" r:id="R62a835cd317b49b9"/>
+    <p:sldId xmlns:r="http://schemas.openxmlformats.org/officeDocument/2006/relationships" id="258" r:id="Rc03537b3afc14c01"/>
   </p:sldIdLst>
   <p:sldSz cx="18288000" cy="10287000"/>
   <p:notesSz cx="6858000" cy="9144000"/>
@@ -448,7 +449,17 @@
           </a:p>
           <a:p xmlns:a="http://schemas.openxmlformats.org/drawingml/2006/main">
             <a:r>
-              <a:t>계약: ASR-QA-v4</a:t>
+              <a:t>계약: ASR-QA-v5</a:t>
+            </a:r>
+          </a:p>
+          <a:p xmlns:a="http://schemas.openxmlformats.org/drawingml/2006/main">
+            <a:r>
+              <a:t>공통 활동: W100 사용자 100/Agent 30장면, 5block, 3 독립 run</a:t>
+            </a:r>
+          </a:p>
+          <a:p xmlns:a="http://schemas.openxmlformats.org/drawingml/2006/main">
+            <a:r>
+              <a:t>활동 SHA-256: 911ce3ae13588c27b6902a5a0abb17714c4059a9a80bceaa890c1dfb3e26eb7f</a:t>
             </a:r>
           </a:p>
           <a:p xmlns:a="http://schemas.openxmlformats.org/drawingml/2006/main">
@@ -458,7 +469,7 @@
           </a:p>
           <a:p xmlns:a="http://schemas.openxmlformats.org/drawingml/2006/main">
             <a:r>
-              <a:t>원본 SHA-256: 8235a96137f71406fbede7c2021ad6476f62e7009d2f645a5dbaaa48e9787d0e</a:t>
+              <a:t>원본 SHA-256: 0e304faddf43b212900ce12f712a1d5cad5bd3cf601bc77a94f3f267d5fa2933</a:t>
             </a:r>
           </a:p>
           <a:p xmlns:a="http://schemas.openxmlformats.org/drawingml/2006/main">
@@ -513,7 +524,7 @@
           </a:p>
           <a:p xmlns:a="http://schemas.openxmlformats.org/drawingml/2006/main">
             <a:r>
-              <a:t>03-02 공통 QA 계약 v4: ../../architecture/12-decisions/decision-packages/03-02-quality-attribute-definitions.md</a:t>
+              <a:t>03-02 공통 QA 계약 v5: ../../architecture/12-decisions/decision-packages/03-02-quality-attribute-definitions.md</a:t>
             </a:r>
           </a:p>
           <a:p xmlns:a="http://schemas.openxmlformats.org/drawingml/2006/main">
@@ -803,7 +814,7 @@
           </a:p>
           <a:p xmlns:a="http://schemas.openxmlformats.org/drawingml/2006/main">
             <a:r>
-              <a:t>- 각 사례는 독립 snapshot이다. `D1`, `T메일` 등의 ID는 사례 namespace 안의 평가용 의미 ID이며 실제 runtime ID는 사전 선언한 대응으로 연결한다. 다른 사례의 자료/Task/cache가 섞이지 않는다. 현재 요청의 Task/지칭 정답을 모델 입력으로 주지 않는다.</a:t>
+              <a:t>- 각 사례의 논리적 초기 상황은 독립 snapshot이다. W100에서는 §8.0의 공통 자원 pool 안에서 해당 사례의 namespace와 초기 owner 사실을 복원한다. 복원/준비의 비용과 할당 peak도 자원 지표에 포함하며 메모리 원장을 초기화하지 않는다. `D1`, `T메일` 등의 ID는 사례 namespace 안의 평가용 의미 ID이며 실제 runtime ID는 사전 선언한 대응으로 연결한다. 다른 사례의 자료/Task는 의미 판단에 섞이지 않는다. 같은 source hash/revision/허용을 만족한 REUSE의 cache는 유지할 수 있다. 완료 이력은 활동 끝까지 보존하되 현재 요청의 조회 scope와 구별한다. 현재 요청의 Task/지칭 정답을 모델 입력으로 주지 않는다.</a:t>
             </a:r>
           </a:p>
           <a:p xmlns:a="http://schemas.openxmlformats.org/drawingml/2006/main">
@@ -2638,7 +2649,7 @@
           </a:p>
           <a:p xmlns:a="http://schemas.openxmlformats.org/drawingml/2006/main">
             <a:r>
-              <a:t>| 반복 | 각 사례의 지정 조건을 5회 실행. 매 반복은 초기 상태를 복원하고 필요한 준비 이력을 다시 처리. 실행 간 cache/Task/질문 누적을 섞지 않음 |</a:t>
+              <a:t>| 반복 | R1의 다섯 block에서 각 사례의 CORE 관측을 한 번씩 선택해 총 5회. 매 CORE의 논리적 초기 상태/준비를 복원하고 block 이력과 관측 scope를 구별. REUSE/BURST/R2/R3는 별도 보호 근거 |</a:t>
             </a:r>
           </a:p>
           <a:p xmlns:a="http://schemas.openxmlformats.org/drawingml/2006/main">
@@ -2748,12 +2759,12 @@
           </a:p>
           <a:p xmlns:a="http://schemas.openxmlformats.org/drawingml/2006/main">
             <a:r>
-              <a:t>DP 1개의 A/B: 180회 실행 / 1,080개 항목</a:t>
-            </a:r>
-          </a:p>
-          <a:p xmlns:a="http://schemas.openxmlformats.org/drawingml/2006/main">
-            <a:r>
-              <a:t>네 DP를 모두 비교: 720회 실행 / 4,320개 항목</a:t>
+              <a:t>DP 1개의 A/B: 정확성 채점 관측 180회 / 1,080개 항목</a:t>
+            </a:r>
+          </a:p>
+          <a:p xmlns:a="http://schemas.openxmlformats.org/drawingml/2006/main">
+            <a:r>
+              <a:t>네 DP를 모두 비교: 정확성 채점 관측 720회 / 4,320개 항목</a:t>
             </a:r>
           </a:p>
           <a:p xmlns:a="http://schemas.openxmlformats.org/drawingml/2006/main">
@@ -2768,7 +2779,7 @@
           </a:p>
           <a:p xmlns:a="http://schemas.openxmlformats.org/drawingml/2006/main">
             <a:r>
-              <a:t>이는 선택한 대표 장면에서의 PoC 정확률이다. 상황군은 각각 3개지만 N/W/X는 8/1/9개이며 제품 빈도로 가중하거나 모든 조건을 균등하게 검증하지 않는다. 90회 또는 540개 항목을 모두 독립 표본으로 주장하지 않는다. 반복과 같은 대화의 후속 관측은 해당 사례에 묶는다. 서로 다른 DP의 분자/분모를 합쳐 하나의 VIA 제품 정확률로 만들지 않는다.</a:t>
+              <a:t>위 숫자는 §8.0 R1 CORE의 채점 분모다. 전체 자원 campaign은 후보당 130장면 × 3회 = 390장면이며 정확성/시간용 입력을 따로 추가하지 않는다. 이는 선택한 대표 장면에서의 PoC 정확률이다. 상황군은 각각 3개지만 N/W/X는 8/1/9개이며 제품 빈도로 가중하거나 모든 조건을 균등하게 검증하지 않는다. 90회 또는 540개 항목을 모두 독립 표본으로 주장하지 않는다. 반복과 같은 대화의 후속 관측은 해당 사례에 묶는다. 서로 다른 DP의 분자/분모를 합쳐 하나의 VIA 제품 정확률로 만들지 않는다.</a:t>
             </a:r>
           </a:p>
           <a:p xmlns:a="http://schemas.openxmlformats.org/drawingml/2006/main">
@@ -3138,7 +3149,7 @@
           </a:p>
           <a:p xmlns:a="http://schemas.openxmlformats.org/drawingml/2006/main">
             <a:r>
-              <a:t>초기 상태는 보고서 업무 T보고서와 메일 업무 T메일이 각각 존재하고, 보고서 대상은 D1@v1, 기간은 올해 3분기, 형식은 문장이라고 둔다. 메일 대상/수신자와 지시는 이미 정해져 있다. 현재 준비 중인 보고서 후속 변경 요청은 아직 외부에 전송되지 않았다. 기존 두 업무의 외부 접수 사실은 있고 메일의 실제 전송 효과는 아직 없다. 사용자가 “보고서는 표로 바꾸고 메일은 그대로”라고 정정한 뒤 이전 입력을 기준으로 만든 의미 후보가 늦게 돌아온다. 공통 외부 Agent는 올바른 변경 요청의 접수만 확인하고 완료는 알리지 않는다.</a:t>
+              <a:t>초기 상태는 보고서 업무 T보고서와 메일 업무 T메일이 각각 존재하고, 보고서 대상은 D1@v1, 기간은 올해 3분기, 형식은 문장이라고 둔다. 메일 대상/수신자와 지시는 이미 정해져 있다. 현재 준비 중인 보고서 후속 변경 요청은 아직 외부에 전송되지 않았다. 기존 두 업무의 외부 접수 사실은 있고 메일의 실제 전송 효과는 아직 없다. 사용자가 “보고서는 표로 바꾸고 메일은 그대로”라고 정정한 뒤 이전 입력을 기준으로 만든 의미 후보가 늦게 돌아온다. 이 정확성 checkpoint에서는 공통 외부 Agent의 변경 접수까지만 확인한다. W100은 그 뒤 §8.0의 공통 최종 결과 tail로 이어지며 이 정답표의 접수 상태를 완료 상태로 바꾸지 않는다.</a:t>
             </a:r>
           </a:p>
           <a:p xmlns:a="http://schemas.openxmlformats.org/drawingml/2006/main">
@@ -3723,7 +3734,7 @@
           </a:p>
           <a:p xmlns:a="http://schemas.openxmlformats.org/drawingml/2006/main">
             <a:r>
-              <a:t>4. **동일 준비 상태 복원:** N/W/X의 동일 원본/외부 이력을 각각의 후보가 처리하게 한다. W에는 120초 준비 창, X에는 공통 변경/교차 script를 적용한다. 시험용 의미/파생 자료를 정답으로 선주입하지 않는다.</a:t>
+              <a:t>4. **동일 준비 상태 복원:** N/W/X의 동일 원본/외부 이력을 각각의 후보가 처리하게 한다. W는 원본대로 마지막 준비 사건 뒤 5초를 기다리며 120초는 전체 준비 실패를 닫는 상한이다. X에는 공통 변경/교차 script를 적용한다. 시험용 의미/파생 자료를 정답으로 선주입하지 않는다.</a:t>
             </a:r>
           </a:p>
           <a:p xmlns:a="http://schemas.openxmlformats.org/drawingml/2006/main">
@@ -3753,7 +3764,7 @@
           </a:p>
           <a:p xmlns:a="http://schemas.openxmlformats.org/drawingml/2006/main">
             <a:r>
-              <a:t>60초/10분은 미완료를 무한 대기로 숨기지 않기 위한 정확성 시험의 관찰 상한이다. 빠른 응답 목표나 정상적인 제품 응답시간 SLA를 이 숫자로 정의하지 않는다. 시간/비용/메모리 raw trace는 함께 수집할 수 있지만 그 QA의 대표 지표/목표는 이후 별도로 확정한다.</a:t>
+              <a:t>60초/10분은 미완료를 무한 대기로 숨기지 않기 위한 정확성 시험의 관찰 상한이다. 빠른 응답 목표나 정상적인 제품 응답시간 SLA를 이 숫자로 정의하지 않는다. 시간/비용/메모리 raw trace는 같은 W100에서 함께 수집하고 §4/5/7의 완성된 대표 지표/목표로 집계한다.</a:t>
             </a:r>
           </a:p>
           <a:p xmlns:a="http://schemas.openxmlformats.org/drawingml/2006/main">
@@ -3908,7 +3919,7 @@
           </a:p>
           <a:p xmlns:a="http://schemas.openxmlformats.org/drawingml/2006/main">
             <a:r>
-              <a:t>03-02 공통 QA 계약 v4: ../../architecture/12-decisions/decision-packages/03-02-quality-attribute-definitions.md</a:t>
+              <a:t>03-02 공통 QA 계약 v5: ../../architecture/12-decisions/decision-packages/03-02-quality-attribute-definitions.md</a:t>
             </a:r>
           </a:p>
           <a:p xmlns:a="http://schemas.openxmlformats.org/drawingml/2006/main">
@@ -3933,7 +3944,7 @@
           </a:p>
           <a:p xmlns:a="http://schemas.openxmlformats.org/drawingml/2006/main">
             <a:r>
-              <a:t>**관리 ID: ASR-QA-02 — 상호작용 응답시간, ASR-QA-03 — VIA 요청 처리시간.** 둘 다 초 단위의 산술평균을 대표값으로 사용한다. 각 6개 대표 장면을 5회 반복하므로 후보당 30개 값이다. 정확성의 90회/540개 분모를 시간 지표에 복사하지 않는다. 기존 정확성 사례의 자료와 사건을 재사용하고, 전체 완료를 보는 시간 장면에만 명시적인 최종 결과 사건을 추가한다.</a:t>
+              <a:t>**관리 ID: ASR-QA-02 — 상호작용 응답시간, ASR-QA-03 — VIA 요청 처리시간.** 둘 다 초 단위의 산술평균을 대표값으로 사용한다. 각 6개 대표 장면을 5회 반복하므로 후보당 30개 값이다. 정확성의 90회/540개 분모를 시간 지표에 복사하지 않는다. §8.0의 같은 S 사례에서 첫 반응과 전체 완료를 읽는다. 명시한 최종 결과 사건은 모든 QA에 공통인 tail이며 시간 시험만의 변형이 아니다.</a:t>
             </a:r>
           </a:p>
           <a:p xmlns:a="http://schemas.openxmlformats.org/drawingml/2006/main">
@@ -4178,12 +4189,7 @@
           </a:p>
           <a:p xmlns:a="http://schemas.openxmlformats.org/drawingml/2006/main">
             <a:r>
-              <a:t>아래 T-01~06은 정확성 원본과 구별하는 **시간 전용 파생 장면**이다. 기존 S 사례의 정확성 종료/정답/분모를 수정하지 않는다. 각 5회, 총 30회이며 확인 답변은 실제 질문 전달 뒤 2초에 Voice로 준다. 문서/메일 Agent가 업무를 실제 접수하면 최종 결과는 8초 뒤 사용 가능해진다. 이 8초는 외부 업무 노드로 제외하며 자료 내용/결과 version은 양안에서 같다. 업무 내용의 전문적 품질을 VIA QA로 채점하지 않는다.</a:t>
-            </a:r>
-          </a:p>
-          <a:p xmlns:a="http://schemas.openxmlformats.org/drawingml/2006/main">
-            <a:r>
-              <a:t/>
+              <a:t>아래 T-01~06은 **W100에서 같은 S 사례를 끝까지 처리할 때 읽는 전체 사이클 관측 구간**이다. 별도의 시간 전용 입력을 만들지 않는다. 기존 정확성 C1~C6는 원본에 정한 접수/제어 checkpoint에서 채점하고, 그 뒤의 최종 결과 사건은 공통 lifecycle tail로 이어 비용/메모리와 시간 모두에 적용한다. R1 CORE 다섯 block에서 각 T를 한 번씩 읽어 총 30회다. 확인 답변은 S6-01 원본대로 실제 질문 전달 뒤 **1초**에 시작한다. 장기 문서/메일 작업의 최종 결과는 실제 접수 뒤 8초에 사용 가능하며 이 외부 업무 노드는 시간 귀속에서 제외한다. S1-01 한정 조회의 0.2초는 원본대로 보존한다. 실제 VIA 연결/모델/네트워크/음성 시간은 남긴다.</a:t>
             </a:r>
           </a:p>
           <a:p xmlns:a="http://schemas.openxmlformats.org/drawingml/2006/main">
@@ -4198,7 +4204,7 @@
           </a:p>
           <a:p xmlns:a="http://schemas.openxmlformats.org/drawingml/2006/main">
             <a:r>
-              <a:t>| T-01 / S1-01 | D1 마감일 문의, 원본의 직접/한정 위임 허용. 위임이면 같은 날짜 결과를 접수+8초에 반환 | 발화 종료부터 D1 마감 10월 15일의 최종 전달 |</a:t>
+              <a:t>| T-01 / S1-01 | D1 마감일 문의, 원본의 직접/한정 위임 허용. 위임이면 원본대로 같은 날짜 결과를 접수+0.2초에 반환 | 발화 종료부터 D1 마감 10월 15일의 최종 전달 |</a:t>
             </a:r>
           </a:p>
           <a:p xmlns:a="http://schemas.openxmlformats.org/drawingml/2006/main">
@@ -4223,7 +4229,7 @@
           </a:p>
           <a:p xmlns:a="http://schemas.openxmlformats.org/drawingml/2006/main">
             <a:r>
-              <a:t>| T-06 / S6-01 | 두 보고서 중 대상/수정 내용 확인. 원본에 정한 후속 답변을 실제 질문+2초에 주고 지정 보고서의 `ConfirmedRevision@v2` 반환 | 최초 발화 종료부터 확인 후 수정 결과 전달. 질문만 제시하고 끝내지 않음 |</a:t>
+              <a:t>| T-06 / S6-01 | 두 보고서 중 대상/수정 내용 확인. 원본에 정한 후속 답변을 실제 질문+1초에 주고 지정 보고서의 `ConfirmedRevision@v2` 반환 | 최초 발화 종료부터 확인 후 수정 결과 전달. 질문만 제시하고 끝내지 않음 |</a:t>
             </a:r>
           </a:p>
           <a:p xmlns:a="http://schemas.openxmlformats.org/drawingml/2006/main">
@@ -4528,7 +4534,7 @@
           </a:p>
           <a:p xmlns:a="http://schemas.openxmlformats.org/drawingml/2006/main">
             <a:r>
-              <a:t>03-02 공통 QA 계약 v4: ../../architecture/12-decisions/decision-packages/03-02-quality-attribute-definitions.md</a:t>
+              <a:t>03-02 공통 QA 계약 v5: ../../architecture/12-decisions/decision-packages/03-02-quality-attribute-definitions.md</a:t>
             </a:r>
           </a:p>
           <a:p xmlns:a="http://schemas.openxmlformats.org/drawingml/2006/main">
@@ -4553,7 +4559,7 @@
           </a:p>
           <a:p xmlns:a="http://schemas.openxmlformats.org/drawingml/2006/main">
             <a:r>
-              <a:t>**관리 ID: ASR-QA-02 — 상호작용 응답시간, ASR-QA-03 — VIA 요청 처리시간.** 둘 다 초 단위의 산술평균을 대표값으로 사용한다. 각 6개 대표 장면을 5회 반복하므로 후보당 30개 값이다. 정확성의 90회/540개 분모를 시간 지표에 복사하지 않는다. 기존 정확성 사례의 자료와 사건을 재사용하고, 전체 완료를 보는 시간 장면에만 명시적인 최종 결과 사건을 추가한다.</a:t>
+              <a:t>**관리 ID: ASR-QA-02 — 상호작용 응답시간, ASR-QA-03 — VIA 요청 처리시간.** 둘 다 초 단위의 산술평균을 대표값으로 사용한다. 각 6개 대표 장면을 5회 반복하므로 후보당 30개 값이다. 정확성의 90회/540개 분모를 시간 지표에 복사하지 않는다. §8.0의 같은 S 사례에서 첫 반응과 전체 완료를 읽는다. 명시한 최종 결과 사건은 모든 QA에 공통인 tail이며 시간 시험만의 변형이 아니다.</a:t>
             </a:r>
           </a:p>
           <a:p xmlns:a="http://schemas.openxmlformats.org/drawingml/2006/main">
@@ -4798,12 +4804,7 @@
           </a:p>
           <a:p xmlns:a="http://schemas.openxmlformats.org/drawingml/2006/main">
             <a:r>
-              <a:t>아래 T-01~06은 정확성 원본과 구별하는 **시간 전용 파생 장면**이다. 기존 S 사례의 정확성 종료/정답/분모를 수정하지 않는다. 각 5회, 총 30회이며 확인 답변은 실제 질문 전달 뒤 2초에 Voice로 준다. 문서/메일 Agent가 업무를 실제 접수하면 최종 결과는 8초 뒤 사용 가능해진다. 이 8초는 외부 업무 노드로 제외하며 자료 내용/결과 version은 양안에서 같다. 업무 내용의 전문적 품질을 VIA QA로 채점하지 않는다.</a:t>
-            </a:r>
-          </a:p>
-          <a:p xmlns:a="http://schemas.openxmlformats.org/drawingml/2006/main">
-            <a:r>
-              <a:t/>
+              <a:t>아래 T-01~06은 **W100에서 같은 S 사례를 끝까지 처리할 때 읽는 전체 사이클 관측 구간**이다. 별도의 시간 전용 입력을 만들지 않는다. 기존 정확성 C1~C6는 원본에 정한 접수/제어 checkpoint에서 채점하고, 그 뒤의 최종 결과 사건은 공통 lifecycle tail로 이어 비용/메모리와 시간 모두에 적용한다. R1 CORE 다섯 block에서 각 T를 한 번씩 읽어 총 30회다. 확인 답변은 S6-01 원본대로 실제 질문 전달 뒤 **1초**에 시작한다. 장기 문서/메일 작업의 최종 결과는 실제 접수 뒤 8초에 사용 가능하며 이 외부 업무 노드는 시간 귀속에서 제외한다. S1-01 한정 조회의 0.2초는 원본대로 보존한다. 실제 VIA 연결/모델/네트워크/음성 시간은 남긴다.</a:t>
             </a:r>
           </a:p>
           <a:p xmlns:a="http://schemas.openxmlformats.org/drawingml/2006/main">
@@ -4818,7 +4819,7 @@
           </a:p>
           <a:p xmlns:a="http://schemas.openxmlformats.org/drawingml/2006/main">
             <a:r>
-              <a:t>| T-01 / S1-01 | D1 마감일 문의, 원본의 직접/한정 위임 허용. 위임이면 같은 날짜 결과를 접수+8초에 반환 | 발화 종료부터 D1 마감 10월 15일의 최종 전달 |</a:t>
+              <a:t>| T-01 / S1-01 | D1 마감일 문의, 원본의 직접/한정 위임 허용. 위임이면 원본대로 같은 날짜 결과를 접수+0.2초에 반환 | 발화 종료부터 D1 마감 10월 15일의 최종 전달 |</a:t>
             </a:r>
           </a:p>
           <a:p xmlns:a="http://schemas.openxmlformats.org/drawingml/2006/main">
@@ -4843,7 +4844,7 @@
           </a:p>
           <a:p xmlns:a="http://schemas.openxmlformats.org/drawingml/2006/main">
             <a:r>
-              <a:t>| T-06 / S6-01 | 두 보고서 중 대상/수정 내용 확인. 원본에 정한 후속 답변을 실제 질문+2초에 주고 지정 보고서의 `ConfirmedRevision@v2` 반환 | 최초 발화 종료부터 확인 후 수정 결과 전달. 질문만 제시하고 끝내지 않음 |</a:t>
+              <a:t>| T-06 / S6-01 | 두 보고서 중 대상/수정 내용 확인. 원본에 정한 후속 답변을 실제 질문+1초에 주고 지정 보고서의 `ConfirmedRevision@v2` 반환 | 최초 발화 종료부터 확인 후 수정 결과 전달. 질문만 제시하고 끝내지 않음 |</a:t>
             </a:r>
           </a:p>
           <a:p xmlns:a="http://schemas.openxmlformats.org/drawingml/2006/main">
@@ -5094,6 +5095,431 @@
           <a:p xmlns:a="http://schemas.openxmlformats.org/drawingml/2006/main">
             <a:r>
               <a:t>두 QA 모두 같은 값이 나올 수 있다. 예를 들어 44에서 첫 반응은 같은 local stop지만 전체 후속 준비 전이는 다를 수 있고, 45에서 게시 준비가 없는 첫 요청은 B가 느릴 수 있다. 모든 네 DP에 반드시 반대 부호의 결과를 만들도록 지표나 사례를 바꾸지 않는다.</a:t>
+            </a:r>
+          </a:p>
+          <a:p xmlns:a="http://schemas.openxmlformats.org/drawingml/2006/main">
+            <a:r>
+              <a:t/>
+            </a:r>
+          </a:p>
+          <a:p xmlns:a="http://schemas.openxmlformats.org/drawingml/2006/main">
+            <a:r>
+              <a:t/>
+            </a:r>
+          </a:p>
+          <a:p xmlns:a="http://schemas.openxmlformats.org/drawingml/2006/main">
+            <a:r>
+              <a:t>공통 활동 상세 §8.0</a:t>
+            </a:r>
+          </a:p>
+          <a:p xmlns:a="http://schemas.openxmlformats.org/drawingml/2006/main">
+            <a:r>
+              <a:t>공통 PoC 환경과 A/B 비교 방법</a:t>
+            </a:r>
+          </a:p>
+          <a:p xmlns:a="http://schemas.openxmlformats.org/drawingml/2006/main">
+            <a:r>
+              <a:t/>
+            </a:r>
+          </a:p>
+          <a:p xmlns:a="http://schemas.openxmlformats.org/drawingml/2006/main">
+            <a:r>
+              <a:t>공통 입력/원천 사건/후보/모델 조건은 여섯 QA에 공유하고, 각 QA의 분모/시간/금액/변경/메모리 경계는 §3~7의 완료 정의를 따른다. 공통 전사/장치 replay를 실제 ASR 정확도나 물리 장치 응답시간 실측으로 해석하지 않는다.</a:t>
+            </a:r>
+          </a:p>
+          <a:p xmlns:a="http://schemas.openxmlformats.org/drawingml/2006/main">
+            <a:r>
+              <a:t/>
+            </a:r>
+          </a:p>
+          <a:p xmlns:a="http://schemas.openxmlformats.org/drawingml/2006/main">
+            <a:r>
+              <a:t>### 8.0 공통 활동 W100: 사용량과 관측 대응</a:t>
+            </a:r>
+          </a:p>
+          <a:p xmlns:a="http://schemas.openxmlformats.org/drawingml/2006/main">
+            <a:r>
+              <a:t/>
+            </a:r>
+          </a:p>
+          <a:p xmlns:a="http://schemas.openxmlformats.org/drawingml/2006/main">
+            <a:r>
+              <a:t>#### 8.0.1 사용량을 정의하는 이유와 범위</a:t>
+            </a:r>
+          </a:p>
+          <a:p xmlns:a="http://schemas.openxmlformats.org/drawingml/2006/main">
+            <a:r>
+              <a:t/>
+            </a:r>
+          </a:p>
+          <a:p xmlns:a="http://schemas.openxmlformats.org/drawingml/2006/main">
+            <a:r>
+              <a:t>**W100은 기존 18개 사례로 구성한 합성 표준 활동이다.** 사용자의 실제 일일 빈도 자료가 없는 PoC에서 A/B가 같은 기능과 부하를 처리하도록 평가용 사용량을 명시했다. 100은 사용자 입력 장면 수다. 신규 업무/조회뿐 아니라 정정/취소/확인/재연결이 들어간다. Agent가 먼저 질문/결과를 보내는 장면은 별도로 30건이다. S5-03은 Agent 결과로 시작하지만 재연결한 사용자의 명시적 조회 발화가 있으므로 사용량 원장에서는 사용자 장면 1건이다. S6의 계획된 답변은 그 장면 내부 후속 발화이며 장면을 추가하지 않는다.</a:t>
+            </a:r>
+          </a:p>
+          <a:p xmlns:a="http://schemas.openxmlformats.org/drawingml/2006/main">
+            <a:r>
+              <a:t/>
+            </a:r>
+          </a:p>
+          <a:p xmlns:a="http://schemas.openxmlformats.org/drawingml/2006/main">
+            <a:r>
+              <a:t>원천은 §3의 18개 초기 상황/입력/경쟁 사건/정답과 아래 공통 lifecycle tail이다. **QA별로 다른 업무나 외부 결과를 만들지 않는다.** 평가 관측 단위가 다르므로 모든 QA의 분모가 같을 필요는 없다. 정확성은 조건, 시간은 사건 경계, 비용은 활동 전체 청구, 메모리는 활동 전체 동시 할당을 읽는다. 변경 용이성은 여섯 구조 변경 과제이며 변경 뒤 같은 기능/활동 계약을 유지한다.</a:t>
+            </a:r>
+          </a:p>
+          <a:p xmlns:a="http://schemas.openxmlformats.org/drawingml/2006/main">
+            <a:r>
+              <a:t/>
+            </a:r>
+          </a:p>
+          <a:p xmlns:a="http://schemas.openxmlformats.org/drawingml/2006/main">
+            <a:r>
+              <a:t>[공통 활동 입력](./03-02-common-workload.json)은 이 절의 machine-readable 사용량/음성/호출 예산이고 [사건 목록](./03-02-workload-manifest.json)은 각 장면의 case/hash/CORE 여부/I/T 연결을 130행으로 생성한다. [활동 검산기](../../../../scripts/architecture/qa_common_workload.py)는 입력 목록을 컴파일할 뿐 후보/harness/API를 실행하지 않는다. 참조 계산과 두 발표자료도 같은 원본/manifest hash를 사용한다.</a:t>
+            </a:r>
+          </a:p>
+          <a:p xmlns:a="http://schemas.openxmlformats.org/drawingml/2006/main">
+            <a:r>
+              <a:t/>
+            </a:r>
+          </a:p>
+          <a:p xmlns:a="http://schemas.openxmlformats.org/drawingml/2006/main">
+            <a:r>
+              <a:t>#### 8.0.2 사례별 횟수와 음성 길이</a:t>
+            </a:r>
+          </a:p>
+          <a:p xmlns:a="http://schemas.openxmlformats.org/drawingml/2006/main">
+            <a:r>
+              <a:t/>
+            </a:r>
+          </a:p>
+          <a:p xmlns:a="http://schemas.openxmlformats.org/drawingml/2006/main">
+            <a:r>
+              <a:t>| 원본 사례 | W100 횟수 | 입력 장면 분류 | 최초 발화 초/회 | 지정 답변 초/회 | 출력 음성 예산 초/회 | 반응 관측 | 사이클 관측 |</a:t>
+            </a:r>
+          </a:p>
+          <a:p xmlns:a="http://schemas.openxmlformats.org/drawingml/2006/main">
+            <a:r>
+              <a:t>| --- | --- | --- | --- | --- | --- | --- | --- |</a:t>
+            </a:r>
+          </a:p>
+          <a:p xmlns:a="http://schemas.openxmlformats.org/drawingml/2006/main">
+            <a:r>
+              <a:t>| S1-01 | 8 | 사용자 | 2 | 0 | 3 | 없음 | T-01 |</a:t>
+            </a:r>
+          </a:p>
+          <a:p xmlns:a="http://schemas.openxmlformats.org/drawingml/2006/main">
+            <a:r>
+              <a:t>| S1-02 | 8 | 사용자 | 3 | 0 | 8 | 없음 | T-02 |</a:t>
+            </a:r>
+          </a:p>
+          <a:p xmlns:a="http://schemas.openxmlformats.org/drawingml/2006/main">
+            <a:r>
+              <a:t>| S1-03 | 8 | 사용자 | 3 | 0 | 4 | 없음 | 없음 |</a:t>
+            </a:r>
+          </a:p>
+          <a:p xmlns:a="http://schemas.openxmlformats.org/drawingml/2006/main">
+            <a:r>
+              <a:t>| S2-01 | 8 | 사용자 | 2 | 0 | 5 | 없음 | 없음 |</a:t>
+            </a:r>
+          </a:p>
+          <a:p xmlns:a="http://schemas.openxmlformats.org/drawingml/2006/main">
+            <a:r>
+              <a:t>| S2-02 | 8 | 사용자 | 3 | 0 | 18 | 없음 | T-03 |</a:t>
+            </a:r>
+          </a:p>
+          <a:p xmlns:a="http://schemas.openxmlformats.org/drawingml/2006/main">
+            <a:r>
+              <a:t>| S2-03 | 8 | 사용자 | 2 | 0 | 4 | 없음 | 없음 |</a:t>
+            </a:r>
+          </a:p>
+          <a:p xmlns:a="http://schemas.openxmlformats.org/drawingml/2006/main">
+            <a:r>
+              <a:t>| S3-01 | 5 | 사용자 | 3 | 0 | 6 | 없음 | 없음 |</a:t>
+            </a:r>
+          </a:p>
+          <a:p xmlns:a="http://schemas.openxmlformats.org/drawingml/2006/main">
+            <a:r>
+              <a:t>| S3-02 | 5 | 사용자 | 3 | 0 | 10 | 없음 | T-04 |</a:t>
+            </a:r>
+          </a:p>
+          <a:p xmlns:a="http://schemas.openxmlformats.org/drawingml/2006/main">
+            <a:r>
+              <a:t>| S3-03 | 5 | 사용자 | 3 | 0 | 6 | 없음 | 없음 |</a:t>
+            </a:r>
+          </a:p>
+          <a:p xmlns:a="http://schemas.openxmlformats.org/drawingml/2006/main">
+            <a:r>
+              <a:t>| S4-01 | 5 | 사용자 | 2 | 0 | 9 | I-02 | T-05 |</a:t>
+            </a:r>
+          </a:p>
+          <a:p xmlns:a="http://schemas.openxmlformats.org/drawingml/2006/main">
+            <a:r>
+              <a:t>| S4-02 | 5 | 사용자 | 2 | 0 | 8 | I-01 | 없음 |</a:t>
+            </a:r>
+          </a:p>
+          <a:p xmlns:a="http://schemas.openxmlformats.org/drawingml/2006/main">
+            <a:r>
+              <a:t>| S4-03 | 5 | 사용자 | 2 | 0 | 5 | I-03 | 없음 |</a:t>
+            </a:r>
+          </a:p>
+          <a:p xmlns:a="http://schemas.openxmlformats.org/drawingml/2006/main">
+            <a:r>
+              <a:t>| S5-01 | 15 | Agent | 0 | 0 | 5 | I-04 | 없음 |</a:t>
+            </a:r>
+          </a:p>
+          <a:p xmlns:a="http://schemas.openxmlformats.org/drawingml/2006/main">
+            <a:r>
+              <a:t>| S5-02 | 15 | Agent | 0 | 0 | 6 | I-05 | 없음 |</a:t>
+            </a:r>
+          </a:p>
+          <a:p xmlns:a="http://schemas.openxmlformats.org/drawingml/2006/main">
+            <a:r>
+              <a:t>| S5-03 | 7 | 사용자 | 2 | 0 | 4 | 없음 | 없음 |</a:t>
+            </a:r>
+          </a:p>
+          <a:p xmlns:a="http://schemas.openxmlformats.org/drawingml/2006/main">
+            <a:r>
+              <a:t>| S6-01 | 5 | 사용자 | 2 | 3 | 14 | 없음 | T-06 |</a:t>
+            </a:r>
+          </a:p>
+          <a:p xmlns:a="http://schemas.openxmlformats.org/drawingml/2006/main">
+            <a:r>
+              <a:t>| S6-02 | 5 | 사용자 | 1 | 3 | 14 | 없음 | 없음 |</a:t>
+            </a:r>
+          </a:p>
+          <a:p xmlns:a="http://schemas.openxmlformats.org/drawingml/2006/main">
+            <a:r>
+              <a:t>| S6-03 | 5 | 사용자 | 2 | 0 | 5 | I-06 | 없음 |</a:t>
+            </a:r>
+          </a:p>
+          <a:p xmlns:a="http://schemas.openxmlformats.org/drawingml/2006/main">
+            <a:r>
+              <a:t/>
+            </a:r>
+          </a:p>
+          <a:p xmlns:a="http://schemas.openxmlformats.org/drawingml/2006/main">
+            <a:r>
+              <a:t>사용자 장면 합 100, Agent 장면 합 30이다. 최초 입력의 replay 길이는 §3 사건 구간으로 정한 **fixture 조건**이고 합 234초다. S6-01/02 각 5회의 후속 답변 3초를 더해 계획된 입력은 **110발화/264초**다. 추가 확인은 §3 공통 답변 정책대로 공급하고 실제 청구를 더한다. S5-03의 2초 재연결 요청은 최초 발화 열에 이미 포함했다.</a:t>
+            </a:r>
+          </a:p>
+          <a:p xmlns:a="http://schemas.openxmlformats.org/drawingml/2006/main">
+            <a:r>
+              <a:t/>
+            </a:r>
+          </a:p>
+          <a:p xmlns:a="http://schemas.openxmlformats.org/drawingml/2006/main">
+            <a:r>
+              <a:t>출력 길이는 **작성자의 참조 예산**이며 모델 성능/자연 발화 길이 보장이 아니다. 위 표의 필수 사실 전달과 공통 tail을 합해 914초다. S2-02 18초는 과거의 실제 재생 설명 8초와 현재 접수/결과 10초, S4-02 8초는 중단 전 재생 4초와 새 설명 4초를 포함한다. S6-01/02 14초는 확인 질문과 허용 범위/결과 전달의 합이다. 나머지는 해당 C6 사실과 tail 전달의 총 길이 예산이다. 실제 모델 생성/재생/폐기 청구량을 예산값으로 덮어쓰지 않는다. Text 표시 길이와 음성 시간의 임의 token 환산도 하지 않는다.</a:t>
+            </a:r>
+          </a:p>
+          <a:p xmlns:a="http://schemas.openxmlformats.org/drawingml/2006/main">
+            <a:r>
+              <a:t/>
+            </a:r>
+          </a:p>
+          <a:p xmlns:a="http://schemas.openxmlformats.org/drawingml/2006/main">
+            <a:r>
+              <a:t>#### 8.0.3 다섯 block의 입력 순서와 관측 선택</a:t>
+            </a:r>
+          </a:p>
+          <a:p xmlns:a="http://schemas.openxmlformats.org/drawingml/2006/main">
+            <a:r>
+              <a:t/>
+            </a:r>
+          </a:p>
+          <a:p xmlns:a="http://schemas.openxmlformats.org/drawingml/2006/main">
+            <a:r>
+              <a:t>각 block은 **CORE 18장면 + REUSE 4장면 + BURST 4장면 = 26장면**이다. 다섯 block이 사용자 100/Agent 30의 130장면을 만든다. CORE는 S1-01부터 S6-03까지 위 표 순서로 각 한 번이다. 각 장면은 필수 checkpoint와 tail까지 진행한 뒤 다음 장면을 시작한다. 아래 REUSE는 같은 block에서 이미 허용된 원본 version/제공 권한을 확인한 뒤 재사용한다. 기존 현재 Task를 임의 정답으로 배치하지 않고 요청 ID/외부 실행 ID는 occurrence namespace로 구별한다.</a:t>
+            </a:r>
+          </a:p>
+          <a:p xmlns:a="http://schemas.openxmlformats.org/drawingml/2006/main">
+            <a:r>
+              <a:t/>
+            </a:r>
+          </a:p>
+          <a:p xmlns:a="http://schemas.openxmlformats.org/drawingml/2006/main">
+            <a:r>
+              <a:t>| block | REUSE 네 장면 순서 | BURST 네 장면 순서 |</a:t>
+            </a:r>
+          </a:p>
+          <a:p xmlns:a="http://schemas.openxmlformats.org/drawingml/2006/main">
+            <a:r>
+              <a:t>| --- | --- | --- |</a:t>
+            </a:r>
+          </a:p>
+          <a:p xmlns:a="http://schemas.openxmlformats.org/drawingml/2006/main">
+            <a:r>
+              <a:t>| B1 | S1-01, S1-02, S2-01, S2-02 | S5-01, S5-02, S5-01, S5-02 |</a:t>
+            </a:r>
+          </a:p>
+          <a:p xmlns:a="http://schemas.openxmlformats.org/drawingml/2006/main">
+            <a:r>
+              <a:t>| B2 | S1-01, S1-03, S2-01, S2-03 | 동일 |</a:t>
+            </a:r>
+          </a:p>
+          <a:p xmlns:a="http://schemas.openxmlformats.org/drawingml/2006/main">
+            <a:r>
+              <a:t>| B3 | S1-02, S1-03, S2-02, S2-03 | 동일 |</a:t>
+            </a:r>
+          </a:p>
+          <a:p xmlns:a="http://schemas.openxmlformats.org/drawingml/2006/main">
+            <a:r>
+              <a:t>| B4 | S1-01, S1-02, S2-01, S2-02 | 동일 |</a:t>
+            </a:r>
+          </a:p>
+          <a:p xmlns:a="http://schemas.openxmlformats.org/drawingml/2006/main">
+            <a:r>
+              <a:t>| B5 | S1-03, S2-03, S5-03, S5-03 | 동일 |</a:t>
+            </a:r>
+          </a:p>
+          <a:p xmlns:a="http://schemas.openxmlformats.org/drawingml/2006/main">
+            <a:r>
+              <a:t/>
+            </a:r>
+          </a:p>
+          <a:p xmlns:a="http://schemas.openxmlformats.org/drawingml/2006/main">
+            <a:r>
+              <a:t>BURST의 네 Agent 장면 최초 원천 사건을 상대 0/0.02/0.04/0.06초에 공급하고 각 장면 내부의 원본 후속 순서를 보존한다. 사용자 음성을 네 개 중첩시키는 시험은 아니다. 네 장면이 각각 사용하는 두 Task를 pool의 여덟 slot에 배치하고 T보호와 background 한 Task의 두 slot을 유지해 **활성 최대 10개**다. CORE/REUSE는 이 pool의 필요한 slot만 해당 초기 사실로 복원한다. 완료된 관련 작업은 active slot에서 빠져 이력으로 남는다. 이 합성 replay suite의 slot은 현재 제시하는 scoped scene의 owner이며 10은 그 scene에서 동시에 처리하는 Task 상한이다. 완료되지 않은 질문/취소 접수는 먼저 원본 checkpoint/5초 늦은 사건 관찰을 충족한 뒤 scope를 닫고 원래 대기 상태/receipt를 그대로 활동 이력에 보존한다. 전체 미완료 Task를 10개로 자른다거나 외부 대기를 성공 완료로 바꾸는 실제 운용 정책은 아니다. 다음 scene의 before-state 복원과 구분하고 scope 회수 비용/peak도 센다.</a:t>
+            </a:r>
+          </a:p>
+          <a:p xmlns:a="http://schemas.openxmlformats.org/drawingml/2006/main">
+            <a:r>
+              <a:t/>
+            </a:r>
+          </a:p>
+          <a:p xmlns:a="http://schemas.openxmlformats.org/drawingml/2006/main">
+            <a:r>
+              <a:t>block의 마지막 BURST checkpoint 이후 B01~B04, B05~B08, …, B17~B20의 background 원본을 각각 한 번 `v1→v2` 갱신한다. 각 원본은 초기 30개 source 중 하나이며 locator와 권한은 그대로, 내용의 수치 한 곳만 1 증가한다. 입력 목록 순서로 0.01초 간격 제공하고 같은 block의 maintenance tick 두 개를 직렬 제공한다. 총 **20개 background 변경/10개 tick**이다. §3의 S2-03 등 내부 X 갱신은 이 20개와 별개로 이미 장면에 포함되며 별도 호출을 중복 청구하지 않는다. B5 마지막 갱신 뒤 B20의 제공 동의를 철회해 원문/파생/Context 신규 소비를 차단한다. 후보의 실제 생산/재해석/철회 비용은 모두 남긴다.</a:t>
+            </a:r>
+          </a:p>
+          <a:p xmlns:a="http://schemas.openxmlformats.org/drawingml/2006/main">
+            <a:r>
+              <a:t/>
+            </a:r>
+          </a:p>
+          <a:p xmlns:a="http://schemas.openxmlformats.org/drawingml/2006/main">
+            <a:r>
+              <a:t>R1/R2/R3는 동일 초기 자료를 가진 **세 독립 활동**이다. 대표 정확성/시간 표본은 결과 전에 지정한 **R1 CORE만** 읽는다. 다섯 block의 18개가 90회/540개, I/T 여섯 개가 각각 30개다. REUSE/BURST와 R2/R3의 실패/필수 위반은 별도 보호 근거로 전부 보고하며 대표 정확성 분모에 임의 가산하거나 가장 좋은 run으로 교체하지 않는다. 비용은 세 활동 전체의 평균, 메모리는 세 활동 전체의 최대다. 실제 세 run 없이 같은 계산을 복제해 반복 측정이라고 부르지 않는다.</a:t>
+            </a:r>
+          </a:p>
+          <a:p xmlns:a="http://schemas.openxmlformats.org/drawingml/2006/main">
+            <a:r>
+              <a:t/>
+            </a:r>
+          </a:p>
+          <a:p xmlns:a="http://schemas.openxmlformats.org/drawingml/2006/main">
+            <a:r>
+              <a:t>#### 8.0.4 초기 데이터, 복원과 동시 부하</a:t>
+            </a:r>
+          </a:p>
+          <a:p xmlns:a="http://schemas.openxmlformats.org/drawingml/2006/main">
+            <a:r>
+              <a:t/>
+            </a:r>
+          </a:p>
+          <a:p xmlns:a="http://schemas.openxmlformats.org/drawingml/2006/main">
+            <a:r>
+              <a:t>각 활동은 원천 대화 2,000turn/완료 Task 200개/문서와 일정 등 source 30개(전체 합성 payload 20MiB)에서 시작한다. 30개 source slot은 B01~B20과 C01~C10이다. Bnn의 제목은 `W100 background source Bnn`, v1의 `value=100+nn`, v2는 `101+nn`이며 read/모델 제공을 허용한다. C slot에는 해당 사례의 원본 D/Cal/표/E1을 namespace 대응으로 제공한다. background 대화 H0001~H2000은 시간순으로 `배경 기록 {id}: B{((id-1)%20)+1}@v1의 값은 {100+((id-1)%20)+1}이다`와 실제 전달 receipt를 갖는다. 완료 Task HT001~HT200은 같은 순환 B source의 read-only 값 조회이며 ACCEPTED→COMPLETED→실제 전달 원천 사실을 갖는다. 현재 요청과 의미 관계를 선결합하지 않는다. UTF-8 원본/turn/Task payload 합을 20×1,024×1,024byte로 맞추도록 미사용 B 본문에 공백을 채운다. DB/index/runtime의 물리적 추가 overhead는 별도 메모리다. 활성 Task 10은 초기 Task를 무조건 10개 더 넣는 뜻이 아니라 공통 pool의 상한이며 BURST의 8개 관련 Task+2개 보호/background로 최대 10개를 제공한다. 실제 과거 원문과 실제 전달/수정/허용 이력을 제공하고 현재 요청의 정답/파생 관계는 넣지 않는다. namespace 대응표는 source/Task 식별을 위한 fixture map이며 모델의 지칭/Task 정답으로 주지 않는다. 각 사례가 읽을 수 있는 scope/사실은 §3 명세 그대로다. 무관한 background 자료는 모델 의미 입력에 무제한 섞지 않지만 전체 이력/DB/copy 메모리에는 포함한다.</a:t>
+            </a:r>
+          </a:p>
+          <a:p xmlns:a="http://schemas.openxmlformats.org/drawingml/2006/main">
+            <a:r>
+              <a:t/>
+            </a:r>
+          </a:p>
+          <a:p xmlns:a="http://schemas.openxmlformats.org/drawingml/2006/main">
+            <a:r>
+              <a:t>CORE 전에 해당 논리적 초기 owner 사실을 복원하고 필요한 W 준비를 실제 후보 경로로 처리한다. 복원은 input fixture일 뿐 후보가 처리해야 할 결과를 대신하지 않는다. 후보가 낸 상태/오류를 완료 snapshot으로 덮어쓰지 않고 checkpoint와 tail을 검사한 뒤에만 다음 fixture로 진행한다. 초기/복원/생산의 청구와 일시적 old/new snapshot 이중 할당을 모두 세며 **각 block 완료 이력은 활동 끝까지 남긴다.** 같은 source hash/revision/permission에 한정한 REUSE cache는 허용한다. 충돌 namespace의 cache나 현재성 불일치는 무효화한다.</a:t>
+            </a:r>
+          </a:p>
+          <a:p xmlns:a="http://schemas.openxmlformats.org/drawingml/2006/main">
+            <a:r>
+              <a:t/>
+            </a:r>
+          </a:p>
+          <a:p xmlns:a="http://schemas.openxmlformats.org/drawingml/2006/main">
+            <a:r>
+              <a:t>cloud call의 동시 상한은 4개이며 양안에 같은 queue/취소/timeout 계약을 적용한다. 호출 4개를 강제로 만들어 메모리를 늘리지 않는다. capture의 제공 원본/보존 창은 최대 15개 RGBA frame이며 scene 내부의 시각/포인터/허용 규칙은 §3과 같다. 동시 할당과 준비를 비교할 수 있도록 초기화부터 마지막 신규 입력 이후까지 원장을 연다. 마지막 철회 뒤 신규 입력을 멈추고 처리 가능한 VIA job/queue를 최대 30초에 drain한다. 30초는 대표 요청 처리 예산 10초의 세 배로 회수 여유를 둔 작성자 보호 한도다. 외부 업무/미응답 질문의 정당한 대기 상태는 보존한다. drain 완료 뒤 10초 idle probe에 새 maintenance를 넣지 않는다. 10초/50ms는 최소 200개 시간 sample로 단기 회수/잔류 증가를 확인하기 위한 관측 가정이며 장시간 누수의 부재를 증명하지 않는다. 전체 기능 checkpoint/tail 누락 또는 필수 위반이 있으면 작은 비용/메모리도 목표 달성이 아니다.</a:t>
+            </a:r>
+          </a:p>
+          <a:p xmlns:a="http://schemas.openxmlformats.org/drawingml/2006/main">
+            <a:r>
+              <a:t/>
+            </a:r>
+          </a:p>
+          <a:p xmlns:a="http://schemas.openxmlformats.org/drawingml/2006/main">
+            <a:r>
+              <a:t>#### 8.0.5 공통 후속 사건과 QA별 관측</a:t>
+            </a:r>
+          </a:p>
+          <a:p xmlns:a="http://schemas.openxmlformats.org/drawingml/2006/main">
+            <a:r>
+              <a:t/>
+            </a:r>
+          </a:p>
+          <a:p xmlns:a="http://schemas.openxmlformats.org/drawingml/2006/main">
+            <a:r>
+              <a:t>| 연결 | 같은 장면의 공통 종료/tail | 읽는 지표 |</a:t>
+            </a:r>
+          </a:p>
+          <a:p xmlns:a="http://schemas.openxmlformats.org/drawingml/2006/main">
+            <a:r>
+              <a:t>| --- | --- | --- |</a:t>
+            </a:r>
+          </a:p>
+          <a:p xmlns:a="http://schemas.openxmlformats.org/drawingml/2006/main">
+            <a:r>
+              <a:t>| S1-01 / T-01 | 원본 한정 조회: 직접 또는 외부 접수+0.2초 날짜 결과. 별도 8초 결과를 만들지 않음 | 정확성 C6과 cycle 최종 전달 |</a:t>
+            </a:r>
+          </a:p>
+          <a:p xmlns:a="http://schemas.openxmlformats.org/drawingml/2006/main">
+            <a:r>
+              <a:t>| S1-02 / T-02 | 원본 접수 receipt로 C5/C6 채점한 뒤 실제 작성 접수+8초에 ReportQ3@v1 결과 | 전체 cycle, 청구/할당 |</a:t>
+            </a:r>
+          </a:p>
+          <a:p xmlns:a="http://schemas.openxmlformats.org/drawingml/2006/main">
+            <a:r>
+              <a:t>| S2-02 / T-03 | 원본 준비 5초/접수 checkpoint 뒤 Proposal@v1 결과를 접수+8초에 반환 | cycle은 현재 발화부터, 자원은 과거 준비도 포함 |</a:t>
+            </a:r>
+          </a:p>
+          <a:p xmlns:a="http://schemas.openxmlformats.org/drawingml/2006/main">
+            <a:r>
+              <a:t>| S3-02 / T-04 | 현재 K현재 요약과 중복 처리 원본 유지, 실제 SEND 접수+8초 MailCurrent@v1:SENT | cycle은 현재 요약→전송→확인, 중복 effect 금지 |</a:t>
+            </a:r>
+          </a:p>
+          <a:p xmlns:a="http://schemas.openxmlformats.org/drawingml/2006/main">
+            <a:r>
+              <a:t>| S4-01 / I-02 / T-05 | 원본 정정 접수/메일 유지 checkpoint 이후 변경 접수+8초 ReportRevised@v2 결과 | 같은 정정의 첫 반응과 최종 전달을 각각 관측 |</a:t>
+            </a:r>
+          </a:p>
+          <a:p xmlns:a="http://schemas.openxmlformats.org/drawingml/2006/main">
+            <a:r>
+              <a:t>| S6-01 / T-06 | 원본 실제 확인 질문+1초에 3초 답변. 실제 유효 수정 접수+8초 ConfirmedRevision@v2 결과 | 사람 기다림/외부 업무만 제외한 cycle |</a:t>
+            </a:r>
+          </a:p>
+          <a:p xmlns:a="http://schemas.openxmlformats.org/drawingml/2006/main">
+            <a:r>
+              <a:t>| S2-03 | 원본 v1 지정 표 작성 접수 뒤 실제 접수+8초 결과(TablePast@v1) | 대표 T 없음, 비용/메모리와 기능 보호에는 포함 |</a:t>
+            </a:r>
+          </a:p>
+          <a:p xmlns:a="http://schemas.openxmlformats.org/drawingml/2006/main">
+            <a:r>
+              <a:t>| 나머지 11개 사례 | §3의 실제 조회/선호/제어/질문/결과/승인 범위/거부 checkpoint가 그 장면의 끝. 취소 접수는 완료 취소가 아니며 기다리는 질문을 임의 답변하지 않음 | C6와 지정 I, 전체 청구/할당 |</a:t>
+            </a:r>
+          </a:p>
+          <a:p xmlns:a="http://schemas.openxmlformats.org/drawingml/2006/main">
+            <a:r>
+              <a:t/>
+            </a:r>
+          </a:p>
+          <a:p xmlns:a="http://schemas.openxmlformats.org/drawingml/2006/main">
+            <a:r>
+              <a:t>위 tail은 모든 CORE/REUSE/BURST와 모든 run/QA에 공통이다. 최종 payload/source/version/허용과 실제 전달을 검사하며 접수 인사를 최종 결과로 세지 않는다. 정확성의 기존 108개 정답 명세는 해당 checkpoint에서 보존하고 tail 실패는 cycle/resource/필수 기능 보호에 기록한다. 각 관측은 `run/block/occurrence/case/source-vector/checkpoint/tail/I/T`를 동일 원장 key로 조인한다. QA-05 변경의 완료 검사도 이 기능/상태/권한 회귀와 W100의 사용량/동시성/보관 계약을 유지하는지 확인한다. 390장면 모두를 정확성 대표 분모로 키우지 않는다.</a:t>
+            </a:r>
+          </a:p>
+          <a:p xmlns:a="http://schemas.openxmlformats.org/drawingml/2006/main">
+            <a:r>
+              <a:t/>
             </a:r>
           </a:p>
           <a:p xmlns:a="http://schemas.openxmlformats.org/drawingml/2006/main">
@@ -5183,7 +5609,17 @@
           </a:p>
           <a:p xmlns:a="http://schemas.openxmlformats.org/drawingml/2006/main">
             <a:r>
-              <a:t>계약: ASR-QA-v4</a:t>
+              <a:t>계약: ASR-QA-v5</a:t>
+            </a:r>
+          </a:p>
+          <a:p xmlns:a="http://schemas.openxmlformats.org/drawingml/2006/main">
+            <a:r>
+              <a:t>공통 활동: W100 사용자 100/Agent 30장면, 5block, 3 독립 run</a:t>
+            </a:r>
+          </a:p>
+          <a:p xmlns:a="http://schemas.openxmlformats.org/drawingml/2006/main">
+            <a:r>
+              <a:t>활동 SHA-256: 911ce3ae13588c27b6902a5a0abb17714c4059a9a80bceaa890c1dfb3e26eb7f</a:t>
             </a:r>
           </a:p>
           <a:p xmlns:a="http://schemas.openxmlformats.org/drawingml/2006/main">
@@ -5193,7 +5629,7 @@
           </a:p>
           <a:p xmlns:a="http://schemas.openxmlformats.org/drawingml/2006/main">
             <a:r>
-              <a:t>원본 SHA-256: 8235a96137f71406fbede7c2021ad6476f62e7009d2f645a5dbaaa48e9787d0e</a:t>
+              <a:t>원본 SHA-256: 0e304faddf43b212900ce12f712a1d5cad5bd3cf601bc77a94f3f267d5fa2933</a:t>
             </a:r>
           </a:p>
           <a:p xmlns:a="http://schemas.openxmlformats.org/drawingml/2006/main">
@@ -5218,17 +5654,17 @@
           </a:p>
           <a:p xmlns:a="http://schemas.openxmlformats.org/drawingml/2006/main">
             <a:r>
-              <a:t>측정 지표: 8시간 평균 총 모델 비용(USD). 100개 목표/배경 생산/재시도/음성과 청구 context를 모두 합산</a:t>
-            </a:r>
-          </a:p>
-          <a:p xmlns:a="http://schemas.openxmlformats.org/drawingml/2006/main">
-            <a:r>
-              <a:t>목표: $1.50/8시간 이하</a:t>
-            </a:r>
-          </a:p>
-          <a:p xmlns:a="http://schemas.openxmlformats.org/drawingml/2006/main">
-            <a:r>
-              <a:t>목표 근거: 하루 100개 목표와 청구 음성 입력 30분/출력 10분의 공개 단가 계산 $1.1325에 추가 생산/재시도 여유 $0.3675를 둔 작성자 예산 (§5.3)</a:t>
+              <a:t>측정 지표: 표준 활동 W100 1회 평균 총 모델 비용(USD/묶음). 사용자 입력 100건과 Agent 발신 30건의 전체 청구를 3회 독립 수행해 평균</a:t>
+            </a:r>
+          </a:p>
+          <a:p xmlns:a="http://schemas.openxmlformats.org/drawingml/2006/main">
+            <a:r>
+              <a:t>목표: $1.50/W100 이하</a:t>
+            </a:r>
+          </a:p>
+          <a:p xmlns:a="http://schemas.openxmlformats.org/drawingml/2006/main">
+            <a:r>
+              <a:t>목표 근거: 18개 대표 사례에서 구성한 동일 활동의 의미 300호출 예산/음성 입력 264초/출력 914초 참조 계산 $1.0987에 추가 생산/재시도 여유 $0.4013을 둔 작성자 예산 (§5.3, §8.0)</a:t>
             </a:r>
           </a:p>
           <a:p xmlns:a="http://schemas.openxmlformats.org/drawingml/2006/main">
@@ -5253,7 +5689,7 @@
           </a:p>
           <a:p xmlns:a="http://schemas.openxmlformats.org/drawingml/2006/main">
             <a:r>
-              <a:t>03-02 공통 QA 계약 v4: ../../architecture/12-decisions/decision-packages/03-02-quality-attribute-definitions.md</a:t>
+              <a:t>03-02 공통 QA 계약 v5: ../../architecture/12-decisions/decision-packages/03-02-quality-attribute-definitions.md</a:t>
             </a:r>
           </a:p>
           <a:p xmlns:a="http://schemas.openxmlformats.org/drawingml/2006/main">
@@ -5298,17 +5734,17 @@
           </a:p>
           <a:p xmlns:a="http://schemas.openxmlformats.org/drawingml/2006/main">
             <a:r>
-              <a:t>**동일한 사용자 활동을 처리하는 동안 VIA의 음성/의미 모델 사용에 드는 금액.** 대표 지표는 **표준 8시간 활동의 총 모델 비용(USD/8시간)**이다. 입력 목표 수를 후보가 만든 Task/호출 수로 나눠 비용을 낮추지 않는다. 100개 요청 목표는 고정 workload의 설명이며 대표 비용 분모는 동일한 8시간이다.</a:t>
-            </a:r>
-          </a:p>
-          <a:p xmlns:a="http://schemas.openxmlformats.org/drawingml/2006/main">
-            <a:r>
-              <a:t/>
-            </a:r>
-          </a:p>
-          <a:p xmlns:a="http://schemas.openxmlformats.org/drawingml/2006/main">
-            <a:r>
-              <a:t>음성 입력/전사, 현재 의미, 과거 관계 생산/갱신, 질문/응답 내용과 음성 출력, 재시도, 늦어서 폐기된 청구 출력과 미사용 배경 생산을 포함한다. 외부 Downstream Agent가 자체 업무에 쓴 모델/도구 금액은 제외하고 별도 원장으로 남긴다. CPU/IPC/저장 비용은 모델 비용에 임의 단가로 섞지 않는다. 모델 call ID 하나를 41과 45 비용에 중복 가산하지 않는다.</a:t>
+              <a:t>**동일한 사용자 활동을 처리하는 동안 VIA의 음성/의미 모델 사용에 드는 금액.** 대표 지표는 **표준 활동 W100 1회 평균 총 모델 비용(USD/묶음)**이다. §8.0의 100개 사용자 입력 장면과 30개 Agent 발신 장면을 모두 처리한 금액을 구하고, 같은 초기 자료로 독립 수행한 R1/R2/R3의 산술평균을 낸다. 입력 개수는 정정/제어/확인 장면을 포함하며 모델 호출이나 Task 수로 다시 나누지 않는다. 보조 값 `$ / 100개 사용자 입력 장면`은 W100 총액과 같고, `$ / 사용자 입력 장면`은 총액/100이다. Agent 후속 처리 비용도 이 환산에 포함한다.</a:t>
+            </a:r>
+          </a:p>
+          <a:p xmlns:a="http://schemas.openxmlformats.org/drawingml/2006/main">
+            <a:r>
+              <a:t/>
+            </a:r>
+          </a:p>
+          <a:p xmlns:a="http://schemas.openxmlformats.org/drawingml/2006/main">
+            <a:r>
+              <a:t>음성 입력/전사, 현재 의미, 초기 과거 생산/갱신, 질문/응답/음성 출력, 재시도, 늦어서 폐기된 청구 출력과 미사용 배경 생산을 포함한다. 외부 Downstream Agent가 자체 업무에 쓴 모델/도구 금액은 별도 원장이다. CPU/IPC/저장 비용은 모델 비용에 임의 단가로 섞지 않는다. 같은 provider call ID는 한 번만 청구한다.</a:t>
             </a:r>
           </a:p>
           <a:p xmlns:a="http://schemas.openxmlformats.org/drawingml/2006/main">
@@ -5323,17 +5759,22 @@
           </a:p>
           <a:p xmlns:a="http://schemas.openxmlformats.org/drawingml/2006/main">
             <a:r>
-              <a:t>C8h = Σ 의미 호출(input_tokens × 0.80 + billed_output_tokens × 4.00) / 1,000,000</a:t>
-            </a:r>
-          </a:p>
-          <a:p xmlns:a="http://schemas.openxmlformats.org/drawingml/2006/main">
-            <a:r>
-              <a:t>    + audio_input_minutes × 0.005 + audio_output_minutes × 0.018</a:t>
-            </a:r>
-          </a:p>
-          <a:p xmlns:a="http://schemas.openxmlformats.org/drawingml/2006/main">
-            <a:r>
-              <a:t>    + (voice_text_input_tokens × 0.75 + voice_text_output_tokens × 4.50) / 1,000,000</a:t>
+              <a:t>CW100 = Σ 의미 호출(input_tokens × 0.80 + billed_output_tokens × 4.00) / 1,000,000</a:t>
+            </a:r>
+          </a:p>
+          <a:p xmlns:a="http://schemas.openxmlformats.org/drawingml/2006/main">
+            <a:r>
+              <a:t>      + audio_input_minutes × 0.005 + audio_output_minutes × 0.018</a:t>
+            </a:r>
+          </a:p>
+          <a:p xmlns:a="http://schemas.openxmlformats.org/drawingml/2006/main">
+            <a:r>
+              <a:t>      + (voice_text_input_tokens × 0.75 + voice_text_output_tokens × 4.50) / 1,000,000</a:t>
+            </a:r>
+          </a:p>
+          <a:p xmlns:a="http://schemas.openxmlformats.org/drawingml/2006/main">
+            <a:r>
+              <a:t>ASR-QA-04 = (CW100_R1 + CW100_R2 + CW100_R3) / 3</a:t>
             </a:r>
           </a:p>
           <a:p xmlns:a="http://schemas.openxmlformats.org/drawingml/2006/main">
@@ -5348,27 +5789,37 @@
           </a:p>
           <a:p xmlns:a="http://schemas.openxmlformats.org/drawingml/2006/main">
             <a:r>
-              <a:t>단가는 §8.4의 공개 reference다. 분 기반 음성 환산과 audio token 청구를 동시에 적용하지 않는다. 실측에서는 사용량 응답/청구 규칙을 우선하며 reasoning, image token, retained context, tool schema와 재전송도 해당 청구 입력/출력으로 기록한다. caching 할인을 기준값에 넣지 않는다. 할인 profile은 같은 양안에 같은 공개 조건으로만 추가한다.</a:t>
-            </a:r>
-          </a:p>
-          <a:p xmlns:a="http://schemas.openxmlformats.org/drawingml/2006/main">
-            <a:r>
-              <a:t/>
-            </a:r>
-          </a:p>
-          <a:p xmlns:a="http://schemas.openxmlformats.org/drawingml/2006/main">
-            <a:r>
-              <a:t>### 5.2 공통 8시간 workload와 호출 원장</a:t>
-            </a:r>
-          </a:p>
-          <a:p xmlns:a="http://schemas.openxmlformats.org/drawingml/2006/main">
-            <a:r>
-              <a:t/>
-            </a:r>
-          </a:p>
-          <a:p xmlns:a="http://schemas.openxmlformats.org/drawingml/2006/main">
-            <a:r>
-              <a:t>| 고정 입력 | 값과 사건 규칙 |</a:t>
+              <a:t>단가는 §8.4의 공개 reference다. 분 기반 음성 근사와 audio token 청구를 동시에 적용하지 않는다. 실측에서는 usage/청구 규칙을 우선하며 reasoning, image token, retained context, tool schema와 재전송도 해당 청구량에 포함한다. caching 할인은 공통 기본값에 넣지 않고 양안 같은 공개 조건의 추가 profile로만 계산한다.</a:t>
+            </a:r>
+          </a:p>
+          <a:p xmlns:a="http://schemas.openxmlformats.org/drawingml/2006/main">
+            <a:r>
+              <a:t/>
+            </a:r>
+          </a:p>
+          <a:p xmlns:a="http://schemas.openxmlformats.org/drawingml/2006/main">
+            <a:r>
+              <a:t>### 5.2 공통 활동과 호출 원장</a:t>
+            </a:r>
+          </a:p>
+          <a:p xmlns:a="http://schemas.openxmlformats.org/drawingml/2006/main">
+            <a:r>
+              <a:t/>
+            </a:r>
+          </a:p>
+          <a:p xmlns:a="http://schemas.openxmlformats.org/drawingml/2006/main">
+            <a:r>
+              <a:t>**사용량의 유일한 원본은 §8.0과 [공통 활동 입력](./03-02-common-workload.json)이다.** W100 130장면의 사례/순서는 [사건 목록](./03-02-workload-manifest.json)으로 검산한다. 초기화, CORE, REUSE, BURST, source 갱신/철회, drain/idle의 청구를 모두 합산한다. QA마다 요청 개수/발화/최종 사건을 따로 바꾸지 않는다.</a:t>
+            </a:r>
+          </a:p>
+          <a:p xmlns:a="http://schemas.openxmlformats.org/drawingml/2006/main">
+            <a:r>
+              <a:t/>
+            </a:r>
+          </a:p>
+          <a:p xmlns:a="http://schemas.openxmlformats.org/drawingml/2006/main">
+            <a:r>
+              <a:t>| 청구량의 근거 | W100 기준값과 실제 비교 규칙 |</a:t>
             </a:r>
           </a:p>
           <a:p xmlns:a="http://schemas.openxmlformats.org/drawingml/2006/main">
@@ -5378,57 +5829,47 @@
           </a:p>
           <a:p xmlns:a="http://schemas.openxmlformats.org/drawingml/2006/main">
             <a:r>
-              <a:t>| 사용자 요청 목표 | 100개: 명시적 기본 25, 과거/지칭 25, 복합 관계 20, 정정/제어 15, 확인/권한 15. S1/S2/S3/S4/S6 원본을 순환 재사용하며 S5의 비동기 질문/결과 30개를 같은 기간에 추가. 후속 답변과 알림은 새 요청 수로 세지 않음 |</a:t>
-            </a:r>
-          </a:p>
-          <a:p xmlns:a="http://schemas.openxmlformats.org/drawingml/2006/main">
-            <a:r>
-              <a:t>| 초기 원본 | 2,000개 과거 대화 turn, 완료 Task 200개, 현재 Task 10개, 문서/일정 source 30개. 전체 합성 payload 20MiB, 현재 scenario locator는 §3 자료에 대응. 양안 같은 owner snapshot에서 시작하며 정답 의미를 미리 생산하지 않음 |</a:t>
-            </a:r>
-          </a:p>
-          <a:p xmlns:a="http://schemas.openxmlformats.org/drawingml/2006/main">
-            <a:r>
-              <a:t>| 활동 시각 | 100개 목표의 최초 입력은 0~465.6분에 등간격(465.6/99분). 첫 5분의 초기화/관계 생산도 기간에 포함. Task event 10개는 30/60/.../300분에 하나씩, 나머지 20개는 360분/390분에 각각 10개씩 1초 간격으로 제공. 변경 source event는 20/40/.../400분의 총 20개 |</a:t>
-            </a:r>
-          </a:p>
-          <a:p xmlns:a="http://schemas.openxmlformats.org/drawingml/2006/main">
-            <a:r>
-              <a:t>| 음성 | **청구 대상 입력 30분/출력 10분**을 기준 workload 가정으로 둠. 후속 질문/답변/알림 포함. 단순 마이크 ON 8시간을 30분 청구라고 치환하지 않으며 실제 송신/usage 원장으로 확인 |</a:t>
-            </a:r>
-          </a:p>
-          <a:p xmlns:a="http://schemas.openxmlformats.org/drawingml/2006/main">
-            <a:r>
-              <a:t>| 음성 Text/context | 입력 50,000 token/출력 10,000 token의 기준 청구 가정. session context 재입력이 있으면 매 청구에 포함. 8시간 한 연결의 context 재사용이 무료라고 가정하지 않음 |</a:t>
-            </a:r>
-          </a:p>
-          <a:p xmlns:a="http://schemas.openxmlformats.org/drawingml/2006/main">
-            <a:r>
-              <a:t>| 의미 호출 예산 기준 | 100개 목표 × 평균 3호출 × 입력 2,000/출력 200 token = 총 입력 600,000/출력 60,000 token. 추가 background/retry는 별도 행으로 가산하며 이 평균을 후보에 강제하지 않음 |</a:t>
-            </a:r>
-          </a:p>
-          <a:p xmlns:a="http://schemas.openxmlformats.org/drawingml/2006/main">
-            <a:r>
-              <a:t>| 반복과 비교 | 동일 day script 3회, 각 회 초기화. 총 비용을 3회 산술평균. 계산에서는 동일 usage ledger의 기준/민감도 값을 산출하며 3회 복제로 통계적 표본을 만든다고 하지 않음 |</a:t>
-            </a:r>
-          </a:p>
-          <a:p xmlns:a="http://schemas.openxmlformats.org/drawingml/2006/main">
-            <a:r>
-              <a:t/>
-            </a:r>
-          </a:p>
-          <a:p xmlns:a="http://schemas.openxmlformats.org/drawingml/2006/main">
-            <a:r>
-              <a:t>8시간 source script는 18개 내용의 새 변형 전수 검사가 아니다. 반복/갱신/유휴 생산 비용을 놓치지 않도록 과제 수와 사건 수를 확대한 자원 workload다. 변경 source 20개는 version/사실을 바꾸는 사건이며 변경 용이성의 여섯 개발 과제와 구별한다. 45A의 cache/부분 갱신과 45B의 선택적 생산도 허용하되 실제 소비/준비/무효화 비용을 기록한다.</a:t>
-            </a:r>
-          </a:p>
-          <a:p xmlns:a="http://schemas.openxmlformats.org/drawingml/2006/main">
-            <a:r>
-              <a:t/>
-            </a:r>
-          </a:p>
-          <a:p xmlns:a="http://schemas.openxmlformats.org/drawingml/2006/main">
-            <a:r>
-              <a:t>원장 열은 `call_id, source_execution_key, dp_option, role, trigger_event, purpose, source_vector, start/end, input/output/reasoning/image/audio_usage, billed, outcome, used_by, USD, evidence_level`이다. timeout/cancel/미사용을 `billed=false`로 추정하지 않는다. provider가 usage를 주지 않으면 요청/출력 기록에서 보수적인 token 상한을 적용해 **상한 계산**이라고 표시한다. 평가 세션 미실행은 결과 상태이고 비용 정의의 빈칸이 아니다.</a:t>
+              <a:t>| 사용자와 Agent 장면 | 100/30건. 초기 요청뿐 아니라 정정/제어/확인과 실제 질문/결과 전달을 포함. 실제 내부 호출 수는 구조의 결과 |</a:t>
+            </a:r>
+          </a:p>
+          <a:p xmlns:a="http://schemas.openxmlformats.org/drawingml/2006/main">
+            <a:r>
+              <a:t>| 입력 음성 | 최초 발화 합 234초 + S6-01/02의 지정 후속 답변 합 30초 = **264초(4.4분)**. S5-03의 재연결 발화는 100건에 포함. 추가 확인 답변/송신 무음/재전송도 청구되면 더함 |</a:t>
+            </a:r>
+          </a:p>
+          <a:p xmlns:a="http://schemas.openxmlformats.org/drawingml/2006/main">
+            <a:r>
+              <a:t>| 출력 음성 | 사례별 필요한 전달의 작성자 길이 예산 합 **914초(15.233333분)**. S2-02의 초기 실제 설명과 S4-02의 중단 전 실제 재생도 포함. 실제 출력/중단/청구 길이를 우선하며 미사용 생성도 청구되면 포함 |</a:t>
+            </a:r>
+          </a:p>
+          <a:p xmlns:a="http://schemas.openxmlformats.org/drawingml/2006/main">
+            <a:r>
+              <a:t>| 음성 Text/context | 기준 입력 50,000/output 10,000token. 130장면 × 입력 context 350token + 초기/제어 4,500token, 130장면 × 별도 Text 출력 70token + 초기/제어 900token의 작성자 예산. audio에 이미 청구한 token을 별도 Text로 중복 계상하지 않고 실제 별도 Text 청구를 우선 |</a:t>
+            </a:r>
+          </a:p>
+          <a:p xmlns:a="http://schemas.openxmlformats.org/drawingml/2006/main">
+            <a:r>
+              <a:t>| 의미 호출 | 사용자 해석/결과 200 + Agent 질문/결과 60 + source 갱신 20 + 전체 block 초기/과거 준비 20 = **300호출 예산**. 각 입력 2,000/output 200token. 양안 호출을 300개로 강제하지 않음 |</a:t>
+            </a:r>
+          </a:p>
+          <a:p xmlns:a="http://schemas.openxmlformats.org/drawingml/2006/main">
+            <a:r>
+              <a:t>| 초기/갱신 생산 | source 변경 20건은 원천 사건 수다. 45B의 production 20회와 같다고 가정하지 않음. 모든 block의 2,000turn/200 Task 초기 생산이 예산보다 크면 추가 비용을 기록. 완성된 파생 의미 무료 선주입 금지 |</a:t>
+            </a:r>
+          </a:p>
+          <a:p xmlns:a="http://schemas.openxmlformats.org/drawingml/2006/main">
+            <a:r>
+              <a:t>| 독립 반복 | 동일 W100을 세 번 초기화. 세 실제 비용/청구량과 평균/범위를 공개. 같은 계산 원장을 3번 복제해 통계적 증거로 만들지 않음 |</a:t>
+            </a:r>
+          </a:p>
+          <a:p xmlns:a="http://schemas.openxmlformats.org/drawingml/2006/main">
+            <a:r>
+              <a:t/>
+            </a:r>
+          </a:p>
+          <a:p xmlns:a="http://schemas.openxmlformats.org/drawingml/2006/main">
+            <a:r>
+              <a:t>원장 열은 `run_id, block, occurrence_id, call_id, source_execution_key, dp_option, role, trigger_event, purpose, source_vector, start/end, input/output/reasoning/image/audio_usage, billed, outcome, used_by, USD, evidence_level`이다. timeout/cancel/미사용을 `billed=false`로 추정하지 않는다. usage가 없으면 기록에서 보수적인 token 상한을 적용해 **상한 계산**으로 표시한다. 불필요한 확인은 각 사례의 공통 후속 정책에 따라 처리하며 추가 수고/시간/비용을 모두 남긴다.</a:t>
             </a:r>
           </a:p>
           <a:p xmlns:a="http://schemas.openxmlformats.org/drawingml/2006/main">
@@ -5448,17 +5889,17 @@
           </a:p>
           <a:p xmlns:a="http://schemas.openxmlformats.org/drawingml/2006/main">
             <a:r>
-              <a:t>**목표: 8시간 평균 총 모델 비용 $1.50 이하.** 목표당 보조 환산은 $0.015이며 22일의 동일 활동이면 $33이다. USD 그대로 관리하고 환율/세금/마진/서비스 가격을 섞지 않는다. 이 금액은 사용자 또는 과제 사업자가 이미 확정한 상품 가격이 아니라 작성자가 제안한 모델 예산이다.</a:t>
-            </a:r>
-          </a:p>
-          <a:p xmlns:a="http://schemas.openxmlformats.org/drawingml/2006/main">
-            <a:r>
-              <a:t/>
-            </a:r>
-          </a:p>
-          <a:p xmlns:a="http://schemas.openxmlformats.org/drawingml/2006/main">
-            <a:r>
-              <a:t>| 기준 workload의 계산 | 금액 |</a:t>
+              <a:t>**목표: W100 1회 평균 총 모델 비용 $1.50 이하.** 고정 활동의 사용자 입력 한 장면당 보조 환산은 $0.015다. W100은 합성 PoC 부하이므로 실제 하루/월 사용량 또는 월 요금으로 환산하지 않는다. USD 그대로 관리하며 세금/환율/마진과 제품 서비스 가격을 섞지 않는다.</a:t>
+            </a:r>
+          </a:p>
+          <a:p xmlns:a="http://schemas.openxmlformats.org/drawingml/2006/main">
+            <a:r>
+              <a:t/>
+            </a:r>
+          </a:p>
+          <a:p xmlns:a="http://schemas.openxmlformats.org/drawingml/2006/main">
+            <a:r>
+              <a:t>| 기준 W100의 계산 | 금액 |</a:t>
             </a:r>
           </a:p>
           <a:p xmlns:a="http://schemas.openxmlformats.org/drawingml/2006/main">
@@ -5478,12 +5919,12 @@
           </a:p>
           <a:p xmlns:a="http://schemas.openxmlformats.org/drawingml/2006/main">
             <a:r>
-              <a:t>| 음성 입력 30분 × $0.005/분 | $0.1500 |</a:t>
-            </a:r>
-          </a:p>
-          <a:p xmlns:a="http://schemas.openxmlformats.org/drawingml/2006/main">
-            <a:r>
-              <a:t>| 음성 출력 10분 × $0.018/분 | $0.1800 |</a:t>
+              <a:t>| 음성 입력 264/60분 × $0.005/분 | $0.0220 |</a:t>
+            </a:r>
+          </a:p>
+          <a:p xmlns:a="http://schemas.openxmlformats.org/drawingml/2006/main">
+            <a:r>
+              <a:t>| 음성 출력 914/60분 × $0.018/분 | $0.2742 |</a:t>
             </a:r>
           </a:p>
           <a:p xmlns:a="http://schemas.openxmlformats.org/drawingml/2006/main">
@@ -5498,32 +5939,32 @@
           </a:p>
           <a:p xmlns:a="http://schemas.openxmlformats.org/drawingml/2006/main">
             <a:r>
-              <a:t>| 기본 합계 | **$1.1325** |</a:t>
-            </a:r>
-          </a:p>
-          <a:p xmlns:a="http://schemas.openxmlformats.org/drawingml/2006/main">
-            <a:r>
-              <a:t>| 추가 생산/재시도/길이 증가에 남는 예산 | **$0.3675** |</a:t>
-            </a:r>
-          </a:p>
-          <a:p xmlns:a="http://schemas.openxmlformats.org/drawingml/2006/main">
-            <a:r>
-              <a:t/>
-            </a:r>
-          </a:p>
-          <a:p xmlns:a="http://schemas.openxmlformats.org/drawingml/2006/main">
-            <a:r>
-              <a:t>**과제 근거:** VIA는 상시 대화와 여러 업무의 후속 처리를 제공하므로 요청 때만의 싼 단일 호출을 제시해서는 지속 운용 가능성을 설명할 수 없다. 하루 100개 목표/40분 음성의 기본 reference $1.1325에 추가 처리 여유 $0.3675를 두어 $1.50을 선택했다. 기본값 대비 약 32.45% 여유이며 총 예산의 24.5%다. 품질을 위해 필요한 재판단은 허용하되 배경 생산이 이 여유를 지속적으로 소모하는지 비교한다. 비용을 맞추려고 확인/현재성/허용 검사를 제거하면 정확성에서 손실을 남긴다.</a:t>
-            </a:r>
-          </a:p>
-          <a:p xmlns:a="http://schemas.openxmlformats.org/drawingml/2006/main">
-            <a:r>
-              <a:t/>
-            </a:r>
-          </a:p>
-          <a:p xmlns:a="http://schemas.openxmlformats.org/drawingml/2006/main">
-            <a:r>
-              <a:t>**차이 기준:** 하루 $0.15 이상, 즉 예산의 10% 차이를 의미 있는 비용 차이로 본다. 실제 반복이면 3회 각각의 비용/usage와 범위를 공개하고 같은 방향을 확인한다. 참조 계산이면 사용 횟수/재사용 빈도/음성 길이를 0.5배/1배/2배로 바꿔 조건부 손익을 보인다. 작은 차이는 그대로 금액으로 보고하고 등급 차이만으로 선택하지 않는다.</a:t>
+              <a:t>| 기본 합계 | **$1.0987** |</a:t>
+            </a:r>
+          </a:p>
+          <a:p xmlns:a="http://schemas.openxmlformats.org/drawingml/2006/main">
+            <a:r>
+              <a:t>| 추가 생산/재시도/길이 증가 예산 | **$0.4013** |</a:t>
+            </a:r>
+          </a:p>
+          <a:p xmlns:a="http://schemas.openxmlformats.org/drawingml/2006/main">
+            <a:r>
+              <a:t/>
+            </a:r>
+          </a:p>
+          <a:p xmlns:a="http://schemas.openxmlformats.org/drawingml/2006/main">
+            <a:r>
+              <a:t>**과제 근거:** VIA는 같은 대화에서 과거 근거와 여러 업무의 후속 처리를 연결해야 한다. 18개 대표 사례의 명시적 조회/과거 재사용/정정/질문/결과를 포함하는 W100에서 이 기능을 제공한 전체 모델 비용을 제한한다. 위 역할별 300호출과 실제 사례에 연결한 음성 길이 예산으로 기본 $1.0987을 산정하고 초기 생산/추가 확인/재시도에 $0.4013을 남겨 $1.50을 선택했다. 기본값 대비 약 36.53%, 총액의 약 26.75% 여유다. 이 한도는 외부 시장 단가가 보장하는 처리 성능이나 사용자와 합의된 상품 예산이 아니라 작성자의 설계 평가 예산이다. 출력 길이/초기 생산이 더 크면 목표 미달을 그대로 남긴다.</a:t>
+            </a:r>
+          </a:p>
+          <a:p xmlns:a="http://schemas.openxmlformats.org/drawingml/2006/main">
+            <a:r>
+              <a:t/>
+            </a:r>
+          </a:p>
+          <a:p xmlns:a="http://schemas.openxmlformats.org/drawingml/2006/main">
+            <a:r>
+              <a:t>**차이 기준: $0.15/W100 이상**, 예산의 10%. 실제 반복이면 3회별 차이/범위와 같은 방향을 확인한다. 계산이면 같은 장면 구성에서 cache miss/추가 호출/실제 음성 길이 가정을 절반/기준/두 배로 바꾼다. 부하량 자체를 50/100/200건으로 바꾸는 별도 profile은 양안에 함께 적용하고 W100 대표값과 섞지 않는다. 기능 포기/미완료/필수 위반이 있는 낮은 비용은 목표 달성으로 판정하지 않는다.</a:t>
             </a:r>
           </a:p>
           <a:p xmlns:a="http://schemas.openxmlformats.org/drawingml/2006/main">
@@ -5553,7 +5994,7 @@
           </a:p>
           <a:p xmlns:a="http://schemas.openxmlformats.org/drawingml/2006/main">
             <a:r>
-              <a:t>- A: 하루 실제 cache miss 40회, miss당 과거 근거 추가 입력 4,000/출력 200 token이면 `40 × $0.004 = $0.160`.</a:t>
+              <a:t>- A: W100에서 실제 cache miss 40회, miss당 과거 근거 추가 입력 4,000/출력 200 token이면 `40 × $0.004 = $0.160`.</a:t>
             </a:r>
           </a:p>
           <a:p xmlns:a="http://schemas.openxmlformats.org/drawingml/2006/main">
@@ -5633,7 +6074,7 @@
           </a:p>
           <a:p xmlns:a="http://schemas.openxmlformats.org/drawingml/2006/main">
             <a:r>
-              <a:t>03-02 공통 QA 계약 v4: ../../architecture/12-decisions/decision-packages/03-02-quality-attribute-definitions.md</a:t>
+              <a:t>03-02 공통 QA 계약 v5: ../../architecture/12-decisions/decision-packages/03-02-quality-attribute-definitions.md</a:t>
             </a:r>
           </a:p>
           <a:p xmlns:a="http://schemas.openxmlformats.org/drawingml/2006/main">
@@ -6028,7 +6469,7 @@
           </a:p>
           <a:p xmlns:a="http://schemas.openxmlformats.org/drawingml/2006/main">
             <a:r>
-              <a:t>측정 지표: 최대 전체 commit 메모리(MiB) = 모든 VIA process의 private commit + 고유 공유 anonymous commit의 동시 합 최대</a:t>
+              <a:t>측정 지표: 최대 전체 commit 메모리(MiB) = 같은 W100 3회 중 모든 VIA process의 private commit + 고유 공유 anonymous commit의 동시 합 최대</a:t>
             </a:r>
           </a:p>
           <a:p xmlns:a="http://schemas.openxmlformats.org/drawingml/2006/main">
@@ -6063,7 +6504,7 @@
           </a:p>
           <a:p xmlns:a="http://schemas.openxmlformats.org/drawingml/2006/main">
             <a:r>
-              <a:t>03-02 공통 QA 계약 v4: ../../architecture/12-decisions/decision-packages/03-02-quality-attribute-definitions.md</a:t>
+              <a:t>03-02 공통 QA 계약 v5: ../../architecture/12-decisions/decision-packages/03-02-quality-attribute-definitions.md</a:t>
             </a:r>
           </a:p>
           <a:p xmlns:a="http://schemas.openxmlformats.org/drawingml/2006/main">
@@ -6108,7 +6549,7 @@
           </a:p>
           <a:p xmlns:a="http://schemas.openxmlformats.org/drawingml/2006/main">
             <a:r>
-              <a:t>**동일한 활동과 동시 부하에서 VIA가 로컬 PC에 할당해 유지하는 메모리의 최대량.** 대표값은 **8시간 동안 VIA 전체 프로세스의 최대 동시 commit 메모리(MiB)**다. 순간별 모든 VIA process의 private committed bytes와 공유 anonymous section의 고유 committed bytes를 한 번씩 합한 뒤 최대값을 구한다.</a:t>
+              <a:t>**동일한 활동과 동시 부하에서 VIA가 로컬 PC에 할당해 유지하는 메모리의 최대량.** 대표값은 **같은 W100 세 번의 전체 활동에서 VIA 전체 프로세스의 최대 동시 commit 메모리(MiB)**다. 순간별 모든 VIA process의 private committed bytes와 공유 anonymous section의 고유 committed bytes를 한 번씩 합한 뒤 최대값을 구한다.</a:t>
             </a:r>
           </a:p>
           <a:p xmlns:a="http://schemas.openxmlformats.org/drawingml/2006/main">
@@ -6173,27 +6614,37 @@
           </a:p>
           <a:p xmlns:a="http://schemas.openxmlformats.org/drawingml/2006/main">
             <a:r>
-              <a:t>### 7.2 고정 장치, 부하와 관찰 기간</a:t>
-            </a:r>
-          </a:p>
-          <a:p xmlns:a="http://schemas.openxmlformats.org/drawingml/2006/main">
-            <a:r>
-              <a:t/>
-            </a:r>
-          </a:p>
-          <a:p xmlns:a="http://schemas.openxmlformats.org/drawingml/2006/main">
-            <a:r>
-              <a:t>장치는 §8.4의 **Galaxy Book6 Ultra NP960UJH-XG3IN, Windows 11, RAM 32GB급**이다. 가격 reference와 현재 접근 중인 Mac은 Windows 실측 기기가 아니다. AC 전원, 동일 전원 모드, 동일 Office/browser의 외부 부하를 고정한다.</a:t>
-            </a:r>
-          </a:p>
-          <a:p xmlns:a="http://schemas.openxmlformats.org/drawingml/2006/main">
-            <a:r>
-              <a:t/>
-            </a:r>
-          </a:p>
-          <a:p xmlns:a="http://schemas.openxmlformats.org/drawingml/2006/main">
-            <a:r>
-              <a:t>| 단계 | 기간 | VIA workload와 확인할 값 |</a:t>
+              <a:t>### 7.2 고정 장치, 공통 부하와 관찰 구간</a:t>
+            </a:r>
+          </a:p>
+          <a:p xmlns:a="http://schemas.openxmlformats.org/drawingml/2006/main">
+            <a:r>
+              <a:t/>
+            </a:r>
+          </a:p>
+          <a:p xmlns:a="http://schemas.openxmlformats.org/drawingml/2006/main">
+            <a:r>
+              <a:t>장치는 §8.4의 **Galaxy Book6 Ultra NP960UJH-XG3IN, Windows 11, RAM 32GB급**이다. AC 전원/전원 모드와 Office/browser 부하를 고정한다. 현재 접근 중인 Mac에서 산출한 참조 계산은 Windows 실측이 아니다.</a:t>
+            </a:r>
+          </a:p>
+          <a:p xmlns:a="http://schemas.openxmlformats.org/drawingml/2006/main">
+            <a:r>
+              <a:t/>
+            </a:r>
+          </a:p>
+          <a:p xmlns:a="http://schemas.openxmlformats.org/drawingml/2006/main">
+            <a:r>
+              <a:t>**비용과 정확히 같은 W100을 읽는다.** 초기 2,000turn/완료 Task 200개/원본 30개(20MiB), 활성 Task 최대 10개, cloud call 최대 4개, 130장면, background source 갱신 20건/maintenance tick 10회와 마지막 철회를 동일하게 적용한다. 10개 Task/4호출은 동시에 요구하거나 허용하는 부하의 상한이며 후보의 호출을 네 개로 강제하지 않는다. 논리적 Task pool과 burst의 역할은 §8.0에 정의했다.</a:t>
+            </a:r>
+          </a:p>
+          <a:p xmlns:a="http://schemas.openxmlformats.org/drawingml/2006/main">
+            <a:r>
+              <a:t/>
+            </a:r>
+          </a:p>
+          <a:p xmlns:a="http://schemas.openxmlformats.org/drawingml/2006/main">
+            <a:r>
+              <a:t>| 단계 | 종료 조건 | 관측에 포함할 것 |</a:t>
             </a:r>
           </a:p>
           <a:p xmlns:a="http://schemas.openxmlformats.org/drawingml/2006/main">
@@ -6203,42 +6654,47 @@
           </a:p>
           <a:p xmlns:a="http://schemas.openxmlformats.org/drawingml/2006/main">
             <a:r>
-              <a:t>| cold/초기화 | 0~5분 | owner snapshot/DB/cache/cloud session 초기화. B 초기 생산의 메모리/비용 포함 |</a:t>
-            </a:r>
-          </a:p>
-          <a:p xmlns:a="http://schemas.openxmlformats.org/drawingml/2006/main">
-            <a:r>
-              <a:t>| 일반 활동 | 5~360분 | §5.2의 동일 100개 목표/30개 비동기 event/20개 source 변경 중 해당 시각의 사건. Task 10개 활성, cloud call 최대 4개 |</a:t>
-            </a:r>
-          </a:p>
-          <a:p xmlns:a="http://schemas.openxmlformats.org/drawingml/2006/main">
-            <a:r>
-              <a:t>| 반복/집중 활동 | 360~420분 | 같은 source 재사용과 정정. 360분/390분에 네 개 동시 처리와 10개 event/1초 burst를 배치하되 추가 신규 목표 대신 기존 목표의 후속 사건으로 구성 |</a:t>
-            </a:r>
-          </a:p>
-          <a:p xmlns:a="http://schemas.openxmlformats.org/drawingml/2006/main">
-            <a:r>
-              <a:t>| 철회/회수/유휴 | 420~480분 | 450분에 source 하나의 제공 동의 철회, 관련 파생물/Context 신규 사용 차단. 470~480분은 신규 목표 없이 drain/idle, 잔류 메모리 확인 |</a:t>
-            </a:r>
-          </a:p>
-          <a:p xmlns:a="http://schemas.openxmlformats.org/drawingml/2006/main">
-            <a:r>
-              <a:t/>
-            </a:r>
-          </a:p>
-          <a:p xmlns:a="http://schemas.openxmlformats.org/drawingml/2006/main">
-            <a:r>
-              <a:t>§5.2의 마지막 입력 시각은 465.6분으로 정하고 **470분 이후 신규 요청은 없다**. 100개 최초 입력을 `0~465.6분 등간격`으로 배치한다. 일반 활동과 마지막 집중 구간은 같은 workload의 단계 구분이지 전체 사건을 두 번 실행한다는 뜻이 아니다. 순서를 바꿀 수 없는 정확성 X 사건은 해당 목표 내부 상대 순서를 유지한다. 초기 데이터와 모든 후속 사건의 비용도 §5의 같은 8시간 원장에 들어간다.</a:t>
-            </a:r>
-          </a:p>
-          <a:p xmlns:a="http://schemas.openxmlformats.org/drawingml/2006/main">
-            <a:r>
-              <a:t/>
-            </a:r>
-          </a:p>
-          <a:p xmlns:a="http://schemas.openxmlformats.org/drawingml/2006/main">
-            <a:r>
-              <a:t>근거 보관/질문/유효 Task의 사용자 기능은 양안 같다. capture는 2880×1800 RGBA 원본 한 장 약 19.775MiB, 최대 15장으로 약 296.63MiB이며 최대 512MiB budget 안에서 원본/전달 copy를 관리하는 **가정**이다. 후보는 같은 보존 범위에서 압축/참조 공유를 사용할 수 있고 그 처리 시간도 QA-02/03에 남긴다. 45B에만 무제한 모든 과거를 RAM 상주시키거나 A의 정상 cache를 없애지 않는다.</a:t>
+              <a:t>| 초기화/준비 | 최초 CORE 입력 준비 | owner 원본 복원/DB/cloud session/실제 파생 생산. peak 원장 시작 후 수행 |</a:t>
+            </a:r>
+          </a:p>
+          <a:p xmlns:a="http://schemas.openxmlformats.org/drawingml/2006/main">
+            <a:r>
+              <a:t>| CORE/REUSE | 각 block의 18+4 장면 checkpoint/tail 충족 | 과거 준비/캐시/정정/후속 결과, 이전 block의 완료 이력 유지 |</a:t>
+            </a:r>
+          </a:p>
+          <a:p xmlns:a="http://schemas.openxmlformats.org/drawingml/2006/main">
+            <a:r>
+              <a:t>| BURST/갱신 | 네 Agent 장면과 네 source 변경 반영 | 네 장면 0/0.02/0.04/0.06초 제공, 최대 4호출의 실제 겹침, queue/copy/무효화 |</a:t>
+            </a:r>
+          </a:p>
+          <a:p xmlns:a="http://schemas.openxmlformats.org/drawingml/2006/main">
+            <a:r>
+              <a:t>| 철회/drain | 마지막 source 철회 뒤 새 입력 없이 최대 30초 | 파생/Context 신규 사용 차단, 처리 가능한 VIA queue/job 회수. 외부 Task의 정당한 대기 상태는 보존 |</a:t>
+            </a:r>
+          </a:p>
+          <a:p xmlns:a="http://schemas.openxmlformats.org/drawingml/2006/main">
+            <a:r>
+              <a:t>| 유휴 probe | drain 완료 뒤 10초 | 시작/끝 commit과 구간 최대. 새 요청/추가 maintenance 없음, pending 외부 질문을 삭제해 성공으로 바꾸지 않음 |</a:t>
+            </a:r>
+          </a:p>
+          <a:p xmlns:a="http://schemas.openxmlformats.org/drawingml/2006/main">
+            <a:r>
+              <a:t/>
+            </a:r>
+          </a:p>
+          <a:p xmlns:a="http://schemas.openxmlformats.org/drawingml/2006/main">
+            <a:r>
+              <a:t>완료 history를 block마다 삭제해 메모리 증가를 숨기지 않는다. 후보가 job을 포기하거나 drain deadline을 넘으면 낮은 peak도 자원 목표 달성이 아니다. probe가 끝날 때까지 전체 비용 원장도 열린다. 실측 반복 R1/R2/R3는 서로 독립 초기화하지만 각 활동 내부의 peak와 history는 초기화하지 않는다.</a:t>
+            </a:r>
+          </a:p>
+          <a:p xmlns:a="http://schemas.openxmlformats.org/drawingml/2006/main">
+            <a:r>
+              <a:t/>
+            </a:r>
+          </a:p>
+          <a:p xmlns:a="http://schemas.openxmlformats.org/drawingml/2006/main">
+            <a:r>
+              <a:t>공통 capture는 2880×1800 RGBA 원본 한 장 약 19.775MiB, 보존 창 최대 15장으로 약 296.63MiB다. 512MiB capture 예산에는 음성/전사/전달 copy도 포함하므로 원본과 완전한 15장 복사본을 동시에 보관하면 예산을 넘을 수 있다. 같은 원천 사건/15장 보관 범위에서 압축/참조 공유를 허용하고 처리 시간은 QA-02/03에 남긴다. 45B의 과거 RAM 상주나 42B helper/복사 비용을 빠뜨리지 않으며 강한 A의 정상 cache도 보존한다.</a:t>
             </a:r>
           </a:p>
           <a:p xmlns:a="http://schemas.openxmlformats.org/drawingml/2006/main">
@@ -6343,7 +6799,7 @@
           </a:p>
           <a:p xmlns:a="http://schemas.openxmlformats.org/drawingml/2006/main">
             <a:r>
-              <a:t>보조 보호 조건은 앞의 working-set 합 6GiB 이하와 **470~480분 잔류 commit의 증가가 16MiB 이하**다. 필수 근거/작업을 유지한 채 배경 queue를 회수하는지 확인한다. 16MiB는 작은 page/cache fluctuation을 허용하는 진단 예산이고 product leak 0의 증명은 아니다. workload가 기능을 포기하고 더 적게 저장한 경우 정확성/지원 범위 손실과 함께 보고한다.</a:t>
+              <a:t>보조 보호 조건은 앞의 working-set 합 6GiB 이하와 **drain 뒤 10초 유휴 probe의 종료 commit - 시작 commit이 16MiB 이하**다. 필수 근거/작업을 유지한 채 배경 queue를 회수하는지 확인한다. probe 중 최대값도 전체 peak에 남기며 종료-시작이 음수면 증가 0으로 보고한다. 16MiB는 작은 page/cache fluctuation을 허용하는 진단 예산이고 product leak 0의 증명은 아니다. workload가 기능을 포기하고 더 적게 저장한 경우 정확성/지원 범위 손실과 함께 보고한다.</a:t>
             </a:r>
           </a:p>
           <a:p xmlns:a="http://schemas.openxmlformats.org/drawingml/2006/main">
@@ -6373,7 +6829,7 @@
           </a:p>
           <a:p xmlns:a="http://schemas.openxmlformats.org/drawingml/2006/main">
             <a:r>
-              <a:t>3. 8시간 session을 3회 초기화해 수행하고 **세 session의 최대 중 가장 큰 값**을 대표 보고값으로 쓴다. 각 session의 peak와 시각/phase, idle 변화, sample 누락을 공개한다. process restart에서 peak 원장을 리셋하지 않는다.</a:t>
+              <a:t>3. 같은 W100을 3회 독립 초기화해 수행하고 **세 활동의 최대 중 가장 큰 값**을 대표 보고값으로 쓴다. 각 run의 peak와 시각/phase, idle 변화, sample 누락을 공개한다. process restart에서 peak 원장을 리셋하지 않는다.</a:t>
             </a:r>
           </a:p>
           <a:p xmlns:a="http://schemas.openxmlformats.org/drawingml/2006/main">
@@ -6394,6 +6850,971 @@
           <a:p xmlns:a="http://schemas.openxmlformats.org/drawingml/2006/main">
             <a:r>
               <a:t>**차이 기준: 128MiB 이상**, 목표 4GiB의 약 3.125%와 기본 상태/queue budget 한 묶음 크기다. polling 오차/allocator reserve 차이보다 구조의 동시 상태 차이를 보려는 작성자 기준이다. 계산에서는 추가 process heap, 중복 message copy, cache 크기를 절반/기준/두 배로 바꿔 확인한다. 41의 해석 Context/frame/부분 상태, 42의 추가 service/접수/outbox, 44의 continuation/window/buffer, 45의 원문 cache/게시 index/coverage/backlog가 참여한다. 어느 안도 무조건 작다고 확정하지 않는다.</a:t>
+            </a:r>
+          </a:p>
+          <a:p xmlns:a="http://schemas.openxmlformats.org/drawingml/2006/main">
+            <a:r>
+              <a:t/>
+            </a:r>
+          </a:p>
+          <a:p xmlns:a="http://schemas.openxmlformats.org/drawingml/2006/main">
+            <a:r>
+              <a:t/>
+            </a:r>
+          </a:p>
+          <a:p xmlns:a="http://schemas.openxmlformats.org/drawingml/2006/main">
+            <a:r>
+              <a:t>공통 활동 상세 §8.0</a:t>
+            </a:r>
+          </a:p>
+          <a:p xmlns:a="http://schemas.openxmlformats.org/drawingml/2006/main">
+            <a:r>
+              <a:t>공통 PoC 환경과 A/B 비교 방법</a:t>
+            </a:r>
+          </a:p>
+          <a:p xmlns:a="http://schemas.openxmlformats.org/drawingml/2006/main">
+            <a:r>
+              <a:t/>
+            </a:r>
+          </a:p>
+          <a:p xmlns:a="http://schemas.openxmlformats.org/drawingml/2006/main">
+            <a:r>
+              <a:t>공통 입력/원천 사건/후보/모델 조건은 여섯 QA에 공유하고, 각 QA의 분모/시간/금액/변경/메모리 경계는 §3~7의 완료 정의를 따른다. 공통 전사/장치 replay를 실제 ASR 정확도나 물리 장치 응답시간 실측으로 해석하지 않는다.</a:t>
+            </a:r>
+          </a:p>
+          <a:p xmlns:a="http://schemas.openxmlformats.org/drawingml/2006/main">
+            <a:r>
+              <a:t/>
+            </a:r>
+          </a:p>
+          <a:p xmlns:a="http://schemas.openxmlformats.org/drawingml/2006/main">
+            <a:r>
+              <a:t>### 8.0 공통 활동 W100: 사용량과 관측 대응</a:t>
+            </a:r>
+          </a:p>
+          <a:p xmlns:a="http://schemas.openxmlformats.org/drawingml/2006/main">
+            <a:r>
+              <a:t/>
+            </a:r>
+          </a:p>
+          <a:p xmlns:a="http://schemas.openxmlformats.org/drawingml/2006/main">
+            <a:r>
+              <a:t>#### 8.0.1 사용량을 정의하는 이유와 범위</a:t>
+            </a:r>
+          </a:p>
+          <a:p xmlns:a="http://schemas.openxmlformats.org/drawingml/2006/main">
+            <a:r>
+              <a:t/>
+            </a:r>
+          </a:p>
+          <a:p xmlns:a="http://schemas.openxmlformats.org/drawingml/2006/main">
+            <a:r>
+              <a:t>**W100은 기존 18개 사례로 구성한 합성 표준 활동이다.** 사용자의 실제 일일 빈도 자료가 없는 PoC에서 A/B가 같은 기능과 부하를 처리하도록 평가용 사용량을 명시했다. 100은 사용자 입력 장면 수다. 신규 업무/조회뿐 아니라 정정/취소/확인/재연결이 들어간다. Agent가 먼저 질문/결과를 보내는 장면은 별도로 30건이다. S5-03은 Agent 결과로 시작하지만 재연결한 사용자의 명시적 조회 발화가 있으므로 사용량 원장에서는 사용자 장면 1건이다. S6의 계획된 답변은 그 장면 내부 후속 발화이며 장면을 추가하지 않는다.</a:t>
+            </a:r>
+          </a:p>
+          <a:p xmlns:a="http://schemas.openxmlformats.org/drawingml/2006/main">
+            <a:r>
+              <a:t/>
+            </a:r>
+          </a:p>
+          <a:p xmlns:a="http://schemas.openxmlformats.org/drawingml/2006/main">
+            <a:r>
+              <a:t>원천은 §3의 18개 초기 상황/입력/경쟁 사건/정답과 아래 공통 lifecycle tail이다. **QA별로 다른 업무나 외부 결과를 만들지 않는다.** 평가 관측 단위가 다르므로 모든 QA의 분모가 같을 필요는 없다. 정확성은 조건, 시간은 사건 경계, 비용은 활동 전체 청구, 메모리는 활동 전체 동시 할당을 읽는다. 변경 용이성은 여섯 구조 변경 과제이며 변경 뒤 같은 기능/활동 계약을 유지한다.</a:t>
+            </a:r>
+          </a:p>
+          <a:p xmlns:a="http://schemas.openxmlformats.org/drawingml/2006/main">
+            <a:r>
+              <a:t/>
+            </a:r>
+          </a:p>
+          <a:p xmlns:a="http://schemas.openxmlformats.org/drawingml/2006/main">
+            <a:r>
+              <a:t>[공통 활동 입력](./03-02-common-workload.json)은 이 절의 machine-readable 사용량/음성/호출 예산이고 [사건 목록](./03-02-workload-manifest.json)은 각 장면의 case/hash/CORE 여부/I/T 연결을 130행으로 생성한다. [활동 검산기](../../../../scripts/architecture/qa_common_workload.py)는 입력 목록을 컴파일할 뿐 후보/harness/API를 실행하지 않는다. 참조 계산과 두 발표자료도 같은 원본/manifest hash를 사용한다.</a:t>
+            </a:r>
+          </a:p>
+          <a:p xmlns:a="http://schemas.openxmlformats.org/drawingml/2006/main">
+            <a:r>
+              <a:t/>
+            </a:r>
+          </a:p>
+          <a:p xmlns:a="http://schemas.openxmlformats.org/drawingml/2006/main">
+            <a:r>
+              <a:t>#### 8.0.2 사례별 횟수와 음성 길이</a:t>
+            </a:r>
+          </a:p>
+          <a:p xmlns:a="http://schemas.openxmlformats.org/drawingml/2006/main">
+            <a:r>
+              <a:t/>
+            </a:r>
+          </a:p>
+          <a:p xmlns:a="http://schemas.openxmlformats.org/drawingml/2006/main">
+            <a:r>
+              <a:t>| 원본 사례 | W100 횟수 | 입력 장면 분류 | 최초 발화 초/회 | 지정 답변 초/회 | 출력 음성 예산 초/회 | 반응 관측 | 사이클 관측 |</a:t>
+            </a:r>
+          </a:p>
+          <a:p xmlns:a="http://schemas.openxmlformats.org/drawingml/2006/main">
+            <a:r>
+              <a:t>| --- | --- | --- | --- | --- | --- | --- | --- |</a:t>
+            </a:r>
+          </a:p>
+          <a:p xmlns:a="http://schemas.openxmlformats.org/drawingml/2006/main">
+            <a:r>
+              <a:t>| S1-01 | 8 | 사용자 | 2 | 0 | 3 | 없음 | T-01 |</a:t>
+            </a:r>
+          </a:p>
+          <a:p xmlns:a="http://schemas.openxmlformats.org/drawingml/2006/main">
+            <a:r>
+              <a:t>| S1-02 | 8 | 사용자 | 3 | 0 | 8 | 없음 | T-02 |</a:t>
+            </a:r>
+          </a:p>
+          <a:p xmlns:a="http://schemas.openxmlformats.org/drawingml/2006/main">
+            <a:r>
+              <a:t>| S1-03 | 8 | 사용자 | 3 | 0 | 4 | 없음 | 없음 |</a:t>
+            </a:r>
+          </a:p>
+          <a:p xmlns:a="http://schemas.openxmlformats.org/drawingml/2006/main">
+            <a:r>
+              <a:t>| S2-01 | 8 | 사용자 | 2 | 0 | 5 | 없음 | 없음 |</a:t>
+            </a:r>
+          </a:p>
+          <a:p xmlns:a="http://schemas.openxmlformats.org/drawingml/2006/main">
+            <a:r>
+              <a:t>| S2-02 | 8 | 사용자 | 3 | 0 | 18 | 없음 | T-03 |</a:t>
+            </a:r>
+          </a:p>
+          <a:p xmlns:a="http://schemas.openxmlformats.org/drawingml/2006/main">
+            <a:r>
+              <a:t>| S2-03 | 8 | 사용자 | 2 | 0 | 4 | 없음 | 없음 |</a:t>
+            </a:r>
+          </a:p>
+          <a:p xmlns:a="http://schemas.openxmlformats.org/drawingml/2006/main">
+            <a:r>
+              <a:t>| S3-01 | 5 | 사용자 | 3 | 0 | 6 | 없음 | 없음 |</a:t>
+            </a:r>
+          </a:p>
+          <a:p xmlns:a="http://schemas.openxmlformats.org/drawingml/2006/main">
+            <a:r>
+              <a:t>| S3-02 | 5 | 사용자 | 3 | 0 | 10 | 없음 | T-04 |</a:t>
+            </a:r>
+          </a:p>
+          <a:p xmlns:a="http://schemas.openxmlformats.org/drawingml/2006/main">
+            <a:r>
+              <a:t>| S3-03 | 5 | 사용자 | 3 | 0 | 6 | 없음 | 없음 |</a:t>
+            </a:r>
+          </a:p>
+          <a:p xmlns:a="http://schemas.openxmlformats.org/drawingml/2006/main">
+            <a:r>
+              <a:t>| S4-01 | 5 | 사용자 | 2 | 0 | 9 | I-02 | T-05 |</a:t>
+            </a:r>
+          </a:p>
+          <a:p xmlns:a="http://schemas.openxmlformats.org/drawingml/2006/main">
+            <a:r>
+              <a:t>| S4-02 | 5 | 사용자 | 2 | 0 | 8 | I-01 | 없음 |</a:t>
+            </a:r>
+          </a:p>
+          <a:p xmlns:a="http://schemas.openxmlformats.org/drawingml/2006/main">
+            <a:r>
+              <a:t>| S4-03 | 5 | 사용자 | 2 | 0 | 5 | I-03 | 없음 |</a:t>
+            </a:r>
+          </a:p>
+          <a:p xmlns:a="http://schemas.openxmlformats.org/drawingml/2006/main">
+            <a:r>
+              <a:t>| S5-01 | 15 | Agent | 0 | 0 | 5 | I-04 | 없음 |</a:t>
+            </a:r>
+          </a:p>
+          <a:p xmlns:a="http://schemas.openxmlformats.org/drawingml/2006/main">
+            <a:r>
+              <a:t>| S5-02 | 15 | Agent | 0 | 0 | 6 | I-05 | 없음 |</a:t>
+            </a:r>
+          </a:p>
+          <a:p xmlns:a="http://schemas.openxmlformats.org/drawingml/2006/main">
+            <a:r>
+              <a:t>| S5-03 | 7 | 사용자 | 2 | 0 | 4 | 없음 | 없음 |</a:t>
+            </a:r>
+          </a:p>
+          <a:p xmlns:a="http://schemas.openxmlformats.org/drawingml/2006/main">
+            <a:r>
+              <a:t>| S6-01 | 5 | 사용자 | 2 | 3 | 14 | 없음 | T-06 |</a:t>
+            </a:r>
+          </a:p>
+          <a:p xmlns:a="http://schemas.openxmlformats.org/drawingml/2006/main">
+            <a:r>
+              <a:t>| S6-02 | 5 | 사용자 | 1 | 3 | 14 | 없음 | 없음 |</a:t>
+            </a:r>
+          </a:p>
+          <a:p xmlns:a="http://schemas.openxmlformats.org/drawingml/2006/main">
+            <a:r>
+              <a:t>| S6-03 | 5 | 사용자 | 2 | 0 | 5 | I-06 | 없음 |</a:t>
+            </a:r>
+          </a:p>
+          <a:p xmlns:a="http://schemas.openxmlformats.org/drawingml/2006/main">
+            <a:r>
+              <a:t/>
+            </a:r>
+          </a:p>
+          <a:p xmlns:a="http://schemas.openxmlformats.org/drawingml/2006/main">
+            <a:r>
+              <a:t>사용자 장면 합 100, Agent 장면 합 30이다. 최초 입력의 replay 길이는 §3 사건 구간으로 정한 **fixture 조건**이고 합 234초다. S6-01/02 각 5회의 후속 답변 3초를 더해 계획된 입력은 **110발화/264초**다. 추가 확인은 §3 공통 답변 정책대로 공급하고 실제 청구를 더한다. S5-03의 2초 재연결 요청은 최초 발화 열에 이미 포함했다.</a:t>
+            </a:r>
+          </a:p>
+          <a:p xmlns:a="http://schemas.openxmlformats.org/drawingml/2006/main">
+            <a:r>
+              <a:t/>
+            </a:r>
+          </a:p>
+          <a:p xmlns:a="http://schemas.openxmlformats.org/drawingml/2006/main">
+            <a:r>
+              <a:t>출력 길이는 **작성자의 참조 예산**이며 모델 성능/자연 발화 길이 보장이 아니다. 위 표의 필수 사실 전달과 공통 tail을 합해 914초다. S2-02 18초는 과거의 실제 재생 설명 8초와 현재 접수/결과 10초, S4-02 8초는 중단 전 재생 4초와 새 설명 4초를 포함한다. S6-01/02 14초는 확인 질문과 허용 범위/결과 전달의 합이다. 나머지는 해당 C6 사실과 tail 전달의 총 길이 예산이다. 실제 모델 생성/재생/폐기 청구량을 예산값으로 덮어쓰지 않는다. Text 표시 길이와 음성 시간의 임의 token 환산도 하지 않는다.</a:t>
+            </a:r>
+          </a:p>
+          <a:p xmlns:a="http://schemas.openxmlformats.org/drawingml/2006/main">
+            <a:r>
+              <a:t/>
+            </a:r>
+          </a:p>
+          <a:p xmlns:a="http://schemas.openxmlformats.org/drawingml/2006/main">
+            <a:r>
+              <a:t>#### 8.0.3 다섯 block의 입력 순서와 관측 선택</a:t>
+            </a:r>
+          </a:p>
+          <a:p xmlns:a="http://schemas.openxmlformats.org/drawingml/2006/main">
+            <a:r>
+              <a:t/>
+            </a:r>
+          </a:p>
+          <a:p xmlns:a="http://schemas.openxmlformats.org/drawingml/2006/main">
+            <a:r>
+              <a:t>각 block은 **CORE 18장면 + REUSE 4장면 + BURST 4장면 = 26장면**이다. 다섯 block이 사용자 100/Agent 30의 130장면을 만든다. CORE는 S1-01부터 S6-03까지 위 표 순서로 각 한 번이다. 각 장면은 필수 checkpoint와 tail까지 진행한 뒤 다음 장면을 시작한다. 아래 REUSE는 같은 block에서 이미 허용된 원본 version/제공 권한을 확인한 뒤 재사용한다. 기존 현재 Task를 임의 정답으로 배치하지 않고 요청 ID/외부 실행 ID는 occurrence namespace로 구별한다.</a:t>
+            </a:r>
+          </a:p>
+          <a:p xmlns:a="http://schemas.openxmlformats.org/drawingml/2006/main">
+            <a:r>
+              <a:t/>
+            </a:r>
+          </a:p>
+          <a:p xmlns:a="http://schemas.openxmlformats.org/drawingml/2006/main">
+            <a:r>
+              <a:t>| block | REUSE 네 장면 순서 | BURST 네 장면 순서 |</a:t>
+            </a:r>
+          </a:p>
+          <a:p xmlns:a="http://schemas.openxmlformats.org/drawingml/2006/main">
+            <a:r>
+              <a:t>| --- | --- | --- |</a:t>
+            </a:r>
+          </a:p>
+          <a:p xmlns:a="http://schemas.openxmlformats.org/drawingml/2006/main">
+            <a:r>
+              <a:t>| B1 | S1-01, S1-02, S2-01, S2-02 | S5-01, S5-02, S5-01, S5-02 |</a:t>
+            </a:r>
+          </a:p>
+          <a:p xmlns:a="http://schemas.openxmlformats.org/drawingml/2006/main">
+            <a:r>
+              <a:t>| B2 | S1-01, S1-03, S2-01, S2-03 | 동일 |</a:t>
+            </a:r>
+          </a:p>
+          <a:p xmlns:a="http://schemas.openxmlformats.org/drawingml/2006/main">
+            <a:r>
+              <a:t>| B3 | S1-02, S1-03, S2-02, S2-03 | 동일 |</a:t>
+            </a:r>
+          </a:p>
+          <a:p xmlns:a="http://schemas.openxmlformats.org/drawingml/2006/main">
+            <a:r>
+              <a:t>| B4 | S1-01, S1-02, S2-01, S2-02 | 동일 |</a:t>
+            </a:r>
+          </a:p>
+          <a:p xmlns:a="http://schemas.openxmlformats.org/drawingml/2006/main">
+            <a:r>
+              <a:t>| B5 | S1-03, S2-03, S5-03, S5-03 | 동일 |</a:t>
+            </a:r>
+          </a:p>
+          <a:p xmlns:a="http://schemas.openxmlformats.org/drawingml/2006/main">
+            <a:r>
+              <a:t/>
+            </a:r>
+          </a:p>
+          <a:p xmlns:a="http://schemas.openxmlformats.org/drawingml/2006/main">
+            <a:r>
+              <a:t>BURST의 네 Agent 장면 최초 원천 사건을 상대 0/0.02/0.04/0.06초에 공급하고 각 장면 내부의 원본 후속 순서를 보존한다. 사용자 음성을 네 개 중첩시키는 시험은 아니다. 네 장면이 각각 사용하는 두 Task를 pool의 여덟 slot에 배치하고 T보호와 background 한 Task의 두 slot을 유지해 **활성 최대 10개**다. CORE/REUSE는 이 pool의 필요한 slot만 해당 초기 사실로 복원한다. 완료된 관련 작업은 active slot에서 빠져 이력으로 남는다. 이 합성 replay suite의 slot은 현재 제시하는 scoped scene의 owner이며 10은 그 scene에서 동시에 처리하는 Task 상한이다. 완료되지 않은 질문/취소 접수는 먼저 원본 checkpoint/5초 늦은 사건 관찰을 충족한 뒤 scope를 닫고 원래 대기 상태/receipt를 그대로 활동 이력에 보존한다. 전체 미완료 Task를 10개로 자른다거나 외부 대기를 성공 완료로 바꾸는 실제 운용 정책은 아니다. 다음 scene의 before-state 복원과 구분하고 scope 회수 비용/peak도 센다.</a:t>
+            </a:r>
+          </a:p>
+          <a:p xmlns:a="http://schemas.openxmlformats.org/drawingml/2006/main">
+            <a:r>
+              <a:t/>
+            </a:r>
+          </a:p>
+          <a:p xmlns:a="http://schemas.openxmlformats.org/drawingml/2006/main">
+            <a:r>
+              <a:t>block의 마지막 BURST checkpoint 이후 B01~B04, B05~B08, …, B17~B20의 background 원본을 각각 한 번 `v1→v2` 갱신한다. 각 원본은 초기 30개 source 중 하나이며 locator와 권한은 그대로, 내용의 수치 한 곳만 1 증가한다. 입력 목록 순서로 0.01초 간격 제공하고 같은 block의 maintenance tick 두 개를 직렬 제공한다. 총 **20개 background 변경/10개 tick**이다. §3의 S2-03 등 내부 X 갱신은 이 20개와 별개로 이미 장면에 포함되며 별도 호출을 중복 청구하지 않는다. B5 마지막 갱신 뒤 B20의 제공 동의를 철회해 원문/파생/Context 신규 소비를 차단한다. 후보의 실제 생산/재해석/철회 비용은 모두 남긴다.</a:t>
+            </a:r>
+          </a:p>
+          <a:p xmlns:a="http://schemas.openxmlformats.org/drawingml/2006/main">
+            <a:r>
+              <a:t/>
+            </a:r>
+          </a:p>
+          <a:p xmlns:a="http://schemas.openxmlformats.org/drawingml/2006/main">
+            <a:r>
+              <a:t>R1/R2/R3는 동일 초기 자료를 가진 **세 독립 활동**이다. 대표 정확성/시간 표본은 결과 전에 지정한 **R1 CORE만** 읽는다. 다섯 block의 18개가 90회/540개, I/T 여섯 개가 각각 30개다. REUSE/BURST와 R2/R3의 실패/필수 위반은 별도 보호 근거로 전부 보고하며 대표 정확성 분모에 임의 가산하거나 가장 좋은 run으로 교체하지 않는다. 비용은 세 활동 전체의 평균, 메모리는 세 활동 전체의 최대다. 실제 세 run 없이 같은 계산을 복제해 반복 측정이라고 부르지 않는다.</a:t>
+            </a:r>
+          </a:p>
+          <a:p xmlns:a="http://schemas.openxmlformats.org/drawingml/2006/main">
+            <a:r>
+              <a:t/>
+            </a:r>
+          </a:p>
+          <a:p xmlns:a="http://schemas.openxmlformats.org/drawingml/2006/main">
+            <a:r>
+              <a:t>#### 8.0.4 초기 데이터, 복원과 동시 부하</a:t>
+            </a:r>
+          </a:p>
+          <a:p xmlns:a="http://schemas.openxmlformats.org/drawingml/2006/main">
+            <a:r>
+              <a:t/>
+            </a:r>
+          </a:p>
+          <a:p xmlns:a="http://schemas.openxmlformats.org/drawingml/2006/main">
+            <a:r>
+              <a:t>각 활동은 원천 대화 2,000turn/완료 Task 200개/문서와 일정 등 source 30개(전체 합성 payload 20MiB)에서 시작한다. 30개 source slot은 B01~B20과 C01~C10이다. Bnn의 제목은 `W100 background source Bnn`, v1의 `value=100+nn`, v2는 `101+nn`이며 read/모델 제공을 허용한다. C slot에는 해당 사례의 원본 D/Cal/표/E1을 namespace 대응으로 제공한다. background 대화 H0001~H2000은 시간순으로 `배경 기록 {id}: B{((id-1)%20)+1}@v1의 값은 {100+((id-1)%20)+1}이다`와 실제 전달 receipt를 갖는다. 완료 Task HT001~HT200은 같은 순환 B source의 read-only 값 조회이며 ACCEPTED→COMPLETED→실제 전달 원천 사실을 갖는다. 현재 요청과 의미 관계를 선결합하지 않는다. UTF-8 원본/turn/Task payload 합을 20×1,024×1,024byte로 맞추도록 미사용 B 본문에 공백을 채운다. DB/index/runtime의 물리적 추가 overhead는 별도 메모리다. 활성 Task 10은 초기 Task를 무조건 10개 더 넣는 뜻이 아니라 공통 pool의 상한이며 BURST의 8개 관련 Task+2개 보호/background로 최대 10개를 제공한다. 실제 과거 원문과 실제 전달/수정/허용 이력을 제공하고 현재 요청의 정답/파생 관계는 넣지 않는다. namespace 대응표는 source/Task 식별을 위한 fixture map이며 모델의 지칭/Task 정답으로 주지 않는다. 각 사례가 읽을 수 있는 scope/사실은 §3 명세 그대로다. 무관한 background 자료는 모델 의미 입력에 무제한 섞지 않지만 전체 이력/DB/copy 메모리에는 포함한다.</a:t>
+            </a:r>
+          </a:p>
+          <a:p xmlns:a="http://schemas.openxmlformats.org/drawingml/2006/main">
+            <a:r>
+              <a:t/>
+            </a:r>
+          </a:p>
+          <a:p xmlns:a="http://schemas.openxmlformats.org/drawingml/2006/main">
+            <a:r>
+              <a:t>CORE 전에 해당 논리적 초기 owner 사실을 복원하고 필요한 W 준비를 실제 후보 경로로 처리한다. 복원은 input fixture일 뿐 후보가 처리해야 할 결과를 대신하지 않는다. 후보가 낸 상태/오류를 완료 snapshot으로 덮어쓰지 않고 checkpoint와 tail을 검사한 뒤에만 다음 fixture로 진행한다. 초기/복원/생산의 청구와 일시적 old/new snapshot 이중 할당을 모두 세며 **각 block 완료 이력은 활동 끝까지 남긴다.** 같은 source hash/revision/permission에 한정한 REUSE cache는 허용한다. 충돌 namespace의 cache나 현재성 불일치는 무효화한다.</a:t>
+            </a:r>
+          </a:p>
+          <a:p xmlns:a="http://schemas.openxmlformats.org/drawingml/2006/main">
+            <a:r>
+              <a:t/>
+            </a:r>
+          </a:p>
+          <a:p xmlns:a="http://schemas.openxmlformats.org/drawingml/2006/main">
+            <a:r>
+              <a:t>cloud call의 동시 상한은 4개이며 양안에 같은 queue/취소/timeout 계약을 적용한다. 호출 4개를 강제로 만들어 메모리를 늘리지 않는다. capture의 제공 원본/보존 창은 최대 15개 RGBA frame이며 scene 내부의 시각/포인터/허용 규칙은 §3과 같다. 동시 할당과 준비를 비교할 수 있도록 초기화부터 마지막 신규 입력 이후까지 원장을 연다. 마지막 철회 뒤 신규 입력을 멈추고 처리 가능한 VIA job/queue를 최대 30초에 drain한다. 30초는 대표 요청 처리 예산 10초의 세 배로 회수 여유를 둔 작성자 보호 한도다. 외부 업무/미응답 질문의 정당한 대기 상태는 보존한다. drain 완료 뒤 10초 idle probe에 새 maintenance를 넣지 않는다. 10초/50ms는 최소 200개 시간 sample로 단기 회수/잔류 증가를 확인하기 위한 관측 가정이며 장시간 누수의 부재를 증명하지 않는다. 전체 기능 checkpoint/tail 누락 또는 필수 위반이 있으면 작은 비용/메모리도 목표 달성이 아니다.</a:t>
+            </a:r>
+          </a:p>
+          <a:p xmlns:a="http://schemas.openxmlformats.org/drawingml/2006/main">
+            <a:r>
+              <a:t/>
+            </a:r>
+          </a:p>
+          <a:p xmlns:a="http://schemas.openxmlformats.org/drawingml/2006/main">
+            <a:r>
+              <a:t>#### 8.0.5 공통 후속 사건과 QA별 관측</a:t>
+            </a:r>
+          </a:p>
+          <a:p xmlns:a="http://schemas.openxmlformats.org/drawingml/2006/main">
+            <a:r>
+              <a:t/>
+            </a:r>
+          </a:p>
+          <a:p xmlns:a="http://schemas.openxmlformats.org/drawingml/2006/main">
+            <a:r>
+              <a:t>| 연결 | 같은 장면의 공통 종료/tail | 읽는 지표 |</a:t>
+            </a:r>
+          </a:p>
+          <a:p xmlns:a="http://schemas.openxmlformats.org/drawingml/2006/main">
+            <a:r>
+              <a:t>| --- | --- | --- |</a:t>
+            </a:r>
+          </a:p>
+          <a:p xmlns:a="http://schemas.openxmlformats.org/drawingml/2006/main">
+            <a:r>
+              <a:t>| S1-01 / T-01 | 원본 한정 조회: 직접 또는 외부 접수+0.2초 날짜 결과. 별도 8초 결과를 만들지 않음 | 정확성 C6과 cycle 최종 전달 |</a:t>
+            </a:r>
+          </a:p>
+          <a:p xmlns:a="http://schemas.openxmlformats.org/drawingml/2006/main">
+            <a:r>
+              <a:t>| S1-02 / T-02 | 원본 접수 receipt로 C5/C6 채점한 뒤 실제 작성 접수+8초에 ReportQ3@v1 결과 | 전체 cycle, 청구/할당 |</a:t>
+            </a:r>
+          </a:p>
+          <a:p xmlns:a="http://schemas.openxmlformats.org/drawingml/2006/main">
+            <a:r>
+              <a:t>| S2-02 / T-03 | 원본 준비 5초/접수 checkpoint 뒤 Proposal@v1 결과를 접수+8초에 반환 | cycle은 현재 발화부터, 자원은 과거 준비도 포함 |</a:t>
+            </a:r>
+          </a:p>
+          <a:p xmlns:a="http://schemas.openxmlformats.org/drawingml/2006/main">
+            <a:r>
+              <a:t>| S3-02 / T-04 | 현재 K현재 요약과 중복 처리 원본 유지, 실제 SEND 접수+8초 MailCurrent@v1:SENT | cycle은 현재 요약→전송→확인, 중복 effect 금지 |</a:t>
+            </a:r>
+          </a:p>
+          <a:p xmlns:a="http://schemas.openxmlformats.org/drawingml/2006/main">
+            <a:r>
+              <a:t>| S4-01 / I-02 / T-05 | 원본 정정 접수/메일 유지 checkpoint 이후 변경 접수+8초 ReportRevised@v2 결과 | 같은 정정의 첫 반응과 최종 전달을 각각 관측 |</a:t>
+            </a:r>
+          </a:p>
+          <a:p xmlns:a="http://schemas.openxmlformats.org/drawingml/2006/main">
+            <a:r>
+              <a:t>| S6-01 / T-06 | 원본 실제 확인 질문+1초에 3초 답변. 실제 유효 수정 접수+8초 ConfirmedRevision@v2 결과 | 사람 기다림/외부 업무만 제외한 cycle |</a:t>
+            </a:r>
+          </a:p>
+          <a:p xmlns:a="http://schemas.openxmlformats.org/drawingml/2006/main">
+            <a:r>
+              <a:t>| S2-03 | 원본 v1 지정 표 작성 접수 뒤 실제 접수+8초 결과(TablePast@v1) | 대표 T 없음, 비용/메모리와 기능 보호에는 포함 |</a:t>
+            </a:r>
+          </a:p>
+          <a:p xmlns:a="http://schemas.openxmlformats.org/drawingml/2006/main">
+            <a:r>
+              <a:t>| 나머지 11개 사례 | §3의 실제 조회/선호/제어/질문/결과/승인 범위/거부 checkpoint가 그 장면의 끝. 취소 접수는 완료 취소가 아니며 기다리는 질문을 임의 답변하지 않음 | C6와 지정 I, 전체 청구/할당 |</a:t>
+            </a:r>
+          </a:p>
+          <a:p xmlns:a="http://schemas.openxmlformats.org/drawingml/2006/main">
+            <a:r>
+              <a:t/>
+            </a:r>
+          </a:p>
+          <a:p xmlns:a="http://schemas.openxmlformats.org/drawingml/2006/main">
+            <a:r>
+              <a:t>위 tail은 모든 CORE/REUSE/BURST와 모든 run/QA에 공통이다. 최종 payload/source/version/허용과 실제 전달을 검사하며 접수 인사를 최종 결과로 세지 않는다. 정확성의 기존 108개 정답 명세는 해당 checkpoint에서 보존하고 tail 실패는 cycle/resource/필수 기능 보호에 기록한다. 각 관측은 `run/block/occurrence/case/source-vector/checkpoint/tail/I/T`를 동일 원장 key로 조인한다. QA-05 변경의 완료 검사도 이 기능/상태/권한 회귀와 W100의 사용량/동시성/보관 계약을 유지하는지 확인한다. 390장면 모두를 정확성 대표 분모로 키우지 않는다.</a:t>
+            </a:r>
+          </a:p>
+          <a:p xmlns:a="http://schemas.openxmlformats.org/drawingml/2006/main">
+            <a:r>
+              <a:t/>
+            </a:r>
+          </a:p>
+          <a:p xmlns:a="http://schemas.openxmlformats.org/drawingml/2006/main">
+            <a:r>
+              <a:t/>
+            </a:r>
+          </a:p>
+          <a:p xmlns:a="http://schemas.openxmlformats.org/drawingml/2006/main">
+            <a:r>
+              <a:t/>
+            </a:r>
+          </a:p>
+          <a:p xmlns:a="http://schemas.openxmlformats.org/drawingml/2006/main">
+            <a:r>
+              <a:t>등급은 원지표를 표시하는 작성자 규칙이며 QA 간 합산하지 않음. 측정 전에는 점수를 생성하지 않음.</a:t>
+            </a:r>
+          </a:p>
+        </p:txBody>
+      </p:sp>
+      <p:sp>
+        <p:nvSpPr>
+          <p:cNvPr id="4" name="Slide Number Placeholder 3"/>
+          <p:cNvSpPr>
+            <a:spLocks xmlns:a="http://schemas.openxmlformats.org/drawingml/2006/main" noGrp="1"/>
+          </p:cNvSpPr>
+          <p:nvPr>
+            <p:ph type="sldNum" idx="5"/>
+          </p:nvPr>
+        </p:nvSpPr>
+        <p:spPr/>
+        <p:txBody>
+          <a:bodyPr xmlns:a="http://schemas.openxmlformats.org/drawingml/2006/main"/>
+          <a:lstStyle xmlns:a="http://schemas.openxmlformats.org/drawingml/2006/main"/>
+          <a:p xmlns:a="http://schemas.openxmlformats.org/drawingml/2006/main"/>
+        </p:txBody>
+      </p:sp>
+    </p:spTree>
+  </p:cSld>
+  <p:clrMapOvr>
+    <a:masterClrMapping xmlns:a="http://schemas.openxmlformats.org/drawingml/2006/main"/>
+  </p:clrMapOvr>
+</p:notes>
+</file>
+
+<file path=ppt/notesSlides/notesSlide3.xml><?xml version="1.0" encoding="utf-8"?>
+<p:notes xmlns:p="http://schemas.openxmlformats.org/presentationml/2006/main">
+  <p:cSld>
+    <p:spTree>
+      <p:nvGrpSpPr>
+        <p:cNvPr id="1" name=""/>
+        <p:cNvGrpSpPr/>
+        <p:nvPr/>
+      </p:nvGrpSpPr>
+      <p:grpSpPr>
+        <a:xfrm xmlns:a="http://schemas.openxmlformats.org/drawingml/2006/main"/>
+      </p:grpSpPr>
+      <p:sp>
+        <p:nvSpPr>
+          <p:cNvPr id="2" name="Slide Image Placeholder 1"/>
+          <p:cNvSpPr>
+            <a:spLocks xmlns:a="http://schemas.openxmlformats.org/drawingml/2006/main" noGrp="1"/>
+          </p:cNvSpPr>
+          <p:nvPr>
+            <p:ph type="sldImg" idx="0"/>
+          </p:nvPr>
+        </p:nvSpPr>
+        <p:spPr/>
+      </p:sp>
+      <p:sp>
+        <p:nvSpPr>
+          <p:cNvPr id="3" name="Notes Placeholder 2"/>
+          <p:cNvSpPr>
+            <a:spLocks xmlns:a="http://schemas.openxmlformats.org/drawingml/2006/main" noGrp="1"/>
+          </p:cNvSpPr>
+          <p:nvPr>
+            <p:ph type="body" idx="1"/>
+          </p:nvPr>
+        </p:nvSpPr>
+        <p:spPr/>
+        <p:txBody>
+          <a:bodyPr xmlns:a="http://schemas.openxmlformats.org/drawingml/2006/main"/>
+          <a:lstStyle xmlns:a="http://schemas.openxmlformats.org/drawingml/2006/main"/>
+          <a:p xmlns:a="http://schemas.openxmlformats.org/drawingml/2006/main">
+            <a:r>
+              <a:t>원본: docs/architecture/12-decisions/decision-packages/03-02-quality-attribute-definitions.md</a:t>
+            </a:r>
+          </a:p>
+          <a:p xmlns:a="http://schemas.openxmlformats.org/drawingml/2006/main">
+            <a:r>
+              <a:t>계약: ASR-QA-v5</a:t>
+            </a:r>
+          </a:p>
+          <a:p xmlns:a="http://schemas.openxmlformats.org/drawingml/2006/main">
+            <a:r>
+              <a:t>공통 활동: W100 사용자 100/Agent 30장면, 5block, 3 독립 run</a:t>
+            </a:r>
+          </a:p>
+          <a:p xmlns:a="http://schemas.openxmlformats.org/drawingml/2006/main">
+            <a:r>
+              <a:t>활동 SHA-256: 911ce3ae13588c27b6902a5a0abb17714c4059a9a80bceaa890c1dfb3e26eb7f</a:t>
+            </a:r>
+          </a:p>
+          <a:p xmlns:a="http://schemas.openxmlformats.org/drawingml/2006/main">
+            <a:r>
+              <a:t>작성일: 2026-10-11</a:t>
+            </a:r>
+          </a:p>
+          <a:p xmlns:a="http://schemas.openxmlformats.org/drawingml/2006/main">
+            <a:r>
+              <a:t>원본 SHA-256: 0e304faddf43b212900ce12f712a1d5cad5bd3cf601bc77a94f3f267d5fa2933</a:t>
+            </a:r>
+          </a:p>
+          <a:p xmlns:a="http://schemas.openxmlformats.org/drawingml/2006/main">
+            <a:r>
+              <a:t>우선순위: ASR-QA-01부터 번호순. 목표는 작성자 PoC 예산이며 실제 제품/모델/Windows 성능 결과가 아님. 제공한 PNG 레퍼런스의 스타일만 적용하고 타 과제의 요구/수치는 가져오지 않음.</a:t>
+            </a:r>
+          </a:p>
+          <a:p xmlns:a="http://schemas.openxmlformats.org/drawingml/2006/main">
+            <a:r>
+              <a:t/>
+            </a:r>
+          </a:p>
+          <a:p xmlns:a="http://schemas.openxmlformats.org/drawingml/2006/main">
+            <a:r>
+              <a:t/>
+            </a:r>
+          </a:p>
+          <a:p xmlns:a="http://schemas.openxmlformats.org/drawingml/2006/main">
+            <a:r>
+              <a:t>공통 활동 상세 §8.0</a:t>
+            </a:r>
+          </a:p>
+          <a:p xmlns:a="http://schemas.openxmlformats.org/drawingml/2006/main">
+            <a:r>
+              <a:t>공통 PoC 환경과 A/B 비교 방법</a:t>
+            </a:r>
+          </a:p>
+          <a:p xmlns:a="http://schemas.openxmlformats.org/drawingml/2006/main">
+            <a:r>
+              <a:t/>
+            </a:r>
+          </a:p>
+          <a:p xmlns:a="http://schemas.openxmlformats.org/drawingml/2006/main">
+            <a:r>
+              <a:t>공통 입력/원천 사건/후보/모델 조건은 여섯 QA에 공유하고, 각 QA의 분모/시간/금액/변경/메모리 경계는 §3~7의 완료 정의를 따른다. 공통 전사/장치 replay를 실제 ASR 정확도나 물리 장치 응답시간 실측으로 해석하지 않는다.</a:t>
+            </a:r>
+          </a:p>
+          <a:p xmlns:a="http://schemas.openxmlformats.org/drawingml/2006/main">
+            <a:r>
+              <a:t/>
+            </a:r>
+          </a:p>
+          <a:p xmlns:a="http://schemas.openxmlformats.org/drawingml/2006/main">
+            <a:r>
+              <a:t>### 8.0 공통 활동 W100: 사용량과 관측 대응</a:t>
+            </a:r>
+          </a:p>
+          <a:p xmlns:a="http://schemas.openxmlformats.org/drawingml/2006/main">
+            <a:r>
+              <a:t/>
+            </a:r>
+          </a:p>
+          <a:p xmlns:a="http://schemas.openxmlformats.org/drawingml/2006/main">
+            <a:r>
+              <a:t>#### 8.0.1 사용량을 정의하는 이유와 범위</a:t>
+            </a:r>
+          </a:p>
+          <a:p xmlns:a="http://schemas.openxmlformats.org/drawingml/2006/main">
+            <a:r>
+              <a:t/>
+            </a:r>
+          </a:p>
+          <a:p xmlns:a="http://schemas.openxmlformats.org/drawingml/2006/main">
+            <a:r>
+              <a:t>**W100은 기존 18개 사례로 구성한 합성 표준 활동이다.** 사용자의 실제 일일 빈도 자료가 없는 PoC에서 A/B가 같은 기능과 부하를 처리하도록 평가용 사용량을 명시했다. 100은 사용자 입력 장면 수다. 신규 업무/조회뿐 아니라 정정/취소/확인/재연결이 들어간다. Agent가 먼저 질문/결과를 보내는 장면은 별도로 30건이다. S5-03은 Agent 결과로 시작하지만 재연결한 사용자의 명시적 조회 발화가 있으므로 사용량 원장에서는 사용자 장면 1건이다. S6의 계획된 답변은 그 장면 내부 후속 발화이며 장면을 추가하지 않는다.</a:t>
+            </a:r>
+          </a:p>
+          <a:p xmlns:a="http://schemas.openxmlformats.org/drawingml/2006/main">
+            <a:r>
+              <a:t/>
+            </a:r>
+          </a:p>
+          <a:p xmlns:a="http://schemas.openxmlformats.org/drawingml/2006/main">
+            <a:r>
+              <a:t>원천은 §3의 18개 초기 상황/입력/경쟁 사건/정답과 아래 공통 lifecycle tail이다. **QA별로 다른 업무나 외부 결과를 만들지 않는다.** 평가 관측 단위가 다르므로 모든 QA의 분모가 같을 필요는 없다. 정확성은 조건, 시간은 사건 경계, 비용은 활동 전체 청구, 메모리는 활동 전체 동시 할당을 읽는다. 변경 용이성은 여섯 구조 변경 과제이며 변경 뒤 같은 기능/활동 계약을 유지한다.</a:t>
+            </a:r>
+          </a:p>
+          <a:p xmlns:a="http://schemas.openxmlformats.org/drawingml/2006/main">
+            <a:r>
+              <a:t/>
+            </a:r>
+          </a:p>
+          <a:p xmlns:a="http://schemas.openxmlformats.org/drawingml/2006/main">
+            <a:r>
+              <a:t>[공통 활동 입력](./03-02-common-workload.json)은 이 절의 machine-readable 사용량/음성/호출 예산이고 [사건 목록](./03-02-workload-manifest.json)은 각 장면의 case/hash/CORE 여부/I/T 연결을 130행으로 생성한다. [활동 검산기](../../../../scripts/architecture/qa_common_workload.py)는 입력 목록을 컴파일할 뿐 후보/harness/API를 실행하지 않는다. 참조 계산과 두 발표자료도 같은 원본/manifest hash를 사용한다.</a:t>
+            </a:r>
+          </a:p>
+          <a:p xmlns:a="http://schemas.openxmlformats.org/drawingml/2006/main">
+            <a:r>
+              <a:t/>
+            </a:r>
+          </a:p>
+          <a:p xmlns:a="http://schemas.openxmlformats.org/drawingml/2006/main">
+            <a:r>
+              <a:t>#### 8.0.2 사례별 횟수와 음성 길이</a:t>
+            </a:r>
+          </a:p>
+          <a:p xmlns:a="http://schemas.openxmlformats.org/drawingml/2006/main">
+            <a:r>
+              <a:t/>
+            </a:r>
+          </a:p>
+          <a:p xmlns:a="http://schemas.openxmlformats.org/drawingml/2006/main">
+            <a:r>
+              <a:t>| 원본 사례 | W100 횟수 | 입력 장면 분류 | 최초 발화 초/회 | 지정 답변 초/회 | 출력 음성 예산 초/회 | 반응 관측 | 사이클 관측 |</a:t>
+            </a:r>
+          </a:p>
+          <a:p xmlns:a="http://schemas.openxmlformats.org/drawingml/2006/main">
+            <a:r>
+              <a:t>| --- | --- | --- | --- | --- | --- | --- | --- |</a:t>
+            </a:r>
+          </a:p>
+          <a:p xmlns:a="http://schemas.openxmlformats.org/drawingml/2006/main">
+            <a:r>
+              <a:t>| S1-01 | 8 | 사용자 | 2 | 0 | 3 | 없음 | T-01 |</a:t>
+            </a:r>
+          </a:p>
+          <a:p xmlns:a="http://schemas.openxmlformats.org/drawingml/2006/main">
+            <a:r>
+              <a:t>| S1-02 | 8 | 사용자 | 3 | 0 | 8 | 없음 | T-02 |</a:t>
+            </a:r>
+          </a:p>
+          <a:p xmlns:a="http://schemas.openxmlformats.org/drawingml/2006/main">
+            <a:r>
+              <a:t>| S1-03 | 8 | 사용자 | 3 | 0 | 4 | 없음 | 없음 |</a:t>
+            </a:r>
+          </a:p>
+          <a:p xmlns:a="http://schemas.openxmlformats.org/drawingml/2006/main">
+            <a:r>
+              <a:t>| S2-01 | 8 | 사용자 | 2 | 0 | 5 | 없음 | 없음 |</a:t>
+            </a:r>
+          </a:p>
+          <a:p xmlns:a="http://schemas.openxmlformats.org/drawingml/2006/main">
+            <a:r>
+              <a:t>| S2-02 | 8 | 사용자 | 3 | 0 | 18 | 없음 | T-03 |</a:t>
+            </a:r>
+          </a:p>
+          <a:p xmlns:a="http://schemas.openxmlformats.org/drawingml/2006/main">
+            <a:r>
+              <a:t>| S2-03 | 8 | 사용자 | 2 | 0 | 4 | 없음 | 없음 |</a:t>
+            </a:r>
+          </a:p>
+          <a:p xmlns:a="http://schemas.openxmlformats.org/drawingml/2006/main">
+            <a:r>
+              <a:t>| S3-01 | 5 | 사용자 | 3 | 0 | 6 | 없음 | 없음 |</a:t>
+            </a:r>
+          </a:p>
+          <a:p xmlns:a="http://schemas.openxmlformats.org/drawingml/2006/main">
+            <a:r>
+              <a:t>| S3-02 | 5 | 사용자 | 3 | 0 | 10 | 없음 | T-04 |</a:t>
+            </a:r>
+          </a:p>
+          <a:p xmlns:a="http://schemas.openxmlformats.org/drawingml/2006/main">
+            <a:r>
+              <a:t>| S3-03 | 5 | 사용자 | 3 | 0 | 6 | 없음 | 없음 |</a:t>
+            </a:r>
+          </a:p>
+          <a:p xmlns:a="http://schemas.openxmlformats.org/drawingml/2006/main">
+            <a:r>
+              <a:t>| S4-01 | 5 | 사용자 | 2 | 0 | 9 | I-02 | T-05 |</a:t>
+            </a:r>
+          </a:p>
+          <a:p xmlns:a="http://schemas.openxmlformats.org/drawingml/2006/main">
+            <a:r>
+              <a:t>| S4-02 | 5 | 사용자 | 2 | 0 | 8 | I-01 | 없음 |</a:t>
+            </a:r>
+          </a:p>
+          <a:p xmlns:a="http://schemas.openxmlformats.org/drawingml/2006/main">
+            <a:r>
+              <a:t>| S4-03 | 5 | 사용자 | 2 | 0 | 5 | I-03 | 없음 |</a:t>
+            </a:r>
+          </a:p>
+          <a:p xmlns:a="http://schemas.openxmlformats.org/drawingml/2006/main">
+            <a:r>
+              <a:t>| S5-01 | 15 | Agent | 0 | 0 | 5 | I-04 | 없음 |</a:t>
+            </a:r>
+          </a:p>
+          <a:p xmlns:a="http://schemas.openxmlformats.org/drawingml/2006/main">
+            <a:r>
+              <a:t>| S5-02 | 15 | Agent | 0 | 0 | 6 | I-05 | 없음 |</a:t>
+            </a:r>
+          </a:p>
+          <a:p xmlns:a="http://schemas.openxmlformats.org/drawingml/2006/main">
+            <a:r>
+              <a:t>| S5-03 | 7 | 사용자 | 2 | 0 | 4 | 없음 | 없음 |</a:t>
+            </a:r>
+          </a:p>
+          <a:p xmlns:a="http://schemas.openxmlformats.org/drawingml/2006/main">
+            <a:r>
+              <a:t>| S6-01 | 5 | 사용자 | 2 | 3 | 14 | 없음 | T-06 |</a:t>
+            </a:r>
+          </a:p>
+          <a:p xmlns:a="http://schemas.openxmlformats.org/drawingml/2006/main">
+            <a:r>
+              <a:t>| S6-02 | 5 | 사용자 | 1 | 3 | 14 | 없음 | 없음 |</a:t>
+            </a:r>
+          </a:p>
+          <a:p xmlns:a="http://schemas.openxmlformats.org/drawingml/2006/main">
+            <a:r>
+              <a:t>| S6-03 | 5 | 사용자 | 2 | 0 | 5 | I-06 | 없음 |</a:t>
+            </a:r>
+          </a:p>
+          <a:p xmlns:a="http://schemas.openxmlformats.org/drawingml/2006/main">
+            <a:r>
+              <a:t/>
+            </a:r>
+          </a:p>
+          <a:p xmlns:a="http://schemas.openxmlformats.org/drawingml/2006/main">
+            <a:r>
+              <a:t>사용자 장면 합 100, Agent 장면 합 30이다. 최초 입력의 replay 길이는 §3 사건 구간으로 정한 **fixture 조건**이고 합 234초다. S6-01/02 각 5회의 후속 답변 3초를 더해 계획된 입력은 **110발화/264초**다. 추가 확인은 §3 공통 답변 정책대로 공급하고 실제 청구를 더한다. S5-03의 2초 재연결 요청은 최초 발화 열에 이미 포함했다.</a:t>
+            </a:r>
+          </a:p>
+          <a:p xmlns:a="http://schemas.openxmlformats.org/drawingml/2006/main">
+            <a:r>
+              <a:t/>
+            </a:r>
+          </a:p>
+          <a:p xmlns:a="http://schemas.openxmlformats.org/drawingml/2006/main">
+            <a:r>
+              <a:t>출력 길이는 **작성자의 참조 예산**이며 모델 성능/자연 발화 길이 보장이 아니다. 위 표의 필수 사실 전달과 공통 tail을 합해 914초다. S2-02 18초는 과거의 실제 재생 설명 8초와 현재 접수/결과 10초, S4-02 8초는 중단 전 재생 4초와 새 설명 4초를 포함한다. S6-01/02 14초는 확인 질문과 허용 범위/결과 전달의 합이다. 나머지는 해당 C6 사실과 tail 전달의 총 길이 예산이다. 실제 모델 생성/재생/폐기 청구량을 예산값으로 덮어쓰지 않는다. Text 표시 길이와 음성 시간의 임의 token 환산도 하지 않는다.</a:t>
+            </a:r>
+          </a:p>
+          <a:p xmlns:a="http://schemas.openxmlformats.org/drawingml/2006/main">
+            <a:r>
+              <a:t/>
+            </a:r>
+          </a:p>
+          <a:p xmlns:a="http://schemas.openxmlformats.org/drawingml/2006/main">
+            <a:r>
+              <a:t>#### 8.0.3 다섯 block의 입력 순서와 관측 선택</a:t>
+            </a:r>
+          </a:p>
+          <a:p xmlns:a="http://schemas.openxmlformats.org/drawingml/2006/main">
+            <a:r>
+              <a:t/>
+            </a:r>
+          </a:p>
+          <a:p xmlns:a="http://schemas.openxmlformats.org/drawingml/2006/main">
+            <a:r>
+              <a:t>각 block은 **CORE 18장면 + REUSE 4장면 + BURST 4장면 = 26장면**이다. 다섯 block이 사용자 100/Agent 30의 130장면을 만든다. CORE는 S1-01부터 S6-03까지 위 표 순서로 각 한 번이다. 각 장면은 필수 checkpoint와 tail까지 진행한 뒤 다음 장면을 시작한다. 아래 REUSE는 같은 block에서 이미 허용된 원본 version/제공 권한을 확인한 뒤 재사용한다. 기존 현재 Task를 임의 정답으로 배치하지 않고 요청 ID/외부 실행 ID는 occurrence namespace로 구별한다.</a:t>
+            </a:r>
+          </a:p>
+          <a:p xmlns:a="http://schemas.openxmlformats.org/drawingml/2006/main">
+            <a:r>
+              <a:t/>
+            </a:r>
+          </a:p>
+          <a:p xmlns:a="http://schemas.openxmlformats.org/drawingml/2006/main">
+            <a:r>
+              <a:t>| block | REUSE 네 장면 순서 | BURST 네 장면 순서 |</a:t>
+            </a:r>
+          </a:p>
+          <a:p xmlns:a="http://schemas.openxmlformats.org/drawingml/2006/main">
+            <a:r>
+              <a:t>| --- | --- | --- |</a:t>
+            </a:r>
+          </a:p>
+          <a:p xmlns:a="http://schemas.openxmlformats.org/drawingml/2006/main">
+            <a:r>
+              <a:t>| B1 | S1-01, S1-02, S2-01, S2-02 | S5-01, S5-02, S5-01, S5-02 |</a:t>
+            </a:r>
+          </a:p>
+          <a:p xmlns:a="http://schemas.openxmlformats.org/drawingml/2006/main">
+            <a:r>
+              <a:t>| B2 | S1-01, S1-03, S2-01, S2-03 | 동일 |</a:t>
+            </a:r>
+          </a:p>
+          <a:p xmlns:a="http://schemas.openxmlformats.org/drawingml/2006/main">
+            <a:r>
+              <a:t>| B3 | S1-02, S1-03, S2-02, S2-03 | 동일 |</a:t>
+            </a:r>
+          </a:p>
+          <a:p xmlns:a="http://schemas.openxmlformats.org/drawingml/2006/main">
+            <a:r>
+              <a:t>| B4 | S1-01, S1-02, S2-01, S2-02 | 동일 |</a:t>
+            </a:r>
+          </a:p>
+          <a:p xmlns:a="http://schemas.openxmlformats.org/drawingml/2006/main">
+            <a:r>
+              <a:t>| B5 | S1-03, S2-03, S5-03, S5-03 | 동일 |</a:t>
+            </a:r>
+          </a:p>
+          <a:p xmlns:a="http://schemas.openxmlformats.org/drawingml/2006/main">
+            <a:r>
+              <a:t/>
+            </a:r>
+          </a:p>
+          <a:p xmlns:a="http://schemas.openxmlformats.org/drawingml/2006/main">
+            <a:r>
+              <a:t>BURST의 네 Agent 장면 최초 원천 사건을 상대 0/0.02/0.04/0.06초에 공급하고 각 장면 내부의 원본 후속 순서를 보존한다. 사용자 음성을 네 개 중첩시키는 시험은 아니다. 네 장면이 각각 사용하는 두 Task를 pool의 여덟 slot에 배치하고 T보호와 background 한 Task의 두 slot을 유지해 **활성 최대 10개**다. CORE/REUSE는 이 pool의 필요한 slot만 해당 초기 사실로 복원한다. 완료된 관련 작업은 active slot에서 빠져 이력으로 남는다. 이 합성 replay suite의 slot은 현재 제시하는 scoped scene의 owner이며 10은 그 scene에서 동시에 처리하는 Task 상한이다. 완료되지 않은 질문/취소 접수는 먼저 원본 checkpoint/5초 늦은 사건 관찰을 충족한 뒤 scope를 닫고 원래 대기 상태/receipt를 그대로 활동 이력에 보존한다. 전체 미완료 Task를 10개로 자른다거나 외부 대기를 성공 완료로 바꾸는 실제 운용 정책은 아니다. 다음 scene의 before-state 복원과 구분하고 scope 회수 비용/peak도 센다.</a:t>
+            </a:r>
+          </a:p>
+          <a:p xmlns:a="http://schemas.openxmlformats.org/drawingml/2006/main">
+            <a:r>
+              <a:t/>
+            </a:r>
+          </a:p>
+          <a:p xmlns:a="http://schemas.openxmlformats.org/drawingml/2006/main">
+            <a:r>
+              <a:t>block의 마지막 BURST checkpoint 이후 B01~B04, B05~B08, …, B17~B20의 background 원본을 각각 한 번 `v1→v2` 갱신한다. 각 원본은 초기 30개 source 중 하나이며 locator와 권한은 그대로, 내용의 수치 한 곳만 1 증가한다. 입력 목록 순서로 0.01초 간격 제공하고 같은 block의 maintenance tick 두 개를 직렬 제공한다. 총 **20개 background 변경/10개 tick**이다. §3의 S2-03 등 내부 X 갱신은 이 20개와 별개로 이미 장면에 포함되며 별도 호출을 중복 청구하지 않는다. B5 마지막 갱신 뒤 B20의 제공 동의를 철회해 원문/파생/Context 신규 소비를 차단한다. 후보의 실제 생산/재해석/철회 비용은 모두 남긴다.</a:t>
+            </a:r>
+          </a:p>
+          <a:p xmlns:a="http://schemas.openxmlformats.org/drawingml/2006/main">
+            <a:r>
+              <a:t/>
+            </a:r>
+          </a:p>
+          <a:p xmlns:a="http://schemas.openxmlformats.org/drawingml/2006/main">
+            <a:r>
+              <a:t>R1/R2/R3는 동일 초기 자료를 가진 **세 독립 활동**이다. 대표 정확성/시간 표본은 결과 전에 지정한 **R1 CORE만** 읽는다. 다섯 block의 18개가 90회/540개, I/T 여섯 개가 각각 30개다. REUSE/BURST와 R2/R3의 실패/필수 위반은 별도 보호 근거로 전부 보고하며 대표 정확성 분모에 임의 가산하거나 가장 좋은 run으로 교체하지 않는다. 비용은 세 활동 전체의 평균, 메모리는 세 활동 전체의 최대다. 실제 세 run 없이 같은 계산을 복제해 반복 측정이라고 부르지 않는다.</a:t>
+            </a:r>
+          </a:p>
+          <a:p xmlns:a="http://schemas.openxmlformats.org/drawingml/2006/main">
+            <a:r>
+              <a:t/>
+            </a:r>
+          </a:p>
+          <a:p xmlns:a="http://schemas.openxmlformats.org/drawingml/2006/main">
+            <a:r>
+              <a:t>#### 8.0.4 초기 데이터, 복원과 동시 부하</a:t>
+            </a:r>
+          </a:p>
+          <a:p xmlns:a="http://schemas.openxmlformats.org/drawingml/2006/main">
+            <a:r>
+              <a:t/>
+            </a:r>
+          </a:p>
+          <a:p xmlns:a="http://schemas.openxmlformats.org/drawingml/2006/main">
+            <a:r>
+              <a:t>각 활동은 원천 대화 2,000turn/완료 Task 200개/문서와 일정 등 source 30개(전체 합성 payload 20MiB)에서 시작한다. 30개 source slot은 B01~B20과 C01~C10이다. Bnn의 제목은 `W100 background source Bnn`, v1의 `value=100+nn`, v2는 `101+nn`이며 read/모델 제공을 허용한다. C slot에는 해당 사례의 원본 D/Cal/표/E1을 namespace 대응으로 제공한다. background 대화 H0001~H2000은 시간순으로 `배경 기록 {id}: B{((id-1)%20)+1}@v1의 값은 {100+((id-1)%20)+1}이다`와 실제 전달 receipt를 갖는다. 완료 Task HT001~HT200은 같은 순환 B source의 read-only 값 조회이며 ACCEPTED→COMPLETED→실제 전달 원천 사실을 갖는다. 현재 요청과 의미 관계를 선결합하지 않는다. UTF-8 원본/turn/Task payload 합을 20×1,024×1,024byte로 맞추도록 미사용 B 본문에 공백을 채운다. DB/index/runtime의 물리적 추가 overhead는 별도 메모리다. 활성 Task 10은 초기 Task를 무조건 10개 더 넣는 뜻이 아니라 공통 pool의 상한이며 BURST의 8개 관련 Task+2개 보호/background로 최대 10개를 제공한다. 실제 과거 원문과 실제 전달/수정/허용 이력을 제공하고 현재 요청의 정답/파생 관계는 넣지 않는다. namespace 대응표는 source/Task 식별을 위한 fixture map이며 모델의 지칭/Task 정답으로 주지 않는다. 각 사례가 읽을 수 있는 scope/사실은 §3 명세 그대로다. 무관한 background 자료는 모델 의미 입력에 무제한 섞지 않지만 전체 이력/DB/copy 메모리에는 포함한다.</a:t>
+            </a:r>
+          </a:p>
+          <a:p xmlns:a="http://schemas.openxmlformats.org/drawingml/2006/main">
+            <a:r>
+              <a:t/>
+            </a:r>
+          </a:p>
+          <a:p xmlns:a="http://schemas.openxmlformats.org/drawingml/2006/main">
+            <a:r>
+              <a:t>CORE 전에 해당 논리적 초기 owner 사실을 복원하고 필요한 W 준비를 실제 후보 경로로 처리한다. 복원은 input fixture일 뿐 후보가 처리해야 할 결과를 대신하지 않는다. 후보가 낸 상태/오류를 완료 snapshot으로 덮어쓰지 않고 checkpoint와 tail을 검사한 뒤에만 다음 fixture로 진행한다. 초기/복원/생산의 청구와 일시적 old/new snapshot 이중 할당을 모두 세며 **각 block 완료 이력은 활동 끝까지 남긴다.** 같은 source hash/revision/permission에 한정한 REUSE cache는 허용한다. 충돌 namespace의 cache나 현재성 불일치는 무효화한다.</a:t>
+            </a:r>
+          </a:p>
+          <a:p xmlns:a="http://schemas.openxmlformats.org/drawingml/2006/main">
+            <a:r>
+              <a:t/>
+            </a:r>
+          </a:p>
+          <a:p xmlns:a="http://schemas.openxmlformats.org/drawingml/2006/main">
+            <a:r>
+              <a:t>cloud call의 동시 상한은 4개이며 양안에 같은 queue/취소/timeout 계약을 적용한다. 호출 4개를 강제로 만들어 메모리를 늘리지 않는다. capture의 제공 원본/보존 창은 최대 15개 RGBA frame이며 scene 내부의 시각/포인터/허용 규칙은 §3과 같다. 동시 할당과 준비를 비교할 수 있도록 초기화부터 마지막 신규 입력 이후까지 원장을 연다. 마지막 철회 뒤 신규 입력을 멈추고 처리 가능한 VIA job/queue를 최대 30초에 drain한다. 30초는 대표 요청 처리 예산 10초의 세 배로 회수 여유를 둔 작성자 보호 한도다. 외부 업무/미응답 질문의 정당한 대기 상태는 보존한다. drain 완료 뒤 10초 idle probe에 새 maintenance를 넣지 않는다. 10초/50ms는 최소 200개 시간 sample로 단기 회수/잔류 증가를 확인하기 위한 관측 가정이며 장시간 누수의 부재를 증명하지 않는다. 전체 기능 checkpoint/tail 누락 또는 필수 위반이 있으면 작은 비용/메모리도 목표 달성이 아니다.</a:t>
+            </a:r>
+          </a:p>
+          <a:p xmlns:a="http://schemas.openxmlformats.org/drawingml/2006/main">
+            <a:r>
+              <a:t/>
+            </a:r>
+          </a:p>
+          <a:p xmlns:a="http://schemas.openxmlformats.org/drawingml/2006/main">
+            <a:r>
+              <a:t>#### 8.0.5 공통 후속 사건과 QA별 관측</a:t>
+            </a:r>
+          </a:p>
+          <a:p xmlns:a="http://schemas.openxmlformats.org/drawingml/2006/main">
+            <a:r>
+              <a:t/>
+            </a:r>
+          </a:p>
+          <a:p xmlns:a="http://schemas.openxmlformats.org/drawingml/2006/main">
+            <a:r>
+              <a:t>| 연결 | 같은 장면의 공통 종료/tail | 읽는 지표 |</a:t>
+            </a:r>
+          </a:p>
+          <a:p xmlns:a="http://schemas.openxmlformats.org/drawingml/2006/main">
+            <a:r>
+              <a:t>| --- | --- | --- |</a:t>
+            </a:r>
+          </a:p>
+          <a:p xmlns:a="http://schemas.openxmlformats.org/drawingml/2006/main">
+            <a:r>
+              <a:t>| S1-01 / T-01 | 원본 한정 조회: 직접 또는 외부 접수+0.2초 날짜 결과. 별도 8초 결과를 만들지 않음 | 정확성 C6과 cycle 최종 전달 |</a:t>
+            </a:r>
+          </a:p>
+          <a:p xmlns:a="http://schemas.openxmlformats.org/drawingml/2006/main">
+            <a:r>
+              <a:t>| S1-02 / T-02 | 원본 접수 receipt로 C5/C6 채점한 뒤 실제 작성 접수+8초에 ReportQ3@v1 결과 | 전체 cycle, 청구/할당 |</a:t>
+            </a:r>
+          </a:p>
+          <a:p xmlns:a="http://schemas.openxmlformats.org/drawingml/2006/main">
+            <a:r>
+              <a:t>| S2-02 / T-03 | 원본 준비 5초/접수 checkpoint 뒤 Proposal@v1 결과를 접수+8초에 반환 | cycle은 현재 발화부터, 자원은 과거 준비도 포함 |</a:t>
+            </a:r>
+          </a:p>
+          <a:p xmlns:a="http://schemas.openxmlformats.org/drawingml/2006/main">
+            <a:r>
+              <a:t>| S3-02 / T-04 | 현재 K현재 요약과 중복 처리 원본 유지, 실제 SEND 접수+8초 MailCurrent@v1:SENT | cycle은 현재 요약→전송→확인, 중복 effect 금지 |</a:t>
+            </a:r>
+          </a:p>
+          <a:p xmlns:a="http://schemas.openxmlformats.org/drawingml/2006/main">
+            <a:r>
+              <a:t>| S4-01 / I-02 / T-05 | 원본 정정 접수/메일 유지 checkpoint 이후 변경 접수+8초 ReportRevised@v2 결과 | 같은 정정의 첫 반응과 최종 전달을 각각 관측 |</a:t>
+            </a:r>
+          </a:p>
+          <a:p xmlns:a="http://schemas.openxmlformats.org/drawingml/2006/main">
+            <a:r>
+              <a:t>| S6-01 / T-06 | 원본 실제 확인 질문+1초에 3초 답변. 실제 유효 수정 접수+8초 ConfirmedRevision@v2 결과 | 사람 기다림/외부 업무만 제외한 cycle |</a:t>
+            </a:r>
+          </a:p>
+          <a:p xmlns:a="http://schemas.openxmlformats.org/drawingml/2006/main">
+            <a:r>
+              <a:t>| S2-03 | 원본 v1 지정 표 작성 접수 뒤 실제 접수+8초 결과(TablePast@v1) | 대표 T 없음, 비용/메모리와 기능 보호에는 포함 |</a:t>
+            </a:r>
+          </a:p>
+          <a:p xmlns:a="http://schemas.openxmlformats.org/drawingml/2006/main">
+            <a:r>
+              <a:t>| 나머지 11개 사례 | §3의 실제 조회/선호/제어/질문/결과/승인 범위/거부 checkpoint가 그 장면의 끝. 취소 접수는 완료 취소가 아니며 기다리는 질문을 임의 답변하지 않음 | C6와 지정 I, 전체 청구/할당 |</a:t>
+            </a:r>
+          </a:p>
+          <a:p xmlns:a="http://schemas.openxmlformats.org/drawingml/2006/main">
+            <a:r>
+              <a:t/>
+            </a:r>
+          </a:p>
+          <a:p xmlns:a="http://schemas.openxmlformats.org/drawingml/2006/main">
+            <a:r>
+              <a:t>위 tail은 모든 CORE/REUSE/BURST와 모든 run/QA에 공통이다. 최종 payload/source/version/허용과 실제 전달을 검사하며 접수 인사를 최종 결과로 세지 않는다. 정확성의 기존 108개 정답 명세는 해당 checkpoint에서 보존하고 tail 실패는 cycle/resource/필수 기능 보호에 기록한다. 각 관측은 `run/block/occurrence/case/source-vector/checkpoint/tail/I/T`를 동일 원장 key로 조인한다. QA-05 변경의 완료 검사도 이 기능/상태/권한 회귀와 W100의 사용량/동시성/보관 계약을 유지하는지 확인한다. 390장면 모두를 정확성 대표 분모로 키우지 않는다.</a:t>
+            </a:r>
+          </a:p>
+          <a:p xmlns:a="http://schemas.openxmlformats.org/drawingml/2006/main">
+            <a:r>
+              <a:t/>
             </a:r>
           </a:p>
           <a:p xmlns:a="http://schemas.openxmlformats.org/drawingml/2006/main">
@@ -6476,7 +7897,7 @@
   </p:cSld>
   <p:clrMap bg1="lt1" tx1="dk1" bg2="lt2" tx2="dk2" accent1="accent1" accent2="accent2" accent3="accent3" accent4="accent4" accent5="accent5" accent6="accent6" hlink="hlink" folHlink="folHlink"/>
   <p:sldLayoutIdLst>
-    <p:sldLayoutId xmlns:r="http://schemas.openxmlformats.org/officeDocument/2006/relationships" id="2147483649" r:id="R22216869b79849c3"/>
+    <p:sldLayoutId xmlns:r="http://schemas.openxmlformats.org/officeDocument/2006/relationships" id="2147483649" r:id="R8e44eca94cf745a9"/>
   </p:sldLayoutIdLst>
   <p:txStyles>
     <p:titleStyle>
@@ -7027,7 +8448,7 @@
           <p:cNvPr id="8" name="title">
             <a:extLst xmlns:a="http://schemas.openxmlformats.org/drawingml/2006/main">
               <a:ext uri="{FF2B5EF4-FFF2-40B4-BE49-F238E27FC236}">
-                <a16:creationId xmlns:a16="http://schemas.microsoft.com/office/drawing/2014/main" id="{B1234605-8C15-4B9A-BF86-633CEC2FCA0F}"/>
+                <a16:creationId xmlns:a16="http://schemas.microsoft.com/office/drawing/2014/main" id="{87718A9F-90F4-4569-8AA2-F1345D685A87}"/>
               </a:ext>
             </a:extLst>
           </p:cNvPr>
@@ -7084,7 +8505,7 @@
           <p:cNvPr id="2" name="header-rule">
             <a:extLst xmlns:a="http://schemas.openxmlformats.org/drawingml/2006/main">
               <a:ext uri="{FF2B5EF4-FFF2-40B4-BE49-F238E27FC236}">
-                <a16:creationId xmlns:a16="http://schemas.microsoft.com/office/drawing/2014/main" id="{560B46CF-1F50-4E02-9FC5-60249679B06E}"/>
+                <a16:creationId xmlns:a16="http://schemas.microsoft.com/office/drawing/2014/main" id="{7B33F023-6E16-4CAE-A73D-20C5D05E9F4C}"/>
               </a:ext>
             </a:extLst>
           </p:cNvPr>
@@ -7114,7 +8535,7 @@
           <p:cNvPr id="3" name="page">
             <a:extLst xmlns:a="http://schemas.openxmlformats.org/drawingml/2006/main">
               <a:ext uri="{FF2B5EF4-FFF2-40B4-BE49-F238E27FC236}">
-                <a16:creationId xmlns:a16="http://schemas.microsoft.com/office/drawing/2014/main" id="{2A93DB0B-52D1-4C90-90A9-B871569C505F}"/>
+                <a16:creationId xmlns:a16="http://schemas.microsoft.com/office/drawing/2014/main" id="{0EE7076F-69CE-446F-9E81-7369B905C08B}"/>
               </a:ext>
             </a:extLst>
           </p:cNvPr>
@@ -7161,7 +8582,7 @@
                 <a:ea typeface="Apple SD Gothic Neo"/>
                 <a:cs typeface="Apple SD Gothic Neo"/>
               </a:rPr>
-              <a:t>1 / 2</a:t>
+              <a:t>1 / 3</a:t>
             </a:r>
           </a:p>
         </p:txBody>
@@ -7171,7 +8592,7 @@
           <p:cNvPr id="4" name="headline">
             <a:extLst xmlns:a="http://schemas.openxmlformats.org/drawingml/2006/main">
               <a:ext uri="{FF2B5EF4-FFF2-40B4-BE49-F238E27FC236}">
-                <a16:creationId xmlns:a16="http://schemas.microsoft.com/office/drawing/2014/main" id="{37569F14-E14C-4EE4-9A49-F28F44D62D75}"/>
+                <a16:creationId xmlns:a16="http://schemas.microsoft.com/office/drawing/2014/main" id="{560E6851-3B46-4338-9666-842F7329206B}"/>
               </a:ext>
             </a:extLst>
           </p:cNvPr>
@@ -7228,7 +8649,7 @@
           <p:cNvPr id="5" name="scope">
             <a:extLst xmlns:a="http://schemas.openxmlformats.org/drawingml/2006/main">
               <a:ext uri="{FF2B5EF4-FFF2-40B4-BE49-F238E27FC236}">
-                <a16:creationId xmlns:a16="http://schemas.microsoft.com/office/drawing/2014/main" id="{15BBF275-DCD3-4AF2-846E-0D4A6F2A2370}"/>
+                <a16:creationId xmlns:a16="http://schemas.microsoft.com/office/drawing/2014/main" id="{84287D11-E665-4AE4-B8CC-3A37EFF5805E}"/>
               </a:ext>
             </a:extLst>
           </p:cNvPr>
@@ -7275,7 +8696,7 @@
                 <a:ea typeface="Apple SD Gothic Neo"/>
                 <a:cs typeface="Apple SD Gothic Neo"/>
               </a:rPr>
-              <a:t>QA 번호순으로 우선 선택하고 낮은 순위 약점은 tactic으로 보완</a:t>
+              <a:t>같은 W100: 사용자 100 + Agent 30장면. QA 번호순 우선 선택, 낮은 순위 약점은 tactic으로 보완</a:t>
             </a:r>
           </a:p>
         </p:txBody>
@@ -7986,7 +9407,7 @@
           <p:cNvPr id="7" name="footer">
             <a:extLst xmlns:a="http://schemas.openxmlformats.org/drawingml/2006/main">
               <a:ext uri="{FF2B5EF4-FFF2-40B4-BE49-F238E27FC236}">
-                <a16:creationId xmlns:a16="http://schemas.microsoft.com/office/drawing/2014/main" id="{FD7CDADC-841B-4CB8-853F-2C355122DABD}"/>
+                <a16:creationId xmlns:a16="http://schemas.microsoft.com/office/drawing/2014/main" id="{3203E885-611F-44B8-A6B9-5614A3A28326}"/>
               </a:ext>
             </a:extLst>
           </p:cNvPr>
@@ -8033,7 +9454,7 @@
                 <a:ea typeface="Apple SD Gothic Neo"/>
                 <a:cs typeface="Apple SD Gothic Neo"/>
               </a:rPr>
-              <a:t>공통 QA 계약 v4 / 작성자 PoC 평가안. 상세 정답/경계/실패/출처는 03-02와 발표자 노트</a:t>
+              <a:t>W100: 정확성 540개, 시간 각 30개 / 외부 업무와 사용자 답변 대기 제외 / 비용과 메모리는 같은 활동 3회</a:t>
             </a:r>
           </a:p>
         </p:txBody>
@@ -8041,7 +9462,7 @@
     </p:spTree>
     <p:extLst>
       <p:ext uri="{BB962C8B-B14F-4D97-AF65-F5344CB8AC3E}">
-        <p14:creationId xmlns:p14="http://schemas.microsoft.com/office/powerpoint/2010/main" val="920534288"/>
+        <p14:creationId xmlns:p14="http://schemas.microsoft.com/office/powerpoint/2010/main" val="92453822"/>
       </p:ext>
     </p:extLst>
   </p:cSld>
@@ -8072,7 +9493,7 @@
           <p:cNvPr id="8" name="title">
             <a:extLst xmlns:a="http://schemas.openxmlformats.org/drawingml/2006/main">
               <a:ext uri="{FF2B5EF4-FFF2-40B4-BE49-F238E27FC236}">
-                <a16:creationId xmlns:a16="http://schemas.microsoft.com/office/drawing/2014/main" id="{25947634-12E0-4974-9BE3-38205E8719A5}"/>
+                <a16:creationId xmlns:a16="http://schemas.microsoft.com/office/drawing/2014/main" id="{11026A18-0265-4CFB-86E3-6091599FB8F0}"/>
               </a:ext>
             </a:extLst>
           </p:cNvPr>
@@ -8129,7 +9550,7 @@
           <p:cNvPr id="2" name="header-rule">
             <a:extLst xmlns:a="http://schemas.openxmlformats.org/drawingml/2006/main">
               <a:ext uri="{FF2B5EF4-FFF2-40B4-BE49-F238E27FC236}">
-                <a16:creationId xmlns:a16="http://schemas.microsoft.com/office/drawing/2014/main" id="{D31B8CC4-7429-4B8B-92C2-187D9863D34A}"/>
+                <a16:creationId xmlns:a16="http://schemas.microsoft.com/office/drawing/2014/main" id="{4679207A-1AEE-422D-A5C3-ECC8E2AD051C}"/>
               </a:ext>
             </a:extLst>
           </p:cNvPr>
@@ -8159,7 +9580,7 @@
           <p:cNvPr id="3" name="page">
             <a:extLst xmlns:a="http://schemas.openxmlformats.org/drawingml/2006/main">
               <a:ext uri="{FF2B5EF4-FFF2-40B4-BE49-F238E27FC236}">
-                <a16:creationId xmlns:a16="http://schemas.microsoft.com/office/drawing/2014/main" id="{F007AC52-D809-4CA5-816A-B6DB5FCB4CC9}"/>
+                <a16:creationId xmlns:a16="http://schemas.microsoft.com/office/drawing/2014/main" id="{B5A95913-E448-4273-B2C7-CFDDACF19770}"/>
               </a:ext>
             </a:extLst>
           </p:cNvPr>
@@ -8206,7 +9627,7 @@
                 <a:ea typeface="Apple SD Gothic Neo"/>
                 <a:cs typeface="Apple SD Gothic Neo"/>
               </a:rPr>
-              <a:t>2 / 2</a:t>
+              <a:t>2 / 3</a:t>
             </a:r>
           </a:p>
         </p:txBody>
@@ -8216,7 +9637,7 @@
           <p:cNvPr id="4" name="headline">
             <a:extLst xmlns:a="http://schemas.openxmlformats.org/drawingml/2006/main">
               <a:ext uri="{FF2B5EF4-FFF2-40B4-BE49-F238E27FC236}">
-                <a16:creationId xmlns:a16="http://schemas.microsoft.com/office/drawing/2014/main" id="{649EEE11-0A0C-4340-90D8-AEB4EE10DBF8}"/>
+                <a16:creationId xmlns:a16="http://schemas.microsoft.com/office/drawing/2014/main" id="{A67FCAED-F684-472F-8BDC-ADD18F48ECC1}"/>
               </a:ext>
             </a:extLst>
           </p:cNvPr>
@@ -8273,7 +9694,7 @@
           <p:cNvPr id="5" name="scope">
             <a:extLst xmlns:a="http://schemas.openxmlformats.org/drawingml/2006/main">
               <a:ext uri="{FF2B5EF4-FFF2-40B4-BE49-F238E27FC236}">
-                <a16:creationId xmlns:a16="http://schemas.microsoft.com/office/drawing/2014/main" id="{9EE4D708-74D7-485F-B297-D5CBA2FF2037}"/>
+                <a16:creationId xmlns:a16="http://schemas.microsoft.com/office/drawing/2014/main" id="{8723EFE3-1762-4A8D-B0E5-9B01B9BA7445}"/>
               </a:ext>
             </a:extLst>
           </p:cNvPr>
@@ -8320,7 +9741,7 @@
                 <a:ea typeface="Apple SD Gothic Neo"/>
                 <a:cs typeface="Apple SD Gothic Neo"/>
               </a:rPr>
-              <a:t>QA 번호순으로 우선 선택하고 낮은 순위 약점은 tactic으로 보완</a:t>
+              <a:t>같은 W100: 사용자 100 + Agent 30장면. QA 번호순 우선 선택, 낮은 순위 약점은 tactic으로 보완</a:t>
             </a:r>
           </a:p>
         </p:txBody>
@@ -8606,7 +10027,7 @@
                           <a:ea typeface="Apple SD Gothic Neo"/>
                           <a:cs typeface="Apple SD Gothic Neo"/>
                         </a:rPr>
-                        <a:t>8시간 총 모델 비용 ≤ $1.50</a:t>
+                        <a:t>W100 1회 평균 모델 비용 ≤ $1.50</a:t>
                       </a:r>
                     </a:p>
                     <a:p>
@@ -8620,7 +10041,7 @@
                           <a:ea typeface="Apple SD Gothic Neo"/>
                           <a:cs typeface="Apple SD Gothic Neo"/>
                         </a:rPr>
-                        <a:t>측정: 동일 8시간 활동의 청구 사용량 × 공개 단가</a:t>
+                        <a:t>측정: 사용자 100 + Agent 30장면 전체 청구량 × 단가</a:t>
                       </a:r>
                     </a:p>
                     <a:p>
@@ -8634,7 +10055,7 @@
                           <a:ea typeface="Apple SD Gothic Neo"/>
                           <a:cs typeface="Apple SD Gothic Neo"/>
                         </a:rPr>
-                        <a:t>근거: 기본 $1.1325 + 추가 생산/재시도 여유 $0.3675</a:t>
+                        <a:t>근거: 기본 $1.0987 + 추가 생산/재시도 여유 $0.4013</a:t>
                       </a:r>
                     </a:p>
                   </a:txBody>
@@ -9000,7 +10421,7 @@
                           <a:ea typeface="Apple SD Gothic Neo"/>
                           <a:cs typeface="Apple SD Gothic Neo"/>
                         </a:rPr>
-                        <a:t>측정: 8시간/3session 중 가장 큰 동시 commit량</a:t>
+                        <a:t>측정: 같은 W100 3회 중 가장 큰 동시 commit량</a:t>
                       </a:r>
                     </a:p>
                     <a:p>
@@ -9059,7 +10480,7 @@
           <p:cNvPr id="7" name="footer">
             <a:extLst xmlns:a="http://schemas.openxmlformats.org/drawingml/2006/main">
               <a:ext uri="{FF2B5EF4-FFF2-40B4-BE49-F238E27FC236}">
-                <a16:creationId xmlns:a16="http://schemas.microsoft.com/office/drawing/2014/main" id="{5BB8D1EC-5C8D-460C-AB85-4D1E3DB4D30E}"/>
+                <a16:creationId xmlns:a16="http://schemas.microsoft.com/office/drawing/2014/main" id="{D31171A7-D605-4D82-AE61-71A5580875C9}"/>
               </a:ext>
             </a:extLst>
           </p:cNvPr>
@@ -9106,7 +10527,7 @@
                 <a:ea typeface="Apple SD Gothic Neo"/>
                 <a:cs typeface="Apple SD Gothic Neo"/>
               </a:rPr>
-              <a:t>공통 QA 계약 v4 / 작성자 PoC 평가안. 상세 정답/경계/실패/출처는 03-02와 발표자 노트</a:t>
+              <a:t>W100: 정확성 540개, 시간 각 30개 / 외부 업무와 사용자 답변 대기 제외 / 비용과 메모리는 같은 활동 3회</a:t>
             </a:r>
           </a:p>
         </p:txBody>
@@ -9114,7 +10535,1025 @@
     </p:spTree>
     <p:extLst>
       <p:ext uri="{BB962C8B-B14F-4D97-AF65-F5344CB8AC3E}">
-        <p14:creationId xmlns:p14="http://schemas.microsoft.com/office/powerpoint/2010/main" val="1417893180"/>
+        <p14:creationId xmlns:p14="http://schemas.microsoft.com/office/powerpoint/2010/main" val="371708280"/>
+      </p:ext>
+    </p:extLst>
+  </p:cSld>
+</p:sld>
+</file>
+
+<file path=ppt/slides/slide3.xml><?xml version="1.0" encoding="utf-8"?>
+<p:sld xmlns:p="http://schemas.openxmlformats.org/presentationml/2006/main">
+  <p:cSld>
+    <p:bg>
+      <p:bgPr>
+        <a:solidFill xmlns:a="http://schemas.openxmlformats.org/drawingml/2006/main">
+          <a:srgbClr val="FFFFFF"/>
+        </a:solidFill>
+      </p:bgPr>
+    </p:bg>
+    <p:spTree>
+      <p:nvGrpSpPr>
+        <p:cNvPr id="1" name=""/>
+        <p:cNvGrpSpPr/>
+        <p:nvPr/>
+      </p:nvGrpSpPr>
+      <p:grpSpPr>
+        <a:xfrm xmlns:a="http://schemas.openxmlformats.org/drawingml/2006/main"/>
+      </p:grpSpPr>
+      <p:sp>
+        <p:nvSpPr>
+          <p:cNvPr id="8" name="title">
+            <a:extLst xmlns:a="http://schemas.openxmlformats.org/drawingml/2006/main">
+              <a:ext uri="{FF2B5EF4-FFF2-40B4-BE49-F238E27FC236}">
+                <a16:creationId xmlns:a16="http://schemas.microsoft.com/office/drawing/2014/main" id="{14A549F0-5695-4FFE-BEE4-8220CA0EC9D3}"/>
+              </a:ext>
+            </a:extLst>
+          </p:cNvPr>
+          <p:cNvSpPr>
+            <a:spLocks xmlns:a="http://schemas.openxmlformats.org/drawingml/2006/main" noGrp="1"/>
+          </p:cNvSpPr>
+          <p:nvPr/>
+        </p:nvSpPr>
+        <p:spPr>
+          <a:xfrm xmlns:a="http://schemas.openxmlformats.org/drawingml/2006/main">
+            <a:off x="457200" y="247650"/>
+            <a:ext cx="15716250" cy="800100"/>
+          </a:xfrm>
+          <a:prstGeom xmlns:a="http://schemas.openxmlformats.org/drawingml/2006/main" prst="rect">
+            <a:avLst/>
+          </a:prstGeom>
+          <a:noFill xmlns:a="http://schemas.openxmlformats.org/drawingml/2006/main"/>
+          <a:ln xmlns:a="http://schemas.openxmlformats.org/drawingml/2006/main" w="0">
+            <a:noFill/>
+          </a:ln>
+        </p:spPr>
+        <p:txBody>
+          <a:bodyPr xmlns:a="http://schemas.openxmlformats.org/drawingml/2006/main" wrap="none" lIns="0" tIns="0" rIns="0" bIns="0">
+            <a:noAutofit/>
+          </a:bodyPr>
+          <a:lstStyle xmlns:a="http://schemas.openxmlformats.org/drawingml/2006/main"/>
+          <a:p xmlns:a="http://schemas.openxmlformats.org/drawingml/2006/main">
+            <a:pPr>
+              <a:defRPr sz="4425" b="1">
+                <a:solidFill>
+                  <a:srgbClr val="222A35"/>
+                </a:solidFill>
+                <a:latin typeface="Apple SD Gothic Neo"/>
+                <a:ea typeface="Apple SD Gothic Neo"/>
+                <a:cs typeface="Apple SD Gothic Neo"/>
+              </a:defRPr>
+            </a:pPr>
+            <a:r>
+              <a:rPr sz="4425" b="1">
+                <a:solidFill>
+                  <a:srgbClr val="222A35"/>
+                </a:solidFill>
+                <a:latin typeface="Apple SD Gothic Neo"/>
+                <a:ea typeface="Apple SD Gothic Neo"/>
+                <a:cs typeface="Apple SD Gothic Neo"/>
+              </a:rPr>
+              <a:t>공통 평가 활동</a:t>
+            </a:r>
+          </a:p>
+        </p:txBody>
+      </p:sp>
+      <p:sp>
+        <p:nvSpPr>
+          <p:cNvPr id="2" name="header-rule">
+            <a:extLst xmlns:a="http://schemas.openxmlformats.org/drawingml/2006/main">
+              <a:ext uri="{FF2B5EF4-FFF2-40B4-BE49-F238E27FC236}">
+                <a16:creationId xmlns:a16="http://schemas.microsoft.com/office/drawing/2014/main" id="{95CF3A28-878A-4AE5-9BF4-34712FA9397C}"/>
+              </a:ext>
+            </a:extLst>
+          </p:cNvPr>
+          <p:cNvSpPr>
+            <a:spLocks xmlns:a="http://schemas.openxmlformats.org/drawingml/2006/main" noGrp="1"/>
+          </p:cNvSpPr>
+          <p:nvPr/>
+        </p:nvSpPr>
+        <p:spPr>
+          <a:xfrm xmlns:a="http://schemas.openxmlformats.org/drawingml/2006/main">
+            <a:off x="457200" y="1066800"/>
+            <a:ext cx="17373600" cy="19050"/>
+          </a:xfrm>
+          <a:prstGeom xmlns:a="http://schemas.openxmlformats.org/drawingml/2006/main" prst="rect">
+            <a:avLst/>
+          </a:prstGeom>
+          <a:solidFill xmlns:a="http://schemas.openxmlformats.org/drawingml/2006/main">
+            <a:srgbClr val="9E9E9E"/>
+          </a:solidFill>
+          <a:ln xmlns:a="http://schemas.openxmlformats.org/drawingml/2006/main" w="0">
+            <a:noFill/>
+          </a:ln>
+        </p:spPr>
+      </p:sp>
+      <p:sp>
+        <p:nvSpPr>
+          <p:cNvPr id="3" name="page">
+            <a:extLst xmlns:a="http://schemas.openxmlformats.org/drawingml/2006/main">
+              <a:ext uri="{FF2B5EF4-FFF2-40B4-BE49-F238E27FC236}">
+                <a16:creationId xmlns:a16="http://schemas.microsoft.com/office/drawing/2014/main" id="{CDA858B6-036D-43A6-9E77-54C2F7A4ACF8}"/>
+              </a:ext>
+            </a:extLst>
+          </p:cNvPr>
+          <p:cNvSpPr>
+            <a:spLocks xmlns:a="http://schemas.openxmlformats.org/drawingml/2006/main" noGrp="1"/>
+          </p:cNvSpPr>
+          <p:nvPr/>
+        </p:nvSpPr>
+        <p:spPr>
+          <a:xfrm xmlns:a="http://schemas.openxmlformats.org/drawingml/2006/main">
+            <a:off x="16611600" y="504825"/>
+            <a:ext cx="1219200" cy="333375"/>
+          </a:xfrm>
+          <a:prstGeom xmlns:a="http://schemas.openxmlformats.org/drawingml/2006/main" prst="rect">
+            <a:avLst/>
+          </a:prstGeom>
+          <a:noFill xmlns:a="http://schemas.openxmlformats.org/drawingml/2006/main"/>
+          <a:ln xmlns:a="http://schemas.openxmlformats.org/drawingml/2006/main" w="0">
+            <a:noFill/>
+          </a:ln>
+        </p:spPr>
+        <p:txBody>
+          <a:bodyPr xmlns:a="http://schemas.openxmlformats.org/drawingml/2006/main" wrap="none" lIns="0" tIns="0" rIns="0" bIns="0">
+            <a:noAutofit/>
+          </a:bodyPr>
+          <a:lstStyle xmlns:a="http://schemas.openxmlformats.org/drawingml/2006/main"/>
+          <a:p xmlns:a="http://schemas.openxmlformats.org/drawingml/2006/main">
+            <a:pPr>
+              <a:defRPr sz="1875" b="0">
+                <a:solidFill>
+                  <a:srgbClr val="56606B"/>
+                </a:solidFill>
+                <a:latin typeface="Apple SD Gothic Neo"/>
+                <a:ea typeface="Apple SD Gothic Neo"/>
+                <a:cs typeface="Apple SD Gothic Neo"/>
+              </a:defRPr>
+            </a:pPr>
+            <a:r>
+              <a:rPr sz="1875" b="0">
+                <a:solidFill>
+                  <a:srgbClr val="56606B"/>
+                </a:solidFill>
+                <a:latin typeface="Apple SD Gothic Neo"/>
+                <a:ea typeface="Apple SD Gothic Neo"/>
+                <a:cs typeface="Apple SD Gothic Neo"/>
+              </a:rPr>
+              <a:t>3 / 3</a:t>
+            </a:r>
+          </a:p>
+        </p:txBody>
+      </p:sp>
+      <p:sp>
+        <p:nvSpPr>
+          <p:cNvPr id="4" name="headline">
+            <a:extLst xmlns:a="http://schemas.openxmlformats.org/drawingml/2006/main">
+              <a:ext uri="{FF2B5EF4-FFF2-40B4-BE49-F238E27FC236}">
+                <a16:creationId xmlns:a16="http://schemas.microsoft.com/office/drawing/2014/main" id="{EFF55D77-2BD4-42ED-B57F-EAC43746D369}"/>
+              </a:ext>
+            </a:extLst>
+          </p:cNvPr>
+          <p:cNvSpPr>
+            <a:spLocks xmlns:a="http://schemas.openxmlformats.org/drawingml/2006/main" noGrp="1"/>
+          </p:cNvSpPr>
+          <p:nvPr/>
+        </p:nvSpPr>
+        <p:spPr>
+          <a:xfrm xmlns:a="http://schemas.openxmlformats.org/drawingml/2006/main">
+            <a:off x="457200" y="1285875"/>
+            <a:ext cx="17373600" cy="485775"/>
+          </a:xfrm>
+          <a:prstGeom xmlns:a="http://schemas.openxmlformats.org/drawingml/2006/main" prst="rect">
+            <a:avLst/>
+          </a:prstGeom>
+          <a:noFill xmlns:a="http://schemas.openxmlformats.org/drawingml/2006/main"/>
+          <a:ln xmlns:a="http://schemas.openxmlformats.org/drawingml/2006/main" w="0">
+            <a:noFill/>
+          </a:ln>
+        </p:spPr>
+        <p:txBody>
+          <a:bodyPr xmlns:a="http://schemas.openxmlformats.org/drawingml/2006/main" wrap="none" lIns="0" tIns="0" rIns="0" bIns="0">
+            <a:noAutofit/>
+          </a:bodyPr>
+          <a:lstStyle xmlns:a="http://schemas.openxmlformats.org/drawingml/2006/main"/>
+          <a:p xmlns:a="http://schemas.openxmlformats.org/drawingml/2006/main">
+            <a:pPr>
+              <a:defRPr sz="3150" b="1">
+                <a:solidFill>
+                  <a:srgbClr val="4472C4"/>
+                </a:solidFill>
+                <a:latin typeface="Apple SD Gothic Neo"/>
+                <a:ea typeface="Apple SD Gothic Neo"/>
+                <a:cs typeface="Apple SD Gothic Neo"/>
+              </a:defRPr>
+            </a:pPr>
+            <a:r>
+              <a:rPr sz="3150" b="1">
+                <a:solidFill>
+                  <a:srgbClr val="4472C4"/>
+                </a:solidFill>
+                <a:latin typeface="Apple SD Gothic Neo"/>
+                <a:ea typeface="Apple SD Gothic Neo"/>
+                <a:cs typeface="Apple SD Gothic Neo"/>
+              </a:rPr>
+              <a:t>W100: 같은 요청과 후속 사건으로 여섯 QA 평가</a:t>
+            </a:r>
+          </a:p>
+        </p:txBody>
+      </p:sp>
+      <p:sp>
+        <p:nvSpPr>
+          <p:cNvPr id="5" name="scope">
+            <a:extLst xmlns:a="http://schemas.openxmlformats.org/drawingml/2006/main">
+              <a:ext uri="{FF2B5EF4-FFF2-40B4-BE49-F238E27FC236}">
+                <a16:creationId xmlns:a16="http://schemas.microsoft.com/office/drawing/2014/main" id="{4878716E-C69E-43C9-87D4-F33E7E195A5C}"/>
+              </a:ext>
+            </a:extLst>
+          </p:cNvPr>
+          <p:cNvSpPr>
+            <a:spLocks xmlns:a="http://schemas.openxmlformats.org/drawingml/2006/main" noGrp="1"/>
+          </p:cNvSpPr>
+          <p:nvPr/>
+        </p:nvSpPr>
+        <p:spPr>
+          <a:xfrm xmlns:a="http://schemas.openxmlformats.org/drawingml/2006/main">
+            <a:off x="457200" y="1819275"/>
+            <a:ext cx="17373600" cy="342900"/>
+          </a:xfrm>
+          <a:prstGeom xmlns:a="http://schemas.openxmlformats.org/drawingml/2006/main" prst="rect">
+            <a:avLst/>
+          </a:prstGeom>
+          <a:noFill xmlns:a="http://schemas.openxmlformats.org/drawingml/2006/main"/>
+          <a:ln xmlns:a="http://schemas.openxmlformats.org/drawingml/2006/main" w="0">
+            <a:noFill/>
+          </a:ln>
+        </p:spPr>
+        <p:txBody>
+          <a:bodyPr xmlns:a="http://schemas.openxmlformats.org/drawingml/2006/main" wrap="none" lIns="0" tIns="0" rIns="0" bIns="0">
+            <a:noAutofit/>
+          </a:bodyPr>
+          <a:lstStyle xmlns:a="http://schemas.openxmlformats.org/drawingml/2006/main"/>
+          <a:p xmlns:a="http://schemas.openxmlformats.org/drawingml/2006/main">
+            <a:pPr>
+              <a:defRPr sz="2175" b="0">
+                <a:solidFill>
+                  <a:srgbClr val="222A35"/>
+                </a:solidFill>
+                <a:latin typeface="Apple SD Gothic Neo"/>
+                <a:ea typeface="Apple SD Gothic Neo"/>
+                <a:cs typeface="Apple SD Gothic Neo"/>
+              </a:defRPr>
+            </a:pPr>
+            <a:r>
+              <a:rPr sz="2175" b="0">
+                <a:solidFill>
+                  <a:srgbClr val="222A35"/>
+                </a:solidFill>
+                <a:latin typeface="Apple SD Gothic Neo"/>
+                <a:ea typeface="Apple SD Gothic Neo"/>
+                <a:cs typeface="Apple SD Gothic Neo"/>
+              </a:rPr>
+              <a:t>기존 18개 사례를 재사용한 합성 PoC 부하. 실제 하루 사용량을 주장하는 수치는 아님</a:t>
+            </a:r>
+          </a:p>
+        </p:txBody>
+      </p:sp>
+      <p:graphicFrame>
+        <p:nvGraphicFramePr>
+          <p:cNvPr id="13" name=""/>
+          <p:cNvGraphicFramePr/>
+          <p:nvPr/>
+        </p:nvGraphicFramePr>
+        <p:xfrm>
+          <a:off xmlns:a="http://schemas.openxmlformats.org/drawingml/2006/main" x="457200" y="2286000"/>
+          <a:ext xmlns:a="http://schemas.openxmlformats.org/drawingml/2006/main" cx="17373600" cy="7486650"/>
+        </p:xfrm>
+        <a:graphic xmlns:a="http://schemas.openxmlformats.org/drawingml/2006/main">
+          <a:graphicData uri="http://schemas.openxmlformats.org/drawingml/2006/table">
+            <a:tbl>
+              <a:tblPr firstRow="0" bandRow="0"/>
+              <a:tblGrid>
+                <a:gridCol w="2667000"/>
+                <a:gridCol w="8001000"/>
+                <a:gridCol w="6705600"/>
+              </a:tblGrid>
+              <a:tr h="476250">
+                <a:tc>
+                  <a:txBody>
+                    <a:bodyPr/>
+                    <a:lstStyle/>
+                    <a:p>
+                      <a:pPr algn="l"/>
+                      <a:r>
+                        <a:rPr sz="2100" b="1">
+                          <a:solidFill>
+                            <a:srgbClr val="FFFFFF"/>
+                          </a:solidFill>
+                          <a:latin typeface="Apple SD Gothic Neo"/>
+                          <a:ea typeface="Apple SD Gothic Neo"/>
+                          <a:cs typeface="Apple SD Gothic Neo"/>
+                        </a:rPr>
+                        <a:t>활동 / 관측</a:t>
+                      </a:r>
+                    </a:p>
+                  </a:txBody>
+                  <a:tcPr marL="133350" marR="114300" marT="57150" marB="57150" anchor="ctr">
+                    <a:solidFill>
+                      <a:srgbClr val="4472C4"/>
+                    </a:solidFill>
+                  </a:tcPr>
+                </a:tc>
+                <a:tc>
+                  <a:txBody>
+                    <a:bodyPr/>
+                    <a:lstStyle/>
+                    <a:p>
+                      <a:pPr algn="l"/>
+                      <a:r>
+                        <a:rPr sz="2100" b="1">
+                          <a:solidFill>
+                            <a:srgbClr val="FFFFFF"/>
+                          </a:solidFill>
+                          <a:latin typeface="Apple SD Gothic Neo"/>
+                          <a:ea typeface="Apple SD Gothic Neo"/>
+                          <a:cs typeface="Apple SD Gothic Neo"/>
+                        </a:rPr>
+                        <a:t>고정 조건</a:t>
+                      </a:r>
+                    </a:p>
+                  </a:txBody>
+                  <a:tcPr marL="133350" marR="114300" marT="57150" marB="57150" anchor="ctr">
+                    <a:solidFill>
+                      <a:srgbClr val="4472C4"/>
+                    </a:solidFill>
+                  </a:tcPr>
+                </a:tc>
+                <a:tc>
+                  <a:txBody>
+                    <a:bodyPr/>
+                    <a:lstStyle/>
+                    <a:p>
+                      <a:pPr algn="l"/>
+                      <a:r>
+                        <a:rPr sz="2100" b="1">
+                          <a:solidFill>
+                            <a:srgbClr val="FFFFFF"/>
+                          </a:solidFill>
+                          <a:latin typeface="Apple SD Gothic Neo"/>
+                          <a:ea typeface="Apple SD Gothic Neo"/>
+                          <a:cs typeface="Apple SD Gothic Neo"/>
+                        </a:rPr>
+                        <a:t>QA에서 읽는 값</a:t>
+                      </a:r>
+                    </a:p>
+                  </a:txBody>
+                  <a:tcPr marL="133350" marR="114300" marT="57150" marB="57150" anchor="ctr">
+                    <a:solidFill>
+                      <a:srgbClr val="4472C4"/>
+                    </a:solidFill>
+                  </a:tcPr>
+                </a:tc>
+              </a:tr>
+              <a:tr h="1162050">
+                <a:tc>
+                  <a:txBody>
+                    <a:bodyPr/>
+                    <a:lstStyle/>
+                    <a:p>
+                      <a:pPr algn="l"/>
+                      <a:r>
+                        <a:rPr sz="2100" b="0">
+                          <a:solidFill>
+                            <a:srgbClr val="222A35"/>
+                          </a:solidFill>
+                          <a:latin typeface="Apple SD Gothic Neo"/>
+                          <a:ea typeface="Apple SD Gothic Neo"/>
+                          <a:cs typeface="Apple SD Gothic Neo"/>
+                        </a:rPr>
+                        <a:t>입력 장면</a:t>
+                      </a:r>
+                    </a:p>
+                  </a:txBody>
+                  <a:tcPr marL="133350" marR="114300" marT="57150" marB="57150" anchor="ctr">
+                    <a:solidFill>
+                      <a:srgbClr val="FFF6DE"/>
+                    </a:solidFill>
+                  </a:tcPr>
+                </a:tc>
+                <a:tc>
+                  <a:txBody>
+                    <a:bodyPr/>
+                    <a:lstStyle/>
+                    <a:p>
+                      <a:pPr algn="l"/>
+                      <a:r>
+                        <a:rPr sz="2100" b="0">
+                          <a:solidFill>
+                            <a:srgbClr val="222A35"/>
+                          </a:solidFill>
+                          <a:latin typeface="Apple SD Gothic Neo"/>
+                          <a:ea typeface="Apple SD Gothic Neo"/>
+                          <a:cs typeface="Apple SD Gothic Neo"/>
+                        </a:rPr>
+                        <a:t>사용자 100건 + Agent 발신 30건</a:t>
+                      </a:r>
+                    </a:p>
+                    <a:p>
+                      <a:pPr algn="l"/>
+                      <a:r>
+                        <a:rPr sz="2100" b="0">
+                          <a:solidFill>
+                            <a:srgbClr val="222A35"/>
+                          </a:solidFill>
+                          <a:latin typeface="Apple SD Gothic Neo"/>
+                          <a:ea typeface="Apple SD Gothic Neo"/>
+                          <a:cs typeface="Apple SD Gothic Neo"/>
+                        </a:rPr>
+                        <a:t>조회, 과거 재사용, 복합 요청, 정정, 질문과 결과</a:t>
+                      </a:r>
+                    </a:p>
+                  </a:txBody>
+                  <a:tcPr marL="133350" marR="114300" marT="57150" marB="57150" anchor="ctr">
+                    <a:solidFill>
+                      <a:srgbClr val="FFF6DE"/>
+                    </a:solidFill>
+                  </a:tcPr>
+                </a:tc>
+                <a:tc>
+                  <a:txBody>
+                    <a:bodyPr/>
+                    <a:lstStyle/>
+                    <a:p>
+                      <a:pPr algn="l"/>
+                      <a:r>
+                        <a:rPr sz="2100" b="0">
+                          <a:solidFill>
+                            <a:srgbClr val="222A35"/>
+                          </a:solidFill>
+                          <a:latin typeface="Apple SD Gothic Neo"/>
+                          <a:ea typeface="Apple SD Gothic Neo"/>
+                          <a:cs typeface="Apple SD Gothic Neo"/>
+                        </a:rPr>
+                        <a:t>18개 사례의 같은 입력 / 원본 / 허용 / 후속 사건</a:t>
+                      </a:r>
+                    </a:p>
+                  </a:txBody>
+                  <a:tcPr marL="133350" marR="114300" marT="57150" marB="57150" anchor="ctr">
+                    <a:solidFill>
+                      <a:srgbClr val="FFF6DE"/>
+                    </a:solidFill>
+                  </a:tcPr>
+                </a:tc>
+              </a:tr>
+              <a:tr h="1162050">
+                <a:tc>
+                  <a:txBody>
+                    <a:bodyPr/>
+                    <a:lstStyle/>
+                    <a:p>
+                      <a:pPr algn="l"/>
+                      <a:r>
+                        <a:rPr sz="2100" b="0">
+                          <a:solidFill>
+                            <a:srgbClr val="222A35"/>
+                          </a:solidFill>
+                          <a:latin typeface="Apple SD Gothic Neo"/>
+                          <a:ea typeface="Apple SD Gothic Neo"/>
+                          <a:cs typeface="Apple SD Gothic Neo"/>
+                        </a:rPr>
+                        <a:t>반복과 집중</a:t>
+                      </a:r>
+                    </a:p>
+                  </a:txBody>
+                  <a:tcPr marL="133350" marR="114300" marT="57150" marB="57150" anchor="ctr">
+                    <a:solidFill>
+                      <a:srgbClr val="FFF6DE"/>
+                    </a:solidFill>
+                  </a:tcPr>
+                </a:tc>
+                <a:tc>
+                  <a:txBody>
+                    <a:bodyPr/>
+                    <a:lstStyle/>
+                    <a:p>
+                      <a:pPr algn="l"/>
+                      <a:r>
+                        <a:rPr sz="2100" b="0">
+                          <a:solidFill>
+                            <a:srgbClr val="222A35"/>
+                          </a:solidFill>
+                          <a:latin typeface="Apple SD Gothic Neo"/>
+                          <a:ea typeface="Apple SD Gothic Neo"/>
+                          <a:cs typeface="Apple SD Gothic Neo"/>
+                        </a:rPr>
+                        <a:t>5block × (CORE 18 + REUSE 4 + BURST 4)</a:t>
+                      </a:r>
+                    </a:p>
+                    <a:p>
+                      <a:pPr algn="l"/>
+                      <a:r>
+                        <a:rPr sz="2100" b="0">
+                          <a:solidFill>
+                            <a:srgbClr val="222A35"/>
+                          </a:solidFill>
+                          <a:latin typeface="Apple SD Gothic Neo"/>
+                          <a:ea typeface="Apple SD Gothic Neo"/>
+                          <a:cs typeface="Apple SD Gothic Neo"/>
+                        </a:rPr>
+                        <a:t>Agent burst는 0 / 0.02 / 0.04 / 0.06초에 제공</a:t>
+                      </a:r>
+                    </a:p>
+                  </a:txBody>
+                  <a:tcPr marL="133350" marR="114300" marT="57150" marB="57150" anchor="ctr">
+                    <a:solidFill>
+                      <a:srgbClr val="FFF6DE"/>
+                    </a:solidFill>
+                  </a:tcPr>
+                </a:tc>
+                <a:tc>
+                  <a:txBody>
+                    <a:bodyPr/>
+                    <a:lstStyle/>
+                    <a:p>
+                      <a:pPr algn="l"/>
+                      <a:r>
+                        <a:rPr sz="2100" b="0">
+                          <a:solidFill>
+                            <a:srgbClr val="222A35"/>
+                          </a:solidFill>
+                          <a:latin typeface="Apple SD Gothic Neo"/>
+                          <a:ea typeface="Apple SD Gothic Neo"/>
+                          <a:cs typeface="Apple SD Gothic Neo"/>
+                        </a:rPr>
+                        <a:t>같은 원본 재사용 / 경쟁 / 추가 상태와 copy</a:t>
+                      </a:r>
+                    </a:p>
+                  </a:txBody>
+                  <a:tcPr marL="133350" marR="114300" marT="57150" marB="57150" anchor="ctr">
+                    <a:solidFill>
+                      <a:srgbClr val="FFF6DE"/>
+                    </a:solidFill>
+                  </a:tcPr>
+                </a:tc>
+              </a:tr>
+              <a:tr h="1162050">
+                <a:tc>
+                  <a:txBody>
+                    <a:bodyPr/>
+                    <a:lstStyle/>
+                    <a:p>
+                      <a:pPr algn="l"/>
+                      <a:r>
+                        <a:rPr sz="2100" b="0">
+                          <a:solidFill>
+                            <a:srgbClr val="222A35"/>
+                          </a:solidFill>
+                          <a:latin typeface="Apple SD Gothic Neo"/>
+                          <a:ea typeface="Apple SD Gothic Neo"/>
+                          <a:cs typeface="Apple SD Gothic Neo"/>
+                        </a:rPr>
+                        <a:t>초기 자료와 동시 부하</a:t>
+                      </a:r>
+                    </a:p>
+                  </a:txBody>
+                  <a:tcPr marL="133350" marR="114300" marT="57150" marB="57150" anchor="ctr">
+                    <a:solidFill>
+                      <a:srgbClr val="FFF6DE"/>
+                    </a:solidFill>
+                  </a:tcPr>
+                </a:tc>
+                <a:tc>
+                  <a:txBody>
+                    <a:bodyPr/>
+                    <a:lstStyle/>
+                    <a:p>
+                      <a:pPr algn="l"/>
+                      <a:r>
+                        <a:rPr sz="2100" b="0">
+                          <a:solidFill>
+                            <a:srgbClr val="222A35"/>
+                          </a:solidFill>
+                          <a:latin typeface="Apple SD Gothic Neo"/>
+                          <a:ea typeface="Apple SD Gothic Neo"/>
+                          <a:cs typeface="Apple SD Gothic Neo"/>
+                        </a:rPr>
+                        <a:t>과거 2,000turn / 완료 Task 200개 / 원본 30개</a:t>
+                      </a:r>
+                    </a:p>
+                    <a:p>
+                      <a:pPr algn="l"/>
+                      <a:r>
+                        <a:rPr sz="2100" b="0">
+                          <a:solidFill>
+                            <a:srgbClr val="222A35"/>
+                          </a:solidFill>
+                          <a:latin typeface="Apple SD Gothic Neo"/>
+                          <a:ea typeface="Apple SD Gothic Neo"/>
+                          <a:cs typeface="Apple SD Gothic Neo"/>
+                        </a:rPr>
+                        <a:t>활성 Task 최대 10개 / cloud call 최대 4개</a:t>
+                      </a:r>
+                    </a:p>
+                  </a:txBody>
+                  <a:tcPr marL="133350" marR="114300" marT="57150" marB="57150" anchor="ctr">
+                    <a:solidFill>
+                      <a:srgbClr val="FFF6DE"/>
+                    </a:solidFill>
+                  </a:tcPr>
+                </a:tc>
+                <a:tc>
+                  <a:txBody>
+                    <a:bodyPr/>
+                    <a:lstStyle/>
+                    <a:p>
+                      <a:pPr algn="l"/>
+                      <a:r>
+                        <a:rPr sz="2100" b="0">
+                          <a:solidFill>
+                            <a:srgbClr val="222A35"/>
+                          </a:solidFill>
+                          <a:latin typeface="Apple SD Gothic Neo"/>
+                          <a:ea typeface="Apple SD Gothic Neo"/>
+                          <a:cs typeface="Apple SD Gothic Neo"/>
+                        </a:rPr>
+                        <a:t>복원, 초기 생산, 준비 비용과 동시 할당도 포함</a:t>
+                      </a:r>
+                    </a:p>
+                  </a:txBody>
+                  <a:tcPr marL="133350" marR="114300" marT="57150" marB="57150" anchor="ctr">
+                    <a:solidFill>
+                      <a:srgbClr val="FFF6DE"/>
+                    </a:solidFill>
+                  </a:tcPr>
+                </a:tc>
+              </a:tr>
+              <a:tr h="1162050">
+                <a:tc>
+                  <a:txBody>
+                    <a:bodyPr/>
+                    <a:lstStyle/>
+                    <a:p>
+                      <a:pPr algn="l"/>
+                      <a:r>
+                        <a:rPr sz="2100" b="0">
+                          <a:solidFill>
+                            <a:srgbClr val="222A35"/>
+                          </a:solidFill>
+                          <a:latin typeface="Apple SD Gothic Neo"/>
+                          <a:ea typeface="Apple SD Gothic Neo"/>
+                          <a:cs typeface="Apple SD Gothic Neo"/>
+                        </a:rPr>
+                        <a:t>정확성과 시간</a:t>
+                      </a:r>
+                    </a:p>
+                  </a:txBody>
+                  <a:tcPr marL="133350" marR="114300" marT="57150" marB="57150" anchor="ctr">
+                    <a:solidFill>
+                      <a:srgbClr val="FFF6DE"/>
+                    </a:solidFill>
+                  </a:tcPr>
+                </a:tc>
+                <a:tc>
+                  <a:txBody>
+                    <a:bodyPr/>
+                    <a:lstStyle/>
+                    <a:p>
+                      <a:pPr algn="l"/>
+                      <a:r>
+                        <a:rPr sz="2100" b="0">
+                          <a:solidFill>
+                            <a:srgbClr val="222A35"/>
+                          </a:solidFill>
+                          <a:latin typeface="Apple SD Gothic Neo"/>
+                          <a:ea typeface="Apple SD Gothic Neo"/>
+                          <a:cs typeface="Apple SD Gothic Neo"/>
+                        </a:rPr>
+                        <a:t>R1 CORE의 18개 × 5회 = 90회</a:t>
+                      </a:r>
+                    </a:p>
+                    <a:p>
+                      <a:pPr algn="l"/>
+                      <a:r>
+                        <a:rPr sz="2100" b="0">
+                          <a:solidFill>
+                            <a:srgbClr val="222A35"/>
+                          </a:solidFill>
+                          <a:latin typeface="Apple SD Gothic Neo"/>
+                          <a:ea typeface="Apple SD Gothic Neo"/>
+                          <a:cs typeface="Apple SD Gothic Neo"/>
+                        </a:rPr>
+                        <a:t>같은 장면의 첫 유효 반응과 최종 결과 관측</a:t>
+                      </a:r>
+                    </a:p>
+                  </a:txBody>
+                  <a:tcPr marL="133350" marR="114300" marT="57150" marB="57150" anchor="ctr">
+                    <a:solidFill>
+                      <a:srgbClr val="FFF6DE"/>
+                    </a:solidFill>
+                  </a:tcPr>
+                </a:tc>
+                <a:tc>
+                  <a:txBody>
+                    <a:bodyPr/>
+                    <a:lstStyle/>
+                    <a:p>
+                      <a:pPr algn="l"/>
+                      <a:r>
+                        <a:rPr sz="2100" b="0">
+                          <a:solidFill>
+                            <a:srgbClr val="222A35"/>
+                          </a:solidFill>
+                          <a:latin typeface="Apple SD Gothic Neo"/>
+                          <a:ea typeface="Apple SD Gothic Neo"/>
+                          <a:cs typeface="Apple SD Gothic Neo"/>
+                        </a:rPr>
+                        <a:t>정확성 540조건 / I와 T 각각 30관측</a:t>
+                      </a:r>
+                    </a:p>
+                  </a:txBody>
+                  <a:tcPr marL="133350" marR="114300" marT="57150" marB="57150" anchor="ctr">
+                    <a:solidFill>
+                      <a:srgbClr val="FFF6DE"/>
+                    </a:solidFill>
+                  </a:tcPr>
+                </a:tc>
+              </a:tr>
+              <a:tr h="1352550">
+                <a:tc>
+                  <a:txBody>
+                    <a:bodyPr/>
+                    <a:lstStyle/>
+                    <a:p>
+                      <a:pPr algn="l"/>
+                      <a:r>
+                        <a:rPr sz="2100" b="0">
+                          <a:solidFill>
+                            <a:srgbClr val="222A35"/>
+                          </a:solidFill>
+                          <a:latin typeface="Apple SD Gothic Neo"/>
+                          <a:ea typeface="Apple SD Gothic Neo"/>
+                          <a:cs typeface="Apple SD Gothic Neo"/>
+                        </a:rPr>
+                        <a:t>비용과 메모리</a:t>
+                      </a:r>
+                    </a:p>
+                  </a:txBody>
+                  <a:tcPr marL="133350" marR="114300" marT="57150" marB="57150" anchor="ctr">
+                    <a:solidFill>
+                      <a:srgbClr val="FFF6DE"/>
+                    </a:solidFill>
+                  </a:tcPr>
+                </a:tc>
+                <a:tc>
+                  <a:txBody>
+                    <a:bodyPr/>
+                    <a:lstStyle/>
+                    <a:p>
+                      <a:pPr algn="l"/>
+                      <a:r>
+                        <a:rPr sz="2100" b="0">
+                          <a:solidFill>
+                            <a:srgbClr val="222A35"/>
+                          </a:solidFill>
+                          <a:latin typeface="Apple SD Gothic Neo"/>
+                          <a:ea typeface="Apple SD Gothic Neo"/>
+                          <a:cs typeface="Apple SD Gothic Neo"/>
+                        </a:rPr>
+                        <a:t>동일 W100을 3회 독립 수행</a:t>
+                      </a:r>
+                    </a:p>
+                    <a:p>
+                      <a:pPr algn="l"/>
+                      <a:r>
+                        <a:rPr sz="2100" b="0">
+                          <a:solidFill>
+                            <a:srgbClr val="222A35"/>
+                          </a:solidFill>
+                          <a:latin typeface="Apple SD Gothic Neo"/>
+                          <a:ea typeface="Apple SD Gothic Neo"/>
+                          <a:cs typeface="Apple SD Gothic Neo"/>
+                        </a:rPr>
+                        <a:t>입력 음성 264초 / 출력 참조 예산 914초</a:t>
+                      </a:r>
+                    </a:p>
+                  </a:txBody>
+                  <a:tcPr marL="133350" marR="114300" marT="57150" marB="57150" anchor="ctr">
+                    <a:solidFill>
+                      <a:srgbClr val="FFF6DE"/>
+                    </a:solidFill>
+                  </a:tcPr>
+                </a:tc>
+                <a:tc>
+                  <a:txBody>
+                    <a:bodyPr/>
+                    <a:lstStyle/>
+                    <a:p>
+                      <a:pPr algn="l"/>
+                      <a:r>
+                        <a:rPr sz="2100" b="0">
+                          <a:solidFill>
+                            <a:srgbClr val="222A35"/>
+                          </a:solidFill>
+                          <a:latin typeface="Apple SD Gothic Neo"/>
+                          <a:ea typeface="Apple SD Gothic Neo"/>
+                          <a:cs typeface="Apple SD Gothic Neo"/>
+                        </a:rPr>
+                        <a:t>비용: 활동 총액의 평균 ≤ $1.50</a:t>
+                      </a:r>
+                    </a:p>
+                    <a:p>
+                      <a:pPr algn="l"/>
+                      <a:r>
+                        <a:rPr sz="2100" b="0">
+                          <a:solidFill>
+                            <a:srgbClr val="222A35"/>
+                          </a:solidFill>
+                          <a:latin typeface="Apple SD Gothic Neo"/>
+                          <a:ea typeface="Apple SD Gothic Neo"/>
+                          <a:cs typeface="Apple SD Gothic Neo"/>
+                        </a:rPr>
+                        <a:t>메모리: 모든 활동의 최대 commit ≤ 4GiB</a:t>
+                      </a:r>
+                    </a:p>
+                  </a:txBody>
+                  <a:tcPr marL="133350" marR="114300" marT="57150" marB="57150" anchor="ctr">
+                    <a:solidFill>
+                      <a:srgbClr val="FFF6DE"/>
+                    </a:solidFill>
+                  </a:tcPr>
+                </a:tc>
+              </a:tr>
+              <a:tr h="1009650">
+                <a:tc>
+                  <a:txBody>
+                    <a:bodyPr/>
+                    <a:lstStyle/>
+                    <a:p>
+                      <a:pPr algn="l"/>
+                      <a:r>
+                        <a:rPr sz="2100" b="0">
+                          <a:solidFill>
+                            <a:srgbClr val="222A35"/>
+                          </a:solidFill>
+                          <a:latin typeface="Apple SD Gothic Neo"/>
+                          <a:ea typeface="Apple SD Gothic Neo"/>
+                          <a:cs typeface="Apple SD Gothic Neo"/>
+                        </a:rPr>
+                        <a:t>회수와 보호</a:t>
+                      </a:r>
+                    </a:p>
+                  </a:txBody>
+                  <a:tcPr marL="133350" marR="114300" marT="57150" marB="57150" anchor="ctr">
+                    <a:solidFill>
+                      <a:srgbClr val="FFF6DE"/>
+                    </a:solidFill>
+                  </a:tcPr>
+                </a:tc>
+                <a:tc>
+                  <a:txBody>
+                    <a:bodyPr/>
+                    <a:lstStyle/>
+                    <a:p>
+                      <a:pPr algn="l"/>
+                      <a:r>
+                        <a:rPr sz="2100" b="0">
+                          <a:solidFill>
+                            <a:srgbClr val="222A35"/>
+                          </a:solidFill>
+                          <a:latin typeface="Apple SD Gothic Neo"/>
+                          <a:ea typeface="Apple SD Gothic Neo"/>
+                          <a:cs typeface="Apple SD Gothic Neo"/>
+                        </a:rPr>
+                        <a:t>원본 갱신 20건 / maintenance 10회 / 마지막 철회</a:t>
+                      </a:r>
+                    </a:p>
+                    <a:p>
+                      <a:pPr algn="l"/>
+                      <a:r>
+                        <a:rPr sz="2100" b="0">
+                          <a:solidFill>
+                            <a:srgbClr val="222A35"/>
+                          </a:solidFill>
+                          <a:latin typeface="Apple SD Gothic Neo"/>
+                          <a:ea typeface="Apple SD Gothic Neo"/>
+                          <a:cs typeface="Apple SD Gothic Neo"/>
+                        </a:rPr>
+                        <a:t>신규 입력 종료 후 drain ≤30초, idle probe 10초</a:t>
+                      </a:r>
+                    </a:p>
+                  </a:txBody>
+                  <a:tcPr marL="133350" marR="114300" marT="57150" marB="57150" anchor="ctr">
+                    <a:solidFill>
+                      <a:srgbClr val="FFF6DE"/>
+                    </a:solidFill>
+                  </a:tcPr>
+                </a:tc>
+                <a:tc>
+                  <a:txBody>
+                    <a:bodyPr/>
+                    <a:lstStyle/>
+                    <a:p>
+                      <a:pPr algn="l"/>
+                      <a:r>
+                        <a:rPr sz="2100" b="0">
+                          <a:solidFill>
+                            <a:srgbClr val="222A35"/>
+                          </a:solidFill>
+                          <a:latin typeface="Apple SD Gothic Neo"/>
+                          <a:ea typeface="Apple SD Gothic Neo"/>
+                          <a:cs typeface="Apple SD Gothic Neo"/>
+                        </a:rPr>
+                        <a:t>완료/권한/중복 회귀 유지, 유휴 증가 ≤16MiB</a:t>
+                      </a:r>
+                    </a:p>
+                    <a:p>
+                      <a:pPr algn="l"/>
+                      <a:r>
+                        <a:rPr sz="2100" b="0">
+                          <a:solidFill>
+                            <a:srgbClr val="222A35"/>
+                          </a:solidFill>
+                          <a:latin typeface="Apple SD Gothic Neo"/>
+                          <a:ea typeface="Apple SD Gothic Neo"/>
+                          <a:cs typeface="Apple SD Gothic Neo"/>
+                        </a:rPr>
+                        <a:t>변경 QA는 별도 6과제에서 같은 기능 계약 유지</a:t>
+                      </a:r>
+                    </a:p>
+                  </a:txBody>
+                  <a:tcPr marL="133350" marR="114300" marT="57150" marB="57150" anchor="ctr">
+                    <a:solidFill>
+                      <a:srgbClr val="FFF6DE"/>
+                    </a:solidFill>
+                  </a:tcPr>
+                </a:tc>
+              </a:tr>
+            </a:tbl>
+          </a:graphicData>
+        </a:graphic>
+      </p:graphicFrame>
+      <p:sp>
+        <p:nvSpPr>
+          <p:cNvPr id="7" name="footer">
+            <a:extLst xmlns:a="http://schemas.openxmlformats.org/drawingml/2006/main">
+              <a:ext uri="{FF2B5EF4-FFF2-40B4-BE49-F238E27FC236}">
+                <a16:creationId xmlns:a16="http://schemas.microsoft.com/office/drawing/2014/main" id="{2314B6E2-0F18-4C6D-A3D5-90B03A865BAC}"/>
+              </a:ext>
+            </a:extLst>
+          </p:cNvPr>
+          <p:cNvSpPr>
+            <a:spLocks xmlns:a="http://schemas.openxmlformats.org/drawingml/2006/main" noGrp="1"/>
+          </p:cNvSpPr>
+          <p:nvPr/>
+        </p:nvSpPr>
+        <p:spPr>
+          <a:xfrm xmlns:a="http://schemas.openxmlformats.org/drawingml/2006/main">
+            <a:off x="457200" y="9906000"/>
+            <a:ext cx="17373600" cy="285750"/>
+          </a:xfrm>
+          <a:prstGeom xmlns:a="http://schemas.openxmlformats.org/drawingml/2006/main" prst="rect">
+            <a:avLst/>
+          </a:prstGeom>
+          <a:noFill xmlns:a="http://schemas.openxmlformats.org/drawingml/2006/main"/>
+          <a:ln xmlns:a="http://schemas.openxmlformats.org/drawingml/2006/main" w="0">
+            <a:noFill/>
+          </a:ln>
+        </p:spPr>
+        <p:txBody>
+          <a:bodyPr xmlns:a="http://schemas.openxmlformats.org/drawingml/2006/main" wrap="none" lIns="0" tIns="0" rIns="0" bIns="0">
+            <a:noAutofit/>
+          </a:bodyPr>
+          <a:lstStyle xmlns:a="http://schemas.openxmlformats.org/drawingml/2006/main"/>
+          <a:p xmlns:a="http://schemas.openxmlformats.org/drawingml/2006/main">
+            <a:pPr>
+              <a:defRPr sz="1650" b="0">
+                <a:solidFill>
+                  <a:srgbClr val="56606B"/>
+                </a:solidFill>
+                <a:latin typeface="Apple SD Gothic Neo"/>
+                <a:ea typeface="Apple SD Gothic Neo"/>
+                <a:cs typeface="Apple SD Gothic Neo"/>
+              </a:defRPr>
+            </a:pPr>
+            <a:r>
+              <a:rPr sz="1650" b="0">
+                <a:solidFill>
+                  <a:srgbClr val="56606B"/>
+                </a:solidFill>
+                <a:latin typeface="Apple SD Gothic Neo"/>
+                <a:ea typeface="Apple SD Gothic Neo"/>
+                <a:cs typeface="Apple SD Gothic Neo"/>
+              </a:rPr>
+              <a:t>03-02 §8.0에 사례별 횟수와 공통 사건 정의 / 비용은 USD/W100, 메모리는 MiB / 작성자 평가 예산</a:t>
+            </a:r>
+          </a:p>
+        </p:txBody>
+      </p:sp>
+    </p:spTree>
+    <p:extLst>
+      <p:ext uri="{BB962C8B-B14F-4D97-AF65-F5344CB8AC3E}">
+        <p14:creationId xmlns:p14="http://schemas.microsoft.com/office/powerpoint/2010/main" val="1312184762"/>
       </p:ext>
     </p:extLst>
   </p:cSld>

</xml_diff>

<commit_message>
docs: replace Groq QA reference with Gemini pricing and Live capability limits
</commit_message>
<xml_diff>
--- a/docs/presentations_files/quality-attributes/VIA-quality-attributes.pptx
+++ b/docs/presentations_files/quality-attributes/VIA-quality-attributes.pptx
@@ -2,18 +2,18 @@
 <file path=ppt/presentation.xml><?xml version="1.0" encoding="utf-8"?>
 <p:presentation xmlns:p="http://schemas.openxmlformats.org/presentationml/2006/main">
   <p:sldMasterIdLst>
-    <p:sldMasterId xmlns:r="http://schemas.openxmlformats.org/officeDocument/2006/relationships" id="2147483648" r:id="Rdb338020027a4cbf"/>
+    <p:sldMasterId xmlns:r="http://schemas.openxmlformats.org/officeDocument/2006/relationships" id="2147483648" r:id="R6ef4b54ff75845a4"/>
   </p:sldMasterIdLst>
   <p:notesMasterIdLst>
-    <p:notesMasterId xmlns:r="http://schemas.openxmlformats.org/officeDocument/2006/relationships" r:id="R3d69dfb7f3cb430e"/>
+    <p:notesMasterId xmlns:r="http://schemas.openxmlformats.org/officeDocument/2006/relationships" r:id="R2518308b863d468c"/>
   </p:notesMasterIdLst>
   <p:sldIdLst>
-    <p:sldId xmlns:r="http://schemas.openxmlformats.org/officeDocument/2006/relationships" id="256" r:id="Re9f0758f24a34aa5"/>
-    <p:sldId xmlns:r="http://schemas.openxmlformats.org/officeDocument/2006/relationships" id="257" r:id="R4bbea0536f414d85"/>
-    <p:sldId xmlns:r="http://schemas.openxmlformats.org/officeDocument/2006/relationships" id="258" r:id="R2111e12e2522440a"/>
-    <p:sldId xmlns:r="http://schemas.openxmlformats.org/officeDocument/2006/relationships" id="259" r:id="Rdf505f5260e64c61"/>
-    <p:sldId xmlns:r="http://schemas.openxmlformats.org/officeDocument/2006/relationships" id="260" r:id="R66a5380a92e645e9"/>
-    <p:sldId xmlns:r="http://schemas.openxmlformats.org/officeDocument/2006/relationships" id="261" r:id="R65c258277b3949c5"/>
+    <p:sldId xmlns:r="http://schemas.openxmlformats.org/officeDocument/2006/relationships" id="256" r:id="R8a278eb5dc3749bc"/>
+    <p:sldId xmlns:r="http://schemas.openxmlformats.org/officeDocument/2006/relationships" id="257" r:id="R6ba8debb836a48a4"/>
+    <p:sldId xmlns:r="http://schemas.openxmlformats.org/officeDocument/2006/relationships" id="258" r:id="R7e16c22dab894b56"/>
+    <p:sldId xmlns:r="http://schemas.openxmlformats.org/officeDocument/2006/relationships" id="259" r:id="Rdeef11fb06be41d9"/>
+    <p:sldId xmlns:r="http://schemas.openxmlformats.org/officeDocument/2006/relationships" id="260" r:id="Rb6196ba3407d4c3a"/>
+    <p:sldId xmlns:r="http://schemas.openxmlformats.org/officeDocument/2006/relationships" id="261" r:id="R3f65e2ee0369415c"/>
   </p:sldIdLst>
   <p:sldSz cx="18288000" cy="10287000"/>
   <p:notesSz cx="6858000" cy="9144000"/>
@@ -472,7 +472,7 @@
           </a:p>
           <a:p xmlns:a="http://schemas.openxmlformats.org/drawingml/2006/main">
             <a:r>
-              <a:t>원본 SHA-256: 199a8277dcefdd94f2cd470355c800923e9c2653b110e873dc3ae2bda5246895</a:t>
+              <a:t>원본 SHA-256: e89c163288eaeceeeea3e8a44ef56f903278aefd9c997db8756bcdd27170d1fa</a:t>
             </a:r>
           </a:p>
           <a:p xmlns:a="http://schemas.openxmlformats.org/drawingml/2006/main">
@@ -3172,7 +3172,7 @@
           </a:p>
           <a:p xmlns:a="http://schemas.openxmlformats.org/drawingml/2006/main">
             <a:r>
-              <a:t>Groq 공식 모델 단가/생성률: https://console.groq.com/docs/models</a:t>
+              <a:t>Google Gemini 3 Flash 공식 단가: https://ai.google.dev/gemini-api/docs/pricing#gemini-3-flash-preview</a:t>
             </a:r>
           </a:p>
           <a:p xmlns:a="http://schemas.openxmlformats.org/drawingml/2006/main">
@@ -3262,7 +3262,7 @@
           </a:p>
           <a:p xmlns:a="http://schemas.openxmlformats.org/drawingml/2006/main">
             <a:r>
-              <a:t>Nielsen의 0.1/1초는 참고 기준이며 평균과 95% 규칙은 작성자 예산이다. 예시 계산은 전사 0.10 + 첫 출력 0.30 + 100/450 생성 + 코드·읽기·확정 0.08 + 음성 0.25 = 0.9522초다. 450 token/s만 외부 참조이고 나머지는 가정이다. 의미 처리가 필요한 정정·질문·거부를 local stop로 대체하지 않는다.</a:t>
+              <a:t>Nielsen의 0.1/1초는 참고 기준이며 평균과 95% 규칙은 작성자 예산이다. Gemini 생성률 200 token/s를 비롯한 지연은 모두 작성자 가정이다. 전사 0.10 + 첫 출력 0.30 + 의미 출력 100/200 + 코드·읽기·확정 0.08 + 음성 0.25 = 1.23초로, 이 직렬 경로는 1초 예산을 넘는다. 유효한 반응에 필요한 의미 출력이 50 token인 경우에만 같은 가정에서 0.98초다. 따라서 필요한 의미를 유지한 짧은 출력, 입력 중 선행 처리 또는 병렬 경로가 목표를 충족하는지 실제 사례에서 확인해야 한다. 50 token은 전체 200 token 호출 예산을 일괄 축소하거나 placeholder를 정답으로 인정하는 규칙이 아니다. 의미 처리가 필요한 정정·질문·거부를 local stop로 대체하지 않는다.</a:t>
             </a:r>
           </a:p>
           <a:p xmlns:a="http://schemas.openxmlformats.org/drawingml/2006/main">
@@ -3462,7 +3462,7 @@
           </a:p>
           <a:p xmlns:a="http://schemas.openxmlformats.org/drawingml/2006/main">
             <a:r>
-              <a:t>Nielsen의 0.1/1초는 참고 기준이며 평균과 95% 규칙은 작성자 예산이다. 예시 계산은 전사 0.10 + 첫 출력 0.30 + 100/450 생성 + 코드·읽기·확정 0.08 + 음성 0.25 = 0.9522초다. 450 token/s만 외부 참조이고 나머지는 가정이다. 의미 처리가 필요한 정정·질문·거부를 local stop로 대체하지 않는다.</a:t>
+              <a:t>Nielsen의 0.1/1초는 참고 기준이며 평균과 95% 규칙은 작성자 예산이다. Gemini 생성률 200 token/s를 비롯한 지연은 모두 작성자 가정이다. 전사 0.10 + 첫 출력 0.30 + 의미 출력 100/200 + 코드·읽기·확정 0.08 + 음성 0.25 = 1.23초로, 이 직렬 경로는 1초 예산을 넘는다. 유효한 반응에 필요한 의미 출력이 50 token인 경우에만 같은 가정에서 0.98초다. 따라서 필요한 의미를 유지한 짧은 출력, 입력 중 선행 처리 또는 병렬 경로가 목표를 충족하는지 실제 사례에서 확인해야 한다. 50 token은 전체 200 token 호출 예산을 일괄 축소하거나 placeholder를 정답으로 인정하는 규칙이 아니다. 의미 처리가 필요한 정정·질문·거부를 local stop로 대체하지 않는다.</a:t>
             </a:r>
           </a:p>
           <a:p xmlns:a="http://schemas.openxmlformats.org/drawingml/2006/main">
@@ -6777,7 +6777,7 @@
           </a:p>
           <a:p xmlns:a="http://schemas.openxmlformats.org/drawingml/2006/main">
             <a:r>
-              <a:t>원본 SHA-256: 199a8277dcefdd94f2cd470355c800923e9c2653b110e873dc3ae2bda5246895</a:t>
+              <a:t>원본 SHA-256: e89c163288eaeceeeea3e8a44ef56f903278aefd9c997db8756bcdd27170d1fa</a:t>
             </a:r>
           </a:p>
           <a:p xmlns:a="http://schemas.openxmlformats.org/drawingml/2006/main">
@@ -6812,7 +6812,7 @@
           </a:p>
           <a:p xmlns:a="http://schemas.openxmlformats.org/drawingml/2006/main">
             <a:r>
-              <a:t>목표 근거: 동일 21사례의 의미 62호출/음성 입력 50초/출력 179초 예산에서 기본 $0.223167, 여유 $0.076833. 호출·출력은 작성자 가정이며 실제 사용량으로 대체 (§5)</a:t>
+              <a:t>목표 근거: 동일 21사례의 의미 62호출/음성 입력 50초/출력 179초 예산에서 기본 $0.173567, 여유 $0.126433. 호출·출력은 작성자 가정이며 실제 사용량으로 대체 (§5)</a:t>
             </a:r>
           </a:p>
           <a:p xmlns:a="http://schemas.openxmlformats.org/drawingml/2006/main">
@@ -6827,7 +6827,7 @@
           </a:p>
           <a:p xmlns:a="http://schemas.openxmlformats.org/drawingml/2006/main">
             <a:r>
-              <a:t>Groq 공식 모델 단가/생성률: https://console.groq.com/docs/models</a:t>
+              <a:t>Google Gemini 3 Flash 공식 단가: https://ai.google.dev/gemini-api/docs/pricing#gemini-3-flash-preview</a:t>
             </a:r>
           </a:p>
           <a:p xmlns:a="http://schemas.openxmlformats.org/drawingml/2006/main">
@@ -6932,7 +6932,7 @@
           </a:p>
           <a:p xmlns:a="http://schemas.openxmlformats.org/drawingml/2006/main">
             <a:r>
-              <a:t>| 의미62호출, 입력124,000/출력12,400 token | 0.148800 |</a:t>
+              <a:t>| 의미62호출, 입력124,000/출력12,400 token | 0.099200 |</a:t>
             </a:r>
           </a:p>
           <a:p xmlns:a="http://schemas.openxmlformats.org/drawingml/2006/main">
@@ -6947,12 +6947,12 @@
           </a:p>
           <a:p xmlns:a="http://schemas.openxmlformats.org/drawingml/2006/main">
             <a:r>
-              <a:t>| 기본 총액 | **0.223167** |</a:t>
-            </a:r>
-          </a:p>
-          <a:p xmlns:a="http://schemas.openxmlformats.org/drawingml/2006/main">
-            <a:r>
-              <a:t>| 초기/추가생산/재시도 여유 | **0.076833** |</a:t>
+              <a:t>| 기본 총액 | **0.173567** |</a:t>
+            </a:r>
+          </a:p>
+          <a:p xmlns:a="http://schemas.openxmlformats.org/drawingml/2006/main">
+            <a:r>
+              <a:t>| 초기/추가생산/재시도 여유 | **0.126433** |</a:t>
             </a:r>
           </a:p>
           <a:p xmlns:a="http://schemas.openxmlformats.org/drawingml/2006/main">
@@ -6967,7 +6967,7 @@
           </a:p>
           <a:p xmlns:a="http://schemas.openxmlformats.org/drawingml/2006/main">
             <a:r>
-              <a:t>W100의 $1.50를 새 묶음에 그대로 적용하지 않고 동일 P21 사용량에서 다시 계산했다. 기본 대비 약 34.43%의 추가 여유를 둔 작성자 평가 예산이며 상품 가격이나 모델 성능 보장이 아니다. Source 변경 4건이 모델 생산 4호출을 강제하지 않는다. 실제 backfill·추가 질문·재시도가 많으면 목표 미달을 그대로 보고한다.</a:t>
+              <a:t>W100의 $1.50를 새 묶음에 그대로 적용하지 않고 동일 P21 사용량에서 다시 계산했다. 기본 대비 약 72.84%의 추가 여유를 둔 작성자 평가 예산이며 상품 가격이나 모델 성능 보장이 아니다. Source 변경 4건이 모델 생산 4호출을 강제하지 않는다. 실제 backfill·추가 질문·재시도가 많으면 목표 미달을 그대로 보고한다.</a:t>
             </a:r>
           </a:p>
           <a:p xmlns:a="http://schemas.openxmlformats.org/drawingml/2006/main">
@@ -11002,7 +11002,7 @@
           </a:p>
           <a:p xmlns:a="http://schemas.openxmlformats.org/drawingml/2006/main">
             <a:r>
-              <a:t>원본 SHA-256: 199a8277dcefdd94f2cd470355c800923e9c2653b110e873dc3ae2bda5246895</a:t>
+              <a:t>원본 SHA-256: e89c163288eaeceeeea3e8a44ef56f903278aefd9c997db8756bcdd27170d1fa</a:t>
             </a:r>
           </a:p>
           <a:p xmlns:a="http://schemas.openxmlformats.org/drawingml/2006/main">
@@ -14262,7 +14262,7 @@
           </a:p>
           <a:p xmlns:a="http://schemas.openxmlformats.org/drawingml/2006/main">
             <a:r>
-              <a:t>원본 SHA-256: 199a8277dcefdd94f2cd470355c800923e9c2653b110e873dc3ae2bda5246895</a:t>
+              <a:t>원본 SHA-256: e89c163288eaeceeeea3e8a44ef56f903278aefd9c997db8756bcdd27170d1fa</a:t>
             </a:r>
           </a:p>
           <a:p xmlns:a="http://schemas.openxmlformats.org/drawingml/2006/main">
@@ -17522,7 +17522,7 @@
           </a:p>
           <a:p xmlns:a="http://schemas.openxmlformats.org/drawingml/2006/main">
             <a:r>
-              <a:t>원본 SHA-256: 199a8277dcefdd94f2cd470355c800923e9c2653b110e873dc3ae2bda5246895</a:t>
+              <a:t>원본 SHA-256: e89c163288eaeceeeea3e8a44ef56f903278aefd9c997db8756bcdd27170d1fa</a:t>
             </a:r>
           </a:p>
           <a:p xmlns:a="http://schemas.openxmlformats.org/drawingml/2006/main">
@@ -20782,7 +20782,7 @@
           </a:p>
           <a:p xmlns:a="http://schemas.openxmlformats.org/drawingml/2006/main">
             <a:r>
-              <a:t>원본 SHA-256: 199a8277dcefdd94f2cd470355c800923e9c2653b110e873dc3ae2bda5246895</a:t>
+              <a:t>원본 SHA-256: e89c163288eaeceeeea3e8a44ef56f903278aefd9c997db8756bcdd27170d1fa</a:t>
             </a:r>
           </a:p>
           <a:p xmlns:a="http://schemas.openxmlformats.org/drawingml/2006/main">
@@ -24015,7 +24015,7 @@
   </p:cSld>
   <p:clrMap bg1="lt1" tx1="dk1" bg2="lt2" tx2="dk2" accent1="accent1" accent2="accent2" accent3="accent3" accent4="accent4" accent5="accent5" accent6="accent6" hlink="hlink" folHlink="folHlink"/>
   <p:sldLayoutIdLst>
-    <p:sldLayoutId xmlns:r="http://schemas.openxmlformats.org/officeDocument/2006/relationships" id="2147483649" r:id="R736ddff16ac34c65"/>
+    <p:sldLayoutId xmlns:r="http://schemas.openxmlformats.org/officeDocument/2006/relationships" id="2147483649" r:id="R22f28c94f3ef4210"/>
   </p:sldLayoutIdLst>
   <p:txStyles>
     <p:titleStyle>
@@ -24566,7 +24566,7 @@
           <p:cNvPr id="8" name="title">
             <a:extLst xmlns:a="http://schemas.openxmlformats.org/drawingml/2006/main">
               <a:ext uri="{FF2B5EF4-FFF2-40B4-BE49-F238E27FC236}">
-                <a16:creationId xmlns:a16="http://schemas.microsoft.com/office/drawing/2014/main" id="{471E296E-CD6E-43A5-8411-762372434639}"/>
+                <a16:creationId xmlns:a16="http://schemas.microsoft.com/office/drawing/2014/main" id="{01A40800-1D08-4B9F-BFC4-59C00ED6CA1D}"/>
               </a:ext>
             </a:extLst>
           </p:cNvPr>
@@ -24623,7 +24623,7 @@
           <p:cNvPr id="2" name="header-rule">
             <a:extLst xmlns:a="http://schemas.openxmlformats.org/drawingml/2006/main">
               <a:ext uri="{FF2B5EF4-FFF2-40B4-BE49-F238E27FC236}">
-                <a16:creationId xmlns:a16="http://schemas.microsoft.com/office/drawing/2014/main" id="{DE8E2894-D1E0-43D7-9A0D-E246C2AB8762}"/>
+                <a16:creationId xmlns:a16="http://schemas.microsoft.com/office/drawing/2014/main" id="{2E10C026-1712-491B-B782-F7D4758E7D34}"/>
               </a:ext>
             </a:extLst>
           </p:cNvPr>
@@ -24653,7 +24653,7 @@
           <p:cNvPr id="3" name="page">
             <a:extLst xmlns:a="http://schemas.openxmlformats.org/drawingml/2006/main">
               <a:ext uri="{FF2B5EF4-FFF2-40B4-BE49-F238E27FC236}">
-                <a16:creationId xmlns:a16="http://schemas.microsoft.com/office/drawing/2014/main" id="{78D0E683-2586-4CDF-8F6B-E0E4581599DE}"/>
+                <a16:creationId xmlns:a16="http://schemas.microsoft.com/office/drawing/2014/main" id="{E3A4CF3D-D86C-4ADA-9B83-1B4AB8D9FD35}"/>
               </a:ext>
             </a:extLst>
           </p:cNvPr>
@@ -24710,7 +24710,7 @@
           <p:cNvPr id="4" name="headline">
             <a:extLst xmlns:a="http://schemas.openxmlformats.org/drawingml/2006/main">
               <a:ext uri="{FF2B5EF4-FFF2-40B4-BE49-F238E27FC236}">
-                <a16:creationId xmlns:a16="http://schemas.microsoft.com/office/drawing/2014/main" id="{D6EB663F-E77D-4EE2-8F58-2EC52D7EFCB9}"/>
+                <a16:creationId xmlns:a16="http://schemas.microsoft.com/office/drawing/2014/main" id="{292B725C-079B-4CCC-94AF-C428048EF712}"/>
               </a:ext>
             </a:extLst>
           </p:cNvPr>
@@ -24767,7 +24767,7 @@
           <p:cNvPr id="5" name="scope">
             <a:extLst xmlns:a="http://schemas.openxmlformats.org/drawingml/2006/main">
               <a:ext uri="{FF2B5EF4-FFF2-40B4-BE49-F238E27FC236}">
-                <a16:creationId xmlns:a16="http://schemas.microsoft.com/office/drawing/2014/main" id="{57088F58-8AA7-4D6F-9023-3A39E09AF080}"/>
+                <a16:creationId xmlns:a16="http://schemas.microsoft.com/office/drawing/2014/main" id="{D107C5B8-31A9-4D83-A7AF-42EA263BAE1A}"/>
               </a:ext>
             </a:extLst>
           </p:cNvPr>
@@ -25525,7 +25525,7 @@
           <p:cNvPr id="7" name="footer">
             <a:extLst xmlns:a="http://schemas.openxmlformats.org/drawingml/2006/main">
               <a:ext uri="{FF2B5EF4-FFF2-40B4-BE49-F238E27FC236}">
-                <a16:creationId xmlns:a16="http://schemas.microsoft.com/office/drawing/2014/main" id="{437D300C-64ED-4372-8396-21C076469DA4}"/>
+                <a16:creationId xmlns:a16="http://schemas.microsoft.com/office/drawing/2014/main" id="{9F9C085A-F731-43F0-B741-56F360529B06}"/>
               </a:ext>
             </a:extLst>
           </p:cNvPr>
@@ -25580,7 +25580,7 @@
     </p:spTree>
     <p:extLst>
       <p:ext uri="{BB962C8B-B14F-4D97-AF65-F5344CB8AC3E}">
-        <p14:creationId xmlns:p14="http://schemas.microsoft.com/office/powerpoint/2010/main" val="905329615"/>
+        <p14:creationId xmlns:p14="http://schemas.microsoft.com/office/powerpoint/2010/main" val="371557259"/>
       </p:ext>
     </p:extLst>
   </p:cSld>
@@ -25611,7 +25611,7 @@
           <p:cNvPr id="8" name="title">
             <a:extLst xmlns:a="http://schemas.openxmlformats.org/drawingml/2006/main">
               <a:ext uri="{FF2B5EF4-FFF2-40B4-BE49-F238E27FC236}">
-                <a16:creationId xmlns:a16="http://schemas.microsoft.com/office/drawing/2014/main" id="{774B63D5-BA39-431A-A829-3FFF8C4B42E4}"/>
+                <a16:creationId xmlns:a16="http://schemas.microsoft.com/office/drawing/2014/main" id="{A48A87DD-CB1C-4129-AF57-602CA23DEEA3}"/>
               </a:ext>
             </a:extLst>
           </p:cNvPr>
@@ -25668,7 +25668,7 @@
           <p:cNvPr id="2" name="header-rule">
             <a:extLst xmlns:a="http://schemas.openxmlformats.org/drawingml/2006/main">
               <a:ext uri="{FF2B5EF4-FFF2-40B4-BE49-F238E27FC236}">
-                <a16:creationId xmlns:a16="http://schemas.microsoft.com/office/drawing/2014/main" id="{2A53B135-BE27-4B35-92B0-90A1D51BC96C}"/>
+                <a16:creationId xmlns:a16="http://schemas.microsoft.com/office/drawing/2014/main" id="{729F2F94-1E00-4A1F-AEB6-890BBB38F6B5}"/>
               </a:ext>
             </a:extLst>
           </p:cNvPr>
@@ -25698,7 +25698,7 @@
           <p:cNvPr id="3" name="page">
             <a:extLst xmlns:a="http://schemas.openxmlformats.org/drawingml/2006/main">
               <a:ext uri="{FF2B5EF4-FFF2-40B4-BE49-F238E27FC236}">
-                <a16:creationId xmlns:a16="http://schemas.microsoft.com/office/drawing/2014/main" id="{ADDE07F8-8150-406F-8714-972E3B9430F7}"/>
+                <a16:creationId xmlns:a16="http://schemas.microsoft.com/office/drawing/2014/main" id="{3D1F658F-4357-4165-9148-2E47501471D1}"/>
               </a:ext>
             </a:extLst>
           </p:cNvPr>
@@ -25755,7 +25755,7 @@
           <p:cNvPr id="4" name="headline">
             <a:extLst xmlns:a="http://schemas.openxmlformats.org/drawingml/2006/main">
               <a:ext uri="{FF2B5EF4-FFF2-40B4-BE49-F238E27FC236}">
-                <a16:creationId xmlns:a16="http://schemas.microsoft.com/office/drawing/2014/main" id="{009DA816-E752-470B-91EB-B27CDC854775}"/>
+                <a16:creationId xmlns:a16="http://schemas.microsoft.com/office/drawing/2014/main" id="{2B1AFE9D-A262-4AFA-91D7-8BE8B47ED968}"/>
               </a:ext>
             </a:extLst>
           </p:cNvPr>
@@ -25812,7 +25812,7 @@
           <p:cNvPr id="5" name="scope">
             <a:extLst xmlns:a="http://schemas.openxmlformats.org/drawingml/2006/main">
               <a:ext uri="{FF2B5EF4-FFF2-40B4-BE49-F238E27FC236}">
-                <a16:creationId xmlns:a16="http://schemas.microsoft.com/office/drawing/2014/main" id="{A37AEB9F-0C62-4D83-98C9-F36F3EE912E9}"/>
+                <a16:creationId xmlns:a16="http://schemas.microsoft.com/office/drawing/2014/main" id="{E6C11848-0FDE-43CD-BA78-961F9AC117E3}"/>
               </a:ext>
             </a:extLst>
           </p:cNvPr>
@@ -26173,7 +26173,7 @@
                           <a:ea typeface="Apple SD Gothic Neo"/>
                           <a:cs typeface="Apple SD Gothic Neo"/>
                         </a:rPr>
-                        <a:t>근거: 기본 $0.223167 + 추가 생산/재시도 여유 $0.076833</a:t>
+                        <a:t>근거: 기본 $0.173567 + 추가 생산/재시도 여유 $0.126433</a:t>
                       </a:r>
                     </a:p>
                   </a:txBody>
@@ -26598,7 +26598,7 @@
           <p:cNvPr id="7" name="footer">
             <a:extLst xmlns:a="http://schemas.openxmlformats.org/drawingml/2006/main">
               <a:ext uri="{FF2B5EF4-FFF2-40B4-BE49-F238E27FC236}">
-                <a16:creationId xmlns:a16="http://schemas.microsoft.com/office/drawing/2014/main" id="{997202D6-E861-4529-9968-BBA7E09E45DB}"/>
+                <a16:creationId xmlns:a16="http://schemas.microsoft.com/office/drawing/2014/main" id="{8DA4B4D0-45E1-418A-AACD-8096F775A15B}"/>
               </a:ext>
             </a:extLst>
           </p:cNvPr>
@@ -26653,7 +26653,7 @@
     </p:spTree>
     <p:extLst>
       <p:ext uri="{BB962C8B-B14F-4D97-AF65-F5344CB8AC3E}">
-        <p14:creationId xmlns:p14="http://schemas.microsoft.com/office/powerpoint/2010/main" val="1857330174"/>
+        <p14:creationId xmlns:p14="http://schemas.microsoft.com/office/powerpoint/2010/main" val="1438102545"/>
       </p:ext>
     </p:extLst>
   </p:cSld>
@@ -26684,7 +26684,7 @@
           <p:cNvPr id="8" name="title">
             <a:extLst xmlns:a="http://schemas.openxmlformats.org/drawingml/2006/main">
               <a:ext uri="{FF2B5EF4-FFF2-40B4-BE49-F238E27FC236}">
-                <a16:creationId xmlns:a16="http://schemas.microsoft.com/office/drawing/2014/main" id="{234E718D-6A83-489E-A545-BB5D797C4575}"/>
+                <a16:creationId xmlns:a16="http://schemas.microsoft.com/office/drawing/2014/main" id="{ECFFFAB3-0863-44D6-AA74-D862C82BA11F}"/>
               </a:ext>
             </a:extLst>
           </p:cNvPr>
@@ -26741,7 +26741,7 @@
           <p:cNvPr id="2" name="header-rule">
             <a:extLst xmlns:a="http://schemas.openxmlformats.org/drawingml/2006/main">
               <a:ext uri="{FF2B5EF4-FFF2-40B4-BE49-F238E27FC236}">
-                <a16:creationId xmlns:a16="http://schemas.microsoft.com/office/drawing/2014/main" id="{11D047B2-717D-4575-B2E2-51D8A63A37F2}"/>
+                <a16:creationId xmlns:a16="http://schemas.microsoft.com/office/drawing/2014/main" id="{ED13E0D7-5F3B-4DB8-B56E-5E7BB7368F89}"/>
               </a:ext>
             </a:extLst>
           </p:cNvPr>
@@ -26771,7 +26771,7 @@
           <p:cNvPr id="3" name="page">
             <a:extLst xmlns:a="http://schemas.openxmlformats.org/drawingml/2006/main">
               <a:ext uri="{FF2B5EF4-FFF2-40B4-BE49-F238E27FC236}">
-                <a16:creationId xmlns:a16="http://schemas.microsoft.com/office/drawing/2014/main" id="{983462D7-77C7-4403-A210-C8DF65A46C71}"/>
+                <a16:creationId xmlns:a16="http://schemas.microsoft.com/office/drawing/2014/main" id="{04C168BF-42F8-45FC-9E95-7555D0EAB55E}"/>
               </a:ext>
             </a:extLst>
           </p:cNvPr>
@@ -26828,7 +26828,7 @@
           <p:cNvPr id="4" name="headline">
             <a:extLst xmlns:a="http://schemas.openxmlformats.org/drawingml/2006/main">
               <a:ext uri="{FF2B5EF4-FFF2-40B4-BE49-F238E27FC236}">
-                <a16:creationId xmlns:a16="http://schemas.microsoft.com/office/drawing/2014/main" id="{F8504D35-8965-443C-8DB1-0007A3AD8456}"/>
+                <a16:creationId xmlns:a16="http://schemas.microsoft.com/office/drawing/2014/main" id="{F0F77C51-5416-49BC-96B3-BFEF8B84F699}"/>
               </a:ext>
             </a:extLst>
           </p:cNvPr>
@@ -26885,7 +26885,7 @@
           <p:cNvPr id="5" name="scope">
             <a:extLst xmlns:a="http://schemas.openxmlformats.org/drawingml/2006/main">
               <a:ext uri="{FF2B5EF4-FFF2-40B4-BE49-F238E27FC236}">
-                <a16:creationId xmlns:a16="http://schemas.microsoft.com/office/drawing/2014/main" id="{B743042B-11DB-420E-B21C-957FD58E0118}"/>
+                <a16:creationId xmlns:a16="http://schemas.microsoft.com/office/drawing/2014/main" id="{FAD4B9ED-2445-4629-AC7C-85659DBE6264}"/>
               </a:ext>
             </a:extLst>
           </p:cNvPr>
@@ -27672,7 +27672,7 @@
           <p:cNvPr id="7" name="footer">
             <a:extLst xmlns:a="http://schemas.openxmlformats.org/drawingml/2006/main">
               <a:ext uri="{FF2B5EF4-FFF2-40B4-BE49-F238E27FC236}">
-                <a16:creationId xmlns:a16="http://schemas.microsoft.com/office/drawing/2014/main" id="{B06D0D60-3713-418E-A130-0C3747B4E804}"/>
+                <a16:creationId xmlns:a16="http://schemas.microsoft.com/office/drawing/2014/main" id="{921F85A3-C9BF-4172-943A-5D0429244656}"/>
               </a:ext>
             </a:extLst>
           </p:cNvPr>
@@ -27727,7 +27727,7 @@
     </p:spTree>
     <p:extLst>
       <p:ext uri="{BB962C8B-B14F-4D97-AF65-F5344CB8AC3E}">
-        <p14:creationId xmlns:p14="http://schemas.microsoft.com/office/powerpoint/2010/main" val="869638352"/>
+        <p14:creationId xmlns:p14="http://schemas.microsoft.com/office/powerpoint/2010/main" val="1267817231"/>
       </p:ext>
     </p:extLst>
   </p:cSld>
@@ -27758,7 +27758,7 @@
           <p:cNvPr id="8" name="title">
             <a:extLst xmlns:a="http://schemas.openxmlformats.org/drawingml/2006/main">
               <a:ext uri="{FF2B5EF4-FFF2-40B4-BE49-F238E27FC236}">
-                <a16:creationId xmlns:a16="http://schemas.microsoft.com/office/drawing/2014/main" id="{7F9700CD-7BA7-418D-8560-4E545AF66A8E}"/>
+                <a16:creationId xmlns:a16="http://schemas.microsoft.com/office/drawing/2014/main" id="{5C350B14-2BB9-461C-949A-68142AAE655E}"/>
               </a:ext>
             </a:extLst>
           </p:cNvPr>
@@ -27815,7 +27815,7 @@
           <p:cNvPr id="2" name="header-rule">
             <a:extLst xmlns:a="http://schemas.openxmlformats.org/drawingml/2006/main">
               <a:ext uri="{FF2B5EF4-FFF2-40B4-BE49-F238E27FC236}">
-                <a16:creationId xmlns:a16="http://schemas.microsoft.com/office/drawing/2014/main" id="{39BEDDE6-4E21-4825-8A70-7F1CBAE5B6A3}"/>
+                <a16:creationId xmlns:a16="http://schemas.microsoft.com/office/drawing/2014/main" id="{6789A051-A02F-4113-A99B-D26701672FB3}"/>
               </a:ext>
             </a:extLst>
           </p:cNvPr>
@@ -27845,7 +27845,7 @@
           <p:cNvPr id="3" name="page">
             <a:extLst xmlns:a="http://schemas.openxmlformats.org/drawingml/2006/main">
               <a:ext uri="{FF2B5EF4-FFF2-40B4-BE49-F238E27FC236}">
-                <a16:creationId xmlns:a16="http://schemas.microsoft.com/office/drawing/2014/main" id="{D09AE70C-6745-468B-A86A-F1EA05AD06C5}"/>
+                <a16:creationId xmlns:a16="http://schemas.microsoft.com/office/drawing/2014/main" id="{FE2A1DE0-D2CB-4454-9812-F4F5DE9E1874}"/>
               </a:ext>
             </a:extLst>
           </p:cNvPr>
@@ -27902,7 +27902,7 @@
           <p:cNvPr id="4" name="headline">
             <a:extLst xmlns:a="http://schemas.openxmlformats.org/drawingml/2006/main">
               <a:ext uri="{FF2B5EF4-FFF2-40B4-BE49-F238E27FC236}">
-                <a16:creationId xmlns:a16="http://schemas.microsoft.com/office/drawing/2014/main" id="{7D8693BC-0AE3-4186-A82A-4C801FC24EC4}"/>
+                <a16:creationId xmlns:a16="http://schemas.microsoft.com/office/drawing/2014/main" id="{8D4F0420-4617-4097-81E2-751518B6B232}"/>
               </a:ext>
             </a:extLst>
           </p:cNvPr>
@@ -27959,7 +27959,7 @@
           <p:cNvPr id="5" name="scope">
             <a:extLst xmlns:a="http://schemas.openxmlformats.org/drawingml/2006/main">
               <a:ext uri="{FF2B5EF4-FFF2-40B4-BE49-F238E27FC236}">
-                <a16:creationId xmlns:a16="http://schemas.microsoft.com/office/drawing/2014/main" id="{9C2EEF8B-9E9B-4C3E-8497-5221D5E1A6C7}"/>
+                <a16:creationId xmlns:a16="http://schemas.microsoft.com/office/drawing/2014/main" id="{E4B2D0BD-9530-4B94-8C86-50BEF00D3ADE}"/>
               </a:ext>
             </a:extLst>
           </p:cNvPr>
@@ -29253,7 +29253,7 @@
           <p:cNvPr id="7" name="footer">
             <a:extLst xmlns:a="http://schemas.openxmlformats.org/drawingml/2006/main">
               <a:ext uri="{FF2B5EF4-FFF2-40B4-BE49-F238E27FC236}">
-                <a16:creationId xmlns:a16="http://schemas.microsoft.com/office/drawing/2014/main" id="{56997F91-AD4A-439D-8F47-C12EBDF55D30}"/>
+                <a16:creationId xmlns:a16="http://schemas.microsoft.com/office/drawing/2014/main" id="{75629E1B-F08A-48C4-87DA-6FE6359B93B0}"/>
               </a:ext>
             </a:extLst>
           </p:cNvPr>
@@ -29308,7 +29308,7 @@
     </p:spTree>
     <p:extLst>
       <p:ext uri="{BB962C8B-B14F-4D97-AF65-F5344CB8AC3E}">
-        <p14:creationId xmlns:p14="http://schemas.microsoft.com/office/powerpoint/2010/main" val="1900876119"/>
+        <p14:creationId xmlns:p14="http://schemas.microsoft.com/office/powerpoint/2010/main" val="410058508"/>
       </p:ext>
     </p:extLst>
   </p:cSld>
@@ -29339,7 +29339,7 @@
           <p:cNvPr id="8" name="title">
             <a:extLst xmlns:a="http://schemas.openxmlformats.org/drawingml/2006/main">
               <a:ext uri="{FF2B5EF4-FFF2-40B4-BE49-F238E27FC236}">
-                <a16:creationId xmlns:a16="http://schemas.microsoft.com/office/drawing/2014/main" id="{C4E089AC-B2F5-45F9-9CA4-93645CB0C8D0}"/>
+                <a16:creationId xmlns:a16="http://schemas.microsoft.com/office/drawing/2014/main" id="{2A948F48-7D32-47E0-A16F-43CA0B5A6202}"/>
               </a:ext>
             </a:extLst>
           </p:cNvPr>
@@ -29396,7 +29396,7 @@
           <p:cNvPr id="2" name="header-rule">
             <a:extLst xmlns:a="http://schemas.openxmlformats.org/drawingml/2006/main">
               <a:ext uri="{FF2B5EF4-FFF2-40B4-BE49-F238E27FC236}">
-                <a16:creationId xmlns:a16="http://schemas.microsoft.com/office/drawing/2014/main" id="{389AD7F6-CCD5-458B-92D1-FE5F135ACFC1}"/>
+                <a16:creationId xmlns:a16="http://schemas.microsoft.com/office/drawing/2014/main" id="{0D74018C-F595-48B7-9626-6071EBCFBFE5}"/>
               </a:ext>
             </a:extLst>
           </p:cNvPr>
@@ -29426,7 +29426,7 @@
           <p:cNvPr id="3" name="page">
             <a:extLst xmlns:a="http://schemas.openxmlformats.org/drawingml/2006/main">
               <a:ext uri="{FF2B5EF4-FFF2-40B4-BE49-F238E27FC236}">
-                <a16:creationId xmlns:a16="http://schemas.microsoft.com/office/drawing/2014/main" id="{930D6139-2C5C-498F-8964-82C5CFC53E5F}"/>
+                <a16:creationId xmlns:a16="http://schemas.microsoft.com/office/drawing/2014/main" id="{FFC771F1-4BC7-4090-8C7A-767272D4B7A4}"/>
               </a:ext>
             </a:extLst>
           </p:cNvPr>
@@ -29483,7 +29483,7 @@
           <p:cNvPr id="4" name="headline">
             <a:extLst xmlns:a="http://schemas.openxmlformats.org/drawingml/2006/main">
               <a:ext uri="{FF2B5EF4-FFF2-40B4-BE49-F238E27FC236}">
-                <a16:creationId xmlns:a16="http://schemas.microsoft.com/office/drawing/2014/main" id="{CC55E19D-3CDD-4CB5-B312-5811BF336DCA}"/>
+                <a16:creationId xmlns:a16="http://schemas.microsoft.com/office/drawing/2014/main" id="{2F707774-A715-4BF2-89B2-28D965977A26}"/>
               </a:ext>
             </a:extLst>
           </p:cNvPr>
@@ -29540,7 +29540,7 @@
           <p:cNvPr id="5" name="scope">
             <a:extLst xmlns:a="http://schemas.openxmlformats.org/drawingml/2006/main">
               <a:ext uri="{FF2B5EF4-FFF2-40B4-BE49-F238E27FC236}">
-                <a16:creationId xmlns:a16="http://schemas.microsoft.com/office/drawing/2014/main" id="{E44F1FC2-59D0-43BD-BAEA-0608D5C22C94}"/>
+                <a16:creationId xmlns:a16="http://schemas.microsoft.com/office/drawing/2014/main" id="{9E774550-2D49-4107-B3DC-E7CFCE3E2EB4}"/>
               </a:ext>
             </a:extLst>
           </p:cNvPr>
@@ -30848,7 +30848,7 @@
           <p:cNvPr id="7" name="footer">
             <a:extLst xmlns:a="http://schemas.openxmlformats.org/drawingml/2006/main">
               <a:ext uri="{FF2B5EF4-FFF2-40B4-BE49-F238E27FC236}">
-                <a16:creationId xmlns:a16="http://schemas.microsoft.com/office/drawing/2014/main" id="{5672B6FB-56C6-4B68-926E-CC546731197C}"/>
+                <a16:creationId xmlns:a16="http://schemas.microsoft.com/office/drawing/2014/main" id="{42276120-A97B-4038-9546-9A4891053912}"/>
               </a:ext>
             </a:extLst>
           </p:cNvPr>
@@ -30903,7 +30903,7 @@
     </p:spTree>
     <p:extLst>
       <p:ext uri="{BB962C8B-B14F-4D97-AF65-F5344CB8AC3E}">
-        <p14:creationId xmlns:p14="http://schemas.microsoft.com/office/powerpoint/2010/main" val="1365331239"/>
+        <p14:creationId xmlns:p14="http://schemas.microsoft.com/office/powerpoint/2010/main" val="891173581"/>
       </p:ext>
     </p:extLst>
   </p:cSld>
@@ -30934,7 +30934,7 @@
           <p:cNvPr id="8" name="title">
             <a:extLst xmlns:a="http://schemas.openxmlformats.org/drawingml/2006/main">
               <a:ext uri="{FF2B5EF4-FFF2-40B4-BE49-F238E27FC236}">
-                <a16:creationId xmlns:a16="http://schemas.microsoft.com/office/drawing/2014/main" id="{2BC367AF-7FAF-456E-8824-0D7C30D196D2}"/>
+                <a16:creationId xmlns:a16="http://schemas.microsoft.com/office/drawing/2014/main" id="{A8F4C509-59F5-4885-B3D0-37536C2A65B9}"/>
               </a:ext>
             </a:extLst>
           </p:cNvPr>
@@ -30991,7 +30991,7 @@
           <p:cNvPr id="2" name="header-rule">
             <a:extLst xmlns:a="http://schemas.openxmlformats.org/drawingml/2006/main">
               <a:ext uri="{FF2B5EF4-FFF2-40B4-BE49-F238E27FC236}">
-                <a16:creationId xmlns:a16="http://schemas.microsoft.com/office/drawing/2014/main" id="{05749FAE-4B5F-4289-B548-F161FEDF32DA}"/>
+                <a16:creationId xmlns:a16="http://schemas.microsoft.com/office/drawing/2014/main" id="{5F01649B-686E-4B59-B054-7585573B8DF2}"/>
               </a:ext>
             </a:extLst>
           </p:cNvPr>
@@ -31021,7 +31021,7 @@
           <p:cNvPr id="3" name="page">
             <a:extLst xmlns:a="http://schemas.openxmlformats.org/drawingml/2006/main">
               <a:ext uri="{FF2B5EF4-FFF2-40B4-BE49-F238E27FC236}">
-                <a16:creationId xmlns:a16="http://schemas.microsoft.com/office/drawing/2014/main" id="{8D5506A6-B2AA-49C4-AA2A-8C1C74258838}"/>
+                <a16:creationId xmlns:a16="http://schemas.microsoft.com/office/drawing/2014/main" id="{777F954D-385C-4641-910F-25FF0E3BB2FF}"/>
               </a:ext>
             </a:extLst>
           </p:cNvPr>
@@ -31078,7 +31078,7 @@
           <p:cNvPr id="4" name="headline">
             <a:extLst xmlns:a="http://schemas.openxmlformats.org/drawingml/2006/main">
               <a:ext uri="{FF2B5EF4-FFF2-40B4-BE49-F238E27FC236}">
-                <a16:creationId xmlns:a16="http://schemas.microsoft.com/office/drawing/2014/main" id="{C0CE7EC8-27F6-4844-9076-578F11CA15A0}"/>
+                <a16:creationId xmlns:a16="http://schemas.microsoft.com/office/drawing/2014/main" id="{37CCE702-BA5D-4D12-A1D7-D8B4D1A15A5B}"/>
               </a:ext>
             </a:extLst>
           </p:cNvPr>
@@ -31135,7 +31135,7 @@
           <p:cNvPr id="5" name="scope">
             <a:extLst xmlns:a="http://schemas.openxmlformats.org/drawingml/2006/main">
               <a:ext uri="{FF2B5EF4-FFF2-40B4-BE49-F238E27FC236}">
-                <a16:creationId xmlns:a16="http://schemas.microsoft.com/office/drawing/2014/main" id="{29A3AE70-E774-4627-AC11-A9CD88F2EC89}"/>
+                <a16:creationId xmlns:a16="http://schemas.microsoft.com/office/drawing/2014/main" id="{F071CAE0-AB91-4CA2-8EC4-8B54F5B3F2B9}"/>
               </a:ext>
             </a:extLst>
           </p:cNvPr>
@@ -32471,7 +32471,7 @@
           <p:cNvPr id="7" name="footer">
             <a:extLst xmlns:a="http://schemas.openxmlformats.org/drawingml/2006/main">
               <a:ext uri="{FF2B5EF4-FFF2-40B4-BE49-F238E27FC236}">
-                <a16:creationId xmlns:a16="http://schemas.microsoft.com/office/drawing/2014/main" id="{B5AA1C72-7C64-47E9-B12B-9F0BB7853778}"/>
+                <a16:creationId xmlns:a16="http://schemas.microsoft.com/office/drawing/2014/main" id="{EA7DFB65-37C5-4BF8-8BAB-30090743ED19}"/>
               </a:ext>
             </a:extLst>
           </p:cNvPr>
@@ -32526,7 +32526,7 @@
     </p:spTree>
     <p:extLst>
       <p:ext uri="{BB962C8B-B14F-4D97-AF65-F5344CB8AC3E}">
-        <p14:creationId xmlns:p14="http://schemas.microsoft.com/office/powerpoint/2010/main" val="1813037975"/>
+        <p14:creationId xmlns:p14="http://schemas.microsoft.com/office/powerpoint/2010/main" val="1203299029"/>
       </p:ext>
     </p:extLst>
   </p:cSld>

</xml_diff>

<commit_message>
docs: use GPT Realtime voice reference and document Qwen pricing benchmarks
</commit_message>
<xml_diff>
--- a/docs/presentations_files/quality-attributes/VIA-quality-attributes.pptx
+++ b/docs/presentations_files/quality-attributes/VIA-quality-attributes.pptx
@@ -2,18 +2,18 @@
 <file path=ppt/presentation.xml><?xml version="1.0" encoding="utf-8"?>
 <p:presentation xmlns:p="http://schemas.openxmlformats.org/presentationml/2006/main">
   <p:sldMasterIdLst>
-    <p:sldMasterId xmlns:r="http://schemas.openxmlformats.org/officeDocument/2006/relationships" id="2147483648" r:id="R6ef4b54ff75845a4"/>
+    <p:sldMasterId xmlns:r="http://schemas.openxmlformats.org/officeDocument/2006/relationships" id="2147483648" r:id="Ra9cd6f0fea754559"/>
   </p:sldMasterIdLst>
   <p:notesMasterIdLst>
-    <p:notesMasterId xmlns:r="http://schemas.openxmlformats.org/officeDocument/2006/relationships" r:id="R2518308b863d468c"/>
+    <p:notesMasterId xmlns:r="http://schemas.openxmlformats.org/officeDocument/2006/relationships" r:id="R6fa42f2316834f57"/>
   </p:notesMasterIdLst>
   <p:sldIdLst>
-    <p:sldId xmlns:r="http://schemas.openxmlformats.org/officeDocument/2006/relationships" id="256" r:id="R8a278eb5dc3749bc"/>
-    <p:sldId xmlns:r="http://schemas.openxmlformats.org/officeDocument/2006/relationships" id="257" r:id="R6ba8debb836a48a4"/>
-    <p:sldId xmlns:r="http://schemas.openxmlformats.org/officeDocument/2006/relationships" id="258" r:id="R7e16c22dab894b56"/>
-    <p:sldId xmlns:r="http://schemas.openxmlformats.org/officeDocument/2006/relationships" id="259" r:id="Rdeef11fb06be41d9"/>
-    <p:sldId xmlns:r="http://schemas.openxmlformats.org/officeDocument/2006/relationships" id="260" r:id="Rb6196ba3407d4c3a"/>
-    <p:sldId xmlns:r="http://schemas.openxmlformats.org/officeDocument/2006/relationships" id="261" r:id="R3f65e2ee0369415c"/>
+    <p:sldId xmlns:r="http://schemas.openxmlformats.org/officeDocument/2006/relationships" id="256" r:id="Re839c732156946ed"/>
+    <p:sldId xmlns:r="http://schemas.openxmlformats.org/officeDocument/2006/relationships" id="257" r:id="R38aed98338724477"/>
+    <p:sldId xmlns:r="http://schemas.openxmlformats.org/officeDocument/2006/relationships" id="258" r:id="Rfc24fb18dd594eaf"/>
+    <p:sldId xmlns:r="http://schemas.openxmlformats.org/officeDocument/2006/relationships" id="259" r:id="R798a56557cec4056"/>
+    <p:sldId xmlns:r="http://schemas.openxmlformats.org/officeDocument/2006/relationships" id="260" r:id="Rcf7b14c0e739472f"/>
+    <p:sldId xmlns:r="http://schemas.openxmlformats.org/officeDocument/2006/relationships" id="261" r:id="Ra914104953f34808"/>
   </p:sldIdLst>
   <p:sldSz cx="18288000" cy="10287000"/>
   <p:notesSz cx="6858000" cy="9144000"/>
@@ -462,7 +462,7 @@
           </a:p>
           <a:p xmlns:a="http://schemas.openxmlformats.org/drawingml/2006/main">
             <a:r>
-              <a:t>활동 SHA-256: cd2e5e9ff24e67a1c31326c95acc0f67d0466e64cd997b9d6ff642d56362bda9</a:t>
+              <a:t>활동 SHA-256: 00fedd21cfe33a3c35990f84af0610bef6fb2f7e9473404d2f935222c3ad084c</a:t>
             </a:r>
           </a:p>
           <a:p xmlns:a="http://schemas.openxmlformats.org/drawingml/2006/main">
@@ -472,7 +472,7 @@
           </a:p>
           <a:p xmlns:a="http://schemas.openxmlformats.org/drawingml/2006/main">
             <a:r>
-              <a:t>원본 SHA-256: e89c163288eaeceeeea3e8a44ef56f903278aefd9c997db8756bcdd27170d1fa</a:t>
+              <a:t>원본 SHA-256: d25a503005403e71d5811d61f20d9c227479bfeb04808ba868ce06adc463e4f8</a:t>
             </a:r>
           </a:p>
           <a:p xmlns:a="http://schemas.openxmlformats.org/drawingml/2006/main">
@@ -6767,7 +6767,7 @@
           </a:p>
           <a:p xmlns:a="http://schemas.openxmlformats.org/drawingml/2006/main">
             <a:r>
-              <a:t>활동 SHA-256: cd2e5e9ff24e67a1c31326c95acc0f67d0466e64cd997b9d6ff642d56362bda9</a:t>
+              <a:t>활동 SHA-256: 00fedd21cfe33a3c35990f84af0610bef6fb2f7e9473404d2f935222c3ad084c</a:t>
             </a:r>
           </a:p>
           <a:p xmlns:a="http://schemas.openxmlformats.org/drawingml/2006/main">
@@ -6777,7 +6777,7 @@
           </a:p>
           <a:p xmlns:a="http://schemas.openxmlformats.org/drawingml/2006/main">
             <a:r>
-              <a:t>원본 SHA-256: e89c163288eaeceeeea3e8a44ef56f903278aefd9c997db8756bcdd27170d1fa</a:t>
+              <a:t>원본 SHA-256: d25a503005403e71d5811d61f20d9c227479bfeb04808ba868ce06adc463e4f8</a:t>
             </a:r>
           </a:p>
           <a:p xmlns:a="http://schemas.openxmlformats.org/drawingml/2006/main">
@@ -6807,12 +6807,12 @@
           </a:p>
           <a:p xmlns:a="http://schemas.openxmlformats.org/drawingml/2006/main">
             <a:r>
-              <a:t>목표: $0.30/P21 이하</a:t>
-            </a:r>
-          </a:p>
-          <a:p xmlns:a="http://schemas.openxmlformats.org/drawingml/2006/main">
-            <a:r>
-              <a:t>목표 근거: 동일 21사례의 의미 62호출/음성 입력 50초/출력 179초 예산에서 기본 $0.173567, 여유 $0.126433. 호출·출력은 작성자 가정이며 실제 사용량으로 대체 (§5)</a:t>
+              <a:t>목표: $0.50/P21 이하</a:t>
+            </a:r>
+          </a:p>
+          <a:p xmlns:a="http://schemas.openxmlformats.org/drawingml/2006/main">
+            <a:r>
+              <a:t>목표 근거: 동일 21사례의 의미 62호출/음성 입력 50초/출력 179초 예산에서 신규 audio·Text 포함 기본 $0.416320, 이력 audio/추가생산/재시도 여유 $0.083680. 호출·출력은 작성자 가정이며 실제 사용량으로 대체 (§5)</a:t>
             </a:r>
           </a:p>
           <a:p xmlns:a="http://schemas.openxmlformats.org/drawingml/2006/main">
@@ -6832,7 +6832,12 @@
           </a:p>
           <a:p xmlns:a="http://schemas.openxmlformats.org/drawingml/2006/main">
             <a:r>
-              <a:t>Google Live 공식 가격표: https://ai.google.dev/gemini-api/docs/pricing</a:t>
+              <a:t>OpenAI GPT Realtime 공식 단가: https://developers.openai.com/api/docs/models/gpt-realtime</a:t>
+            </a:r>
+          </a:p>
+          <a:p xmlns:a="http://schemas.openxmlformats.org/drawingml/2006/main">
+            <a:r>
+              <a:t>OpenAI Realtime 청구: https://developers.openai.com/api/docs/guides/voice-latency-cost</a:t>
             </a:r>
           </a:p>
           <a:p xmlns:a="http://schemas.openxmlformats.org/drawingml/2006/main">
@@ -6937,27 +6942,27 @@
           </a:p>
           <a:p xmlns:a="http://schemas.openxmlformats.org/drawingml/2006/main">
             <a:r>
-              <a:t>| 음성audio 입력50초/출력예산179초 | 0.057867 |</a:t>
-            </a:r>
-          </a:p>
-          <a:p xmlns:a="http://schemas.openxmlformats.org/drawingml/2006/main">
-            <a:r>
-              <a:t>| 음성Text/context 입력10,000/출력2,000 token | 0.016500 |</a:t>
-            </a:r>
-          </a:p>
-          <a:p xmlns:a="http://schemas.openxmlformats.org/drawingml/2006/main">
-            <a:r>
-              <a:t>| 기본 총액 | **0.173567** |</a:t>
-            </a:r>
-          </a:p>
-          <a:p xmlns:a="http://schemas.openxmlformats.org/drawingml/2006/main">
-            <a:r>
-              <a:t>| 초기/추가생산/재시도 여유 | **0.126433** |</a:t>
-            </a:r>
-          </a:p>
-          <a:p xmlns:a="http://schemas.openxmlformats.org/drawingml/2006/main">
-            <a:r>
-              <a:t>| 목표 | **0.30/P21** |</a:t>
+              <a:t>| GPT Realtime 신규 audio 입력50초/출력예산179초 | 0.245120 |</a:t>
+            </a:r>
+          </a:p>
+          <a:p xmlns:a="http://schemas.openxmlformats.org/drawingml/2006/main">
+            <a:r>
+              <a:t>| GPT Realtime 청구 Text/context 입력10,000/출력2,000 token | 0.072000 |</a:t>
+            </a:r>
+          </a:p>
+          <a:p xmlns:a="http://schemas.openxmlformats.org/drawingml/2006/main">
+            <a:r>
+              <a:t>| 신규 audio·청구 Text를 포함한 기본 소계 | **0.416320** |</a:t>
+            </a:r>
+          </a:p>
+          <a:p xmlns:a="http://schemas.openxmlformats.org/drawingml/2006/main">
+            <a:r>
+              <a:t>| 이력 audio 재입력/추가생산/재시도 여유 | **0.083680** |</a:t>
+            </a:r>
+          </a:p>
+          <a:p xmlns:a="http://schemas.openxmlformats.org/drawingml/2006/main">
+            <a:r>
+              <a:t>| 목표 | **0.50/P21** |</a:t>
             </a:r>
           </a:p>
           <a:p xmlns:a="http://schemas.openxmlformats.org/drawingml/2006/main">
@@ -6967,7 +6972,7 @@
           </a:p>
           <a:p xmlns:a="http://schemas.openxmlformats.org/drawingml/2006/main">
             <a:r>
-              <a:t>W100의 $1.50를 새 묶음에 그대로 적용하지 않고 동일 P21 사용량에서 다시 계산했다. 기본 대비 약 72.84%의 추가 여유를 둔 작성자 평가 예산이며 상품 가격이나 모델 성능 보장이 아니다. Source 변경 4건이 모델 생산 4호출을 강제하지 않는다. 실제 backfill·추가 질문·재시도가 많으면 목표 미달을 그대로 보고한다.</a:t>
+              <a:t>음성 기준을 GPT Realtime으로 바꾼 동일 P21에서 다시 계산했다. 기본 소계 대비 약 20.10%의 여유를 둔 $0.50/P21 작성자 평가 예산이며 상품 가격이나 모델 성능 보장이 아니다. 앞의 50/179초는 신규 audio 길이만이므로 이력 audio 재입력의 청구를 포함한 실제 총액이라고 주장하지 않는다. Text 10k/2k는 호출별 누적 청구량의 예산이다. 추가 audio 이력·초기/배경 생산·재시도는 여유에서 부담하며 실제 response usage로 모두 합산한다. 여유 전부를 할인 없는 audio 이력 입력에 쓰면 2,615 token($0.083680)이고 다른 추가 비용이 있으면 그만큼 줄어든다. 캐시 할인/음성 이력의 transcript 대체는 실제 확인된 사용량에만 적용한다. 목표를 맞추기 위해 대화를 매 사례 초기화하거나 VIA의 Task/근거 이력을 없애지 않는다. Source 변경 4건이 모델 생산 4호출을 강제하지 않는다. 실제 backfill·추가 질문·재시도가 많으면 목표 미달을 그대로 보고한다.</a:t>
             </a:r>
           </a:p>
           <a:p xmlns:a="http://schemas.openxmlformats.org/drawingml/2006/main">
@@ -6987,7 +6992,7 @@
           </a:p>
           <a:p xmlns:a="http://schemas.openxmlformats.org/drawingml/2006/main">
             <a:r>
-              <a:t>$0.03/P21 이상을 차이 기준(목표의 10%)으로 두고 다섯 활동의 값·범위·차이 방향과 가정 민감도를 공개한다. S2-04의 cache miss, S2-05의 최초 생산, 미사용 source 4건의 실제 생산, 입출력 길이를 따로 검토한다. A의 cache를 삭제하거나 B에 ready hit를 주입하지 않는다. 기능 미완료·필수 위반을 동반한 낮은 청구는 목표 충족이 아니다.</a:t>
+              <a:t>$0.03/P21 이상을 기존 실용 차이 기준으로 유지하고(개정 목표의 6%) 다섯 활동의 값·범위·차이 방향과 가정 민감도를 공개한다. S2-04의 cache miss, S2-05의 최초 생산, 미사용 source 4건의 실제 생산, 입출력 길이를 따로 검토한다. A의 cache를 삭제하거나 B에 ready hit를 주입하지 않는다. 기능 미완료·필수 위반을 동반한 낮은 청구는 목표 충족이 아니다.</a:t>
             </a:r>
           </a:p>
           <a:p xmlns:a="http://schemas.openxmlformats.org/drawingml/2006/main">
@@ -10992,7 +10997,7 @@
           </a:p>
           <a:p xmlns:a="http://schemas.openxmlformats.org/drawingml/2006/main">
             <a:r>
-              <a:t>활동 SHA-256: cd2e5e9ff24e67a1c31326c95acc0f67d0466e64cd997b9d6ff642d56362bda9</a:t>
+              <a:t>활동 SHA-256: 00fedd21cfe33a3c35990f84af0610bef6fb2f7e9473404d2f935222c3ad084c</a:t>
             </a:r>
           </a:p>
           <a:p xmlns:a="http://schemas.openxmlformats.org/drawingml/2006/main">
@@ -11002,7 +11007,7 @@
           </a:p>
           <a:p xmlns:a="http://schemas.openxmlformats.org/drawingml/2006/main">
             <a:r>
-              <a:t>원본 SHA-256: e89c163288eaeceeeea3e8a44ef56f903278aefd9c997db8756bcdd27170d1fa</a:t>
+              <a:t>원본 SHA-256: d25a503005403e71d5811d61f20d9c227479bfeb04808ba868ce06adc463e4f8</a:t>
             </a:r>
           </a:p>
           <a:p xmlns:a="http://schemas.openxmlformats.org/drawingml/2006/main">
@@ -14252,7 +14257,7 @@
           </a:p>
           <a:p xmlns:a="http://schemas.openxmlformats.org/drawingml/2006/main">
             <a:r>
-              <a:t>활동 SHA-256: cd2e5e9ff24e67a1c31326c95acc0f67d0466e64cd997b9d6ff642d56362bda9</a:t>
+              <a:t>활동 SHA-256: 00fedd21cfe33a3c35990f84af0610bef6fb2f7e9473404d2f935222c3ad084c</a:t>
             </a:r>
           </a:p>
           <a:p xmlns:a="http://schemas.openxmlformats.org/drawingml/2006/main">
@@ -14262,7 +14267,7 @@
           </a:p>
           <a:p xmlns:a="http://schemas.openxmlformats.org/drawingml/2006/main">
             <a:r>
-              <a:t>원본 SHA-256: e89c163288eaeceeeea3e8a44ef56f903278aefd9c997db8756bcdd27170d1fa</a:t>
+              <a:t>원본 SHA-256: d25a503005403e71d5811d61f20d9c227479bfeb04808ba868ce06adc463e4f8</a:t>
             </a:r>
           </a:p>
           <a:p xmlns:a="http://schemas.openxmlformats.org/drawingml/2006/main">
@@ -17512,7 +17517,7 @@
           </a:p>
           <a:p xmlns:a="http://schemas.openxmlformats.org/drawingml/2006/main">
             <a:r>
-              <a:t>활동 SHA-256: cd2e5e9ff24e67a1c31326c95acc0f67d0466e64cd997b9d6ff642d56362bda9</a:t>
+              <a:t>활동 SHA-256: 00fedd21cfe33a3c35990f84af0610bef6fb2f7e9473404d2f935222c3ad084c</a:t>
             </a:r>
           </a:p>
           <a:p xmlns:a="http://schemas.openxmlformats.org/drawingml/2006/main">
@@ -17522,7 +17527,7 @@
           </a:p>
           <a:p xmlns:a="http://schemas.openxmlformats.org/drawingml/2006/main">
             <a:r>
-              <a:t>원본 SHA-256: e89c163288eaeceeeea3e8a44ef56f903278aefd9c997db8756bcdd27170d1fa</a:t>
+              <a:t>원본 SHA-256: d25a503005403e71d5811d61f20d9c227479bfeb04808ba868ce06adc463e4f8</a:t>
             </a:r>
           </a:p>
           <a:p xmlns:a="http://schemas.openxmlformats.org/drawingml/2006/main">
@@ -20772,7 +20777,7 @@
           </a:p>
           <a:p xmlns:a="http://schemas.openxmlformats.org/drawingml/2006/main">
             <a:r>
-              <a:t>활동 SHA-256: cd2e5e9ff24e67a1c31326c95acc0f67d0466e64cd997b9d6ff642d56362bda9</a:t>
+              <a:t>활동 SHA-256: 00fedd21cfe33a3c35990f84af0610bef6fb2f7e9473404d2f935222c3ad084c</a:t>
             </a:r>
           </a:p>
           <a:p xmlns:a="http://schemas.openxmlformats.org/drawingml/2006/main">
@@ -20782,7 +20787,7 @@
           </a:p>
           <a:p xmlns:a="http://schemas.openxmlformats.org/drawingml/2006/main">
             <a:r>
-              <a:t>원본 SHA-256: e89c163288eaeceeeea3e8a44ef56f903278aefd9c997db8756bcdd27170d1fa</a:t>
+              <a:t>원본 SHA-256: d25a503005403e71d5811d61f20d9c227479bfeb04808ba868ce06adc463e4f8</a:t>
             </a:r>
           </a:p>
           <a:p xmlns:a="http://schemas.openxmlformats.org/drawingml/2006/main">
@@ -24015,7 +24020,7 @@
   </p:cSld>
   <p:clrMap bg1="lt1" tx1="dk1" bg2="lt2" tx2="dk2" accent1="accent1" accent2="accent2" accent3="accent3" accent4="accent4" accent5="accent5" accent6="accent6" hlink="hlink" folHlink="folHlink"/>
   <p:sldLayoutIdLst>
-    <p:sldLayoutId xmlns:r="http://schemas.openxmlformats.org/officeDocument/2006/relationships" id="2147483649" r:id="R22f28c94f3ef4210"/>
+    <p:sldLayoutId xmlns:r="http://schemas.openxmlformats.org/officeDocument/2006/relationships" id="2147483649" r:id="R41eb6e39a7f14eb4"/>
   </p:sldLayoutIdLst>
   <p:txStyles>
     <p:titleStyle>
@@ -24566,7 +24571,7 @@
           <p:cNvPr id="8" name="title">
             <a:extLst xmlns:a="http://schemas.openxmlformats.org/drawingml/2006/main">
               <a:ext uri="{FF2B5EF4-FFF2-40B4-BE49-F238E27FC236}">
-                <a16:creationId xmlns:a16="http://schemas.microsoft.com/office/drawing/2014/main" id="{01A40800-1D08-4B9F-BFC4-59C00ED6CA1D}"/>
+                <a16:creationId xmlns:a16="http://schemas.microsoft.com/office/drawing/2014/main" id="{7BED8959-5807-44DB-A739-92299D05645E}"/>
               </a:ext>
             </a:extLst>
           </p:cNvPr>
@@ -24623,7 +24628,7 @@
           <p:cNvPr id="2" name="header-rule">
             <a:extLst xmlns:a="http://schemas.openxmlformats.org/drawingml/2006/main">
               <a:ext uri="{FF2B5EF4-FFF2-40B4-BE49-F238E27FC236}">
-                <a16:creationId xmlns:a16="http://schemas.microsoft.com/office/drawing/2014/main" id="{2E10C026-1712-491B-B782-F7D4758E7D34}"/>
+                <a16:creationId xmlns:a16="http://schemas.microsoft.com/office/drawing/2014/main" id="{2E27125D-60F2-4630-83D1-AF12C515B7B1}"/>
               </a:ext>
             </a:extLst>
           </p:cNvPr>
@@ -24653,7 +24658,7 @@
           <p:cNvPr id="3" name="page">
             <a:extLst xmlns:a="http://schemas.openxmlformats.org/drawingml/2006/main">
               <a:ext uri="{FF2B5EF4-FFF2-40B4-BE49-F238E27FC236}">
-                <a16:creationId xmlns:a16="http://schemas.microsoft.com/office/drawing/2014/main" id="{E3A4CF3D-D86C-4ADA-9B83-1B4AB8D9FD35}"/>
+                <a16:creationId xmlns:a16="http://schemas.microsoft.com/office/drawing/2014/main" id="{3CC887C4-F6A3-4B42-A16A-8B7F1F05AB44}"/>
               </a:ext>
             </a:extLst>
           </p:cNvPr>
@@ -24710,7 +24715,7 @@
           <p:cNvPr id="4" name="headline">
             <a:extLst xmlns:a="http://schemas.openxmlformats.org/drawingml/2006/main">
               <a:ext uri="{FF2B5EF4-FFF2-40B4-BE49-F238E27FC236}">
-                <a16:creationId xmlns:a16="http://schemas.microsoft.com/office/drawing/2014/main" id="{292B725C-079B-4CCC-94AF-C428048EF712}"/>
+                <a16:creationId xmlns:a16="http://schemas.microsoft.com/office/drawing/2014/main" id="{E457B687-B381-462F-B87D-E6EC9526A3BB}"/>
               </a:ext>
             </a:extLst>
           </p:cNvPr>
@@ -24767,7 +24772,7 @@
           <p:cNvPr id="5" name="scope">
             <a:extLst xmlns:a="http://schemas.openxmlformats.org/drawingml/2006/main">
               <a:ext uri="{FF2B5EF4-FFF2-40B4-BE49-F238E27FC236}">
-                <a16:creationId xmlns:a16="http://schemas.microsoft.com/office/drawing/2014/main" id="{D107C5B8-31A9-4D83-A7AF-42EA263BAE1A}"/>
+                <a16:creationId xmlns:a16="http://schemas.microsoft.com/office/drawing/2014/main" id="{456CA4F3-A4AE-45E7-9963-3339E4795226}"/>
               </a:ext>
             </a:extLst>
           </p:cNvPr>
@@ -25525,7 +25530,7 @@
           <p:cNvPr id="7" name="footer">
             <a:extLst xmlns:a="http://schemas.openxmlformats.org/drawingml/2006/main">
               <a:ext uri="{FF2B5EF4-FFF2-40B4-BE49-F238E27FC236}">
-                <a16:creationId xmlns:a16="http://schemas.microsoft.com/office/drawing/2014/main" id="{9F9C085A-F731-43F0-B741-56F360529B06}"/>
+                <a16:creationId xmlns:a16="http://schemas.microsoft.com/office/drawing/2014/main" id="{F918AF23-6A68-4CC6-B968-B6A7AA533A21}"/>
               </a:ext>
             </a:extLst>
           </p:cNvPr>
@@ -25580,7 +25585,7 @@
     </p:spTree>
     <p:extLst>
       <p:ext uri="{BB962C8B-B14F-4D97-AF65-F5344CB8AC3E}">
-        <p14:creationId xmlns:p14="http://schemas.microsoft.com/office/powerpoint/2010/main" val="371557259"/>
+        <p14:creationId xmlns:p14="http://schemas.microsoft.com/office/powerpoint/2010/main" val="1504648296"/>
       </p:ext>
     </p:extLst>
   </p:cSld>
@@ -25611,7 +25616,7 @@
           <p:cNvPr id="8" name="title">
             <a:extLst xmlns:a="http://schemas.openxmlformats.org/drawingml/2006/main">
               <a:ext uri="{FF2B5EF4-FFF2-40B4-BE49-F238E27FC236}">
-                <a16:creationId xmlns:a16="http://schemas.microsoft.com/office/drawing/2014/main" id="{A48A87DD-CB1C-4129-AF57-602CA23DEEA3}"/>
+                <a16:creationId xmlns:a16="http://schemas.microsoft.com/office/drawing/2014/main" id="{FF0F27ED-1ED9-47F0-9C62-31491C94CDBB}"/>
               </a:ext>
             </a:extLst>
           </p:cNvPr>
@@ -25668,7 +25673,7 @@
           <p:cNvPr id="2" name="header-rule">
             <a:extLst xmlns:a="http://schemas.openxmlformats.org/drawingml/2006/main">
               <a:ext uri="{FF2B5EF4-FFF2-40B4-BE49-F238E27FC236}">
-                <a16:creationId xmlns:a16="http://schemas.microsoft.com/office/drawing/2014/main" id="{729F2F94-1E00-4A1F-AEB6-890BBB38F6B5}"/>
+                <a16:creationId xmlns:a16="http://schemas.microsoft.com/office/drawing/2014/main" id="{CC50DD73-EDB4-4DEC-BD76-7D49ABBADA7B}"/>
               </a:ext>
             </a:extLst>
           </p:cNvPr>
@@ -25698,7 +25703,7 @@
           <p:cNvPr id="3" name="page">
             <a:extLst xmlns:a="http://schemas.openxmlformats.org/drawingml/2006/main">
               <a:ext uri="{FF2B5EF4-FFF2-40B4-BE49-F238E27FC236}">
-                <a16:creationId xmlns:a16="http://schemas.microsoft.com/office/drawing/2014/main" id="{3D1F658F-4357-4165-9148-2E47501471D1}"/>
+                <a16:creationId xmlns:a16="http://schemas.microsoft.com/office/drawing/2014/main" id="{3F055C21-5283-40B7-9AB4-23F779DD8979}"/>
               </a:ext>
             </a:extLst>
           </p:cNvPr>
@@ -25755,7 +25760,7 @@
           <p:cNvPr id="4" name="headline">
             <a:extLst xmlns:a="http://schemas.openxmlformats.org/drawingml/2006/main">
               <a:ext uri="{FF2B5EF4-FFF2-40B4-BE49-F238E27FC236}">
-                <a16:creationId xmlns:a16="http://schemas.microsoft.com/office/drawing/2014/main" id="{2B1AFE9D-A262-4AFA-91D7-8BE8B47ED968}"/>
+                <a16:creationId xmlns:a16="http://schemas.microsoft.com/office/drawing/2014/main" id="{F82A499F-E210-47B5-8D9D-E99DA4C623C5}"/>
               </a:ext>
             </a:extLst>
           </p:cNvPr>
@@ -25812,7 +25817,7 @@
           <p:cNvPr id="5" name="scope">
             <a:extLst xmlns:a="http://schemas.openxmlformats.org/drawingml/2006/main">
               <a:ext uri="{FF2B5EF4-FFF2-40B4-BE49-F238E27FC236}">
-                <a16:creationId xmlns:a16="http://schemas.microsoft.com/office/drawing/2014/main" id="{E6C11848-0FDE-43CD-BA78-961F9AC117E3}"/>
+                <a16:creationId xmlns:a16="http://schemas.microsoft.com/office/drawing/2014/main" id="{16F27A96-B975-4D30-8520-93B0BAE53F69}"/>
               </a:ext>
             </a:extLst>
           </p:cNvPr>
@@ -26145,7 +26150,7 @@
                           <a:ea typeface="Apple SD Gothic Neo"/>
                           <a:cs typeface="Apple SD Gothic Neo"/>
                         </a:rPr>
-                        <a:t>P21 1묶음 평균 모델 비용 ≤ $0.30</a:t>
+                        <a:t>P21 1묶음 평균 모델 비용 ≤ $0.50</a:t>
                       </a:r>
                     </a:p>
                     <a:p>
@@ -26173,7 +26178,7 @@
                           <a:ea typeface="Apple SD Gothic Neo"/>
                           <a:cs typeface="Apple SD Gothic Neo"/>
                         </a:rPr>
-                        <a:t>근거: 기본 $0.173567 + 추가 생산/재시도 여유 $0.126433</a:t>
+                        <a:t>근거: 신규 audio·Text 기본 $0.416320 + 추가 여유 $0.083680</a:t>
                       </a:r>
                     </a:p>
                   </a:txBody>
@@ -26598,7 +26603,7 @@
           <p:cNvPr id="7" name="footer">
             <a:extLst xmlns:a="http://schemas.openxmlformats.org/drawingml/2006/main">
               <a:ext uri="{FF2B5EF4-FFF2-40B4-BE49-F238E27FC236}">
-                <a16:creationId xmlns:a16="http://schemas.microsoft.com/office/drawing/2014/main" id="{8DA4B4D0-45E1-418A-AACD-8096F775A15B}"/>
+                <a16:creationId xmlns:a16="http://schemas.microsoft.com/office/drawing/2014/main" id="{C4E82951-2C46-445E-BEA3-8E725A3B35EB}"/>
               </a:ext>
             </a:extLst>
           </p:cNvPr>
@@ -26653,7 +26658,7 @@
     </p:spTree>
     <p:extLst>
       <p:ext uri="{BB962C8B-B14F-4D97-AF65-F5344CB8AC3E}">
-        <p14:creationId xmlns:p14="http://schemas.microsoft.com/office/powerpoint/2010/main" val="1438102545"/>
+        <p14:creationId xmlns:p14="http://schemas.microsoft.com/office/powerpoint/2010/main" val="1776292606"/>
       </p:ext>
     </p:extLst>
   </p:cSld>
@@ -26684,7 +26689,7 @@
           <p:cNvPr id="8" name="title">
             <a:extLst xmlns:a="http://schemas.openxmlformats.org/drawingml/2006/main">
               <a:ext uri="{FF2B5EF4-FFF2-40B4-BE49-F238E27FC236}">
-                <a16:creationId xmlns:a16="http://schemas.microsoft.com/office/drawing/2014/main" id="{ECFFFAB3-0863-44D6-AA74-D862C82BA11F}"/>
+                <a16:creationId xmlns:a16="http://schemas.microsoft.com/office/drawing/2014/main" id="{3624CFB2-432A-4515-B3C8-6B1CB8E500B5}"/>
               </a:ext>
             </a:extLst>
           </p:cNvPr>
@@ -26741,7 +26746,7 @@
           <p:cNvPr id="2" name="header-rule">
             <a:extLst xmlns:a="http://schemas.openxmlformats.org/drawingml/2006/main">
               <a:ext uri="{FF2B5EF4-FFF2-40B4-BE49-F238E27FC236}">
-                <a16:creationId xmlns:a16="http://schemas.microsoft.com/office/drawing/2014/main" id="{ED13E0D7-5F3B-4DB8-B56E-5E7BB7368F89}"/>
+                <a16:creationId xmlns:a16="http://schemas.microsoft.com/office/drawing/2014/main" id="{3FEA3865-F08A-49E9-8CFB-E494A8604EEF}"/>
               </a:ext>
             </a:extLst>
           </p:cNvPr>
@@ -26771,7 +26776,7 @@
           <p:cNvPr id="3" name="page">
             <a:extLst xmlns:a="http://schemas.openxmlformats.org/drawingml/2006/main">
               <a:ext uri="{FF2B5EF4-FFF2-40B4-BE49-F238E27FC236}">
-                <a16:creationId xmlns:a16="http://schemas.microsoft.com/office/drawing/2014/main" id="{04C168BF-42F8-45FC-9E95-7555D0EAB55E}"/>
+                <a16:creationId xmlns:a16="http://schemas.microsoft.com/office/drawing/2014/main" id="{C8E3AE3D-8CFC-4C45-9FD1-05DA56DDDEA7}"/>
               </a:ext>
             </a:extLst>
           </p:cNvPr>
@@ -26828,7 +26833,7 @@
           <p:cNvPr id="4" name="headline">
             <a:extLst xmlns:a="http://schemas.openxmlformats.org/drawingml/2006/main">
               <a:ext uri="{FF2B5EF4-FFF2-40B4-BE49-F238E27FC236}">
-                <a16:creationId xmlns:a16="http://schemas.microsoft.com/office/drawing/2014/main" id="{F0F77C51-5416-49BC-96B3-BFEF8B84F699}"/>
+                <a16:creationId xmlns:a16="http://schemas.microsoft.com/office/drawing/2014/main" id="{BB5A805E-0C8E-42F9-8D63-EC2CFAE05EAD}"/>
               </a:ext>
             </a:extLst>
           </p:cNvPr>
@@ -26885,7 +26890,7 @@
           <p:cNvPr id="5" name="scope">
             <a:extLst xmlns:a="http://schemas.openxmlformats.org/drawingml/2006/main">
               <a:ext uri="{FF2B5EF4-FFF2-40B4-BE49-F238E27FC236}">
-                <a16:creationId xmlns:a16="http://schemas.microsoft.com/office/drawing/2014/main" id="{FAD4B9ED-2445-4629-AC7C-85659DBE6264}"/>
+                <a16:creationId xmlns:a16="http://schemas.microsoft.com/office/drawing/2014/main" id="{8F1C644A-C225-4FD6-8EB9-048C86355532}"/>
               </a:ext>
             </a:extLst>
           </p:cNvPr>
@@ -27428,7 +27433,7 @@
                           <a:ea typeface="Apple SD Gothic Neo"/>
                           <a:cs typeface="Apple SD Gothic Neo"/>
                         </a:rPr>
-                        <a:t>비용 ≤$0.30/P21 / commit ≤4GiB</a:t>
+                        <a:t>비용 ≤$0.50/P21 / commit ≤4GiB</a:t>
                       </a:r>
                     </a:p>
                     <a:p>
@@ -27672,7 +27677,7 @@
           <p:cNvPr id="7" name="footer">
             <a:extLst xmlns:a="http://schemas.openxmlformats.org/drawingml/2006/main">
               <a:ext uri="{FF2B5EF4-FFF2-40B4-BE49-F238E27FC236}">
-                <a16:creationId xmlns:a16="http://schemas.microsoft.com/office/drawing/2014/main" id="{921F85A3-C9BF-4172-943A-5D0429244656}"/>
+                <a16:creationId xmlns:a16="http://schemas.microsoft.com/office/drawing/2014/main" id="{4C361FAC-7CF2-4A80-ABF2-183B63C782ED}"/>
               </a:ext>
             </a:extLst>
           </p:cNvPr>
@@ -27727,7 +27732,7 @@
     </p:spTree>
     <p:extLst>
       <p:ext uri="{BB962C8B-B14F-4D97-AF65-F5344CB8AC3E}">
-        <p14:creationId xmlns:p14="http://schemas.microsoft.com/office/powerpoint/2010/main" val="1267817231"/>
+        <p14:creationId xmlns:p14="http://schemas.microsoft.com/office/powerpoint/2010/main" val="2048637843"/>
       </p:ext>
     </p:extLst>
   </p:cSld>
@@ -27758,7 +27763,7 @@
           <p:cNvPr id="8" name="title">
             <a:extLst xmlns:a="http://schemas.openxmlformats.org/drawingml/2006/main">
               <a:ext uri="{FF2B5EF4-FFF2-40B4-BE49-F238E27FC236}">
-                <a16:creationId xmlns:a16="http://schemas.microsoft.com/office/drawing/2014/main" id="{5C350B14-2BB9-461C-949A-68142AAE655E}"/>
+                <a16:creationId xmlns:a16="http://schemas.microsoft.com/office/drawing/2014/main" id="{4B662A00-F331-4EBC-AAC3-45CC9F41C165}"/>
               </a:ext>
             </a:extLst>
           </p:cNvPr>
@@ -27815,7 +27820,7 @@
           <p:cNvPr id="2" name="header-rule">
             <a:extLst xmlns:a="http://schemas.openxmlformats.org/drawingml/2006/main">
               <a:ext uri="{FF2B5EF4-FFF2-40B4-BE49-F238E27FC236}">
-                <a16:creationId xmlns:a16="http://schemas.microsoft.com/office/drawing/2014/main" id="{6789A051-A02F-4113-A99B-D26701672FB3}"/>
+                <a16:creationId xmlns:a16="http://schemas.microsoft.com/office/drawing/2014/main" id="{F70889D0-51B4-4E1D-8C7D-AA7442E4FD2C}"/>
               </a:ext>
             </a:extLst>
           </p:cNvPr>
@@ -27845,7 +27850,7 @@
           <p:cNvPr id="3" name="page">
             <a:extLst xmlns:a="http://schemas.openxmlformats.org/drawingml/2006/main">
               <a:ext uri="{FF2B5EF4-FFF2-40B4-BE49-F238E27FC236}">
-                <a16:creationId xmlns:a16="http://schemas.microsoft.com/office/drawing/2014/main" id="{FE2A1DE0-D2CB-4454-9812-F4F5DE9E1874}"/>
+                <a16:creationId xmlns:a16="http://schemas.microsoft.com/office/drawing/2014/main" id="{1424BA80-9AE5-449D-B0D0-7E839ED19BBA}"/>
               </a:ext>
             </a:extLst>
           </p:cNvPr>
@@ -27902,7 +27907,7 @@
           <p:cNvPr id="4" name="headline">
             <a:extLst xmlns:a="http://schemas.openxmlformats.org/drawingml/2006/main">
               <a:ext uri="{FF2B5EF4-FFF2-40B4-BE49-F238E27FC236}">
-                <a16:creationId xmlns:a16="http://schemas.microsoft.com/office/drawing/2014/main" id="{8D4F0420-4617-4097-81E2-751518B6B232}"/>
+                <a16:creationId xmlns:a16="http://schemas.microsoft.com/office/drawing/2014/main" id="{1272F382-65DD-422A-8786-4C5FB00A7754}"/>
               </a:ext>
             </a:extLst>
           </p:cNvPr>
@@ -27959,7 +27964,7 @@
           <p:cNvPr id="5" name="scope">
             <a:extLst xmlns:a="http://schemas.openxmlformats.org/drawingml/2006/main">
               <a:ext uri="{FF2B5EF4-FFF2-40B4-BE49-F238E27FC236}">
-                <a16:creationId xmlns:a16="http://schemas.microsoft.com/office/drawing/2014/main" id="{E4B2D0BD-9530-4B94-8C86-50BEF00D3ADE}"/>
+                <a16:creationId xmlns:a16="http://schemas.microsoft.com/office/drawing/2014/main" id="{3C56BD69-5C1B-4AC5-BEDC-41E366C30CFE}"/>
               </a:ext>
             </a:extLst>
           </p:cNvPr>
@@ -29253,7 +29258,7 @@
           <p:cNvPr id="7" name="footer">
             <a:extLst xmlns:a="http://schemas.openxmlformats.org/drawingml/2006/main">
               <a:ext uri="{FF2B5EF4-FFF2-40B4-BE49-F238E27FC236}">
-                <a16:creationId xmlns:a16="http://schemas.microsoft.com/office/drawing/2014/main" id="{75629E1B-F08A-48C4-87DA-6FE6359B93B0}"/>
+                <a16:creationId xmlns:a16="http://schemas.microsoft.com/office/drawing/2014/main" id="{8E924A3F-8653-467A-BE8C-188FF3BBDA03}"/>
               </a:ext>
             </a:extLst>
           </p:cNvPr>
@@ -29308,7 +29313,7 @@
     </p:spTree>
     <p:extLst>
       <p:ext uri="{BB962C8B-B14F-4D97-AF65-F5344CB8AC3E}">
-        <p14:creationId xmlns:p14="http://schemas.microsoft.com/office/powerpoint/2010/main" val="410058508"/>
+        <p14:creationId xmlns:p14="http://schemas.microsoft.com/office/powerpoint/2010/main" val="1035022172"/>
       </p:ext>
     </p:extLst>
   </p:cSld>
@@ -29339,7 +29344,7 @@
           <p:cNvPr id="8" name="title">
             <a:extLst xmlns:a="http://schemas.openxmlformats.org/drawingml/2006/main">
               <a:ext uri="{FF2B5EF4-FFF2-40B4-BE49-F238E27FC236}">
-                <a16:creationId xmlns:a16="http://schemas.microsoft.com/office/drawing/2014/main" id="{2A948F48-7D32-47E0-A16F-43CA0B5A6202}"/>
+                <a16:creationId xmlns:a16="http://schemas.microsoft.com/office/drawing/2014/main" id="{A45DC734-68E2-4E8C-9341-AB22F83CB480}"/>
               </a:ext>
             </a:extLst>
           </p:cNvPr>
@@ -29396,7 +29401,7 @@
           <p:cNvPr id="2" name="header-rule">
             <a:extLst xmlns:a="http://schemas.openxmlformats.org/drawingml/2006/main">
               <a:ext uri="{FF2B5EF4-FFF2-40B4-BE49-F238E27FC236}">
-                <a16:creationId xmlns:a16="http://schemas.microsoft.com/office/drawing/2014/main" id="{0D74018C-F595-48B7-9626-6071EBCFBFE5}"/>
+                <a16:creationId xmlns:a16="http://schemas.microsoft.com/office/drawing/2014/main" id="{99234F12-6E7E-465C-8DAF-F95D70EA65DA}"/>
               </a:ext>
             </a:extLst>
           </p:cNvPr>
@@ -29426,7 +29431,7 @@
           <p:cNvPr id="3" name="page">
             <a:extLst xmlns:a="http://schemas.openxmlformats.org/drawingml/2006/main">
               <a:ext uri="{FF2B5EF4-FFF2-40B4-BE49-F238E27FC236}">
-                <a16:creationId xmlns:a16="http://schemas.microsoft.com/office/drawing/2014/main" id="{FFC771F1-4BC7-4090-8C7A-767272D4B7A4}"/>
+                <a16:creationId xmlns:a16="http://schemas.microsoft.com/office/drawing/2014/main" id="{52EC775C-65B4-491B-A07B-D6D37D0BDEB1}"/>
               </a:ext>
             </a:extLst>
           </p:cNvPr>
@@ -29483,7 +29488,7 @@
           <p:cNvPr id="4" name="headline">
             <a:extLst xmlns:a="http://schemas.openxmlformats.org/drawingml/2006/main">
               <a:ext uri="{FF2B5EF4-FFF2-40B4-BE49-F238E27FC236}">
-                <a16:creationId xmlns:a16="http://schemas.microsoft.com/office/drawing/2014/main" id="{2F707774-A715-4BF2-89B2-28D965977A26}"/>
+                <a16:creationId xmlns:a16="http://schemas.microsoft.com/office/drawing/2014/main" id="{7C85A454-97F5-450E-9AFF-AB0AB53AB2C0}"/>
               </a:ext>
             </a:extLst>
           </p:cNvPr>
@@ -29540,7 +29545,7 @@
           <p:cNvPr id="5" name="scope">
             <a:extLst xmlns:a="http://schemas.openxmlformats.org/drawingml/2006/main">
               <a:ext uri="{FF2B5EF4-FFF2-40B4-BE49-F238E27FC236}">
-                <a16:creationId xmlns:a16="http://schemas.microsoft.com/office/drawing/2014/main" id="{9E774550-2D49-4107-B3DC-E7CFCE3E2EB4}"/>
+                <a16:creationId xmlns:a16="http://schemas.microsoft.com/office/drawing/2014/main" id="{8D4051D2-6029-4B21-9738-1A61D4217D2E}"/>
               </a:ext>
             </a:extLst>
           </p:cNvPr>
@@ -30848,7 +30853,7 @@
           <p:cNvPr id="7" name="footer">
             <a:extLst xmlns:a="http://schemas.openxmlformats.org/drawingml/2006/main">
               <a:ext uri="{FF2B5EF4-FFF2-40B4-BE49-F238E27FC236}">
-                <a16:creationId xmlns:a16="http://schemas.microsoft.com/office/drawing/2014/main" id="{42276120-A97B-4038-9546-9A4891053912}"/>
+                <a16:creationId xmlns:a16="http://schemas.microsoft.com/office/drawing/2014/main" id="{8B03BFE4-188A-4E07-AC4B-1D18DC0C1758}"/>
               </a:ext>
             </a:extLst>
           </p:cNvPr>
@@ -30903,7 +30908,7 @@
     </p:spTree>
     <p:extLst>
       <p:ext uri="{BB962C8B-B14F-4D97-AF65-F5344CB8AC3E}">
-        <p14:creationId xmlns:p14="http://schemas.microsoft.com/office/powerpoint/2010/main" val="891173581"/>
+        <p14:creationId xmlns:p14="http://schemas.microsoft.com/office/powerpoint/2010/main" val="259028113"/>
       </p:ext>
     </p:extLst>
   </p:cSld>
@@ -30934,7 +30939,7 @@
           <p:cNvPr id="8" name="title">
             <a:extLst xmlns:a="http://schemas.openxmlformats.org/drawingml/2006/main">
               <a:ext uri="{FF2B5EF4-FFF2-40B4-BE49-F238E27FC236}">
-                <a16:creationId xmlns:a16="http://schemas.microsoft.com/office/drawing/2014/main" id="{A8F4C509-59F5-4885-B3D0-37536C2A65B9}"/>
+                <a16:creationId xmlns:a16="http://schemas.microsoft.com/office/drawing/2014/main" id="{F7DAF67F-1175-4DBE-BB58-EA26F2912536}"/>
               </a:ext>
             </a:extLst>
           </p:cNvPr>
@@ -30991,7 +30996,7 @@
           <p:cNvPr id="2" name="header-rule">
             <a:extLst xmlns:a="http://schemas.openxmlformats.org/drawingml/2006/main">
               <a:ext uri="{FF2B5EF4-FFF2-40B4-BE49-F238E27FC236}">
-                <a16:creationId xmlns:a16="http://schemas.microsoft.com/office/drawing/2014/main" id="{5F01649B-686E-4B59-B054-7585573B8DF2}"/>
+                <a16:creationId xmlns:a16="http://schemas.microsoft.com/office/drawing/2014/main" id="{9470C8A2-8752-43AF-B6BF-C5C4E7A7C321}"/>
               </a:ext>
             </a:extLst>
           </p:cNvPr>
@@ -31021,7 +31026,7 @@
           <p:cNvPr id="3" name="page">
             <a:extLst xmlns:a="http://schemas.openxmlformats.org/drawingml/2006/main">
               <a:ext uri="{FF2B5EF4-FFF2-40B4-BE49-F238E27FC236}">
-                <a16:creationId xmlns:a16="http://schemas.microsoft.com/office/drawing/2014/main" id="{777F954D-385C-4641-910F-25FF0E3BB2FF}"/>
+                <a16:creationId xmlns:a16="http://schemas.microsoft.com/office/drawing/2014/main" id="{DD88009A-F035-4E63-876E-5603AB70211D}"/>
               </a:ext>
             </a:extLst>
           </p:cNvPr>
@@ -31078,7 +31083,7 @@
           <p:cNvPr id="4" name="headline">
             <a:extLst xmlns:a="http://schemas.openxmlformats.org/drawingml/2006/main">
               <a:ext uri="{FF2B5EF4-FFF2-40B4-BE49-F238E27FC236}">
-                <a16:creationId xmlns:a16="http://schemas.microsoft.com/office/drawing/2014/main" id="{37CCE702-BA5D-4D12-A1D7-D8B4D1A15A5B}"/>
+                <a16:creationId xmlns:a16="http://schemas.microsoft.com/office/drawing/2014/main" id="{4001907E-C726-4D4B-BE37-723239F49EC2}"/>
               </a:ext>
             </a:extLst>
           </p:cNvPr>
@@ -31135,7 +31140,7 @@
           <p:cNvPr id="5" name="scope">
             <a:extLst xmlns:a="http://schemas.openxmlformats.org/drawingml/2006/main">
               <a:ext uri="{FF2B5EF4-FFF2-40B4-BE49-F238E27FC236}">
-                <a16:creationId xmlns:a16="http://schemas.microsoft.com/office/drawing/2014/main" id="{F071CAE0-AB91-4CA2-8EC4-8B54F5B3F2B9}"/>
+                <a16:creationId xmlns:a16="http://schemas.microsoft.com/office/drawing/2014/main" id="{862A8418-1031-4A5F-9B96-0803056FA4FC}"/>
               </a:ext>
             </a:extLst>
           </p:cNvPr>
@@ -32471,7 +32476,7 @@
           <p:cNvPr id="7" name="footer">
             <a:extLst xmlns:a="http://schemas.openxmlformats.org/drawingml/2006/main">
               <a:ext uri="{FF2B5EF4-FFF2-40B4-BE49-F238E27FC236}">
-                <a16:creationId xmlns:a16="http://schemas.microsoft.com/office/drawing/2014/main" id="{EA7DFB65-37C5-4BF8-8BAB-30090743ED19}"/>
+                <a16:creationId xmlns:a16="http://schemas.microsoft.com/office/drawing/2014/main" id="{FE29488F-569C-4E6F-B2AC-49EF16C5A5C8}"/>
               </a:ext>
             </a:extLst>
           </p:cNvPr>
@@ -32526,7 +32531,7 @@
     </p:spTree>
     <p:extLst>
       <p:ext uri="{BB962C8B-B14F-4D97-AF65-F5344CB8AC3E}">
-        <p14:creationId xmlns:p14="http://schemas.microsoft.com/office/powerpoint/2010/main" val="1203299029"/>
+        <p14:creationId xmlns:p14="http://schemas.microsoft.com/office/powerpoint/2010/main" val="1280019452"/>
       </p:ext>
     </p:extLst>
   </p:cSld>

</xml_diff>

<commit_message>
docs: select Qwen 30B and GPT Realtime QA references
</commit_message>
<xml_diff>
--- a/docs/presentations_files/quality-attributes/VIA-quality-attributes.pptx
+++ b/docs/presentations_files/quality-attributes/VIA-quality-attributes.pptx
@@ -2,18 +2,18 @@
 <file path=ppt/presentation.xml><?xml version="1.0" encoding="utf-8"?>
 <p:presentation xmlns:p="http://schemas.openxmlformats.org/presentationml/2006/main">
   <p:sldMasterIdLst>
-    <p:sldMasterId xmlns:r="http://schemas.openxmlformats.org/officeDocument/2006/relationships" id="2147483648" r:id="Ra9cd6f0fea754559"/>
+    <p:sldMasterId xmlns:r="http://schemas.openxmlformats.org/officeDocument/2006/relationships" id="2147483648" r:id="R53ceaff1e4044dbd"/>
   </p:sldMasterIdLst>
   <p:notesMasterIdLst>
-    <p:notesMasterId xmlns:r="http://schemas.openxmlformats.org/officeDocument/2006/relationships" r:id="R6fa42f2316834f57"/>
+    <p:notesMasterId xmlns:r="http://schemas.openxmlformats.org/officeDocument/2006/relationships" r:id="Rc8d9fd91bd21450d"/>
   </p:notesMasterIdLst>
   <p:sldIdLst>
-    <p:sldId xmlns:r="http://schemas.openxmlformats.org/officeDocument/2006/relationships" id="256" r:id="Re839c732156946ed"/>
-    <p:sldId xmlns:r="http://schemas.openxmlformats.org/officeDocument/2006/relationships" id="257" r:id="R38aed98338724477"/>
-    <p:sldId xmlns:r="http://schemas.openxmlformats.org/officeDocument/2006/relationships" id="258" r:id="Rfc24fb18dd594eaf"/>
-    <p:sldId xmlns:r="http://schemas.openxmlformats.org/officeDocument/2006/relationships" id="259" r:id="R798a56557cec4056"/>
-    <p:sldId xmlns:r="http://schemas.openxmlformats.org/officeDocument/2006/relationships" id="260" r:id="Rcf7b14c0e739472f"/>
-    <p:sldId xmlns:r="http://schemas.openxmlformats.org/officeDocument/2006/relationships" id="261" r:id="Ra914104953f34808"/>
+    <p:sldId xmlns:r="http://schemas.openxmlformats.org/officeDocument/2006/relationships" id="256" r:id="R9d55d59f1b68454c"/>
+    <p:sldId xmlns:r="http://schemas.openxmlformats.org/officeDocument/2006/relationships" id="257" r:id="Re57c441a3ad54f30"/>
+    <p:sldId xmlns:r="http://schemas.openxmlformats.org/officeDocument/2006/relationships" id="258" r:id="Rd86eb0d8c49c4839"/>
+    <p:sldId xmlns:r="http://schemas.openxmlformats.org/officeDocument/2006/relationships" id="259" r:id="Rb9e7d281b5b14be7"/>
+    <p:sldId xmlns:r="http://schemas.openxmlformats.org/officeDocument/2006/relationships" id="260" r:id="R376c63a001dd4cec"/>
+    <p:sldId xmlns:r="http://schemas.openxmlformats.org/officeDocument/2006/relationships" id="261" r:id="R97d7501078f5472f"/>
   </p:sldIdLst>
   <p:sldSz cx="18288000" cy="10287000"/>
   <p:notesSz cx="6858000" cy="9144000"/>
@@ -472,7 +472,7 @@
           </a:p>
           <a:p xmlns:a="http://schemas.openxmlformats.org/drawingml/2006/main">
             <a:r>
-              <a:t>원본 SHA-256: d25a503005403e71d5811d61f20d9c227479bfeb04808ba868ce06adc463e4f8</a:t>
+              <a:t>원본 SHA-256: 8520fa1bd1661f72bb87071ab03755964b0539565490994de845bbc086654cfd</a:t>
             </a:r>
           </a:p>
           <a:p xmlns:a="http://schemas.openxmlformats.org/drawingml/2006/main">
@@ -3172,7 +3172,7 @@
           </a:p>
           <a:p xmlns:a="http://schemas.openxmlformats.org/drawingml/2006/main">
             <a:r>
-              <a:t>Google Gemini 3 Flash 공식 단가: https://ai.google.dev/gemini-api/docs/pricing#gemini-3-flash-preview</a:t>
+              <a:t>Qwen 공식 H20 속도 benchmark: https://qwen.readthedocs.io/en/latest/getting_started/speed_benchmark.html</a:t>
             </a:r>
           </a:p>
           <a:p xmlns:a="http://schemas.openxmlformats.org/drawingml/2006/main">
@@ -3262,7 +3262,7 @@
           </a:p>
           <a:p xmlns:a="http://schemas.openxmlformats.org/drawingml/2006/main">
             <a:r>
-              <a:t>Nielsen의 0.1/1초는 참고 기준이며 평균과 95% 규칙은 작성자 예산이다. Gemini 생성률 200 token/s를 비롯한 지연은 모두 작성자 가정이다. 전사 0.10 + 첫 출력 0.30 + 의미 출력 100/200 + 코드·읽기·확정 0.08 + 음성 0.25 = 1.23초로, 이 직렬 경로는 1초 예산을 넘는다. 유효한 반응에 필요한 의미 출력이 50 token인 경우에만 같은 가정에서 0.98초다. 따라서 필요한 의미를 유지한 짧은 출력, 입력 중 선행 처리 또는 병렬 경로가 목표를 충족하는지 실제 사례에서 확인해야 한다. 50 token은 전체 200 token 호출 예산을 일괄 축소하거나 placeholder를 정답으로 인정하는 규칙이 아니다. 의미 처리가 필요한 정정·질문·거부를 local stop로 대체하지 않는다.</a:t>
+              <a:t>Nielsen의 0.1/1초는 참고 기준이며 평균과 95% 규칙은 작성자 예산이다. Qwen 생성률 130 token/s와 TTFT를 비롯한 지연은 §8.4.1.2의 PoC 작성자 가정이다. 전사 0.10 + 첫 출력 0.30 + 의미 출력 100/130 + 코드·읽기·확정 0.08 + 음성 0.25 ≈ 1.499초로, 이 직렬 경로는 1초 예산을 넘는다. 유효한 의미 출력이 50 token이어도 같은 가정에서 약 1.115초로 목표를 넘는다. 두 예시는 전체 반응 모집단의 평균이나 후보 측정값이 아니다. 따라서 필요한 의미를 유지한 짧은 출력, 입력 중 선행 처리 또는 병렬 경로가 목표를 충족하는지 실제 사례에서 확인해야 한다. 50 token은 전체 200 token 호출 예산을 일괄 축소하거나 placeholder를 정답으로 인정하는 규칙이 아니다. 의미 처리가 필요한 정정·질문·거부를 local stop로 대체하지 않는다.</a:t>
             </a:r>
           </a:p>
           <a:p xmlns:a="http://schemas.openxmlformats.org/drawingml/2006/main">
@@ -3462,7 +3462,7 @@
           </a:p>
           <a:p xmlns:a="http://schemas.openxmlformats.org/drawingml/2006/main">
             <a:r>
-              <a:t>Nielsen의 0.1/1초는 참고 기준이며 평균과 95% 규칙은 작성자 예산이다. Gemini 생성률 200 token/s를 비롯한 지연은 모두 작성자 가정이다. 전사 0.10 + 첫 출력 0.30 + 의미 출력 100/200 + 코드·읽기·확정 0.08 + 음성 0.25 = 1.23초로, 이 직렬 경로는 1초 예산을 넘는다. 유효한 반응에 필요한 의미 출력이 50 token인 경우에만 같은 가정에서 0.98초다. 따라서 필요한 의미를 유지한 짧은 출력, 입력 중 선행 처리 또는 병렬 경로가 목표를 충족하는지 실제 사례에서 확인해야 한다. 50 token은 전체 200 token 호출 예산을 일괄 축소하거나 placeholder를 정답으로 인정하는 규칙이 아니다. 의미 처리가 필요한 정정·질문·거부를 local stop로 대체하지 않는다.</a:t>
+              <a:t>Nielsen의 0.1/1초는 참고 기준이며 평균과 95% 규칙은 작성자 예산이다. Qwen 생성률 130 token/s와 TTFT를 비롯한 지연은 §8.4.1.2의 PoC 작성자 가정이다. 전사 0.10 + 첫 출력 0.30 + 의미 출력 100/130 + 코드·읽기·확정 0.08 + 음성 0.25 ≈ 1.499초로, 이 직렬 경로는 1초 예산을 넘는다. 유효한 의미 출력이 50 token이어도 같은 가정에서 약 1.115초로 목표를 넘는다. 두 예시는 전체 반응 모집단의 평균이나 후보 측정값이 아니다. 따라서 필요한 의미를 유지한 짧은 출력, 입력 중 선행 처리 또는 병렬 경로가 목표를 충족하는지 실제 사례에서 확인해야 한다. 50 token은 전체 200 token 호출 예산을 일괄 축소하거나 placeholder를 정답으로 인정하는 규칙이 아니다. 의미 처리가 필요한 정정·질문·거부를 local stop로 대체하지 않는다.</a:t>
             </a:r>
           </a:p>
           <a:p xmlns:a="http://schemas.openxmlformats.org/drawingml/2006/main">
@@ -6663,6 +6663,291 @@
           <a:p xmlns:a="http://schemas.openxmlformats.org/drawingml/2006/main">
             <a:r>
               <a:t>묶음당 21개 시나리오는 사용자 19개 + Agent 단독 2개다. 집중 장면 안에는 Agent 사건 4개가 추가로 들어 있다. Voice 입력 50초와 출력 예산 179초, 반응 27개와 사용자 cycle 19개를 정의했다. 다섯 묶음 전체는 105개 시나리오·630조건·135반응·95cycle이다. 사용자의 하루 빈도를 뜻하지 않는다.</a:t>
+            </a:r>
+          </a:p>
+          <a:p xmlns:a="http://schemas.openxmlformats.org/drawingml/2006/main">
+            <a:r>
+              <a:t/>
+            </a:r>
+          </a:p>
+          <a:p xmlns:a="http://schemas.openxmlformats.org/drawingml/2006/main">
+            <a:r>
+              <a:t/>
+            </a:r>
+          </a:p>
+          <a:p xmlns:a="http://schemas.openxmlformats.org/drawingml/2006/main">
+            <a:r>
+              <a:t>모델 reference 상세 §8.4</a:t>
+            </a:r>
+          </a:p>
+          <a:p xmlns:a="http://schemas.openxmlformats.org/drawingml/2006/main">
+            <a:r>
+              <a:t> 장치와 모델 계산 reference — 2026-10-11 확인</a:t>
+            </a:r>
+          </a:p>
+          <a:p xmlns:a="http://schemas.openxmlformats.org/drawingml/2006/main">
+            <a:r>
+              <a:t/>
+            </a:r>
+          </a:p>
+          <a:p xmlns:a="http://schemas.openxmlformats.org/drawingml/2006/main">
+            <a:r>
+              <a:t>이 reference는 현재 개발 중인 모델/클라우드 서비스의 실제 가격이나 성능을 뜻하지 않는다. 같은 A/B 계산에 쓸 외부 공개 기준이다. 값은 USD, 모델 단가는 1,000,000 token당 표준 유료 요금이며 free tier/할인으로 0원을 만들지 않는다.</a:t>
+            </a:r>
+          </a:p>
+          <a:p xmlns:a="http://schemas.openxmlformats.org/drawingml/2006/main">
+            <a:r>
+              <a:t/>
+            </a:r>
+          </a:p>
+          <a:p xmlns:a="http://schemas.openxmlformats.org/drawingml/2006/main">
+            <a:r>
+              <a:t>| 용도 | 선택 reference / 값 | 출처와 적용 범위 |</a:t>
+            </a:r>
+          </a:p>
+          <a:p xmlns:a="http://schemas.openxmlformats.org/drawingml/2006/main">
+            <a:r>
+              <a:t>| --- | --- | --- |</a:t>
+            </a:r>
+          </a:p>
+          <a:p xmlns:a="http://schemas.openxmlformats.org/drawingml/2006/main">
+            <a:r>
+              <a:t>| Windows PC | **Galaxy Book6 Ultra NP960UJH-XG3IN**, Windows 11 Home, Core Ultra 7 356H, RAM 32GB LPDDR5X, RTX 5070 Laptop GPU 8GB, SSD 1TB | [삼성 공식 SKU 사양](https://www.samsung.com/in/computers/galaxy-book/galaxy-book6-ultra-ultra-7-32gb-1tb-np960ujh-xg3in/). RAM과 VRAM을 같은 자원으로 합치지 않음. 모델은 클라우드이므로 GPU 가중치 적재를 로컬 비용에 가산하지 않음 |</a:t>
+            </a:r>
+          </a:p>
+          <a:p xmlns:a="http://schemas.openxmlformats.org/drawingml/2006/main">
+            <a:r>
+              <a:t>| 의미 LLM의 비용 | **Qwen3-30B-A3B-Instruct-2507**, `qwen3-30b-a3b-instruct-2507`: Alibaba Cloud Model Studio **Singapore / International** 입력 **$0.20**, 출력 **$0.80** / 1M token, non-thinking | [공식 API 모델/단가](https://docs.modelstudio.console.alibabacloud.com/en/model-studio/qwen3-30b-a3b-instruct-2507), [Qwen 공식 모델 카드](https://huggingface.co/Qwen/Qwen3-30B-A3B-Instruct-2507). 약30B 전체/3B 활성 MoE, Text-to-Text. 사용자 승인한 PoC 의미 모델 기준이며 최종 제품 모델/DP 승자 선정은 아님. 같은 provider/region/revision/mode를 양안에 적용 |</a:t>
+            </a:r>
+          </a:p>
+          <a:p xmlns:a="http://schemas.openxmlformats.org/drawingml/2006/main">
+            <a:r>
+              <a:t>| 의미 LLM의 생성 속도 | **작성자 decode 가정 130 token/s**, 민감도 **100 / 130 / 160 token/s**, 기준 TTFT **0.30초** | [Qwen 공식 H20 benchmark](https://qwen.readthedocs.io/en/latest/getting_started/speed_benchmark.html)의 원본 계열 유효 출력률 약122.53~137.11(BF16) 등을 참고한 수치 규모의 가정. Instruct-2507 API의 공개 decode rate/보장/실측이 아니며 공개표에서 TTFT와 decode를 분리 추출한 값도 아님. 가격은 Alibaba API, 속도 근거는 별도 H20 환경임을 §8.4.1.2에 명시 |</a:t>
+            </a:r>
+          </a:p>
+          <a:p xmlns:a="http://schemas.openxmlformats.org/drawingml/2006/main">
+            <a:r>
+              <a:t>| 음성 비용/비동기 대화 기준 | **OpenAI GPT Realtime**, `gpt-realtime` (`gpt-realtime-2025-08-28`): audio 입력 **$32**, 출력 **$64** / 1M token. Text 입력 **$4**, 출력 **$16** / 1M token. cached audio/Text 입력 **$0.40** / 1M token | [공식 모델/단가](https://developers.openai.com/api/docs/models/gpt-realtime), [Realtime 청구](https://developers.openai.com/api/docs/guides/voice-latency-cost), [비동기 함수 호출](https://developers.openai.com/blog/realtime-api). 사용자 입력 약10 audio token/s, assistant 생성 약20 audio token/s로 신규 audio는 **$0.0192/분 입력, $0.0768/분 출력**으로 환산. 특수 token·이력 재입력·Text·폐기 생성은 별도. 공식 페이지의 Deprecated 상태와 관계없이 사용자가 지정한 날짜별 PoC 비용/기능 reference를 고정하며 실서비스의 신규 채택을 뜻하지 않음 |</a:t>
+            </a:r>
+          </a:p>
+          <a:p xmlns:a="http://schemas.openxmlformats.org/drawingml/2006/main">
+            <a:r>
+              <a:t>| 시간 목표의 사용자 근거 | 즉각 제어 **0.1초**, 대화 흐름 **1초**, 주의 유지 **10초**의 상호작용 참조 | [Nielsen Norman Group 원문](https://www.nngroup.com/articles/website-response-times/). VIA의 평균/모집단/추가 지연 예산은 작성자가 선택하며 문헌이 VIA의 평균 목표를 직접 규정했다고 하지 않음 |</a:t>
+            </a:r>
+          </a:p>
+          <a:p xmlns:a="http://schemas.openxmlformats.org/drawingml/2006/main">
+            <a:r>
+              <a:t/>
+            </a:r>
+          </a:p>
+          <a:p xmlns:a="http://schemas.openxmlformats.org/drawingml/2006/main">
+            <a:r>
+              <a:t>음성 비용은 실제로 보내거나 청구되는 audio/context의 양을 사용한다. VAD가 앞단에 있다는 사실만으로 silence/context 재사용 청구가 0이라고 가정하지 않는다. Text prompt/context, 재시도, 취소 불가인 폐기 출력과 미사용 배경 생산도 포함한다. 같은 사용량을 token 요금과 분 요금으로 이중 계산하지 않는다. 모델 제공자가 사용량을 반환한 실측은 그 사용량을 우선하고, 공개 reference 계산은 음성 길이 기반의 근사임을 남긴다.</a:t>
+            </a:r>
+          </a:p>
+          <a:p xmlns:a="http://schemas.openxmlformats.org/drawingml/2006/main">
+            <a:r>
+              <a:t/>
+            </a:r>
+          </a:p>
+          <a:p xmlns:a="http://schemas.openxmlformats.org/drawingml/2006/main">
+            <a:r>
+              <a:t>검산 예시: 의미 호출의 입력 2,000 token/청구 출력 200 token은 `2,000×0.20/1M + 200×0.80/1M = $0.00056`, 작성자 decode 가정의 생성 부분은 `200/130 ≈ 1.538초`다. Instruct-2507은 non-thinking이며 출력200은 실제 답변/frame/tool 출력의 청구 예산이다. 원천/의미/도구 오류의 추가 질문·재시도·폐기 출력을 모두 포함하고 provider별 tokenizer의 실제 사용량을 우선한다. GPT Realtime 신규 audio 입력 1분/출력 1분은 `600×32/1M + 1,200×64/1M = $0.096`이며 Text와 이력 audio 재입력 청구는 별도다. 응답마다 이전 대화가 입력으로 재사용되므로 실제 `response.done`의 modality별 input/output/cached token을 호출 ID로 중복 제거해 합산한다. 초기 2,000turn을 음성 session에 전부 보내도록 강제하지 않으며 실제 보낸 이력·요약·instruction은 청구한다. 별도 input transcription을 켜면 해당 모델 청구도 더한다. 생성 부분 약1.538초를 첫 출력/입력 처리/통신/queue가 포함된 호출 완료 시간으로 쓰지 않는다. Qwen의 기본 예산에는 할인 없는 입력/출력 단가를 사용한다. 실제 cache 할인이나 별도 저장/도구 청구가 있으면 제공사가 확인한 사용량·단가로 원장에 반영하며 Gemini의 cache 단가를 Qwen에 적용하지 않는다.</a:t>
+            </a:r>
+          </a:p>
+          <a:p xmlns:a="http://schemas.openxmlformats.org/drawingml/2006/main">
+            <a:r>
+              <a:t/>
+            </a:r>
+          </a:p>
+          <a:p xmlns:a="http://schemas.openxmlformats.org/drawingml/2006/main">
+            <a:r>
+              <a:t/>
+            </a:r>
+          </a:p>
+          <a:p xmlns:a="http://schemas.openxmlformats.org/drawingml/2006/main">
+            <a:r>
+              <a:t>### 8.4.1 선택한 모델 역할과 입력 범위</a:t>
+            </a:r>
+          </a:p>
+          <a:p xmlns:a="http://schemas.openxmlformats.org/drawingml/2006/main">
+            <a:r>
+              <a:t/>
+            </a:r>
+          </a:p>
+          <a:p xmlns:a="http://schemas.openxmlformats.org/drawingml/2006/main">
+            <a:r>
+              <a:t>사용자는 **Qwen3-30B-A3B 계열 + GPT Realtime**을 이번 PoC의 모델 reference로 지정했다. 비용/API revision은 앞서 가격을 확인한 **Qwen3-30B-A3B-Instruct-2507**로 고정한다. 원본 `qwen3-30b-a3b`나 Thinking-2507/VL 모델과 혼용하지 않는다. 의미 해석·bounded read 판단·41B의 frame 생성에는 Qwen을, 실시간 음성 입출력/대화 지속에는 GPT Realtime을 사용한다. 외부 업무를 VIA에 맡긴 뒤에도 pending 함수 호출 중 대화를 계속한다. VIA가 외부 Agent의 실행/현재 Task/승인/질문/결과 연결의 권위를 유지하며 GPT Realtime의 tool pending을 실제 업무 완료로 해석하지 않는다. 양안은 같은 역할별 모델/설정/입출력 계약을 사용한다.</a:t>
+            </a:r>
+          </a:p>
+          <a:p xmlns:a="http://schemas.openxmlformats.org/drawingml/2006/main">
+            <a:r>
+              <a:t/>
+            </a:r>
+          </a:p>
+          <a:p xmlns:a="http://schemas.openxmlformats.org/drawingml/2006/main">
+            <a:r>
+              <a:t>Qwen은 Text-to-Text 모델이다. P21의 S2-01 등은 이미 원천 observation으로 표 내용/version·관측시각·포인터 이력을 제공하므로, 그 **원천 사실과 span을 공통 text 입력으로 직렬화**한다. 최종 A/B 지칭, Task 연결, revision 선택, 의존 관계 또는 채점 정답을 adapter가 미리 채우지 않는다. 조회하지 않은 원천 내용·권한 없는 내용도 자동으로 넣지 않는다. 소스 원문/구조 정보는 그대로 공급하고, 의미 결합은 각 방안이 생산한다. 원본 화면 frame은 시간/보관/메모리 원장에 유지한다. 이는 픽셀만으로 임의 앱 화면을 인식하는 완성 제품 평가가 아니라 정의된 PoC 원천 자료를 사용하는 범위다. 추가 vision/OCR 모델을 현재 예산에 숨겨 넣지 않는다. 실제 픽셀 인식이 필요해지면 공통 관측 adapter의 추가 모델·비용·지연·권한·손실을 동일하게 명시하고 계약을 개정한다.</a:t>
+            </a:r>
+          </a:p>
+          <a:p xmlns:a="http://schemas.openxmlformats.org/drawingml/2006/main">
+            <a:r>
+              <a:t/>
+            </a:r>
+          </a:p>
+          <a:p xmlns:a="http://schemas.openxmlformats.org/drawingml/2006/main">
+            <a:r>
+              <a:t>Qwen frame/tool 출력은 구문·허용 schema·ID/revision·현재성 검사를 거친다. 모델 이름만으로 JSON/함수 호출이 항상 맞거나 provider가 엄격한 schema decoding을 보장한다고 가정하지 않는다. 잘못된 출력의 재시도와 판단 유보는 같은 사례/실패/청구 원장에 포함한다. GPT Realtime의 structured output 미지원 때문에 음성 모델을 41B의 의미 frame 생산자로 대신 쓰지 않는다. 비용/기능 reference의 지정은 제품 모델 채택, Architecture 대안 선택이나 정확성 측정의 완료가 아니다.</a:t>
+            </a:r>
+          </a:p>
+          <a:p xmlns:a="http://schemas.openxmlformats.org/drawingml/2006/main">
+            <a:r>
+              <a:t/>
+            </a:r>
+          </a:p>
+          <a:p xmlns:a="http://schemas.openxmlformats.org/drawingml/2006/main">
+            <a:r>
+              <a:t>### 8.4.1.1 이전 Gemini 선택 이유와 변경 이력</a:t>
+            </a:r>
+          </a:p>
+          <a:p xmlns:a="http://schemas.openxmlformats.org/drawingml/2006/main">
+            <a:r>
+              <a:t/>
+            </a:r>
+          </a:p>
+          <a:p xmlns:a="http://schemas.openxmlformats.org/drawingml/2006/main">
+            <a:r>
+              <a:t>Gemini 3 Flash Preview의 공개 출시일은 **2025-12-17**이다([Google 출시 공지](https://blog.google/products-and-platforms/products/gemini/gemini-3-flash/)). 이전 선택은 공식 단가와 이미지 입력·함수 호출·structured output을 가진 reference의 편의에 따른 것이며 VIA 우월성이나 Qwen 30B와의 동등성 검증이 아니었다. 이후 정확한 Qwen API 단가를 확인했고 사용자가 Qwen/GPT 조합을 지정했으므로 **Gemini는 현행 의미/비용/속도 기준에서 제외**한다. 같은 124k/12.4k token 예산의 이전 Gemini 의미 비용 $0.09920과 현재 Qwen $0.03472의 차이 $0.06448는 단가 민감도이며 실제 호출/정확성/출력 동등성의 증거가 아니다. 기존 200 token/s와 Gemini cache 요금은 [변경 전 보존본](../../../archive/qa-semantic-reference-before-qwen-20261011/README.md)에 남겼다.</a:t>
+            </a:r>
+          </a:p>
+          <a:p xmlns:a="http://schemas.openxmlformats.org/drawingml/2006/main">
+            <a:r>
+              <a:t/>
+            </a:r>
+          </a:p>
+          <a:p xmlns:a="http://schemas.openxmlformats.org/drawingml/2006/main">
+            <a:r>
+              <a:t>### 8.4.1.2 Groq 밖의 속도 근거와 산식</a:t>
+            </a:r>
+          </a:p>
+          <a:p xmlns:a="http://schemas.openxmlformats.org/drawingml/2006/main">
+            <a:r>
+              <a:t/>
+            </a:r>
+          </a:p>
+          <a:p xmlns:a="http://schemas.openxmlformats.org/drawingml/2006/main">
+            <a:r>
+              <a:t>[Qwen 공식 속도 benchmark](https://qwen.readthedocs.io/en/latest/getting_started/speed_benchmark.html)는 **Qwen3-30B-A3B**를 NVIDIA **H20 96GB 1장**, SGLang **0.4.6.post1**, PyTorch **2.6.0+cu124**, batch **1**, 출력 **2,048 token**으로 평가했다. 입력1 token에서 BF16 **137.18**, FP8 **155.55 token/s**다. 입력6,144 token에서는 BF16 **490.10**, FP8 **551.34**다. 단, 공식 분자는 **입력+출력 token**, 분모는 전체 처리시간이다. 입력6,144의 490.10을 출력 생성률로 쓰지 않는다.</a:t>
+            </a:r>
+          </a:p>
+          <a:p xmlns:a="http://schemas.openxmlformats.org/drawingml/2006/main">
+            <a:r>
+              <a:t/>
+            </a:r>
+          </a:p>
+          <a:p xmlns:a="http://schemas.openxmlformats.org/drawingml/2006/main">
+            <a:r>
+              <a:t>BF16 입력1 조건의 전체 시간은 `2,049/137.18 ≈ 14.94초`, 입력6,144 조건은 `8,192/490.10 ≈ 16.72초`로 복원할 수 있다. 출력/전체시간으로 다시 표현하면 각각 **137.11**과 **122.53 output token/s**이며 이는 prefill까지 포함한 해당 길이의 유효 출력률이다. 이것을 TTFT와 분리된 decode rate로 두고 TTFT를 다시 더하면 입력 처리 시간이 이중 계상된다. 원본 Qwen3 benchmark를 Instruct-2507의 실측 또는 Alibaba Singapore API의 속도로 주장하지 않는다. 서버 측 H20 reference이므로 Windows 노트북의 속도/메모리에도 이전하지 않는다.</a:t>
+            </a:r>
+          </a:p>
+          <a:p xmlns:a="http://schemas.openxmlformats.org/drawingml/2006/main">
+            <a:r>
+              <a:t/>
+            </a:r>
+          </a:p>
+          <a:p xmlns:a="http://schemas.openxmlformats.org/drawingml/2006/main">
+            <a:r>
+              <a:t>따라서 공식 수치 기반의 계산은 **공개된 동일 길이/환경의 전체 처리시간**을 쓰거나, 별도로 검증된 decode rate와 TTFT를 분리해야 한다. 현재는 원본 계열 BF16 유효 출력률 약122.53~137.11과 FP8 입력1 약155.47을 수치 규모의 참고로 삼아 **130 token/s의 독립적인 PoC decode 가정**과 **100/130/160 민감도**를 정했다. 기준 TTFT0.30초, 빠른0.15초, 느린0.80초와 음성 시작0.10/0.25/0.60초도 별도 작성자 가정이다. 이들을 공개표에서 분리 측정한 TTFT/decode로 주장하지 않는다. 특히 2,048 출력의 유효 출력률을 2,000입력/200출력에 보장된 rate로 이전하지 않는다. API 배포의 TTFT/생성률이 있으면 두 가정을 실제 측정으로 함께 교체하고, 공개 benchmark 자체를 재현 계산할 때는 전체시간만 써서 prefill을 중복 계상하지 않는다. API 가격 reference와 별도 H20 속도 reference를 함께 사용하는 경우 비용/속도가 같은 서비스에서 측정됐다는 주장도 하지 않는다.</a:t>
+            </a:r>
+          </a:p>
+          <a:p xmlns:a="http://schemas.openxmlformats.org/drawingml/2006/main">
+            <a:r>
+              <a:t/>
+            </a:r>
+          </a:p>
+          <a:p xmlns:a="http://schemas.openxmlformats.org/drawingml/2006/main">
+            <a:r>
+              <a:t>기존의 **450+ token/s**는 [Groq의 `qwen/qwen3.8-27b` 모델 페이지](https://console.groq.com/docs/model/qwen/qwen3.8-27b)의 제공사 표시값이다. [GroqCloud는 전용 LPU 추론 인프라](https://groq.com/blog/the-groq-lpu-explained)를 사용한다. 이는 Qwen3-30B-A3B-Instruct-2507, NVIDIA GPU 또는 Windows PC의 숫자가 아니다. 해당 450 수치의 LPU 수/세대, precision, prompt/output 길이, 동시 요청 수와 상세 계측 경계는 페이지에 공개되어 있지 않으므로 가정으로 채우지 않는다. Groq은 현행 비용/속도 reference에서 제외하며 이 문단은 이전 근거의 의미를 설명하기 위한 provenance다.</a:t>
+            </a:r>
+          </a:p>
+          <a:p xmlns:a="http://schemas.openxmlformats.org/drawingml/2006/main">
+            <a:r>
+              <a:t/>
+            </a:r>
+          </a:p>
+          <a:p xmlns:a="http://schemas.openxmlformats.org/drawingml/2006/main">
+            <a:r>
+              <a:t>### 8.4.2 Gemini Live와 GPT Realtime의 기능 비교</a:t>
+            </a:r>
+          </a:p>
+          <a:p xmlns:a="http://schemas.openxmlformats.org/drawingml/2006/main">
+            <a:r>
+              <a:t/>
+            </a:r>
+          </a:p>
+          <a:p xmlns:a="http://schemas.openxmlformats.org/drawingml/2006/main">
+            <a:r>
+              <a:t>2026-10-11 확인한 공식 문서 기준으로 같은 실시간 음성 대화 역할을 제공하지만 API/실행 제약은 다르다. 아래 GPT는 사용자가 지칭한 `gpt-realtime` 모델 기준이며 다른 GPT Realtime 모델의 제한으로 확대하지 않는다. 현재 공식 모델 페이지는 해당 모델을 Deprecated로 표시하므로 실제 제품 적용 권고가 아니라 요청한 기능 비교 기준으로만 쓴다.</a:t>
+            </a:r>
+          </a:p>
+          <a:p xmlns:a="http://schemas.openxmlformats.org/drawingml/2006/main">
+            <a:r>
+              <a:t/>
+            </a:r>
+          </a:p>
+          <a:p xmlns:a="http://schemas.openxmlformats.org/drawingml/2006/main">
+            <a:r>
+              <a:t>| 비교 항목 | Gemini 3.1 Flash Live Preview | OpenAI gpt-realtime | VIA에 주는 의미 |</a:t>
+            </a:r>
+          </a:p>
+          <a:p xmlns:a="http://schemas.openxmlformats.org/drawingml/2006/main">
+            <a:r>
+              <a:t>| --- | --- | --- | --- |</a:t>
+            </a:r>
+          </a:p>
+          <a:p xmlns:a="http://schemas.openxmlformats.org/drawingml/2006/main">
+            <a:r>
+              <a:t>| 실시간 음성 입출력, 입력/출력 전사, 발화 중 끼어들기 | 지원 | 지원 | 양쪽 모두 음성 역할의 reference가 될 수 있다. 실제 한국어 품질·지연·중단 시간 동등성은 입증하지 않음 |</a:t>
+            </a:r>
+          </a:p>
+          <a:p xmlns:a="http://schemas.openxmlformats.org/drawingml/2006/main">
+            <a:r>
+              <a:t>| 화면/멀티모달 입력 | Text·이미지·audio·video 입력 | Text·이미지·audio 입력, video 미지원 | GPT에서는 화면 snapshot의 이미지 입력과 video stream 지원을 구별 |</a:t>
+            </a:r>
+          </a:p>
+          <a:p xmlns:a="http://schemas.openxmlformats.org/drawingml/2006/main">
+            <a:r>
+              <a:t>| 함수 호출 | 동기만 지원, tool response 전 응답 대기 | 비동기 tool 흐름 지원 | 긴 Agent 실행을 Gemini Live tool response로 끝날 때까지 기다리게 하지 않음 |</a:t>
+            </a:r>
+          </a:p>
+          <a:p xmlns:a="http://schemas.openxmlformats.org/drawingml/2006/main">
+            <a:r>
+              <a:t>| 직접 연결 | Live API WebSocket | WebRTC / WebSocket / SIP | provider adapter·세션 재연결·audio queue/취소 이벤트를 별도로 구현/계산 |</a:t>
+            </a:r>
+          </a:p>
+          <a:p xmlns:a="http://schemas.openxmlformats.org/drawingml/2006/main">
+            <a:r>
+              <a:t>| structured output | 미지원 | 미지원 | 함수 인자 JSON과 schema 제약 출력 보장을 구별, 의미 모델의 frame 검증은 별도 |</a:t>
+            </a:r>
+          </a:p>
+          <a:p xmlns:a="http://schemas.openxmlformats.org/drawingml/2006/main">
+            <a:r>
+              <a:t/>
+            </a:r>
+          </a:p>
+          <a:p xmlns:a="http://schemas.openxmlformats.org/drawingml/2006/main">
+            <a:r>
+              <a:t>근거: [Gemini Live 모델/제약](https://ai.google.dev/gemini-api/docs/models/gemini-3.1-flash-live-preview), [Live 도구의 동기 제한](https://ai.google.dev/gemini-api/docs/live-api/tools), [Live API 연결](https://ai.google.dev/gemini-api/docs/live-api), [Live VAD/중단](https://ai.google.dev/gemini-api/docs/live-api/capabilities), [OpenAI gpt-realtime](https://developers.openai.com/api/docs/models/gpt-realtime), [Realtime 대화/중단](https://developers.openai.com/api/docs/guides/realtime-conversations), [Realtime 도구](https://developers.openai.com/api/docs/guides/realtime-mcp), [GPT Realtime 비동기 함수 호출 설명](https://developers.openai.com/blog/realtime-api).</a:t>
+            </a:r>
+          </a:p>
+          <a:p xmlns:a="http://schemas.openxmlformats.org/drawingml/2006/main">
+            <a:r>
+              <a:t/>
+            </a:r>
+          </a:p>
+          <a:p xmlns:a="http://schemas.openxmlformats.org/drawingml/2006/main">
+            <a:r>
+              <a:t>VIA는 요청/Task의 권위를 갖고 음성 모델의 임시 session과 구별한다. 긴 업무는 로컬 VIA가 외부 Agent에 비동기로 위임하고, 음성 모델에는 유효한 접수·질문·결과를 제시할 입력을 따로 전달하는 방향으로 reference를 해석한다. 이것은 긴 Agent 결과를 Live 동기 함수 응답으로 기다리는 것과 다르다. 실제 provider의 forced response, cancel, 재연결, 출력 내용 준수와 local playback stop은 adapter/API 검증에서 확인해야 한다. 현재 GPT Realtime reference에서도 local playback stop·새 사용자 요청·동시에 도착한 Agent 질문/결과의 우선순위는 VIA가 관리하고, pending tool의 결과가 없는 동안 완료를 추측해 말하지 못하도록 실제 상태를 전달한다. 이전 Gemini 3.1 검토의 proactive audio/affective dialogue 미지원과 `turn_complete=true`의 활성 generation 중단은 기능 비교의 제한으로 보존한다. 모델 이름만으로 연속 입력/여러 Task 처리 계약이 충족됐다고 하지 않는다.</a:t>
             </a:r>
           </a:p>
           <a:p xmlns:a="http://schemas.openxmlformats.org/drawingml/2006/main">
@@ -6777,7 +7062,7 @@
           </a:p>
           <a:p xmlns:a="http://schemas.openxmlformats.org/drawingml/2006/main">
             <a:r>
-              <a:t>원본 SHA-256: d25a503005403e71d5811d61f20d9c227479bfeb04808ba868ce06adc463e4f8</a:t>
+              <a:t>원본 SHA-256: 8520fa1bd1661f72bb87071ab03755964b0539565490994de845bbc086654cfd</a:t>
             </a:r>
           </a:p>
           <a:p xmlns:a="http://schemas.openxmlformats.org/drawingml/2006/main">
@@ -6812,7 +7097,7 @@
           </a:p>
           <a:p xmlns:a="http://schemas.openxmlformats.org/drawingml/2006/main">
             <a:r>
-              <a:t>목표 근거: 동일 21사례의 의미 62호출/음성 입력 50초/출력 179초 예산에서 신규 audio·Text 포함 기본 $0.416320, 이력 audio/추가생산/재시도 여유 $0.083680. 호출·출력은 작성자 가정이며 실제 사용량으로 대체 (§5)</a:t>
+              <a:t>목표 근거: 동일 21사례의 의미 62호출/음성 입력 50초/출력 179초 예산에서 신규 audio·Text 포함 기본 $0.351840, 이력 audio/추가생산/재시도 여유 $0.148160. 호출·출력은 작성자 가정이며 실제 사용량으로 대체 (§5)</a:t>
             </a:r>
           </a:p>
           <a:p xmlns:a="http://schemas.openxmlformats.org/drawingml/2006/main">
@@ -6827,7 +7112,7 @@
           </a:p>
           <a:p xmlns:a="http://schemas.openxmlformats.org/drawingml/2006/main">
             <a:r>
-              <a:t>Google Gemini 3 Flash 공식 단가: https://ai.google.dev/gemini-api/docs/pricing#gemini-3-flash-preview</a:t>
+              <a:t>Alibaba Qwen Instruct-2507 공식 단가: https://docs.modelstudio.console.alibabacloud.com/en/model-studio/qwen3-30b-a3b-instruct-2507</a:t>
             </a:r>
           </a:p>
           <a:p xmlns:a="http://schemas.openxmlformats.org/drawingml/2006/main">
@@ -6937,7 +7222,7 @@
           </a:p>
           <a:p xmlns:a="http://schemas.openxmlformats.org/drawingml/2006/main">
             <a:r>
-              <a:t>| 의미62호출, 입력124,000/출력12,400 token | 0.099200 |</a:t>
+              <a:t>| 의미62호출, 입력124,000/출력12,400 token | 0.034720 |</a:t>
             </a:r>
           </a:p>
           <a:p xmlns:a="http://schemas.openxmlformats.org/drawingml/2006/main">
@@ -6952,12 +7237,12 @@
           </a:p>
           <a:p xmlns:a="http://schemas.openxmlformats.org/drawingml/2006/main">
             <a:r>
-              <a:t>| 신규 audio·청구 Text를 포함한 기본 소계 | **0.416320** |</a:t>
-            </a:r>
-          </a:p>
-          <a:p xmlns:a="http://schemas.openxmlformats.org/drawingml/2006/main">
-            <a:r>
-              <a:t>| 이력 audio 재입력/추가생산/재시도 여유 | **0.083680** |</a:t>
+              <a:t>| 신규 audio·청구 Text를 포함한 기본 소계 | **0.351840** |</a:t>
+            </a:r>
+          </a:p>
+          <a:p xmlns:a="http://schemas.openxmlformats.org/drawingml/2006/main">
+            <a:r>
+              <a:t>| 이력 audio 재입력/추가생산/재시도 여유 | **0.148160** |</a:t>
             </a:r>
           </a:p>
           <a:p xmlns:a="http://schemas.openxmlformats.org/drawingml/2006/main">
@@ -6972,7 +7257,7 @@
           </a:p>
           <a:p xmlns:a="http://schemas.openxmlformats.org/drawingml/2006/main">
             <a:r>
-              <a:t>음성 기준을 GPT Realtime으로 바꾼 동일 P21에서 다시 계산했다. 기본 소계 대비 약 20.10%의 여유를 둔 $0.50/P21 작성자 평가 예산이며 상품 가격이나 모델 성능 보장이 아니다. 앞의 50/179초는 신규 audio 길이만이므로 이력 audio 재입력의 청구를 포함한 실제 총액이라고 주장하지 않는다. Text 10k/2k는 호출별 누적 청구량의 예산이다. 추가 audio 이력·초기/배경 생산·재시도는 여유에서 부담하며 실제 response usage로 모두 합산한다. 여유 전부를 할인 없는 audio 이력 입력에 쓰면 2,615 token($0.083680)이고 다른 추가 비용이 있으면 그만큼 줄어든다. 캐시 할인/음성 이력의 transcript 대체는 실제 확인된 사용량에만 적용한다. 목표를 맞추기 위해 대화를 매 사례 초기화하거나 VIA의 Task/근거 이력을 없애지 않는다. Source 변경 4건이 모델 생산 4호출을 강제하지 않는다. 실제 backfill·추가 질문·재시도가 많으면 목표 미달을 그대로 보고한다.</a:t>
+              <a:t>의미 기준을 Qwen Instruct-2507, 음성 기준을 GPT Realtime으로 정한 동일 P21에서 다시 계산했다. $0.50 목표는 유지하고 의미 단가 감소분을 추가 처리 여유에 반영한다. 기본 소계 대비 약 42.11%의 여유를 둔 $0.50/P21 작성자 평가 예산이며 상품 가격이나 모델 성능 보장이 아니다. 앞의 50/179초는 신규 audio 길이만이므로 이력 audio 재입력의 청구를 포함한 실제 총액이라고 주장하지 않는다. Text 10k/2k는 호출별 누적 청구량의 예산이다. 추가 audio 이력·초기/배경 생산·재시도는 여유에서 부담하며 실제 response usage로 모두 합산한다. 여유 전부를 할인 없는 audio 이력 입력에 쓰면 4,630 token($0.148160)이고 다른 추가 비용이 있으면 그만큼 줄어든다. 캐시 할인/음성 이력의 transcript 대체는 실제 확인된 사용량에만 적용한다. 목표를 맞추기 위해 대화를 매 사례 초기화하거나 VIA의 Task/근거 이력을 없애지 않는다. Source 변경 4건이 모델 생산 4호출을 강제하지 않는다. 실제 backfill·추가 질문·재시도가 많으면 목표 미달을 그대로 보고한다.</a:t>
             </a:r>
           </a:p>
           <a:p xmlns:a="http://schemas.openxmlformats.org/drawingml/2006/main">
@@ -10893,6 +11178,291 @@
           <a:p xmlns:a="http://schemas.openxmlformats.org/drawingml/2006/main">
             <a:r>
               <a:t>묶음당 21개 시나리오는 사용자 19개 + Agent 단독 2개다. 집중 장면 안에는 Agent 사건 4개가 추가로 들어 있다. Voice 입력 50초와 출력 예산 179초, 반응 27개와 사용자 cycle 19개를 정의했다. 다섯 묶음 전체는 105개 시나리오·630조건·135반응·95cycle이다. 사용자의 하루 빈도를 뜻하지 않는다.</a:t>
+            </a:r>
+          </a:p>
+          <a:p xmlns:a="http://schemas.openxmlformats.org/drawingml/2006/main">
+            <a:r>
+              <a:t/>
+            </a:r>
+          </a:p>
+          <a:p xmlns:a="http://schemas.openxmlformats.org/drawingml/2006/main">
+            <a:r>
+              <a:t/>
+            </a:r>
+          </a:p>
+          <a:p xmlns:a="http://schemas.openxmlformats.org/drawingml/2006/main">
+            <a:r>
+              <a:t>모델 reference 상세 §8.4</a:t>
+            </a:r>
+          </a:p>
+          <a:p xmlns:a="http://schemas.openxmlformats.org/drawingml/2006/main">
+            <a:r>
+              <a:t> 장치와 모델 계산 reference — 2026-10-11 확인</a:t>
+            </a:r>
+          </a:p>
+          <a:p xmlns:a="http://schemas.openxmlformats.org/drawingml/2006/main">
+            <a:r>
+              <a:t/>
+            </a:r>
+          </a:p>
+          <a:p xmlns:a="http://schemas.openxmlformats.org/drawingml/2006/main">
+            <a:r>
+              <a:t>이 reference는 현재 개발 중인 모델/클라우드 서비스의 실제 가격이나 성능을 뜻하지 않는다. 같은 A/B 계산에 쓸 외부 공개 기준이다. 값은 USD, 모델 단가는 1,000,000 token당 표준 유료 요금이며 free tier/할인으로 0원을 만들지 않는다.</a:t>
+            </a:r>
+          </a:p>
+          <a:p xmlns:a="http://schemas.openxmlformats.org/drawingml/2006/main">
+            <a:r>
+              <a:t/>
+            </a:r>
+          </a:p>
+          <a:p xmlns:a="http://schemas.openxmlformats.org/drawingml/2006/main">
+            <a:r>
+              <a:t>| 용도 | 선택 reference / 값 | 출처와 적용 범위 |</a:t>
+            </a:r>
+          </a:p>
+          <a:p xmlns:a="http://schemas.openxmlformats.org/drawingml/2006/main">
+            <a:r>
+              <a:t>| --- | --- | --- |</a:t>
+            </a:r>
+          </a:p>
+          <a:p xmlns:a="http://schemas.openxmlformats.org/drawingml/2006/main">
+            <a:r>
+              <a:t>| Windows PC | **Galaxy Book6 Ultra NP960UJH-XG3IN**, Windows 11 Home, Core Ultra 7 356H, RAM 32GB LPDDR5X, RTX 5070 Laptop GPU 8GB, SSD 1TB | [삼성 공식 SKU 사양](https://www.samsung.com/in/computers/galaxy-book/galaxy-book6-ultra-ultra-7-32gb-1tb-np960ujh-xg3in/). RAM과 VRAM을 같은 자원으로 합치지 않음. 모델은 클라우드이므로 GPU 가중치 적재를 로컬 비용에 가산하지 않음 |</a:t>
+            </a:r>
+          </a:p>
+          <a:p xmlns:a="http://schemas.openxmlformats.org/drawingml/2006/main">
+            <a:r>
+              <a:t>| 의미 LLM의 비용 | **Qwen3-30B-A3B-Instruct-2507**, `qwen3-30b-a3b-instruct-2507`: Alibaba Cloud Model Studio **Singapore / International** 입력 **$0.20**, 출력 **$0.80** / 1M token, non-thinking | [공식 API 모델/단가](https://docs.modelstudio.console.alibabacloud.com/en/model-studio/qwen3-30b-a3b-instruct-2507), [Qwen 공식 모델 카드](https://huggingface.co/Qwen/Qwen3-30B-A3B-Instruct-2507). 약30B 전체/3B 활성 MoE, Text-to-Text. 사용자 승인한 PoC 의미 모델 기준이며 최종 제품 모델/DP 승자 선정은 아님. 같은 provider/region/revision/mode를 양안에 적용 |</a:t>
+            </a:r>
+          </a:p>
+          <a:p xmlns:a="http://schemas.openxmlformats.org/drawingml/2006/main">
+            <a:r>
+              <a:t>| 의미 LLM의 생성 속도 | **작성자 decode 가정 130 token/s**, 민감도 **100 / 130 / 160 token/s**, 기준 TTFT **0.30초** | [Qwen 공식 H20 benchmark](https://qwen.readthedocs.io/en/latest/getting_started/speed_benchmark.html)의 원본 계열 유효 출력률 약122.53~137.11(BF16) 등을 참고한 수치 규모의 가정. Instruct-2507 API의 공개 decode rate/보장/실측이 아니며 공개표에서 TTFT와 decode를 분리 추출한 값도 아님. 가격은 Alibaba API, 속도 근거는 별도 H20 환경임을 §8.4.1.2에 명시 |</a:t>
+            </a:r>
+          </a:p>
+          <a:p xmlns:a="http://schemas.openxmlformats.org/drawingml/2006/main">
+            <a:r>
+              <a:t>| 음성 비용/비동기 대화 기준 | **OpenAI GPT Realtime**, `gpt-realtime` (`gpt-realtime-2025-08-28`): audio 입력 **$32**, 출력 **$64** / 1M token. Text 입력 **$4**, 출력 **$16** / 1M token. cached audio/Text 입력 **$0.40** / 1M token | [공식 모델/단가](https://developers.openai.com/api/docs/models/gpt-realtime), [Realtime 청구](https://developers.openai.com/api/docs/guides/voice-latency-cost), [비동기 함수 호출](https://developers.openai.com/blog/realtime-api). 사용자 입력 약10 audio token/s, assistant 생성 약20 audio token/s로 신규 audio는 **$0.0192/분 입력, $0.0768/분 출력**으로 환산. 특수 token·이력 재입력·Text·폐기 생성은 별도. 공식 페이지의 Deprecated 상태와 관계없이 사용자가 지정한 날짜별 PoC 비용/기능 reference를 고정하며 실서비스의 신규 채택을 뜻하지 않음 |</a:t>
+            </a:r>
+          </a:p>
+          <a:p xmlns:a="http://schemas.openxmlformats.org/drawingml/2006/main">
+            <a:r>
+              <a:t>| 시간 목표의 사용자 근거 | 즉각 제어 **0.1초**, 대화 흐름 **1초**, 주의 유지 **10초**의 상호작용 참조 | [Nielsen Norman Group 원문](https://www.nngroup.com/articles/website-response-times/). VIA의 평균/모집단/추가 지연 예산은 작성자가 선택하며 문헌이 VIA의 평균 목표를 직접 규정했다고 하지 않음 |</a:t>
+            </a:r>
+          </a:p>
+          <a:p xmlns:a="http://schemas.openxmlformats.org/drawingml/2006/main">
+            <a:r>
+              <a:t/>
+            </a:r>
+          </a:p>
+          <a:p xmlns:a="http://schemas.openxmlformats.org/drawingml/2006/main">
+            <a:r>
+              <a:t>음성 비용은 실제로 보내거나 청구되는 audio/context의 양을 사용한다. VAD가 앞단에 있다는 사실만으로 silence/context 재사용 청구가 0이라고 가정하지 않는다. Text prompt/context, 재시도, 취소 불가인 폐기 출력과 미사용 배경 생산도 포함한다. 같은 사용량을 token 요금과 분 요금으로 이중 계산하지 않는다. 모델 제공자가 사용량을 반환한 실측은 그 사용량을 우선하고, 공개 reference 계산은 음성 길이 기반의 근사임을 남긴다.</a:t>
+            </a:r>
+          </a:p>
+          <a:p xmlns:a="http://schemas.openxmlformats.org/drawingml/2006/main">
+            <a:r>
+              <a:t/>
+            </a:r>
+          </a:p>
+          <a:p xmlns:a="http://schemas.openxmlformats.org/drawingml/2006/main">
+            <a:r>
+              <a:t>검산 예시: 의미 호출의 입력 2,000 token/청구 출력 200 token은 `2,000×0.20/1M + 200×0.80/1M = $0.00056`, 작성자 decode 가정의 생성 부분은 `200/130 ≈ 1.538초`다. Instruct-2507은 non-thinking이며 출력200은 실제 답변/frame/tool 출력의 청구 예산이다. 원천/의미/도구 오류의 추가 질문·재시도·폐기 출력을 모두 포함하고 provider별 tokenizer의 실제 사용량을 우선한다. GPT Realtime 신규 audio 입력 1분/출력 1분은 `600×32/1M + 1,200×64/1M = $0.096`이며 Text와 이력 audio 재입력 청구는 별도다. 응답마다 이전 대화가 입력으로 재사용되므로 실제 `response.done`의 modality별 input/output/cached token을 호출 ID로 중복 제거해 합산한다. 초기 2,000turn을 음성 session에 전부 보내도록 강제하지 않으며 실제 보낸 이력·요약·instruction은 청구한다. 별도 input transcription을 켜면 해당 모델 청구도 더한다. 생성 부분 약1.538초를 첫 출력/입력 처리/통신/queue가 포함된 호출 완료 시간으로 쓰지 않는다. Qwen의 기본 예산에는 할인 없는 입력/출력 단가를 사용한다. 실제 cache 할인이나 별도 저장/도구 청구가 있으면 제공사가 확인한 사용량·단가로 원장에 반영하며 Gemini의 cache 단가를 Qwen에 적용하지 않는다.</a:t>
+            </a:r>
+          </a:p>
+          <a:p xmlns:a="http://schemas.openxmlformats.org/drawingml/2006/main">
+            <a:r>
+              <a:t/>
+            </a:r>
+          </a:p>
+          <a:p xmlns:a="http://schemas.openxmlformats.org/drawingml/2006/main">
+            <a:r>
+              <a:t/>
+            </a:r>
+          </a:p>
+          <a:p xmlns:a="http://schemas.openxmlformats.org/drawingml/2006/main">
+            <a:r>
+              <a:t>### 8.4.1 선택한 모델 역할과 입력 범위</a:t>
+            </a:r>
+          </a:p>
+          <a:p xmlns:a="http://schemas.openxmlformats.org/drawingml/2006/main">
+            <a:r>
+              <a:t/>
+            </a:r>
+          </a:p>
+          <a:p xmlns:a="http://schemas.openxmlformats.org/drawingml/2006/main">
+            <a:r>
+              <a:t>사용자는 **Qwen3-30B-A3B 계열 + GPT Realtime**을 이번 PoC의 모델 reference로 지정했다. 비용/API revision은 앞서 가격을 확인한 **Qwen3-30B-A3B-Instruct-2507**로 고정한다. 원본 `qwen3-30b-a3b`나 Thinking-2507/VL 모델과 혼용하지 않는다. 의미 해석·bounded read 판단·41B의 frame 생성에는 Qwen을, 실시간 음성 입출력/대화 지속에는 GPT Realtime을 사용한다. 외부 업무를 VIA에 맡긴 뒤에도 pending 함수 호출 중 대화를 계속한다. VIA가 외부 Agent의 실행/현재 Task/승인/질문/결과 연결의 권위를 유지하며 GPT Realtime의 tool pending을 실제 업무 완료로 해석하지 않는다. 양안은 같은 역할별 모델/설정/입출력 계약을 사용한다.</a:t>
+            </a:r>
+          </a:p>
+          <a:p xmlns:a="http://schemas.openxmlformats.org/drawingml/2006/main">
+            <a:r>
+              <a:t/>
+            </a:r>
+          </a:p>
+          <a:p xmlns:a="http://schemas.openxmlformats.org/drawingml/2006/main">
+            <a:r>
+              <a:t>Qwen은 Text-to-Text 모델이다. P21의 S2-01 등은 이미 원천 observation으로 표 내용/version·관측시각·포인터 이력을 제공하므로, 그 **원천 사실과 span을 공통 text 입력으로 직렬화**한다. 최종 A/B 지칭, Task 연결, revision 선택, 의존 관계 또는 채점 정답을 adapter가 미리 채우지 않는다. 조회하지 않은 원천 내용·권한 없는 내용도 자동으로 넣지 않는다. 소스 원문/구조 정보는 그대로 공급하고, 의미 결합은 각 방안이 생산한다. 원본 화면 frame은 시간/보관/메모리 원장에 유지한다. 이는 픽셀만으로 임의 앱 화면을 인식하는 완성 제품 평가가 아니라 정의된 PoC 원천 자료를 사용하는 범위다. 추가 vision/OCR 모델을 현재 예산에 숨겨 넣지 않는다. 실제 픽셀 인식이 필요해지면 공통 관측 adapter의 추가 모델·비용·지연·권한·손실을 동일하게 명시하고 계약을 개정한다.</a:t>
+            </a:r>
+          </a:p>
+          <a:p xmlns:a="http://schemas.openxmlformats.org/drawingml/2006/main">
+            <a:r>
+              <a:t/>
+            </a:r>
+          </a:p>
+          <a:p xmlns:a="http://schemas.openxmlformats.org/drawingml/2006/main">
+            <a:r>
+              <a:t>Qwen frame/tool 출력은 구문·허용 schema·ID/revision·현재성 검사를 거친다. 모델 이름만으로 JSON/함수 호출이 항상 맞거나 provider가 엄격한 schema decoding을 보장한다고 가정하지 않는다. 잘못된 출력의 재시도와 판단 유보는 같은 사례/실패/청구 원장에 포함한다. GPT Realtime의 structured output 미지원 때문에 음성 모델을 41B의 의미 frame 생산자로 대신 쓰지 않는다. 비용/기능 reference의 지정은 제품 모델 채택, Architecture 대안 선택이나 정확성 측정의 완료가 아니다.</a:t>
+            </a:r>
+          </a:p>
+          <a:p xmlns:a="http://schemas.openxmlformats.org/drawingml/2006/main">
+            <a:r>
+              <a:t/>
+            </a:r>
+          </a:p>
+          <a:p xmlns:a="http://schemas.openxmlformats.org/drawingml/2006/main">
+            <a:r>
+              <a:t>### 8.4.1.1 이전 Gemini 선택 이유와 변경 이력</a:t>
+            </a:r>
+          </a:p>
+          <a:p xmlns:a="http://schemas.openxmlformats.org/drawingml/2006/main">
+            <a:r>
+              <a:t/>
+            </a:r>
+          </a:p>
+          <a:p xmlns:a="http://schemas.openxmlformats.org/drawingml/2006/main">
+            <a:r>
+              <a:t>Gemini 3 Flash Preview의 공개 출시일은 **2025-12-17**이다([Google 출시 공지](https://blog.google/products-and-platforms/products/gemini/gemini-3-flash/)). 이전 선택은 공식 단가와 이미지 입력·함수 호출·structured output을 가진 reference의 편의에 따른 것이며 VIA 우월성이나 Qwen 30B와의 동등성 검증이 아니었다. 이후 정확한 Qwen API 단가를 확인했고 사용자가 Qwen/GPT 조합을 지정했으므로 **Gemini는 현행 의미/비용/속도 기준에서 제외**한다. 같은 124k/12.4k token 예산의 이전 Gemini 의미 비용 $0.09920과 현재 Qwen $0.03472의 차이 $0.06448는 단가 민감도이며 실제 호출/정확성/출력 동등성의 증거가 아니다. 기존 200 token/s와 Gemini cache 요금은 [변경 전 보존본](../../../archive/qa-semantic-reference-before-qwen-20261011/README.md)에 남겼다.</a:t>
+            </a:r>
+          </a:p>
+          <a:p xmlns:a="http://schemas.openxmlformats.org/drawingml/2006/main">
+            <a:r>
+              <a:t/>
+            </a:r>
+          </a:p>
+          <a:p xmlns:a="http://schemas.openxmlformats.org/drawingml/2006/main">
+            <a:r>
+              <a:t>### 8.4.1.2 Groq 밖의 속도 근거와 산식</a:t>
+            </a:r>
+          </a:p>
+          <a:p xmlns:a="http://schemas.openxmlformats.org/drawingml/2006/main">
+            <a:r>
+              <a:t/>
+            </a:r>
+          </a:p>
+          <a:p xmlns:a="http://schemas.openxmlformats.org/drawingml/2006/main">
+            <a:r>
+              <a:t>[Qwen 공식 속도 benchmark](https://qwen.readthedocs.io/en/latest/getting_started/speed_benchmark.html)는 **Qwen3-30B-A3B**를 NVIDIA **H20 96GB 1장**, SGLang **0.4.6.post1**, PyTorch **2.6.0+cu124**, batch **1**, 출력 **2,048 token**으로 평가했다. 입력1 token에서 BF16 **137.18**, FP8 **155.55 token/s**다. 입력6,144 token에서는 BF16 **490.10**, FP8 **551.34**다. 단, 공식 분자는 **입력+출력 token**, 분모는 전체 처리시간이다. 입력6,144의 490.10을 출력 생성률로 쓰지 않는다.</a:t>
+            </a:r>
+          </a:p>
+          <a:p xmlns:a="http://schemas.openxmlformats.org/drawingml/2006/main">
+            <a:r>
+              <a:t/>
+            </a:r>
+          </a:p>
+          <a:p xmlns:a="http://schemas.openxmlformats.org/drawingml/2006/main">
+            <a:r>
+              <a:t>BF16 입력1 조건의 전체 시간은 `2,049/137.18 ≈ 14.94초`, 입력6,144 조건은 `8,192/490.10 ≈ 16.72초`로 복원할 수 있다. 출력/전체시간으로 다시 표현하면 각각 **137.11**과 **122.53 output token/s**이며 이는 prefill까지 포함한 해당 길이의 유효 출력률이다. 이것을 TTFT와 분리된 decode rate로 두고 TTFT를 다시 더하면 입력 처리 시간이 이중 계상된다. 원본 Qwen3 benchmark를 Instruct-2507의 실측 또는 Alibaba Singapore API의 속도로 주장하지 않는다. 서버 측 H20 reference이므로 Windows 노트북의 속도/메모리에도 이전하지 않는다.</a:t>
+            </a:r>
+          </a:p>
+          <a:p xmlns:a="http://schemas.openxmlformats.org/drawingml/2006/main">
+            <a:r>
+              <a:t/>
+            </a:r>
+          </a:p>
+          <a:p xmlns:a="http://schemas.openxmlformats.org/drawingml/2006/main">
+            <a:r>
+              <a:t>따라서 공식 수치 기반의 계산은 **공개된 동일 길이/환경의 전체 처리시간**을 쓰거나, 별도로 검증된 decode rate와 TTFT를 분리해야 한다. 현재는 원본 계열 BF16 유효 출력률 약122.53~137.11과 FP8 입력1 약155.47을 수치 규모의 참고로 삼아 **130 token/s의 독립적인 PoC decode 가정**과 **100/130/160 민감도**를 정했다. 기준 TTFT0.30초, 빠른0.15초, 느린0.80초와 음성 시작0.10/0.25/0.60초도 별도 작성자 가정이다. 이들을 공개표에서 분리 측정한 TTFT/decode로 주장하지 않는다. 특히 2,048 출력의 유효 출력률을 2,000입력/200출력에 보장된 rate로 이전하지 않는다. API 배포의 TTFT/생성률이 있으면 두 가정을 실제 측정으로 함께 교체하고, 공개 benchmark 자체를 재현 계산할 때는 전체시간만 써서 prefill을 중복 계상하지 않는다. API 가격 reference와 별도 H20 속도 reference를 함께 사용하는 경우 비용/속도가 같은 서비스에서 측정됐다는 주장도 하지 않는다.</a:t>
+            </a:r>
+          </a:p>
+          <a:p xmlns:a="http://schemas.openxmlformats.org/drawingml/2006/main">
+            <a:r>
+              <a:t/>
+            </a:r>
+          </a:p>
+          <a:p xmlns:a="http://schemas.openxmlformats.org/drawingml/2006/main">
+            <a:r>
+              <a:t>기존의 **450+ token/s**는 [Groq의 `qwen/qwen3.8-27b` 모델 페이지](https://console.groq.com/docs/model/qwen/qwen3.8-27b)의 제공사 표시값이다. [GroqCloud는 전용 LPU 추론 인프라](https://groq.com/blog/the-groq-lpu-explained)를 사용한다. 이는 Qwen3-30B-A3B-Instruct-2507, NVIDIA GPU 또는 Windows PC의 숫자가 아니다. 해당 450 수치의 LPU 수/세대, precision, prompt/output 길이, 동시 요청 수와 상세 계측 경계는 페이지에 공개되어 있지 않으므로 가정으로 채우지 않는다. Groq은 현행 비용/속도 reference에서 제외하며 이 문단은 이전 근거의 의미를 설명하기 위한 provenance다.</a:t>
+            </a:r>
+          </a:p>
+          <a:p xmlns:a="http://schemas.openxmlformats.org/drawingml/2006/main">
+            <a:r>
+              <a:t/>
+            </a:r>
+          </a:p>
+          <a:p xmlns:a="http://schemas.openxmlformats.org/drawingml/2006/main">
+            <a:r>
+              <a:t>### 8.4.2 Gemini Live와 GPT Realtime의 기능 비교</a:t>
+            </a:r>
+          </a:p>
+          <a:p xmlns:a="http://schemas.openxmlformats.org/drawingml/2006/main">
+            <a:r>
+              <a:t/>
+            </a:r>
+          </a:p>
+          <a:p xmlns:a="http://schemas.openxmlformats.org/drawingml/2006/main">
+            <a:r>
+              <a:t>2026-10-11 확인한 공식 문서 기준으로 같은 실시간 음성 대화 역할을 제공하지만 API/실행 제약은 다르다. 아래 GPT는 사용자가 지칭한 `gpt-realtime` 모델 기준이며 다른 GPT Realtime 모델의 제한으로 확대하지 않는다. 현재 공식 모델 페이지는 해당 모델을 Deprecated로 표시하므로 실제 제품 적용 권고가 아니라 요청한 기능 비교 기준으로만 쓴다.</a:t>
+            </a:r>
+          </a:p>
+          <a:p xmlns:a="http://schemas.openxmlformats.org/drawingml/2006/main">
+            <a:r>
+              <a:t/>
+            </a:r>
+          </a:p>
+          <a:p xmlns:a="http://schemas.openxmlformats.org/drawingml/2006/main">
+            <a:r>
+              <a:t>| 비교 항목 | Gemini 3.1 Flash Live Preview | OpenAI gpt-realtime | VIA에 주는 의미 |</a:t>
+            </a:r>
+          </a:p>
+          <a:p xmlns:a="http://schemas.openxmlformats.org/drawingml/2006/main">
+            <a:r>
+              <a:t>| --- | --- | --- | --- |</a:t>
+            </a:r>
+          </a:p>
+          <a:p xmlns:a="http://schemas.openxmlformats.org/drawingml/2006/main">
+            <a:r>
+              <a:t>| 실시간 음성 입출력, 입력/출력 전사, 발화 중 끼어들기 | 지원 | 지원 | 양쪽 모두 음성 역할의 reference가 될 수 있다. 실제 한국어 품질·지연·중단 시간 동등성은 입증하지 않음 |</a:t>
+            </a:r>
+          </a:p>
+          <a:p xmlns:a="http://schemas.openxmlformats.org/drawingml/2006/main">
+            <a:r>
+              <a:t>| 화면/멀티모달 입력 | Text·이미지·audio·video 입력 | Text·이미지·audio 입력, video 미지원 | GPT에서는 화면 snapshot의 이미지 입력과 video stream 지원을 구별 |</a:t>
+            </a:r>
+          </a:p>
+          <a:p xmlns:a="http://schemas.openxmlformats.org/drawingml/2006/main">
+            <a:r>
+              <a:t>| 함수 호출 | 동기만 지원, tool response 전 응답 대기 | 비동기 tool 흐름 지원 | 긴 Agent 실행을 Gemini Live tool response로 끝날 때까지 기다리게 하지 않음 |</a:t>
+            </a:r>
+          </a:p>
+          <a:p xmlns:a="http://schemas.openxmlformats.org/drawingml/2006/main">
+            <a:r>
+              <a:t>| 직접 연결 | Live API WebSocket | WebRTC / WebSocket / SIP | provider adapter·세션 재연결·audio queue/취소 이벤트를 별도로 구현/계산 |</a:t>
+            </a:r>
+          </a:p>
+          <a:p xmlns:a="http://schemas.openxmlformats.org/drawingml/2006/main">
+            <a:r>
+              <a:t>| structured output | 미지원 | 미지원 | 함수 인자 JSON과 schema 제약 출력 보장을 구별, 의미 모델의 frame 검증은 별도 |</a:t>
+            </a:r>
+          </a:p>
+          <a:p xmlns:a="http://schemas.openxmlformats.org/drawingml/2006/main">
+            <a:r>
+              <a:t/>
+            </a:r>
+          </a:p>
+          <a:p xmlns:a="http://schemas.openxmlformats.org/drawingml/2006/main">
+            <a:r>
+              <a:t>근거: [Gemini Live 모델/제약](https://ai.google.dev/gemini-api/docs/models/gemini-3.1-flash-live-preview), [Live 도구의 동기 제한](https://ai.google.dev/gemini-api/docs/live-api/tools), [Live API 연결](https://ai.google.dev/gemini-api/docs/live-api), [Live VAD/중단](https://ai.google.dev/gemini-api/docs/live-api/capabilities), [OpenAI gpt-realtime](https://developers.openai.com/api/docs/models/gpt-realtime), [Realtime 대화/중단](https://developers.openai.com/api/docs/guides/realtime-conversations), [Realtime 도구](https://developers.openai.com/api/docs/guides/realtime-mcp), [GPT Realtime 비동기 함수 호출 설명](https://developers.openai.com/blog/realtime-api).</a:t>
+            </a:r>
+          </a:p>
+          <a:p xmlns:a="http://schemas.openxmlformats.org/drawingml/2006/main">
+            <a:r>
+              <a:t/>
+            </a:r>
+          </a:p>
+          <a:p xmlns:a="http://schemas.openxmlformats.org/drawingml/2006/main">
+            <a:r>
+              <a:t>VIA는 요청/Task의 권위를 갖고 음성 모델의 임시 session과 구별한다. 긴 업무는 로컬 VIA가 외부 Agent에 비동기로 위임하고, 음성 모델에는 유효한 접수·질문·결과를 제시할 입력을 따로 전달하는 방향으로 reference를 해석한다. 이것은 긴 Agent 결과를 Live 동기 함수 응답으로 기다리는 것과 다르다. 실제 provider의 forced response, cancel, 재연결, 출력 내용 준수와 local playback stop은 adapter/API 검증에서 확인해야 한다. 현재 GPT Realtime reference에서도 local playback stop·새 사용자 요청·동시에 도착한 Agent 질문/결과의 우선순위는 VIA가 관리하고, pending tool의 결과가 없는 동안 완료를 추측해 말하지 못하도록 실제 상태를 전달한다. 이전 Gemini 3.1 검토의 proactive audio/affective dialogue 미지원과 `turn_complete=true`의 활성 generation 중단은 기능 비교의 제한으로 보존한다. 모델 이름만으로 연속 입력/여러 Task 처리 계약이 충족됐다고 하지 않는다.</a:t>
             </a:r>
           </a:p>
           <a:p xmlns:a="http://schemas.openxmlformats.org/drawingml/2006/main">
@@ -11007,7 +11577,7 @@
           </a:p>
           <a:p xmlns:a="http://schemas.openxmlformats.org/drawingml/2006/main">
             <a:r>
-              <a:t>원본 SHA-256: d25a503005403e71d5811d61f20d9c227479bfeb04808ba868ce06adc463e4f8</a:t>
+              <a:t>원본 SHA-256: 8520fa1bd1661f72bb87071ab03755964b0539565490994de845bbc086654cfd</a:t>
             </a:r>
           </a:p>
           <a:p xmlns:a="http://schemas.openxmlformats.org/drawingml/2006/main">
@@ -14153,6 +14723,291 @@
           <a:p xmlns:a="http://schemas.openxmlformats.org/drawingml/2006/main">
             <a:r>
               <a:t>묶음당 21개 시나리오는 사용자 19개 + Agent 단독 2개다. 집중 장면 안에는 Agent 사건 4개가 추가로 들어 있다. Voice 입력 50초와 출력 예산 179초, 반응 27개와 사용자 cycle 19개를 정의했다. 다섯 묶음 전체는 105개 시나리오·630조건·135반응·95cycle이다. 사용자의 하루 빈도를 뜻하지 않는다.</a:t>
+            </a:r>
+          </a:p>
+          <a:p xmlns:a="http://schemas.openxmlformats.org/drawingml/2006/main">
+            <a:r>
+              <a:t/>
+            </a:r>
+          </a:p>
+          <a:p xmlns:a="http://schemas.openxmlformats.org/drawingml/2006/main">
+            <a:r>
+              <a:t/>
+            </a:r>
+          </a:p>
+          <a:p xmlns:a="http://schemas.openxmlformats.org/drawingml/2006/main">
+            <a:r>
+              <a:t>모델 reference 상세 §8.4</a:t>
+            </a:r>
+          </a:p>
+          <a:p xmlns:a="http://schemas.openxmlformats.org/drawingml/2006/main">
+            <a:r>
+              <a:t> 장치와 모델 계산 reference — 2026-10-11 확인</a:t>
+            </a:r>
+          </a:p>
+          <a:p xmlns:a="http://schemas.openxmlformats.org/drawingml/2006/main">
+            <a:r>
+              <a:t/>
+            </a:r>
+          </a:p>
+          <a:p xmlns:a="http://schemas.openxmlformats.org/drawingml/2006/main">
+            <a:r>
+              <a:t>이 reference는 현재 개발 중인 모델/클라우드 서비스의 실제 가격이나 성능을 뜻하지 않는다. 같은 A/B 계산에 쓸 외부 공개 기준이다. 값은 USD, 모델 단가는 1,000,000 token당 표준 유료 요금이며 free tier/할인으로 0원을 만들지 않는다.</a:t>
+            </a:r>
+          </a:p>
+          <a:p xmlns:a="http://schemas.openxmlformats.org/drawingml/2006/main">
+            <a:r>
+              <a:t/>
+            </a:r>
+          </a:p>
+          <a:p xmlns:a="http://schemas.openxmlformats.org/drawingml/2006/main">
+            <a:r>
+              <a:t>| 용도 | 선택 reference / 값 | 출처와 적용 범위 |</a:t>
+            </a:r>
+          </a:p>
+          <a:p xmlns:a="http://schemas.openxmlformats.org/drawingml/2006/main">
+            <a:r>
+              <a:t>| --- | --- | --- |</a:t>
+            </a:r>
+          </a:p>
+          <a:p xmlns:a="http://schemas.openxmlformats.org/drawingml/2006/main">
+            <a:r>
+              <a:t>| Windows PC | **Galaxy Book6 Ultra NP960UJH-XG3IN**, Windows 11 Home, Core Ultra 7 356H, RAM 32GB LPDDR5X, RTX 5070 Laptop GPU 8GB, SSD 1TB | [삼성 공식 SKU 사양](https://www.samsung.com/in/computers/galaxy-book/galaxy-book6-ultra-ultra-7-32gb-1tb-np960ujh-xg3in/). RAM과 VRAM을 같은 자원으로 합치지 않음. 모델은 클라우드이므로 GPU 가중치 적재를 로컬 비용에 가산하지 않음 |</a:t>
+            </a:r>
+          </a:p>
+          <a:p xmlns:a="http://schemas.openxmlformats.org/drawingml/2006/main">
+            <a:r>
+              <a:t>| 의미 LLM의 비용 | **Qwen3-30B-A3B-Instruct-2507**, `qwen3-30b-a3b-instruct-2507`: Alibaba Cloud Model Studio **Singapore / International** 입력 **$0.20**, 출력 **$0.80** / 1M token, non-thinking | [공식 API 모델/단가](https://docs.modelstudio.console.alibabacloud.com/en/model-studio/qwen3-30b-a3b-instruct-2507), [Qwen 공식 모델 카드](https://huggingface.co/Qwen/Qwen3-30B-A3B-Instruct-2507). 약30B 전체/3B 활성 MoE, Text-to-Text. 사용자 승인한 PoC 의미 모델 기준이며 최종 제품 모델/DP 승자 선정은 아님. 같은 provider/region/revision/mode를 양안에 적용 |</a:t>
+            </a:r>
+          </a:p>
+          <a:p xmlns:a="http://schemas.openxmlformats.org/drawingml/2006/main">
+            <a:r>
+              <a:t>| 의미 LLM의 생성 속도 | **작성자 decode 가정 130 token/s**, 민감도 **100 / 130 / 160 token/s**, 기준 TTFT **0.30초** | [Qwen 공식 H20 benchmark](https://qwen.readthedocs.io/en/latest/getting_started/speed_benchmark.html)의 원본 계열 유효 출력률 약122.53~137.11(BF16) 등을 참고한 수치 규모의 가정. Instruct-2507 API의 공개 decode rate/보장/실측이 아니며 공개표에서 TTFT와 decode를 분리 추출한 값도 아님. 가격은 Alibaba API, 속도 근거는 별도 H20 환경임을 §8.4.1.2에 명시 |</a:t>
+            </a:r>
+          </a:p>
+          <a:p xmlns:a="http://schemas.openxmlformats.org/drawingml/2006/main">
+            <a:r>
+              <a:t>| 음성 비용/비동기 대화 기준 | **OpenAI GPT Realtime**, `gpt-realtime` (`gpt-realtime-2025-08-28`): audio 입력 **$32**, 출력 **$64** / 1M token. Text 입력 **$4**, 출력 **$16** / 1M token. cached audio/Text 입력 **$0.40** / 1M token | [공식 모델/단가](https://developers.openai.com/api/docs/models/gpt-realtime), [Realtime 청구](https://developers.openai.com/api/docs/guides/voice-latency-cost), [비동기 함수 호출](https://developers.openai.com/blog/realtime-api). 사용자 입력 약10 audio token/s, assistant 생성 약20 audio token/s로 신규 audio는 **$0.0192/분 입력, $0.0768/분 출력**으로 환산. 특수 token·이력 재입력·Text·폐기 생성은 별도. 공식 페이지의 Deprecated 상태와 관계없이 사용자가 지정한 날짜별 PoC 비용/기능 reference를 고정하며 실서비스의 신규 채택을 뜻하지 않음 |</a:t>
+            </a:r>
+          </a:p>
+          <a:p xmlns:a="http://schemas.openxmlformats.org/drawingml/2006/main">
+            <a:r>
+              <a:t>| 시간 목표의 사용자 근거 | 즉각 제어 **0.1초**, 대화 흐름 **1초**, 주의 유지 **10초**의 상호작용 참조 | [Nielsen Norman Group 원문](https://www.nngroup.com/articles/website-response-times/). VIA의 평균/모집단/추가 지연 예산은 작성자가 선택하며 문헌이 VIA의 평균 목표를 직접 규정했다고 하지 않음 |</a:t>
+            </a:r>
+          </a:p>
+          <a:p xmlns:a="http://schemas.openxmlformats.org/drawingml/2006/main">
+            <a:r>
+              <a:t/>
+            </a:r>
+          </a:p>
+          <a:p xmlns:a="http://schemas.openxmlformats.org/drawingml/2006/main">
+            <a:r>
+              <a:t>음성 비용은 실제로 보내거나 청구되는 audio/context의 양을 사용한다. VAD가 앞단에 있다는 사실만으로 silence/context 재사용 청구가 0이라고 가정하지 않는다. Text prompt/context, 재시도, 취소 불가인 폐기 출력과 미사용 배경 생산도 포함한다. 같은 사용량을 token 요금과 분 요금으로 이중 계산하지 않는다. 모델 제공자가 사용량을 반환한 실측은 그 사용량을 우선하고, 공개 reference 계산은 음성 길이 기반의 근사임을 남긴다.</a:t>
+            </a:r>
+          </a:p>
+          <a:p xmlns:a="http://schemas.openxmlformats.org/drawingml/2006/main">
+            <a:r>
+              <a:t/>
+            </a:r>
+          </a:p>
+          <a:p xmlns:a="http://schemas.openxmlformats.org/drawingml/2006/main">
+            <a:r>
+              <a:t>검산 예시: 의미 호출의 입력 2,000 token/청구 출력 200 token은 `2,000×0.20/1M + 200×0.80/1M = $0.00056`, 작성자 decode 가정의 생성 부분은 `200/130 ≈ 1.538초`다. Instruct-2507은 non-thinking이며 출력200은 실제 답변/frame/tool 출력의 청구 예산이다. 원천/의미/도구 오류의 추가 질문·재시도·폐기 출력을 모두 포함하고 provider별 tokenizer의 실제 사용량을 우선한다. GPT Realtime 신규 audio 입력 1분/출력 1분은 `600×32/1M + 1,200×64/1M = $0.096`이며 Text와 이력 audio 재입력 청구는 별도다. 응답마다 이전 대화가 입력으로 재사용되므로 실제 `response.done`의 modality별 input/output/cached token을 호출 ID로 중복 제거해 합산한다. 초기 2,000turn을 음성 session에 전부 보내도록 강제하지 않으며 실제 보낸 이력·요약·instruction은 청구한다. 별도 input transcription을 켜면 해당 모델 청구도 더한다. 생성 부분 약1.538초를 첫 출력/입력 처리/통신/queue가 포함된 호출 완료 시간으로 쓰지 않는다. Qwen의 기본 예산에는 할인 없는 입력/출력 단가를 사용한다. 실제 cache 할인이나 별도 저장/도구 청구가 있으면 제공사가 확인한 사용량·단가로 원장에 반영하며 Gemini의 cache 단가를 Qwen에 적용하지 않는다.</a:t>
+            </a:r>
+          </a:p>
+          <a:p xmlns:a="http://schemas.openxmlformats.org/drawingml/2006/main">
+            <a:r>
+              <a:t/>
+            </a:r>
+          </a:p>
+          <a:p xmlns:a="http://schemas.openxmlformats.org/drawingml/2006/main">
+            <a:r>
+              <a:t/>
+            </a:r>
+          </a:p>
+          <a:p xmlns:a="http://schemas.openxmlformats.org/drawingml/2006/main">
+            <a:r>
+              <a:t>### 8.4.1 선택한 모델 역할과 입력 범위</a:t>
+            </a:r>
+          </a:p>
+          <a:p xmlns:a="http://schemas.openxmlformats.org/drawingml/2006/main">
+            <a:r>
+              <a:t/>
+            </a:r>
+          </a:p>
+          <a:p xmlns:a="http://schemas.openxmlformats.org/drawingml/2006/main">
+            <a:r>
+              <a:t>사용자는 **Qwen3-30B-A3B 계열 + GPT Realtime**을 이번 PoC의 모델 reference로 지정했다. 비용/API revision은 앞서 가격을 확인한 **Qwen3-30B-A3B-Instruct-2507**로 고정한다. 원본 `qwen3-30b-a3b`나 Thinking-2507/VL 모델과 혼용하지 않는다. 의미 해석·bounded read 판단·41B의 frame 생성에는 Qwen을, 실시간 음성 입출력/대화 지속에는 GPT Realtime을 사용한다. 외부 업무를 VIA에 맡긴 뒤에도 pending 함수 호출 중 대화를 계속한다. VIA가 외부 Agent의 실행/현재 Task/승인/질문/결과 연결의 권위를 유지하며 GPT Realtime의 tool pending을 실제 업무 완료로 해석하지 않는다. 양안은 같은 역할별 모델/설정/입출력 계약을 사용한다.</a:t>
+            </a:r>
+          </a:p>
+          <a:p xmlns:a="http://schemas.openxmlformats.org/drawingml/2006/main">
+            <a:r>
+              <a:t/>
+            </a:r>
+          </a:p>
+          <a:p xmlns:a="http://schemas.openxmlformats.org/drawingml/2006/main">
+            <a:r>
+              <a:t>Qwen은 Text-to-Text 모델이다. P21의 S2-01 등은 이미 원천 observation으로 표 내용/version·관측시각·포인터 이력을 제공하므로, 그 **원천 사실과 span을 공통 text 입력으로 직렬화**한다. 최종 A/B 지칭, Task 연결, revision 선택, 의존 관계 또는 채점 정답을 adapter가 미리 채우지 않는다. 조회하지 않은 원천 내용·권한 없는 내용도 자동으로 넣지 않는다. 소스 원문/구조 정보는 그대로 공급하고, 의미 결합은 각 방안이 생산한다. 원본 화면 frame은 시간/보관/메모리 원장에 유지한다. 이는 픽셀만으로 임의 앱 화면을 인식하는 완성 제품 평가가 아니라 정의된 PoC 원천 자료를 사용하는 범위다. 추가 vision/OCR 모델을 현재 예산에 숨겨 넣지 않는다. 실제 픽셀 인식이 필요해지면 공통 관측 adapter의 추가 모델·비용·지연·권한·손실을 동일하게 명시하고 계약을 개정한다.</a:t>
+            </a:r>
+          </a:p>
+          <a:p xmlns:a="http://schemas.openxmlformats.org/drawingml/2006/main">
+            <a:r>
+              <a:t/>
+            </a:r>
+          </a:p>
+          <a:p xmlns:a="http://schemas.openxmlformats.org/drawingml/2006/main">
+            <a:r>
+              <a:t>Qwen frame/tool 출력은 구문·허용 schema·ID/revision·현재성 검사를 거친다. 모델 이름만으로 JSON/함수 호출이 항상 맞거나 provider가 엄격한 schema decoding을 보장한다고 가정하지 않는다. 잘못된 출력의 재시도와 판단 유보는 같은 사례/실패/청구 원장에 포함한다. GPT Realtime의 structured output 미지원 때문에 음성 모델을 41B의 의미 frame 생산자로 대신 쓰지 않는다. 비용/기능 reference의 지정은 제품 모델 채택, Architecture 대안 선택이나 정확성 측정의 완료가 아니다.</a:t>
+            </a:r>
+          </a:p>
+          <a:p xmlns:a="http://schemas.openxmlformats.org/drawingml/2006/main">
+            <a:r>
+              <a:t/>
+            </a:r>
+          </a:p>
+          <a:p xmlns:a="http://schemas.openxmlformats.org/drawingml/2006/main">
+            <a:r>
+              <a:t>### 8.4.1.1 이전 Gemini 선택 이유와 변경 이력</a:t>
+            </a:r>
+          </a:p>
+          <a:p xmlns:a="http://schemas.openxmlformats.org/drawingml/2006/main">
+            <a:r>
+              <a:t/>
+            </a:r>
+          </a:p>
+          <a:p xmlns:a="http://schemas.openxmlformats.org/drawingml/2006/main">
+            <a:r>
+              <a:t>Gemini 3 Flash Preview의 공개 출시일은 **2025-12-17**이다([Google 출시 공지](https://blog.google/products-and-platforms/products/gemini/gemini-3-flash/)). 이전 선택은 공식 단가와 이미지 입력·함수 호출·structured output을 가진 reference의 편의에 따른 것이며 VIA 우월성이나 Qwen 30B와의 동등성 검증이 아니었다. 이후 정확한 Qwen API 단가를 확인했고 사용자가 Qwen/GPT 조합을 지정했으므로 **Gemini는 현행 의미/비용/속도 기준에서 제외**한다. 같은 124k/12.4k token 예산의 이전 Gemini 의미 비용 $0.09920과 현재 Qwen $0.03472의 차이 $0.06448는 단가 민감도이며 실제 호출/정확성/출력 동등성의 증거가 아니다. 기존 200 token/s와 Gemini cache 요금은 [변경 전 보존본](../../../archive/qa-semantic-reference-before-qwen-20261011/README.md)에 남겼다.</a:t>
+            </a:r>
+          </a:p>
+          <a:p xmlns:a="http://schemas.openxmlformats.org/drawingml/2006/main">
+            <a:r>
+              <a:t/>
+            </a:r>
+          </a:p>
+          <a:p xmlns:a="http://schemas.openxmlformats.org/drawingml/2006/main">
+            <a:r>
+              <a:t>### 8.4.1.2 Groq 밖의 속도 근거와 산식</a:t>
+            </a:r>
+          </a:p>
+          <a:p xmlns:a="http://schemas.openxmlformats.org/drawingml/2006/main">
+            <a:r>
+              <a:t/>
+            </a:r>
+          </a:p>
+          <a:p xmlns:a="http://schemas.openxmlformats.org/drawingml/2006/main">
+            <a:r>
+              <a:t>[Qwen 공식 속도 benchmark](https://qwen.readthedocs.io/en/latest/getting_started/speed_benchmark.html)는 **Qwen3-30B-A3B**를 NVIDIA **H20 96GB 1장**, SGLang **0.4.6.post1**, PyTorch **2.6.0+cu124**, batch **1**, 출력 **2,048 token**으로 평가했다. 입력1 token에서 BF16 **137.18**, FP8 **155.55 token/s**다. 입력6,144 token에서는 BF16 **490.10**, FP8 **551.34**다. 단, 공식 분자는 **입력+출력 token**, 분모는 전체 처리시간이다. 입력6,144의 490.10을 출력 생성률로 쓰지 않는다.</a:t>
+            </a:r>
+          </a:p>
+          <a:p xmlns:a="http://schemas.openxmlformats.org/drawingml/2006/main">
+            <a:r>
+              <a:t/>
+            </a:r>
+          </a:p>
+          <a:p xmlns:a="http://schemas.openxmlformats.org/drawingml/2006/main">
+            <a:r>
+              <a:t>BF16 입력1 조건의 전체 시간은 `2,049/137.18 ≈ 14.94초`, 입력6,144 조건은 `8,192/490.10 ≈ 16.72초`로 복원할 수 있다. 출력/전체시간으로 다시 표현하면 각각 **137.11**과 **122.53 output token/s**이며 이는 prefill까지 포함한 해당 길이의 유효 출력률이다. 이것을 TTFT와 분리된 decode rate로 두고 TTFT를 다시 더하면 입력 처리 시간이 이중 계상된다. 원본 Qwen3 benchmark를 Instruct-2507의 실측 또는 Alibaba Singapore API의 속도로 주장하지 않는다. 서버 측 H20 reference이므로 Windows 노트북의 속도/메모리에도 이전하지 않는다.</a:t>
+            </a:r>
+          </a:p>
+          <a:p xmlns:a="http://schemas.openxmlformats.org/drawingml/2006/main">
+            <a:r>
+              <a:t/>
+            </a:r>
+          </a:p>
+          <a:p xmlns:a="http://schemas.openxmlformats.org/drawingml/2006/main">
+            <a:r>
+              <a:t>따라서 공식 수치 기반의 계산은 **공개된 동일 길이/환경의 전체 처리시간**을 쓰거나, 별도로 검증된 decode rate와 TTFT를 분리해야 한다. 현재는 원본 계열 BF16 유효 출력률 약122.53~137.11과 FP8 입력1 약155.47을 수치 규모의 참고로 삼아 **130 token/s의 독립적인 PoC decode 가정**과 **100/130/160 민감도**를 정했다. 기준 TTFT0.30초, 빠른0.15초, 느린0.80초와 음성 시작0.10/0.25/0.60초도 별도 작성자 가정이다. 이들을 공개표에서 분리 측정한 TTFT/decode로 주장하지 않는다. 특히 2,048 출력의 유효 출력률을 2,000입력/200출력에 보장된 rate로 이전하지 않는다. API 배포의 TTFT/생성률이 있으면 두 가정을 실제 측정으로 함께 교체하고, 공개 benchmark 자체를 재현 계산할 때는 전체시간만 써서 prefill을 중복 계상하지 않는다. API 가격 reference와 별도 H20 속도 reference를 함께 사용하는 경우 비용/속도가 같은 서비스에서 측정됐다는 주장도 하지 않는다.</a:t>
+            </a:r>
+          </a:p>
+          <a:p xmlns:a="http://schemas.openxmlformats.org/drawingml/2006/main">
+            <a:r>
+              <a:t/>
+            </a:r>
+          </a:p>
+          <a:p xmlns:a="http://schemas.openxmlformats.org/drawingml/2006/main">
+            <a:r>
+              <a:t>기존의 **450+ token/s**는 [Groq의 `qwen/qwen3.8-27b` 모델 페이지](https://console.groq.com/docs/model/qwen/qwen3.8-27b)의 제공사 표시값이다. [GroqCloud는 전용 LPU 추론 인프라](https://groq.com/blog/the-groq-lpu-explained)를 사용한다. 이는 Qwen3-30B-A3B-Instruct-2507, NVIDIA GPU 또는 Windows PC의 숫자가 아니다. 해당 450 수치의 LPU 수/세대, precision, prompt/output 길이, 동시 요청 수와 상세 계측 경계는 페이지에 공개되어 있지 않으므로 가정으로 채우지 않는다. Groq은 현행 비용/속도 reference에서 제외하며 이 문단은 이전 근거의 의미를 설명하기 위한 provenance다.</a:t>
+            </a:r>
+          </a:p>
+          <a:p xmlns:a="http://schemas.openxmlformats.org/drawingml/2006/main">
+            <a:r>
+              <a:t/>
+            </a:r>
+          </a:p>
+          <a:p xmlns:a="http://schemas.openxmlformats.org/drawingml/2006/main">
+            <a:r>
+              <a:t>### 8.4.2 Gemini Live와 GPT Realtime의 기능 비교</a:t>
+            </a:r>
+          </a:p>
+          <a:p xmlns:a="http://schemas.openxmlformats.org/drawingml/2006/main">
+            <a:r>
+              <a:t/>
+            </a:r>
+          </a:p>
+          <a:p xmlns:a="http://schemas.openxmlformats.org/drawingml/2006/main">
+            <a:r>
+              <a:t>2026-10-11 확인한 공식 문서 기준으로 같은 실시간 음성 대화 역할을 제공하지만 API/실행 제약은 다르다. 아래 GPT는 사용자가 지칭한 `gpt-realtime` 모델 기준이며 다른 GPT Realtime 모델의 제한으로 확대하지 않는다. 현재 공식 모델 페이지는 해당 모델을 Deprecated로 표시하므로 실제 제품 적용 권고가 아니라 요청한 기능 비교 기준으로만 쓴다.</a:t>
+            </a:r>
+          </a:p>
+          <a:p xmlns:a="http://schemas.openxmlformats.org/drawingml/2006/main">
+            <a:r>
+              <a:t/>
+            </a:r>
+          </a:p>
+          <a:p xmlns:a="http://schemas.openxmlformats.org/drawingml/2006/main">
+            <a:r>
+              <a:t>| 비교 항목 | Gemini 3.1 Flash Live Preview | OpenAI gpt-realtime | VIA에 주는 의미 |</a:t>
+            </a:r>
+          </a:p>
+          <a:p xmlns:a="http://schemas.openxmlformats.org/drawingml/2006/main">
+            <a:r>
+              <a:t>| --- | --- | --- | --- |</a:t>
+            </a:r>
+          </a:p>
+          <a:p xmlns:a="http://schemas.openxmlformats.org/drawingml/2006/main">
+            <a:r>
+              <a:t>| 실시간 음성 입출력, 입력/출력 전사, 발화 중 끼어들기 | 지원 | 지원 | 양쪽 모두 음성 역할의 reference가 될 수 있다. 실제 한국어 품질·지연·중단 시간 동등성은 입증하지 않음 |</a:t>
+            </a:r>
+          </a:p>
+          <a:p xmlns:a="http://schemas.openxmlformats.org/drawingml/2006/main">
+            <a:r>
+              <a:t>| 화면/멀티모달 입력 | Text·이미지·audio·video 입력 | Text·이미지·audio 입력, video 미지원 | GPT에서는 화면 snapshot의 이미지 입력과 video stream 지원을 구별 |</a:t>
+            </a:r>
+          </a:p>
+          <a:p xmlns:a="http://schemas.openxmlformats.org/drawingml/2006/main">
+            <a:r>
+              <a:t>| 함수 호출 | 동기만 지원, tool response 전 응답 대기 | 비동기 tool 흐름 지원 | 긴 Agent 실행을 Gemini Live tool response로 끝날 때까지 기다리게 하지 않음 |</a:t>
+            </a:r>
+          </a:p>
+          <a:p xmlns:a="http://schemas.openxmlformats.org/drawingml/2006/main">
+            <a:r>
+              <a:t>| 직접 연결 | Live API WebSocket | WebRTC / WebSocket / SIP | provider adapter·세션 재연결·audio queue/취소 이벤트를 별도로 구현/계산 |</a:t>
+            </a:r>
+          </a:p>
+          <a:p xmlns:a="http://schemas.openxmlformats.org/drawingml/2006/main">
+            <a:r>
+              <a:t>| structured output | 미지원 | 미지원 | 함수 인자 JSON과 schema 제약 출력 보장을 구별, 의미 모델의 frame 검증은 별도 |</a:t>
+            </a:r>
+          </a:p>
+          <a:p xmlns:a="http://schemas.openxmlformats.org/drawingml/2006/main">
+            <a:r>
+              <a:t/>
+            </a:r>
+          </a:p>
+          <a:p xmlns:a="http://schemas.openxmlformats.org/drawingml/2006/main">
+            <a:r>
+              <a:t>근거: [Gemini Live 모델/제약](https://ai.google.dev/gemini-api/docs/models/gemini-3.1-flash-live-preview), [Live 도구의 동기 제한](https://ai.google.dev/gemini-api/docs/live-api/tools), [Live API 연결](https://ai.google.dev/gemini-api/docs/live-api), [Live VAD/중단](https://ai.google.dev/gemini-api/docs/live-api/capabilities), [OpenAI gpt-realtime](https://developers.openai.com/api/docs/models/gpt-realtime), [Realtime 대화/중단](https://developers.openai.com/api/docs/guides/realtime-conversations), [Realtime 도구](https://developers.openai.com/api/docs/guides/realtime-mcp), [GPT Realtime 비동기 함수 호출 설명](https://developers.openai.com/blog/realtime-api).</a:t>
+            </a:r>
+          </a:p>
+          <a:p xmlns:a="http://schemas.openxmlformats.org/drawingml/2006/main">
+            <a:r>
+              <a:t/>
+            </a:r>
+          </a:p>
+          <a:p xmlns:a="http://schemas.openxmlformats.org/drawingml/2006/main">
+            <a:r>
+              <a:t>VIA는 요청/Task의 권위를 갖고 음성 모델의 임시 session과 구별한다. 긴 업무는 로컬 VIA가 외부 Agent에 비동기로 위임하고, 음성 모델에는 유효한 접수·질문·결과를 제시할 입력을 따로 전달하는 방향으로 reference를 해석한다. 이것은 긴 Agent 결과를 Live 동기 함수 응답으로 기다리는 것과 다르다. 실제 provider의 forced response, cancel, 재연결, 출력 내용 준수와 local playback stop은 adapter/API 검증에서 확인해야 한다. 현재 GPT Realtime reference에서도 local playback stop·새 사용자 요청·동시에 도착한 Agent 질문/결과의 우선순위는 VIA가 관리하고, pending tool의 결과가 없는 동안 완료를 추측해 말하지 못하도록 실제 상태를 전달한다. 이전 Gemini 3.1 검토의 proactive audio/affective dialogue 미지원과 `turn_complete=true`의 활성 generation 중단은 기능 비교의 제한으로 보존한다. 모델 이름만으로 연속 입력/여러 Task 처리 계약이 충족됐다고 하지 않는다.</a:t>
             </a:r>
           </a:p>
           <a:p xmlns:a="http://schemas.openxmlformats.org/drawingml/2006/main">
@@ -14267,7 +15122,7 @@
           </a:p>
           <a:p xmlns:a="http://schemas.openxmlformats.org/drawingml/2006/main">
             <a:r>
-              <a:t>원본 SHA-256: d25a503005403e71d5811d61f20d9c227479bfeb04808ba868ce06adc463e4f8</a:t>
+              <a:t>원본 SHA-256: 8520fa1bd1661f72bb87071ab03755964b0539565490994de845bbc086654cfd</a:t>
             </a:r>
           </a:p>
           <a:p xmlns:a="http://schemas.openxmlformats.org/drawingml/2006/main">
@@ -17413,6 +18268,291 @@
           <a:p xmlns:a="http://schemas.openxmlformats.org/drawingml/2006/main">
             <a:r>
               <a:t>묶음당 21개 시나리오는 사용자 19개 + Agent 단독 2개다. 집중 장면 안에는 Agent 사건 4개가 추가로 들어 있다. Voice 입력 50초와 출력 예산 179초, 반응 27개와 사용자 cycle 19개를 정의했다. 다섯 묶음 전체는 105개 시나리오·630조건·135반응·95cycle이다. 사용자의 하루 빈도를 뜻하지 않는다.</a:t>
+            </a:r>
+          </a:p>
+          <a:p xmlns:a="http://schemas.openxmlformats.org/drawingml/2006/main">
+            <a:r>
+              <a:t/>
+            </a:r>
+          </a:p>
+          <a:p xmlns:a="http://schemas.openxmlformats.org/drawingml/2006/main">
+            <a:r>
+              <a:t/>
+            </a:r>
+          </a:p>
+          <a:p xmlns:a="http://schemas.openxmlformats.org/drawingml/2006/main">
+            <a:r>
+              <a:t>모델 reference 상세 §8.4</a:t>
+            </a:r>
+          </a:p>
+          <a:p xmlns:a="http://schemas.openxmlformats.org/drawingml/2006/main">
+            <a:r>
+              <a:t> 장치와 모델 계산 reference — 2026-10-11 확인</a:t>
+            </a:r>
+          </a:p>
+          <a:p xmlns:a="http://schemas.openxmlformats.org/drawingml/2006/main">
+            <a:r>
+              <a:t/>
+            </a:r>
+          </a:p>
+          <a:p xmlns:a="http://schemas.openxmlformats.org/drawingml/2006/main">
+            <a:r>
+              <a:t>이 reference는 현재 개발 중인 모델/클라우드 서비스의 실제 가격이나 성능을 뜻하지 않는다. 같은 A/B 계산에 쓸 외부 공개 기준이다. 값은 USD, 모델 단가는 1,000,000 token당 표준 유료 요금이며 free tier/할인으로 0원을 만들지 않는다.</a:t>
+            </a:r>
+          </a:p>
+          <a:p xmlns:a="http://schemas.openxmlformats.org/drawingml/2006/main">
+            <a:r>
+              <a:t/>
+            </a:r>
+          </a:p>
+          <a:p xmlns:a="http://schemas.openxmlformats.org/drawingml/2006/main">
+            <a:r>
+              <a:t>| 용도 | 선택 reference / 값 | 출처와 적용 범위 |</a:t>
+            </a:r>
+          </a:p>
+          <a:p xmlns:a="http://schemas.openxmlformats.org/drawingml/2006/main">
+            <a:r>
+              <a:t>| --- | --- | --- |</a:t>
+            </a:r>
+          </a:p>
+          <a:p xmlns:a="http://schemas.openxmlformats.org/drawingml/2006/main">
+            <a:r>
+              <a:t>| Windows PC | **Galaxy Book6 Ultra NP960UJH-XG3IN**, Windows 11 Home, Core Ultra 7 356H, RAM 32GB LPDDR5X, RTX 5070 Laptop GPU 8GB, SSD 1TB | [삼성 공식 SKU 사양](https://www.samsung.com/in/computers/galaxy-book/galaxy-book6-ultra-ultra-7-32gb-1tb-np960ujh-xg3in/). RAM과 VRAM을 같은 자원으로 합치지 않음. 모델은 클라우드이므로 GPU 가중치 적재를 로컬 비용에 가산하지 않음 |</a:t>
+            </a:r>
+          </a:p>
+          <a:p xmlns:a="http://schemas.openxmlformats.org/drawingml/2006/main">
+            <a:r>
+              <a:t>| 의미 LLM의 비용 | **Qwen3-30B-A3B-Instruct-2507**, `qwen3-30b-a3b-instruct-2507`: Alibaba Cloud Model Studio **Singapore / International** 입력 **$0.20**, 출력 **$0.80** / 1M token, non-thinking | [공식 API 모델/단가](https://docs.modelstudio.console.alibabacloud.com/en/model-studio/qwen3-30b-a3b-instruct-2507), [Qwen 공식 모델 카드](https://huggingface.co/Qwen/Qwen3-30B-A3B-Instruct-2507). 약30B 전체/3B 활성 MoE, Text-to-Text. 사용자 승인한 PoC 의미 모델 기준이며 최종 제품 모델/DP 승자 선정은 아님. 같은 provider/region/revision/mode를 양안에 적용 |</a:t>
+            </a:r>
+          </a:p>
+          <a:p xmlns:a="http://schemas.openxmlformats.org/drawingml/2006/main">
+            <a:r>
+              <a:t>| 의미 LLM의 생성 속도 | **작성자 decode 가정 130 token/s**, 민감도 **100 / 130 / 160 token/s**, 기준 TTFT **0.30초** | [Qwen 공식 H20 benchmark](https://qwen.readthedocs.io/en/latest/getting_started/speed_benchmark.html)의 원본 계열 유효 출력률 약122.53~137.11(BF16) 등을 참고한 수치 규모의 가정. Instruct-2507 API의 공개 decode rate/보장/실측이 아니며 공개표에서 TTFT와 decode를 분리 추출한 값도 아님. 가격은 Alibaba API, 속도 근거는 별도 H20 환경임을 §8.4.1.2에 명시 |</a:t>
+            </a:r>
+          </a:p>
+          <a:p xmlns:a="http://schemas.openxmlformats.org/drawingml/2006/main">
+            <a:r>
+              <a:t>| 음성 비용/비동기 대화 기준 | **OpenAI GPT Realtime**, `gpt-realtime` (`gpt-realtime-2025-08-28`): audio 입력 **$32**, 출력 **$64** / 1M token. Text 입력 **$4**, 출력 **$16** / 1M token. cached audio/Text 입력 **$0.40** / 1M token | [공식 모델/단가](https://developers.openai.com/api/docs/models/gpt-realtime), [Realtime 청구](https://developers.openai.com/api/docs/guides/voice-latency-cost), [비동기 함수 호출](https://developers.openai.com/blog/realtime-api). 사용자 입력 약10 audio token/s, assistant 생성 약20 audio token/s로 신규 audio는 **$0.0192/분 입력, $0.0768/분 출력**으로 환산. 특수 token·이력 재입력·Text·폐기 생성은 별도. 공식 페이지의 Deprecated 상태와 관계없이 사용자가 지정한 날짜별 PoC 비용/기능 reference를 고정하며 실서비스의 신규 채택을 뜻하지 않음 |</a:t>
+            </a:r>
+          </a:p>
+          <a:p xmlns:a="http://schemas.openxmlformats.org/drawingml/2006/main">
+            <a:r>
+              <a:t>| 시간 목표의 사용자 근거 | 즉각 제어 **0.1초**, 대화 흐름 **1초**, 주의 유지 **10초**의 상호작용 참조 | [Nielsen Norman Group 원문](https://www.nngroup.com/articles/website-response-times/). VIA의 평균/모집단/추가 지연 예산은 작성자가 선택하며 문헌이 VIA의 평균 목표를 직접 규정했다고 하지 않음 |</a:t>
+            </a:r>
+          </a:p>
+          <a:p xmlns:a="http://schemas.openxmlformats.org/drawingml/2006/main">
+            <a:r>
+              <a:t/>
+            </a:r>
+          </a:p>
+          <a:p xmlns:a="http://schemas.openxmlformats.org/drawingml/2006/main">
+            <a:r>
+              <a:t>음성 비용은 실제로 보내거나 청구되는 audio/context의 양을 사용한다. VAD가 앞단에 있다는 사실만으로 silence/context 재사용 청구가 0이라고 가정하지 않는다. Text prompt/context, 재시도, 취소 불가인 폐기 출력과 미사용 배경 생산도 포함한다. 같은 사용량을 token 요금과 분 요금으로 이중 계산하지 않는다. 모델 제공자가 사용량을 반환한 실측은 그 사용량을 우선하고, 공개 reference 계산은 음성 길이 기반의 근사임을 남긴다.</a:t>
+            </a:r>
+          </a:p>
+          <a:p xmlns:a="http://schemas.openxmlformats.org/drawingml/2006/main">
+            <a:r>
+              <a:t/>
+            </a:r>
+          </a:p>
+          <a:p xmlns:a="http://schemas.openxmlformats.org/drawingml/2006/main">
+            <a:r>
+              <a:t>검산 예시: 의미 호출의 입력 2,000 token/청구 출력 200 token은 `2,000×0.20/1M + 200×0.80/1M = $0.00056`, 작성자 decode 가정의 생성 부분은 `200/130 ≈ 1.538초`다. Instruct-2507은 non-thinking이며 출력200은 실제 답변/frame/tool 출력의 청구 예산이다. 원천/의미/도구 오류의 추가 질문·재시도·폐기 출력을 모두 포함하고 provider별 tokenizer의 실제 사용량을 우선한다. GPT Realtime 신규 audio 입력 1분/출력 1분은 `600×32/1M + 1,200×64/1M = $0.096`이며 Text와 이력 audio 재입력 청구는 별도다. 응답마다 이전 대화가 입력으로 재사용되므로 실제 `response.done`의 modality별 input/output/cached token을 호출 ID로 중복 제거해 합산한다. 초기 2,000turn을 음성 session에 전부 보내도록 강제하지 않으며 실제 보낸 이력·요약·instruction은 청구한다. 별도 input transcription을 켜면 해당 모델 청구도 더한다. 생성 부분 약1.538초를 첫 출력/입력 처리/통신/queue가 포함된 호출 완료 시간으로 쓰지 않는다. Qwen의 기본 예산에는 할인 없는 입력/출력 단가를 사용한다. 실제 cache 할인이나 별도 저장/도구 청구가 있으면 제공사가 확인한 사용량·단가로 원장에 반영하며 Gemini의 cache 단가를 Qwen에 적용하지 않는다.</a:t>
+            </a:r>
+          </a:p>
+          <a:p xmlns:a="http://schemas.openxmlformats.org/drawingml/2006/main">
+            <a:r>
+              <a:t/>
+            </a:r>
+          </a:p>
+          <a:p xmlns:a="http://schemas.openxmlformats.org/drawingml/2006/main">
+            <a:r>
+              <a:t/>
+            </a:r>
+          </a:p>
+          <a:p xmlns:a="http://schemas.openxmlformats.org/drawingml/2006/main">
+            <a:r>
+              <a:t>### 8.4.1 선택한 모델 역할과 입력 범위</a:t>
+            </a:r>
+          </a:p>
+          <a:p xmlns:a="http://schemas.openxmlformats.org/drawingml/2006/main">
+            <a:r>
+              <a:t/>
+            </a:r>
+          </a:p>
+          <a:p xmlns:a="http://schemas.openxmlformats.org/drawingml/2006/main">
+            <a:r>
+              <a:t>사용자는 **Qwen3-30B-A3B 계열 + GPT Realtime**을 이번 PoC의 모델 reference로 지정했다. 비용/API revision은 앞서 가격을 확인한 **Qwen3-30B-A3B-Instruct-2507**로 고정한다. 원본 `qwen3-30b-a3b`나 Thinking-2507/VL 모델과 혼용하지 않는다. 의미 해석·bounded read 판단·41B의 frame 생성에는 Qwen을, 실시간 음성 입출력/대화 지속에는 GPT Realtime을 사용한다. 외부 업무를 VIA에 맡긴 뒤에도 pending 함수 호출 중 대화를 계속한다. VIA가 외부 Agent의 실행/현재 Task/승인/질문/결과 연결의 권위를 유지하며 GPT Realtime의 tool pending을 실제 업무 완료로 해석하지 않는다. 양안은 같은 역할별 모델/설정/입출력 계약을 사용한다.</a:t>
+            </a:r>
+          </a:p>
+          <a:p xmlns:a="http://schemas.openxmlformats.org/drawingml/2006/main">
+            <a:r>
+              <a:t/>
+            </a:r>
+          </a:p>
+          <a:p xmlns:a="http://schemas.openxmlformats.org/drawingml/2006/main">
+            <a:r>
+              <a:t>Qwen은 Text-to-Text 모델이다. P21의 S2-01 등은 이미 원천 observation으로 표 내용/version·관측시각·포인터 이력을 제공하므로, 그 **원천 사실과 span을 공통 text 입력으로 직렬화**한다. 최종 A/B 지칭, Task 연결, revision 선택, 의존 관계 또는 채점 정답을 adapter가 미리 채우지 않는다. 조회하지 않은 원천 내용·권한 없는 내용도 자동으로 넣지 않는다. 소스 원문/구조 정보는 그대로 공급하고, 의미 결합은 각 방안이 생산한다. 원본 화면 frame은 시간/보관/메모리 원장에 유지한다. 이는 픽셀만으로 임의 앱 화면을 인식하는 완성 제품 평가가 아니라 정의된 PoC 원천 자료를 사용하는 범위다. 추가 vision/OCR 모델을 현재 예산에 숨겨 넣지 않는다. 실제 픽셀 인식이 필요해지면 공통 관측 adapter의 추가 모델·비용·지연·권한·손실을 동일하게 명시하고 계약을 개정한다.</a:t>
+            </a:r>
+          </a:p>
+          <a:p xmlns:a="http://schemas.openxmlformats.org/drawingml/2006/main">
+            <a:r>
+              <a:t/>
+            </a:r>
+          </a:p>
+          <a:p xmlns:a="http://schemas.openxmlformats.org/drawingml/2006/main">
+            <a:r>
+              <a:t>Qwen frame/tool 출력은 구문·허용 schema·ID/revision·현재성 검사를 거친다. 모델 이름만으로 JSON/함수 호출이 항상 맞거나 provider가 엄격한 schema decoding을 보장한다고 가정하지 않는다. 잘못된 출력의 재시도와 판단 유보는 같은 사례/실패/청구 원장에 포함한다. GPT Realtime의 structured output 미지원 때문에 음성 모델을 41B의 의미 frame 생산자로 대신 쓰지 않는다. 비용/기능 reference의 지정은 제품 모델 채택, Architecture 대안 선택이나 정확성 측정의 완료가 아니다.</a:t>
+            </a:r>
+          </a:p>
+          <a:p xmlns:a="http://schemas.openxmlformats.org/drawingml/2006/main">
+            <a:r>
+              <a:t/>
+            </a:r>
+          </a:p>
+          <a:p xmlns:a="http://schemas.openxmlformats.org/drawingml/2006/main">
+            <a:r>
+              <a:t>### 8.4.1.1 이전 Gemini 선택 이유와 변경 이력</a:t>
+            </a:r>
+          </a:p>
+          <a:p xmlns:a="http://schemas.openxmlformats.org/drawingml/2006/main">
+            <a:r>
+              <a:t/>
+            </a:r>
+          </a:p>
+          <a:p xmlns:a="http://schemas.openxmlformats.org/drawingml/2006/main">
+            <a:r>
+              <a:t>Gemini 3 Flash Preview의 공개 출시일은 **2025-12-17**이다([Google 출시 공지](https://blog.google/products-and-platforms/products/gemini/gemini-3-flash/)). 이전 선택은 공식 단가와 이미지 입력·함수 호출·structured output을 가진 reference의 편의에 따른 것이며 VIA 우월성이나 Qwen 30B와의 동등성 검증이 아니었다. 이후 정확한 Qwen API 단가를 확인했고 사용자가 Qwen/GPT 조합을 지정했으므로 **Gemini는 현행 의미/비용/속도 기준에서 제외**한다. 같은 124k/12.4k token 예산의 이전 Gemini 의미 비용 $0.09920과 현재 Qwen $0.03472의 차이 $0.06448는 단가 민감도이며 실제 호출/정확성/출력 동등성의 증거가 아니다. 기존 200 token/s와 Gemini cache 요금은 [변경 전 보존본](../../../archive/qa-semantic-reference-before-qwen-20261011/README.md)에 남겼다.</a:t>
+            </a:r>
+          </a:p>
+          <a:p xmlns:a="http://schemas.openxmlformats.org/drawingml/2006/main">
+            <a:r>
+              <a:t/>
+            </a:r>
+          </a:p>
+          <a:p xmlns:a="http://schemas.openxmlformats.org/drawingml/2006/main">
+            <a:r>
+              <a:t>### 8.4.1.2 Groq 밖의 속도 근거와 산식</a:t>
+            </a:r>
+          </a:p>
+          <a:p xmlns:a="http://schemas.openxmlformats.org/drawingml/2006/main">
+            <a:r>
+              <a:t/>
+            </a:r>
+          </a:p>
+          <a:p xmlns:a="http://schemas.openxmlformats.org/drawingml/2006/main">
+            <a:r>
+              <a:t>[Qwen 공식 속도 benchmark](https://qwen.readthedocs.io/en/latest/getting_started/speed_benchmark.html)는 **Qwen3-30B-A3B**를 NVIDIA **H20 96GB 1장**, SGLang **0.4.6.post1**, PyTorch **2.6.0+cu124**, batch **1**, 출력 **2,048 token**으로 평가했다. 입력1 token에서 BF16 **137.18**, FP8 **155.55 token/s**다. 입력6,144 token에서는 BF16 **490.10**, FP8 **551.34**다. 단, 공식 분자는 **입력+출력 token**, 분모는 전체 처리시간이다. 입력6,144의 490.10을 출력 생성률로 쓰지 않는다.</a:t>
+            </a:r>
+          </a:p>
+          <a:p xmlns:a="http://schemas.openxmlformats.org/drawingml/2006/main">
+            <a:r>
+              <a:t/>
+            </a:r>
+          </a:p>
+          <a:p xmlns:a="http://schemas.openxmlformats.org/drawingml/2006/main">
+            <a:r>
+              <a:t>BF16 입력1 조건의 전체 시간은 `2,049/137.18 ≈ 14.94초`, 입력6,144 조건은 `8,192/490.10 ≈ 16.72초`로 복원할 수 있다. 출력/전체시간으로 다시 표현하면 각각 **137.11**과 **122.53 output token/s**이며 이는 prefill까지 포함한 해당 길이의 유효 출력률이다. 이것을 TTFT와 분리된 decode rate로 두고 TTFT를 다시 더하면 입력 처리 시간이 이중 계상된다. 원본 Qwen3 benchmark를 Instruct-2507의 실측 또는 Alibaba Singapore API의 속도로 주장하지 않는다. 서버 측 H20 reference이므로 Windows 노트북의 속도/메모리에도 이전하지 않는다.</a:t>
+            </a:r>
+          </a:p>
+          <a:p xmlns:a="http://schemas.openxmlformats.org/drawingml/2006/main">
+            <a:r>
+              <a:t/>
+            </a:r>
+          </a:p>
+          <a:p xmlns:a="http://schemas.openxmlformats.org/drawingml/2006/main">
+            <a:r>
+              <a:t>따라서 공식 수치 기반의 계산은 **공개된 동일 길이/환경의 전체 처리시간**을 쓰거나, 별도로 검증된 decode rate와 TTFT를 분리해야 한다. 현재는 원본 계열 BF16 유효 출력률 약122.53~137.11과 FP8 입력1 약155.47을 수치 규모의 참고로 삼아 **130 token/s의 독립적인 PoC decode 가정**과 **100/130/160 민감도**를 정했다. 기준 TTFT0.30초, 빠른0.15초, 느린0.80초와 음성 시작0.10/0.25/0.60초도 별도 작성자 가정이다. 이들을 공개표에서 분리 측정한 TTFT/decode로 주장하지 않는다. 특히 2,048 출력의 유효 출력률을 2,000입력/200출력에 보장된 rate로 이전하지 않는다. API 배포의 TTFT/생성률이 있으면 두 가정을 실제 측정으로 함께 교체하고, 공개 benchmark 자체를 재현 계산할 때는 전체시간만 써서 prefill을 중복 계상하지 않는다. API 가격 reference와 별도 H20 속도 reference를 함께 사용하는 경우 비용/속도가 같은 서비스에서 측정됐다는 주장도 하지 않는다.</a:t>
+            </a:r>
+          </a:p>
+          <a:p xmlns:a="http://schemas.openxmlformats.org/drawingml/2006/main">
+            <a:r>
+              <a:t/>
+            </a:r>
+          </a:p>
+          <a:p xmlns:a="http://schemas.openxmlformats.org/drawingml/2006/main">
+            <a:r>
+              <a:t>기존의 **450+ token/s**는 [Groq의 `qwen/qwen3.8-27b` 모델 페이지](https://console.groq.com/docs/model/qwen/qwen3.8-27b)의 제공사 표시값이다. [GroqCloud는 전용 LPU 추론 인프라](https://groq.com/blog/the-groq-lpu-explained)를 사용한다. 이는 Qwen3-30B-A3B-Instruct-2507, NVIDIA GPU 또는 Windows PC의 숫자가 아니다. 해당 450 수치의 LPU 수/세대, precision, prompt/output 길이, 동시 요청 수와 상세 계측 경계는 페이지에 공개되어 있지 않으므로 가정으로 채우지 않는다. Groq은 현행 비용/속도 reference에서 제외하며 이 문단은 이전 근거의 의미를 설명하기 위한 provenance다.</a:t>
+            </a:r>
+          </a:p>
+          <a:p xmlns:a="http://schemas.openxmlformats.org/drawingml/2006/main">
+            <a:r>
+              <a:t/>
+            </a:r>
+          </a:p>
+          <a:p xmlns:a="http://schemas.openxmlformats.org/drawingml/2006/main">
+            <a:r>
+              <a:t>### 8.4.2 Gemini Live와 GPT Realtime의 기능 비교</a:t>
+            </a:r>
+          </a:p>
+          <a:p xmlns:a="http://schemas.openxmlformats.org/drawingml/2006/main">
+            <a:r>
+              <a:t/>
+            </a:r>
+          </a:p>
+          <a:p xmlns:a="http://schemas.openxmlformats.org/drawingml/2006/main">
+            <a:r>
+              <a:t>2026-10-11 확인한 공식 문서 기준으로 같은 실시간 음성 대화 역할을 제공하지만 API/실행 제약은 다르다. 아래 GPT는 사용자가 지칭한 `gpt-realtime` 모델 기준이며 다른 GPT Realtime 모델의 제한으로 확대하지 않는다. 현재 공식 모델 페이지는 해당 모델을 Deprecated로 표시하므로 실제 제품 적용 권고가 아니라 요청한 기능 비교 기준으로만 쓴다.</a:t>
+            </a:r>
+          </a:p>
+          <a:p xmlns:a="http://schemas.openxmlformats.org/drawingml/2006/main">
+            <a:r>
+              <a:t/>
+            </a:r>
+          </a:p>
+          <a:p xmlns:a="http://schemas.openxmlformats.org/drawingml/2006/main">
+            <a:r>
+              <a:t>| 비교 항목 | Gemini 3.1 Flash Live Preview | OpenAI gpt-realtime | VIA에 주는 의미 |</a:t>
+            </a:r>
+          </a:p>
+          <a:p xmlns:a="http://schemas.openxmlformats.org/drawingml/2006/main">
+            <a:r>
+              <a:t>| --- | --- | --- | --- |</a:t>
+            </a:r>
+          </a:p>
+          <a:p xmlns:a="http://schemas.openxmlformats.org/drawingml/2006/main">
+            <a:r>
+              <a:t>| 실시간 음성 입출력, 입력/출력 전사, 발화 중 끼어들기 | 지원 | 지원 | 양쪽 모두 음성 역할의 reference가 될 수 있다. 실제 한국어 품질·지연·중단 시간 동등성은 입증하지 않음 |</a:t>
+            </a:r>
+          </a:p>
+          <a:p xmlns:a="http://schemas.openxmlformats.org/drawingml/2006/main">
+            <a:r>
+              <a:t>| 화면/멀티모달 입력 | Text·이미지·audio·video 입력 | Text·이미지·audio 입력, video 미지원 | GPT에서는 화면 snapshot의 이미지 입력과 video stream 지원을 구별 |</a:t>
+            </a:r>
+          </a:p>
+          <a:p xmlns:a="http://schemas.openxmlformats.org/drawingml/2006/main">
+            <a:r>
+              <a:t>| 함수 호출 | 동기만 지원, tool response 전 응답 대기 | 비동기 tool 흐름 지원 | 긴 Agent 실행을 Gemini Live tool response로 끝날 때까지 기다리게 하지 않음 |</a:t>
+            </a:r>
+          </a:p>
+          <a:p xmlns:a="http://schemas.openxmlformats.org/drawingml/2006/main">
+            <a:r>
+              <a:t>| 직접 연결 | Live API WebSocket | WebRTC / WebSocket / SIP | provider adapter·세션 재연결·audio queue/취소 이벤트를 별도로 구현/계산 |</a:t>
+            </a:r>
+          </a:p>
+          <a:p xmlns:a="http://schemas.openxmlformats.org/drawingml/2006/main">
+            <a:r>
+              <a:t>| structured output | 미지원 | 미지원 | 함수 인자 JSON과 schema 제약 출력 보장을 구별, 의미 모델의 frame 검증은 별도 |</a:t>
+            </a:r>
+          </a:p>
+          <a:p xmlns:a="http://schemas.openxmlformats.org/drawingml/2006/main">
+            <a:r>
+              <a:t/>
+            </a:r>
+          </a:p>
+          <a:p xmlns:a="http://schemas.openxmlformats.org/drawingml/2006/main">
+            <a:r>
+              <a:t>근거: [Gemini Live 모델/제약](https://ai.google.dev/gemini-api/docs/models/gemini-3.1-flash-live-preview), [Live 도구의 동기 제한](https://ai.google.dev/gemini-api/docs/live-api/tools), [Live API 연결](https://ai.google.dev/gemini-api/docs/live-api), [Live VAD/중단](https://ai.google.dev/gemini-api/docs/live-api/capabilities), [OpenAI gpt-realtime](https://developers.openai.com/api/docs/models/gpt-realtime), [Realtime 대화/중단](https://developers.openai.com/api/docs/guides/realtime-conversations), [Realtime 도구](https://developers.openai.com/api/docs/guides/realtime-mcp), [GPT Realtime 비동기 함수 호출 설명](https://developers.openai.com/blog/realtime-api).</a:t>
+            </a:r>
+          </a:p>
+          <a:p xmlns:a="http://schemas.openxmlformats.org/drawingml/2006/main">
+            <a:r>
+              <a:t/>
+            </a:r>
+          </a:p>
+          <a:p xmlns:a="http://schemas.openxmlformats.org/drawingml/2006/main">
+            <a:r>
+              <a:t>VIA는 요청/Task의 권위를 갖고 음성 모델의 임시 session과 구별한다. 긴 업무는 로컬 VIA가 외부 Agent에 비동기로 위임하고, 음성 모델에는 유효한 접수·질문·결과를 제시할 입력을 따로 전달하는 방향으로 reference를 해석한다. 이것은 긴 Agent 결과를 Live 동기 함수 응답으로 기다리는 것과 다르다. 실제 provider의 forced response, cancel, 재연결, 출력 내용 준수와 local playback stop은 adapter/API 검증에서 확인해야 한다. 현재 GPT Realtime reference에서도 local playback stop·새 사용자 요청·동시에 도착한 Agent 질문/결과의 우선순위는 VIA가 관리하고, pending tool의 결과가 없는 동안 완료를 추측해 말하지 못하도록 실제 상태를 전달한다. 이전 Gemini 3.1 검토의 proactive audio/affective dialogue 미지원과 `turn_complete=true`의 활성 generation 중단은 기능 비교의 제한으로 보존한다. 모델 이름만으로 연속 입력/여러 Task 처리 계약이 충족됐다고 하지 않는다.</a:t>
             </a:r>
           </a:p>
           <a:p xmlns:a="http://schemas.openxmlformats.org/drawingml/2006/main">
@@ -17527,7 +18667,7 @@
           </a:p>
           <a:p xmlns:a="http://schemas.openxmlformats.org/drawingml/2006/main">
             <a:r>
-              <a:t>원본 SHA-256: d25a503005403e71d5811d61f20d9c227479bfeb04808ba868ce06adc463e4f8</a:t>
+              <a:t>원본 SHA-256: 8520fa1bd1661f72bb87071ab03755964b0539565490994de845bbc086654cfd</a:t>
             </a:r>
           </a:p>
           <a:p xmlns:a="http://schemas.openxmlformats.org/drawingml/2006/main">
@@ -20673,6 +21813,291 @@
           <a:p xmlns:a="http://schemas.openxmlformats.org/drawingml/2006/main">
             <a:r>
               <a:t>묶음당 21개 시나리오는 사용자 19개 + Agent 단독 2개다. 집중 장면 안에는 Agent 사건 4개가 추가로 들어 있다. Voice 입력 50초와 출력 예산 179초, 반응 27개와 사용자 cycle 19개를 정의했다. 다섯 묶음 전체는 105개 시나리오·630조건·135반응·95cycle이다. 사용자의 하루 빈도를 뜻하지 않는다.</a:t>
+            </a:r>
+          </a:p>
+          <a:p xmlns:a="http://schemas.openxmlformats.org/drawingml/2006/main">
+            <a:r>
+              <a:t/>
+            </a:r>
+          </a:p>
+          <a:p xmlns:a="http://schemas.openxmlformats.org/drawingml/2006/main">
+            <a:r>
+              <a:t/>
+            </a:r>
+          </a:p>
+          <a:p xmlns:a="http://schemas.openxmlformats.org/drawingml/2006/main">
+            <a:r>
+              <a:t>모델 reference 상세 §8.4</a:t>
+            </a:r>
+          </a:p>
+          <a:p xmlns:a="http://schemas.openxmlformats.org/drawingml/2006/main">
+            <a:r>
+              <a:t> 장치와 모델 계산 reference — 2026-10-11 확인</a:t>
+            </a:r>
+          </a:p>
+          <a:p xmlns:a="http://schemas.openxmlformats.org/drawingml/2006/main">
+            <a:r>
+              <a:t/>
+            </a:r>
+          </a:p>
+          <a:p xmlns:a="http://schemas.openxmlformats.org/drawingml/2006/main">
+            <a:r>
+              <a:t>이 reference는 현재 개발 중인 모델/클라우드 서비스의 실제 가격이나 성능을 뜻하지 않는다. 같은 A/B 계산에 쓸 외부 공개 기준이다. 값은 USD, 모델 단가는 1,000,000 token당 표준 유료 요금이며 free tier/할인으로 0원을 만들지 않는다.</a:t>
+            </a:r>
+          </a:p>
+          <a:p xmlns:a="http://schemas.openxmlformats.org/drawingml/2006/main">
+            <a:r>
+              <a:t/>
+            </a:r>
+          </a:p>
+          <a:p xmlns:a="http://schemas.openxmlformats.org/drawingml/2006/main">
+            <a:r>
+              <a:t>| 용도 | 선택 reference / 값 | 출처와 적용 범위 |</a:t>
+            </a:r>
+          </a:p>
+          <a:p xmlns:a="http://schemas.openxmlformats.org/drawingml/2006/main">
+            <a:r>
+              <a:t>| --- | --- | --- |</a:t>
+            </a:r>
+          </a:p>
+          <a:p xmlns:a="http://schemas.openxmlformats.org/drawingml/2006/main">
+            <a:r>
+              <a:t>| Windows PC | **Galaxy Book6 Ultra NP960UJH-XG3IN**, Windows 11 Home, Core Ultra 7 356H, RAM 32GB LPDDR5X, RTX 5070 Laptop GPU 8GB, SSD 1TB | [삼성 공식 SKU 사양](https://www.samsung.com/in/computers/galaxy-book/galaxy-book6-ultra-ultra-7-32gb-1tb-np960ujh-xg3in/). RAM과 VRAM을 같은 자원으로 합치지 않음. 모델은 클라우드이므로 GPU 가중치 적재를 로컬 비용에 가산하지 않음 |</a:t>
+            </a:r>
+          </a:p>
+          <a:p xmlns:a="http://schemas.openxmlformats.org/drawingml/2006/main">
+            <a:r>
+              <a:t>| 의미 LLM의 비용 | **Qwen3-30B-A3B-Instruct-2507**, `qwen3-30b-a3b-instruct-2507`: Alibaba Cloud Model Studio **Singapore / International** 입력 **$0.20**, 출력 **$0.80** / 1M token, non-thinking | [공식 API 모델/단가](https://docs.modelstudio.console.alibabacloud.com/en/model-studio/qwen3-30b-a3b-instruct-2507), [Qwen 공식 모델 카드](https://huggingface.co/Qwen/Qwen3-30B-A3B-Instruct-2507). 약30B 전체/3B 활성 MoE, Text-to-Text. 사용자 승인한 PoC 의미 모델 기준이며 최종 제품 모델/DP 승자 선정은 아님. 같은 provider/region/revision/mode를 양안에 적용 |</a:t>
+            </a:r>
+          </a:p>
+          <a:p xmlns:a="http://schemas.openxmlformats.org/drawingml/2006/main">
+            <a:r>
+              <a:t>| 의미 LLM의 생성 속도 | **작성자 decode 가정 130 token/s**, 민감도 **100 / 130 / 160 token/s**, 기준 TTFT **0.30초** | [Qwen 공식 H20 benchmark](https://qwen.readthedocs.io/en/latest/getting_started/speed_benchmark.html)의 원본 계열 유효 출력률 약122.53~137.11(BF16) 등을 참고한 수치 규모의 가정. Instruct-2507 API의 공개 decode rate/보장/실측이 아니며 공개표에서 TTFT와 decode를 분리 추출한 값도 아님. 가격은 Alibaba API, 속도 근거는 별도 H20 환경임을 §8.4.1.2에 명시 |</a:t>
+            </a:r>
+          </a:p>
+          <a:p xmlns:a="http://schemas.openxmlformats.org/drawingml/2006/main">
+            <a:r>
+              <a:t>| 음성 비용/비동기 대화 기준 | **OpenAI GPT Realtime**, `gpt-realtime` (`gpt-realtime-2025-08-28`): audio 입력 **$32**, 출력 **$64** / 1M token. Text 입력 **$4**, 출력 **$16** / 1M token. cached audio/Text 입력 **$0.40** / 1M token | [공식 모델/단가](https://developers.openai.com/api/docs/models/gpt-realtime), [Realtime 청구](https://developers.openai.com/api/docs/guides/voice-latency-cost), [비동기 함수 호출](https://developers.openai.com/blog/realtime-api). 사용자 입력 약10 audio token/s, assistant 생성 약20 audio token/s로 신규 audio는 **$0.0192/분 입력, $0.0768/분 출력**으로 환산. 특수 token·이력 재입력·Text·폐기 생성은 별도. 공식 페이지의 Deprecated 상태와 관계없이 사용자가 지정한 날짜별 PoC 비용/기능 reference를 고정하며 실서비스의 신규 채택을 뜻하지 않음 |</a:t>
+            </a:r>
+          </a:p>
+          <a:p xmlns:a="http://schemas.openxmlformats.org/drawingml/2006/main">
+            <a:r>
+              <a:t>| 시간 목표의 사용자 근거 | 즉각 제어 **0.1초**, 대화 흐름 **1초**, 주의 유지 **10초**의 상호작용 참조 | [Nielsen Norman Group 원문](https://www.nngroup.com/articles/website-response-times/). VIA의 평균/모집단/추가 지연 예산은 작성자가 선택하며 문헌이 VIA의 평균 목표를 직접 규정했다고 하지 않음 |</a:t>
+            </a:r>
+          </a:p>
+          <a:p xmlns:a="http://schemas.openxmlformats.org/drawingml/2006/main">
+            <a:r>
+              <a:t/>
+            </a:r>
+          </a:p>
+          <a:p xmlns:a="http://schemas.openxmlformats.org/drawingml/2006/main">
+            <a:r>
+              <a:t>음성 비용은 실제로 보내거나 청구되는 audio/context의 양을 사용한다. VAD가 앞단에 있다는 사실만으로 silence/context 재사용 청구가 0이라고 가정하지 않는다. Text prompt/context, 재시도, 취소 불가인 폐기 출력과 미사용 배경 생산도 포함한다. 같은 사용량을 token 요금과 분 요금으로 이중 계산하지 않는다. 모델 제공자가 사용량을 반환한 실측은 그 사용량을 우선하고, 공개 reference 계산은 음성 길이 기반의 근사임을 남긴다.</a:t>
+            </a:r>
+          </a:p>
+          <a:p xmlns:a="http://schemas.openxmlformats.org/drawingml/2006/main">
+            <a:r>
+              <a:t/>
+            </a:r>
+          </a:p>
+          <a:p xmlns:a="http://schemas.openxmlformats.org/drawingml/2006/main">
+            <a:r>
+              <a:t>검산 예시: 의미 호출의 입력 2,000 token/청구 출력 200 token은 `2,000×0.20/1M + 200×0.80/1M = $0.00056`, 작성자 decode 가정의 생성 부분은 `200/130 ≈ 1.538초`다. Instruct-2507은 non-thinking이며 출력200은 실제 답변/frame/tool 출력의 청구 예산이다. 원천/의미/도구 오류의 추가 질문·재시도·폐기 출력을 모두 포함하고 provider별 tokenizer의 실제 사용량을 우선한다. GPT Realtime 신규 audio 입력 1분/출력 1분은 `600×32/1M + 1,200×64/1M = $0.096`이며 Text와 이력 audio 재입력 청구는 별도다. 응답마다 이전 대화가 입력으로 재사용되므로 실제 `response.done`의 modality별 input/output/cached token을 호출 ID로 중복 제거해 합산한다. 초기 2,000turn을 음성 session에 전부 보내도록 강제하지 않으며 실제 보낸 이력·요약·instruction은 청구한다. 별도 input transcription을 켜면 해당 모델 청구도 더한다. 생성 부분 약1.538초를 첫 출력/입력 처리/통신/queue가 포함된 호출 완료 시간으로 쓰지 않는다. Qwen의 기본 예산에는 할인 없는 입력/출력 단가를 사용한다. 실제 cache 할인이나 별도 저장/도구 청구가 있으면 제공사가 확인한 사용량·단가로 원장에 반영하며 Gemini의 cache 단가를 Qwen에 적용하지 않는다.</a:t>
+            </a:r>
+          </a:p>
+          <a:p xmlns:a="http://schemas.openxmlformats.org/drawingml/2006/main">
+            <a:r>
+              <a:t/>
+            </a:r>
+          </a:p>
+          <a:p xmlns:a="http://schemas.openxmlformats.org/drawingml/2006/main">
+            <a:r>
+              <a:t/>
+            </a:r>
+          </a:p>
+          <a:p xmlns:a="http://schemas.openxmlformats.org/drawingml/2006/main">
+            <a:r>
+              <a:t>### 8.4.1 선택한 모델 역할과 입력 범위</a:t>
+            </a:r>
+          </a:p>
+          <a:p xmlns:a="http://schemas.openxmlformats.org/drawingml/2006/main">
+            <a:r>
+              <a:t/>
+            </a:r>
+          </a:p>
+          <a:p xmlns:a="http://schemas.openxmlformats.org/drawingml/2006/main">
+            <a:r>
+              <a:t>사용자는 **Qwen3-30B-A3B 계열 + GPT Realtime**을 이번 PoC의 모델 reference로 지정했다. 비용/API revision은 앞서 가격을 확인한 **Qwen3-30B-A3B-Instruct-2507**로 고정한다. 원본 `qwen3-30b-a3b`나 Thinking-2507/VL 모델과 혼용하지 않는다. 의미 해석·bounded read 판단·41B의 frame 생성에는 Qwen을, 실시간 음성 입출력/대화 지속에는 GPT Realtime을 사용한다. 외부 업무를 VIA에 맡긴 뒤에도 pending 함수 호출 중 대화를 계속한다. VIA가 외부 Agent의 실행/현재 Task/승인/질문/결과 연결의 권위를 유지하며 GPT Realtime의 tool pending을 실제 업무 완료로 해석하지 않는다. 양안은 같은 역할별 모델/설정/입출력 계약을 사용한다.</a:t>
+            </a:r>
+          </a:p>
+          <a:p xmlns:a="http://schemas.openxmlformats.org/drawingml/2006/main">
+            <a:r>
+              <a:t/>
+            </a:r>
+          </a:p>
+          <a:p xmlns:a="http://schemas.openxmlformats.org/drawingml/2006/main">
+            <a:r>
+              <a:t>Qwen은 Text-to-Text 모델이다. P21의 S2-01 등은 이미 원천 observation으로 표 내용/version·관측시각·포인터 이력을 제공하므로, 그 **원천 사실과 span을 공통 text 입력으로 직렬화**한다. 최종 A/B 지칭, Task 연결, revision 선택, 의존 관계 또는 채점 정답을 adapter가 미리 채우지 않는다. 조회하지 않은 원천 내용·권한 없는 내용도 자동으로 넣지 않는다. 소스 원문/구조 정보는 그대로 공급하고, 의미 결합은 각 방안이 생산한다. 원본 화면 frame은 시간/보관/메모리 원장에 유지한다. 이는 픽셀만으로 임의 앱 화면을 인식하는 완성 제품 평가가 아니라 정의된 PoC 원천 자료를 사용하는 범위다. 추가 vision/OCR 모델을 현재 예산에 숨겨 넣지 않는다. 실제 픽셀 인식이 필요해지면 공통 관측 adapter의 추가 모델·비용·지연·권한·손실을 동일하게 명시하고 계약을 개정한다.</a:t>
+            </a:r>
+          </a:p>
+          <a:p xmlns:a="http://schemas.openxmlformats.org/drawingml/2006/main">
+            <a:r>
+              <a:t/>
+            </a:r>
+          </a:p>
+          <a:p xmlns:a="http://schemas.openxmlformats.org/drawingml/2006/main">
+            <a:r>
+              <a:t>Qwen frame/tool 출력은 구문·허용 schema·ID/revision·현재성 검사를 거친다. 모델 이름만으로 JSON/함수 호출이 항상 맞거나 provider가 엄격한 schema decoding을 보장한다고 가정하지 않는다. 잘못된 출력의 재시도와 판단 유보는 같은 사례/실패/청구 원장에 포함한다. GPT Realtime의 structured output 미지원 때문에 음성 모델을 41B의 의미 frame 생산자로 대신 쓰지 않는다. 비용/기능 reference의 지정은 제품 모델 채택, Architecture 대안 선택이나 정확성 측정의 완료가 아니다.</a:t>
+            </a:r>
+          </a:p>
+          <a:p xmlns:a="http://schemas.openxmlformats.org/drawingml/2006/main">
+            <a:r>
+              <a:t/>
+            </a:r>
+          </a:p>
+          <a:p xmlns:a="http://schemas.openxmlformats.org/drawingml/2006/main">
+            <a:r>
+              <a:t>### 8.4.1.1 이전 Gemini 선택 이유와 변경 이력</a:t>
+            </a:r>
+          </a:p>
+          <a:p xmlns:a="http://schemas.openxmlformats.org/drawingml/2006/main">
+            <a:r>
+              <a:t/>
+            </a:r>
+          </a:p>
+          <a:p xmlns:a="http://schemas.openxmlformats.org/drawingml/2006/main">
+            <a:r>
+              <a:t>Gemini 3 Flash Preview의 공개 출시일은 **2025-12-17**이다([Google 출시 공지](https://blog.google/products-and-platforms/products/gemini/gemini-3-flash/)). 이전 선택은 공식 단가와 이미지 입력·함수 호출·structured output을 가진 reference의 편의에 따른 것이며 VIA 우월성이나 Qwen 30B와의 동등성 검증이 아니었다. 이후 정확한 Qwen API 단가를 확인했고 사용자가 Qwen/GPT 조합을 지정했으므로 **Gemini는 현행 의미/비용/속도 기준에서 제외**한다. 같은 124k/12.4k token 예산의 이전 Gemini 의미 비용 $0.09920과 현재 Qwen $0.03472의 차이 $0.06448는 단가 민감도이며 실제 호출/정확성/출력 동등성의 증거가 아니다. 기존 200 token/s와 Gemini cache 요금은 [변경 전 보존본](../../../archive/qa-semantic-reference-before-qwen-20261011/README.md)에 남겼다.</a:t>
+            </a:r>
+          </a:p>
+          <a:p xmlns:a="http://schemas.openxmlformats.org/drawingml/2006/main">
+            <a:r>
+              <a:t/>
+            </a:r>
+          </a:p>
+          <a:p xmlns:a="http://schemas.openxmlformats.org/drawingml/2006/main">
+            <a:r>
+              <a:t>### 8.4.1.2 Groq 밖의 속도 근거와 산식</a:t>
+            </a:r>
+          </a:p>
+          <a:p xmlns:a="http://schemas.openxmlformats.org/drawingml/2006/main">
+            <a:r>
+              <a:t/>
+            </a:r>
+          </a:p>
+          <a:p xmlns:a="http://schemas.openxmlformats.org/drawingml/2006/main">
+            <a:r>
+              <a:t>[Qwen 공식 속도 benchmark](https://qwen.readthedocs.io/en/latest/getting_started/speed_benchmark.html)는 **Qwen3-30B-A3B**를 NVIDIA **H20 96GB 1장**, SGLang **0.4.6.post1**, PyTorch **2.6.0+cu124**, batch **1**, 출력 **2,048 token**으로 평가했다. 입력1 token에서 BF16 **137.18**, FP8 **155.55 token/s**다. 입력6,144 token에서는 BF16 **490.10**, FP8 **551.34**다. 단, 공식 분자는 **입력+출력 token**, 분모는 전체 처리시간이다. 입력6,144의 490.10을 출력 생성률로 쓰지 않는다.</a:t>
+            </a:r>
+          </a:p>
+          <a:p xmlns:a="http://schemas.openxmlformats.org/drawingml/2006/main">
+            <a:r>
+              <a:t/>
+            </a:r>
+          </a:p>
+          <a:p xmlns:a="http://schemas.openxmlformats.org/drawingml/2006/main">
+            <a:r>
+              <a:t>BF16 입력1 조건의 전체 시간은 `2,049/137.18 ≈ 14.94초`, 입력6,144 조건은 `8,192/490.10 ≈ 16.72초`로 복원할 수 있다. 출력/전체시간으로 다시 표현하면 각각 **137.11**과 **122.53 output token/s**이며 이는 prefill까지 포함한 해당 길이의 유효 출력률이다. 이것을 TTFT와 분리된 decode rate로 두고 TTFT를 다시 더하면 입력 처리 시간이 이중 계상된다. 원본 Qwen3 benchmark를 Instruct-2507의 실측 또는 Alibaba Singapore API의 속도로 주장하지 않는다. 서버 측 H20 reference이므로 Windows 노트북의 속도/메모리에도 이전하지 않는다.</a:t>
+            </a:r>
+          </a:p>
+          <a:p xmlns:a="http://schemas.openxmlformats.org/drawingml/2006/main">
+            <a:r>
+              <a:t/>
+            </a:r>
+          </a:p>
+          <a:p xmlns:a="http://schemas.openxmlformats.org/drawingml/2006/main">
+            <a:r>
+              <a:t>따라서 공식 수치 기반의 계산은 **공개된 동일 길이/환경의 전체 처리시간**을 쓰거나, 별도로 검증된 decode rate와 TTFT를 분리해야 한다. 현재는 원본 계열 BF16 유효 출력률 약122.53~137.11과 FP8 입력1 약155.47을 수치 규모의 참고로 삼아 **130 token/s의 독립적인 PoC decode 가정**과 **100/130/160 민감도**를 정했다. 기준 TTFT0.30초, 빠른0.15초, 느린0.80초와 음성 시작0.10/0.25/0.60초도 별도 작성자 가정이다. 이들을 공개표에서 분리 측정한 TTFT/decode로 주장하지 않는다. 특히 2,048 출력의 유효 출력률을 2,000입력/200출력에 보장된 rate로 이전하지 않는다. API 배포의 TTFT/생성률이 있으면 두 가정을 실제 측정으로 함께 교체하고, 공개 benchmark 자체를 재현 계산할 때는 전체시간만 써서 prefill을 중복 계상하지 않는다. API 가격 reference와 별도 H20 속도 reference를 함께 사용하는 경우 비용/속도가 같은 서비스에서 측정됐다는 주장도 하지 않는다.</a:t>
+            </a:r>
+          </a:p>
+          <a:p xmlns:a="http://schemas.openxmlformats.org/drawingml/2006/main">
+            <a:r>
+              <a:t/>
+            </a:r>
+          </a:p>
+          <a:p xmlns:a="http://schemas.openxmlformats.org/drawingml/2006/main">
+            <a:r>
+              <a:t>기존의 **450+ token/s**는 [Groq의 `qwen/qwen3.8-27b` 모델 페이지](https://console.groq.com/docs/model/qwen/qwen3.8-27b)의 제공사 표시값이다. [GroqCloud는 전용 LPU 추론 인프라](https://groq.com/blog/the-groq-lpu-explained)를 사용한다. 이는 Qwen3-30B-A3B-Instruct-2507, NVIDIA GPU 또는 Windows PC의 숫자가 아니다. 해당 450 수치의 LPU 수/세대, precision, prompt/output 길이, 동시 요청 수와 상세 계측 경계는 페이지에 공개되어 있지 않으므로 가정으로 채우지 않는다. Groq은 현행 비용/속도 reference에서 제외하며 이 문단은 이전 근거의 의미를 설명하기 위한 provenance다.</a:t>
+            </a:r>
+          </a:p>
+          <a:p xmlns:a="http://schemas.openxmlformats.org/drawingml/2006/main">
+            <a:r>
+              <a:t/>
+            </a:r>
+          </a:p>
+          <a:p xmlns:a="http://schemas.openxmlformats.org/drawingml/2006/main">
+            <a:r>
+              <a:t>### 8.4.2 Gemini Live와 GPT Realtime의 기능 비교</a:t>
+            </a:r>
+          </a:p>
+          <a:p xmlns:a="http://schemas.openxmlformats.org/drawingml/2006/main">
+            <a:r>
+              <a:t/>
+            </a:r>
+          </a:p>
+          <a:p xmlns:a="http://schemas.openxmlformats.org/drawingml/2006/main">
+            <a:r>
+              <a:t>2026-10-11 확인한 공식 문서 기준으로 같은 실시간 음성 대화 역할을 제공하지만 API/실행 제약은 다르다. 아래 GPT는 사용자가 지칭한 `gpt-realtime` 모델 기준이며 다른 GPT Realtime 모델의 제한으로 확대하지 않는다. 현재 공식 모델 페이지는 해당 모델을 Deprecated로 표시하므로 실제 제품 적용 권고가 아니라 요청한 기능 비교 기준으로만 쓴다.</a:t>
+            </a:r>
+          </a:p>
+          <a:p xmlns:a="http://schemas.openxmlformats.org/drawingml/2006/main">
+            <a:r>
+              <a:t/>
+            </a:r>
+          </a:p>
+          <a:p xmlns:a="http://schemas.openxmlformats.org/drawingml/2006/main">
+            <a:r>
+              <a:t>| 비교 항목 | Gemini 3.1 Flash Live Preview | OpenAI gpt-realtime | VIA에 주는 의미 |</a:t>
+            </a:r>
+          </a:p>
+          <a:p xmlns:a="http://schemas.openxmlformats.org/drawingml/2006/main">
+            <a:r>
+              <a:t>| --- | --- | --- | --- |</a:t>
+            </a:r>
+          </a:p>
+          <a:p xmlns:a="http://schemas.openxmlformats.org/drawingml/2006/main">
+            <a:r>
+              <a:t>| 실시간 음성 입출력, 입력/출력 전사, 발화 중 끼어들기 | 지원 | 지원 | 양쪽 모두 음성 역할의 reference가 될 수 있다. 실제 한국어 품질·지연·중단 시간 동등성은 입증하지 않음 |</a:t>
+            </a:r>
+          </a:p>
+          <a:p xmlns:a="http://schemas.openxmlformats.org/drawingml/2006/main">
+            <a:r>
+              <a:t>| 화면/멀티모달 입력 | Text·이미지·audio·video 입력 | Text·이미지·audio 입력, video 미지원 | GPT에서는 화면 snapshot의 이미지 입력과 video stream 지원을 구별 |</a:t>
+            </a:r>
+          </a:p>
+          <a:p xmlns:a="http://schemas.openxmlformats.org/drawingml/2006/main">
+            <a:r>
+              <a:t>| 함수 호출 | 동기만 지원, tool response 전 응답 대기 | 비동기 tool 흐름 지원 | 긴 Agent 실행을 Gemini Live tool response로 끝날 때까지 기다리게 하지 않음 |</a:t>
+            </a:r>
+          </a:p>
+          <a:p xmlns:a="http://schemas.openxmlformats.org/drawingml/2006/main">
+            <a:r>
+              <a:t>| 직접 연결 | Live API WebSocket | WebRTC / WebSocket / SIP | provider adapter·세션 재연결·audio queue/취소 이벤트를 별도로 구현/계산 |</a:t>
+            </a:r>
+          </a:p>
+          <a:p xmlns:a="http://schemas.openxmlformats.org/drawingml/2006/main">
+            <a:r>
+              <a:t>| structured output | 미지원 | 미지원 | 함수 인자 JSON과 schema 제약 출력 보장을 구별, 의미 모델의 frame 검증은 별도 |</a:t>
+            </a:r>
+          </a:p>
+          <a:p xmlns:a="http://schemas.openxmlformats.org/drawingml/2006/main">
+            <a:r>
+              <a:t/>
+            </a:r>
+          </a:p>
+          <a:p xmlns:a="http://schemas.openxmlformats.org/drawingml/2006/main">
+            <a:r>
+              <a:t>근거: [Gemini Live 모델/제약](https://ai.google.dev/gemini-api/docs/models/gemini-3.1-flash-live-preview), [Live 도구의 동기 제한](https://ai.google.dev/gemini-api/docs/live-api/tools), [Live API 연결](https://ai.google.dev/gemini-api/docs/live-api), [Live VAD/중단](https://ai.google.dev/gemini-api/docs/live-api/capabilities), [OpenAI gpt-realtime](https://developers.openai.com/api/docs/models/gpt-realtime), [Realtime 대화/중단](https://developers.openai.com/api/docs/guides/realtime-conversations), [Realtime 도구](https://developers.openai.com/api/docs/guides/realtime-mcp), [GPT Realtime 비동기 함수 호출 설명](https://developers.openai.com/blog/realtime-api).</a:t>
+            </a:r>
+          </a:p>
+          <a:p xmlns:a="http://schemas.openxmlformats.org/drawingml/2006/main">
+            <a:r>
+              <a:t/>
+            </a:r>
+          </a:p>
+          <a:p xmlns:a="http://schemas.openxmlformats.org/drawingml/2006/main">
+            <a:r>
+              <a:t>VIA는 요청/Task의 권위를 갖고 음성 모델의 임시 session과 구별한다. 긴 업무는 로컬 VIA가 외부 Agent에 비동기로 위임하고, 음성 모델에는 유효한 접수·질문·결과를 제시할 입력을 따로 전달하는 방향으로 reference를 해석한다. 이것은 긴 Agent 결과를 Live 동기 함수 응답으로 기다리는 것과 다르다. 실제 provider의 forced response, cancel, 재연결, 출력 내용 준수와 local playback stop은 adapter/API 검증에서 확인해야 한다. 현재 GPT Realtime reference에서도 local playback stop·새 사용자 요청·동시에 도착한 Agent 질문/결과의 우선순위는 VIA가 관리하고, pending tool의 결과가 없는 동안 완료를 추측해 말하지 못하도록 실제 상태를 전달한다. 이전 Gemini 3.1 검토의 proactive audio/affective dialogue 미지원과 `turn_complete=true`의 활성 generation 중단은 기능 비교의 제한으로 보존한다. 모델 이름만으로 연속 입력/여러 Task 처리 계약이 충족됐다고 하지 않는다.</a:t>
             </a:r>
           </a:p>
           <a:p xmlns:a="http://schemas.openxmlformats.org/drawingml/2006/main">
@@ -20787,7 +22212,7 @@
           </a:p>
           <a:p xmlns:a="http://schemas.openxmlformats.org/drawingml/2006/main">
             <a:r>
-              <a:t>원본 SHA-256: d25a503005403e71d5811d61f20d9c227479bfeb04808ba868ce06adc463e4f8</a:t>
+              <a:t>원본 SHA-256: 8520fa1bd1661f72bb87071ab03755964b0539565490994de845bbc086654cfd</a:t>
             </a:r>
           </a:p>
           <a:p xmlns:a="http://schemas.openxmlformats.org/drawingml/2006/main">
@@ -23933,6 +25358,291 @@
           <a:p xmlns:a="http://schemas.openxmlformats.org/drawingml/2006/main">
             <a:r>
               <a:t>묶음당 21개 시나리오는 사용자 19개 + Agent 단독 2개다. 집중 장면 안에는 Agent 사건 4개가 추가로 들어 있다. Voice 입력 50초와 출력 예산 179초, 반응 27개와 사용자 cycle 19개를 정의했다. 다섯 묶음 전체는 105개 시나리오·630조건·135반응·95cycle이다. 사용자의 하루 빈도를 뜻하지 않는다.</a:t>
+            </a:r>
+          </a:p>
+          <a:p xmlns:a="http://schemas.openxmlformats.org/drawingml/2006/main">
+            <a:r>
+              <a:t/>
+            </a:r>
+          </a:p>
+          <a:p xmlns:a="http://schemas.openxmlformats.org/drawingml/2006/main">
+            <a:r>
+              <a:t/>
+            </a:r>
+          </a:p>
+          <a:p xmlns:a="http://schemas.openxmlformats.org/drawingml/2006/main">
+            <a:r>
+              <a:t>모델 reference 상세 §8.4</a:t>
+            </a:r>
+          </a:p>
+          <a:p xmlns:a="http://schemas.openxmlformats.org/drawingml/2006/main">
+            <a:r>
+              <a:t> 장치와 모델 계산 reference — 2026-10-11 확인</a:t>
+            </a:r>
+          </a:p>
+          <a:p xmlns:a="http://schemas.openxmlformats.org/drawingml/2006/main">
+            <a:r>
+              <a:t/>
+            </a:r>
+          </a:p>
+          <a:p xmlns:a="http://schemas.openxmlformats.org/drawingml/2006/main">
+            <a:r>
+              <a:t>이 reference는 현재 개발 중인 모델/클라우드 서비스의 실제 가격이나 성능을 뜻하지 않는다. 같은 A/B 계산에 쓸 외부 공개 기준이다. 값은 USD, 모델 단가는 1,000,000 token당 표준 유료 요금이며 free tier/할인으로 0원을 만들지 않는다.</a:t>
+            </a:r>
+          </a:p>
+          <a:p xmlns:a="http://schemas.openxmlformats.org/drawingml/2006/main">
+            <a:r>
+              <a:t/>
+            </a:r>
+          </a:p>
+          <a:p xmlns:a="http://schemas.openxmlformats.org/drawingml/2006/main">
+            <a:r>
+              <a:t>| 용도 | 선택 reference / 값 | 출처와 적용 범위 |</a:t>
+            </a:r>
+          </a:p>
+          <a:p xmlns:a="http://schemas.openxmlformats.org/drawingml/2006/main">
+            <a:r>
+              <a:t>| --- | --- | --- |</a:t>
+            </a:r>
+          </a:p>
+          <a:p xmlns:a="http://schemas.openxmlformats.org/drawingml/2006/main">
+            <a:r>
+              <a:t>| Windows PC | **Galaxy Book6 Ultra NP960UJH-XG3IN**, Windows 11 Home, Core Ultra 7 356H, RAM 32GB LPDDR5X, RTX 5070 Laptop GPU 8GB, SSD 1TB | [삼성 공식 SKU 사양](https://www.samsung.com/in/computers/galaxy-book/galaxy-book6-ultra-ultra-7-32gb-1tb-np960ujh-xg3in/). RAM과 VRAM을 같은 자원으로 합치지 않음. 모델은 클라우드이므로 GPU 가중치 적재를 로컬 비용에 가산하지 않음 |</a:t>
+            </a:r>
+          </a:p>
+          <a:p xmlns:a="http://schemas.openxmlformats.org/drawingml/2006/main">
+            <a:r>
+              <a:t>| 의미 LLM의 비용 | **Qwen3-30B-A3B-Instruct-2507**, `qwen3-30b-a3b-instruct-2507`: Alibaba Cloud Model Studio **Singapore / International** 입력 **$0.20**, 출력 **$0.80** / 1M token, non-thinking | [공식 API 모델/단가](https://docs.modelstudio.console.alibabacloud.com/en/model-studio/qwen3-30b-a3b-instruct-2507), [Qwen 공식 모델 카드](https://huggingface.co/Qwen/Qwen3-30B-A3B-Instruct-2507). 약30B 전체/3B 활성 MoE, Text-to-Text. 사용자 승인한 PoC 의미 모델 기준이며 최종 제품 모델/DP 승자 선정은 아님. 같은 provider/region/revision/mode를 양안에 적용 |</a:t>
+            </a:r>
+          </a:p>
+          <a:p xmlns:a="http://schemas.openxmlformats.org/drawingml/2006/main">
+            <a:r>
+              <a:t>| 의미 LLM의 생성 속도 | **작성자 decode 가정 130 token/s**, 민감도 **100 / 130 / 160 token/s**, 기준 TTFT **0.30초** | [Qwen 공식 H20 benchmark](https://qwen.readthedocs.io/en/latest/getting_started/speed_benchmark.html)의 원본 계열 유효 출력률 약122.53~137.11(BF16) 등을 참고한 수치 규모의 가정. Instruct-2507 API의 공개 decode rate/보장/실측이 아니며 공개표에서 TTFT와 decode를 분리 추출한 값도 아님. 가격은 Alibaba API, 속도 근거는 별도 H20 환경임을 §8.4.1.2에 명시 |</a:t>
+            </a:r>
+          </a:p>
+          <a:p xmlns:a="http://schemas.openxmlformats.org/drawingml/2006/main">
+            <a:r>
+              <a:t>| 음성 비용/비동기 대화 기준 | **OpenAI GPT Realtime**, `gpt-realtime` (`gpt-realtime-2025-08-28`): audio 입력 **$32**, 출력 **$64** / 1M token. Text 입력 **$4**, 출력 **$16** / 1M token. cached audio/Text 입력 **$0.40** / 1M token | [공식 모델/단가](https://developers.openai.com/api/docs/models/gpt-realtime), [Realtime 청구](https://developers.openai.com/api/docs/guides/voice-latency-cost), [비동기 함수 호출](https://developers.openai.com/blog/realtime-api). 사용자 입력 약10 audio token/s, assistant 생성 약20 audio token/s로 신규 audio는 **$0.0192/분 입력, $0.0768/분 출력**으로 환산. 특수 token·이력 재입력·Text·폐기 생성은 별도. 공식 페이지의 Deprecated 상태와 관계없이 사용자가 지정한 날짜별 PoC 비용/기능 reference를 고정하며 실서비스의 신규 채택을 뜻하지 않음 |</a:t>
+            </a:r>
+          </a:p>
+          <a:p xmlns:a="http://schemas.openxmlformats.org/drawingml/2006/main">
+            <a:r>
+              <a:t>| 시간 목표의 사용자 근거 | 즉각 제어 **0.1초**, 대화 흐름 **1초**, 주의 유지 **10초**의 상호작용 참조 | [Nielsen Norman Group 원문](https://www.nngroup.com/articles/website-response-times/). VIA의 평균/모집단/추가 지연 예산은 작성자가 선택하며 문헌이 VIA의 평균 목표를 직접 규정했다고 하지 않음 |</a:t>
+            </a:r>
+          </a:p>
+          <a:p xmlns:a="http://schemas.openxmlformats.org/drawingml/2006/main">
+            <a:r>
+              <a:t/>
+            </a:r>
+          </a:p>
+          <a:p xmlns:a="http://schemas.openxmlformats.org/drawingml/2006/main">
+            <a:r>
+              <a:t>음성 비용은 실제로 보내거나 청구되는 audio/context의 양을 사용한다. VAD가 앞단에 있다는 사실만으로 silence/context 재사용 청구가 0이라고 가정하지 않는다. Text prompt/context, 재시도, 취소 불가인 폐기 출력과 미사용 배경 생산도 포함한다. 같은 사용량을 token 요금과 분 요금으로 이중 계산하지 않는다. 모델 제공자가 사용량을 반환한 실측은 그 사용량을 우선하고, 공개 reference 계산은 음성 길이 기반의 근사임을 남긴다.</a:t>
+            </a:r>
+          </a:p>
+          <a:p xmlns:a="http://schemas.openxmlformats.org/drawingml/2006/main">
+            <a:r>
+              <a:t/>
+            </a:r>
+          </a:p>
+          <a:p xmlns:a="http://schemas.openxmlformats.org/drawingml/2006/main">
+            <a:r>
+              <a:t>검산 예시: 의미 호출의 입력 2,000 token/청구 출력 200 token은 `2,000×0.20/1M + 200×0.80/1M = $0.00056`, 작성자 decode 가정의 생성 부분은 `200/130 ≈ 1.538초`다. Instruct-2507은 non-thinking이며 출력200은 실제 답변/frame/tool 출력의 청구 예산이다. 원천/의미/도구 오류의 추가 질문·재시도·폐기 출력을 모두 포함하고 provider별 tokenizer의 실제 사용량을 우선한다. GPT Realtime 신규 audio 입력 1분/출력 1분은 `600×32/1M + 1,200×64/1M = $0.096`이며 Text와 이력 audio 재입력 청구는 별도다. 응답마다 이전 대화가 입력으로 재사용되므로 실제 `response.done`의 modality별 input/output/cached token을 호출 ID로 중복 제거해 합산한다. 초기 2,000turn을 음성 session에 전부 보내도록 강제하지 않으며 실제 보낸 이력·요약·instruction은 청구한다. 별도 input transcription을 켜면 해당 모델 청구도 더한다. 생성 부분 약1.538초를 첫 출력/입력 처리/통신/queue가 포함된 호출 완료 시간으로 쓰지 않는다. Qwen의 기본 예산에는 할인 없는 입력/출력 단가를 사용한다. 실제 cache 할인이나 별도 저장/도구 청구가 있으면 제공사가 확인한 사용량·단가로 원장에 반영하며 Gemini의 cache 단가를 Qwen에 적용하지 않는다.</a:t>
+            </a:r>
+          </a:p>
+          <a:p xmlns:a="http://schemas.openxmlformats.org/drawingml/2006/main">
+            <a:r>
+              <a:t/>
+            </a:r>
+          </a:p>
+          <a:p xmlns:a="http://schemas.openxmlformats.org/drawingml/2006/main">
+            <a:r>
+              <a:t/>
+            </a:r>
+          </a:p>
+          <a:p xmlns:a="http://schemas.openxmlformats.org/drawingml/2006/main">
+            <a:r>
+              <a:t>### 8.4.1 선택한 모델 역할과 입력 범위</a:t>
+            </a:r>
+          </a:p>
+          <a:p xmlns:a="http://schemas.openxmlformats.org/drawingml/2006/main">
+            <a:r>
+              <a:t/>
+            </a:r>
+          </a:p>
+          <a:p xmlns:a="http://schemas.openxmlformats.org/drawingml/2006/main">
+            <a:r>
+              <a:t>사용자는 **Qwen3-30B-A3B 계열 + GPT Realtime**을 이번 PoC의 모델 reference로 지정했다. 비용/API revision은 앞서 가격을 확인한 **Qwen3-30B-A3B-Instruct-2507**로 고정한다. 원본 `qwen3-30b-a3b`나 Thinking-2507/VL 모델과 혼용하지 않는다. 의미 해석·bounded read 판단·41B의 frame 생성에는 Qwen을, 실시간 음성 입출력/대화 지속에는 GPT Realtime을 사용한다. 외부 업무를 VIA에 맡긴 뒤에도 pending 함수 호출 중 대화를 계속한다. VIA가 외부 Agent의 실행/현재 Task/승인/질문/결과 연결의 권위를 유지하며 GPT Realtime의 tool pending을 실제 업무 완료로 해석하지 않는다. 양안은 같은 역할별 모델/설정/입출력 계약을 사용한다.</a:t>
+            </a:r>
+          </a:p>
+          <a:p xmlns:a="http://schemas.openxmlformats.org/drawingml/2006/main">
+            <a:r>
+              <a:t/>
+            </a:r>
+          </a:p>
+          <a:p xmlns:a="http://schemas.openxmlformats.org/drawingml/2006/main">
+            <a:r>
+              <a:t>Qwen은 Text-to-Text 모델이다. P21의 S2-01 등은 이미 원천 observation으로 표 내용/version·관측시각·포인터 이력을 제공하므로, 그 **원천 사실과 span을 공통 text 입력으로 직렬화**한다. 최종 A/B 지칭, Task 연결, revision 선택, 의존 관계 또는 채점 정답을 adapter가 미리 채우지 않는다. 조회하지 않은 원천 내용·권한 없는 내용도 자동으로 넣지 않는다. 소스 원문/구조 정보는 그대로 공급하고, 의미 결합은 각 방안이 생산한다. 원본 화면 frame은 시간/보관/메모리 원장에 유지한다. 이는 픽셀만으로 임의 앱 화면을 인식하는 완성 제품 평가가 아니라 정의된 PoC 원천 자료를 사용하는 범위다. 추가 vision/OCR 모델을 현재 예산에 숨겨 넣지 않는다. 실제 픽셀 인식이 필요해지면 공통 관측 adapter의 추가 모델·비용·지연·권한·손실을 동일하게 명시하고 계약을 개정한다.</a:t>
+            </a:r>
+          </a:p>
+          <a:p xmlns:a="http://schemas.openxmlformats.org/drawingml/2006/main">
+            <a:r>
+              <a:t/>
+            </a:r>
+          </a:p>
+          <a:p xmlns:a="http://schemas.openxmlformats.org/drawingml/2006/main">
+            <a:r>
+              <a:t>Qwen frame/tool 출력은 구문·허용 schema·ID/revision·현재성 검사를 거친다. 모델 이름만으로 JSON/함수 호출이 항상 맞거나 provider가 엄격한 schema decoding을 보장한다고 가정하지 않는다. 잘못된 출력의 재시도와 판단 유보는 같은 사례/실패/청구 원장에 포함한다. GPT Realtime의 structured output 미지원 때문에 음성 모델을 41B의 의미 frame 생산자로 대신 쓰지 않는다. 비용/기능 reference의 지정은 제품 모델 채택, Architecture 대안 선택이나 정확성 측정의 완료가 아니다.</a:t>
+            </a:r>
+          </a:p>
+          <a:p xmlns:a="http://schemas.openxmlformats.org/drawingml/2006/main">
+            <a:r>
+              <a:t/>
+            </a:r>
+          </a:p>
+          <a:p xmlns:a="http://schemas.openxmlformats.org/drawingml/2006/main">
+            <a:r>
+              <a:t>### 8.4.1.1 이전 Gemini 선택 이유와 변경 이력</a:t>
+            </a:r>
+          </a:p>
+          <a:p xmlns:a="http://schemas.openxmlformats.org/drawingml/2006/main">
+            <a:r>
+              <a:t/>
+            </a:r>
+          </a:p>
+          <a:p xmlns:a="http://schemas.openxmlformats.org/drawingml/2006/main">
+            <a:r>
+              <a:t>Gemini 3 Flash Preview의 공개 출시일은 **2025-12-17**이다([Google 출시 공지](https://blog.google/products-and-platforms/products/gemini/gemini-3-flash/)). 이전 선택은 공식 단가와 이미지 입력·함수 호출·structured output을 가진 reference의 편의에 따른 것이며 VIA 우월성이나 Qwen 30B와의 동등성 검증이 아니었다. 이후 정확한 Qwen API 단가를 확인했고 사용자가 Qwen/GPT 조합을 지정했으므로 **Gemini는 현행 의미/비용/속도 기준에서 제외**한다. 같은 124k/12.4k token 예산의 이전 Gemini 의미 비용 $0.09920과 현재 Qwen $0.03472의 차이 $0.06448는 단가 민감도이며 실제 호출/정확성/출력 동등성의 증거가 아니다. 기존 200 token/s와 Gemini cache 요금은 [변경 전 보존본](../../../archive/qa-semantic-reference-before-qwen-20261011/README.md)에 남겼다.</a:t>
+            </a:r>
+          </a:p>
+          <a:p xmlns:a="http://schemas.openxmlformats.org/drawingml/2006/main">
+            <a:r>
+              <a:t/>
+            </a:r>
+          </a:p>
+          <a:p xmlns:a="http://schemas.openxmlformats.org/drawingml/2006/main">
+            <a:r>
+              <a:t>### 8.4.1.2 Groq 밖의 속도 근거와 산식</a:t>
+            </a:r>
+          </a:p>
+          <a:p xmlns:a="http://schemas.openxmlformats.org/drawingml/2006/main">
+            <a:r>
+              <a:t/>
+            </a:r>
+          </a:p>
+          <a:p xmlns:a="http://schemas.openxmlformats.org/drawingml/2006/main">
+            <a:r>
+              <a:t>[Qwen 공식 속도 benchmark](https://qwen.readthedocs.io/en/latest/getting_started/speed_benchmark.html)는 **Qwen3-30B-A3B**를 NVIDIA **H20 96GB 1장**, SGLang **0.4.6.post1**, PyTorch **2.6.0+cu124**, batch **1**, 출력 **2,048 token**으로 평가했다. 입력1 token에서 BF16 **137.18**, FP8 **155.55 token/s**다. 입력6,144 token에서는 BF16 **490.10**, FP8 **551.34**다. 단, 공식 분자는 **입력+출력 token**, 분모는 전체 처리시간이다. 입력6,144의 490.10을 출력 생성률로 쓰지 않는다.</a:t>
+            </a:r>
+          </a:p>
+          <a:p xmlns:a="http://schemas.openxmlformats.org/drawingml/2006/main">
+            <a:r>
+              <a:t/>
+            </a:r>
+          </a:p>
+          <a:p xmlns:a="http://schemas.openxmlformats.org/drawingml/2006/main">
+            <a:r>
+              <a:t>BF16 입력1 조건의 전체 시간은 `2,049/137.18 ≈ 14.94초`, 입력6,144 조건은 `8,192/490.10 ≈ 16.72초`로 복원할 수 있다. 출력/전체시간으로 다시 표현하면 각각 **137.11**과 **122.53 output token/s**이며 이는 prefill까지 포함한 해당 길이의 유효 출력률이다. 이것을 TTFT와 분리된 decode rate로 두고 TTFT를 다시 더하면 입력 처리 시간이 이중 계상된다. 원본 Qwen3 benchmark를 Instruct-2507의 실측 또는 Alibaba Singapore API의 속도로 주장하지 않는다. 서버 측 H20 reference이므로 Windows 노트북의 속도/메모리에도 이전하지 않는다.</a:t>
+            </a:r>
+          </a:p>
+          <a:p xmlns:a="http://schemas.openxmlformats.org/drawingml/2006/main">
+            <a:r>
+              <a:t/>
+            </a:r>
+          </a:p>
+          <a:p xmlns:a="http://schemas.openxmlformats.org/drawingml/2006/main">
+            <a:r>
+              <a:t>따라서 공식 수치 기반의 계산은 **공개된 동일 길이/환경의 전체 처리시간**을 쓰거나, 별도로 검증된 decode rate와 TTFT를 분리해야 한다. 현재는 원본 계열 BF16 유효 출력률 약122.53~137.11과 FP8 입력1 약155.47을 수치 규모의 참고로 삼아 **130 token/s의 독립적인 PoC decode 가정**과 **100/130/160 민감도**를 정했다. 기준 TTFT0.30초, 빠른0.15초, 느린0.80초와 음성 시작0.10/0.25/0.60초도 별도 작성자 가정이다. 이들을 공개표에서 분리 측정한 TTFT/decode로 주장하지 않는다. 특히 2,048 출력의 유효 출력률을 2,000입력/200출력에 보장된 rate로 이전하지 않는다. API 배포의 TTFT/생성률이 있으면 두 가정을 실제 측정으로 함께 교체하고, 공개 benchmark 자체를 재현 계산할 때는 전체시간만 써서 prefill을 중복 계상하지 않는다. API 가격 reference와 별도 H20 속도 reference를 함께 사용하는 경우 비용/속도가 같은 서비스에서 측정됐다는 주장도 하지 않는다.</a:t>
+            </a:r>
+          </a:p>
+          <a:p xmlns:a="http://schemas.openxmlformats.org/drawingml/2006/main">
+            <a:r>
+              <a:t/>
+            </a:r>
+          </a:p>
+          <a:p xmlns:a="http://schemas.openxmlformats.org/drawingml/2006/main">
+            <a:r>
+              <a:t>기존의 **450+ token/s**는 [Groq의 `qwen/qwen3.8-27b` 모델 페이지](https://console.groq.com/docs/model/qwen/qwen3.8-27b)의 제공사 표시값이다. [GroqCloud는 전용 LPU 추론 인프라](https://groq.com/blog/the-groq-lpu-explained)를 사용한다. 이는 Qwen3-30B-A3B-Instruct-2507, NVIDIA GPU 또는 Windows PC의 숫자가 아니다. 해당 450 수치의 LPU 수/세대, precision, prompt/output 길이, 동시 요청 수와 상세 계측 경계는 페이지에 공개되어 있지 않으므로 가정으로 채우지 않는다. Groq은 현행 비용/속도 reference에서 제외하며 이 문단은 이전 근거의 의미를 설명하기 위한 provenance다.</a:t>
+            </a:r>
+          </a:p>
+          <a:p xmlns:a="http://schemas.openxmlformats.org/drawingml/2006/main">
+            <a:r>
+              <a:t/>
+            </a:r>
+          </a:p>
+          <a:p xmlns:a="http://schemas.openxmlformats.org/drawingml/2006/main">
+            <a:r>
+              <a:t>### 8.4.2 Gemini Live와 GPT Realtime의 기능 비교</a:t>
+            </a:r>
+          </a:p>
+          <a:p xmlns:a="http://schemas.openxmlformats.org/drawingml/2006/main">
+            <a:r>
+              <a:t/>
+            </a:r>
+          </a:p>
+          <a:p xmlns:a="http://schemas.openxmlformats.org/drawingml/2006/main">
+            <a:r>
+              <a:t>2026-10-11 확인한 공식 문서 기준으로 같은 실시간 음성 대화 역할을 제공하지만 API/실행 제약은 다르다. 아래 GPT는 사용자가 지칭한 `gpt-realtime` 모델 기준이며 다른 GPT Realtime 모델의 제한으로 확대하지 않는다. 현재 공식 모델 페이지는 해당 모델을 Deprecated로 표시하므로 실제 제품 적용 권고가 아니라 요청한 기능 비교 기준으로만 쓴다.</a:t>
+            </a:r>
+          </a:p>
+          <a:p xmlns:a="http://schemas.openxmlformats.org/drawingml/2006/main">
+            <a:r>
+              <a:t/>
+            </a:r>
+          </a:p>
+          <a:p xmlns:a="http://schemas.openxmlformats.org/drawingml/2006/main">
+            <a:r>
+              <a:t>| 비교 항목 | Gemini 3.1 Flash Live Preview | OpenAI gpt-realtime | VIA에 주는 의미 |</a:t>
+            </a:r>
+          </a:p>
+          <a:p xmlns:a="http://schemas.openxmlformats.org/drawingml/2006/main">
+            <a:r>
+              <a:t>| --- | --- | --- | --- |</a:t>
+            </a:r>
+          </a:p>
+          <a:p xmlns:a="http://schemas.openxmlformats.org/drawingml/2006/main">
+            <a:r>
+              <a:t>| 실시간 음성 입출력, 입력/출력 전사, 발화 중 끼어들기 | 지원 | 지원 | 양쪽 모두 음성 역할의 reference가 될 수 있다. 실제 한국어 품질·지연·중단 시간 동등성은 입증하지 않음 |</a:t>
+            </a:r>
+          </a:p>
+          <a:p xmlns:a="http://schemas.openxmlformats.org/drawingml/2006/main">
+            <a:r>
+              <a:t>| 화면/멀티모달 입력 | Text·이미지·audio·video 입력 | Text·이미지·audio 입력, video 미지원 | GPT에서는 화면 snapshot의 이미지 입력과 video stream 지원을 구별 |</a:t>
+            </a:r>
+          </a:p>
+          <a:p xmlns:a="http://schemas.openxmlformats.org/drawingml/2006/main">
+            <a:r>
+              <a:t>| 함수 호출 | 동기만 지원, tool response 전 응답 대기 | 비동기 tool 흐름 지원 | 긴 Agent 실행을 Gemini Live tool response로 끝날 때까지 기다리게 하지 않음 |</a:t>
+            </a:r>
+          </a:p>
+          <a:p xmlns:a="http://schemas.openxmlformats.org/drawingml/2006/main">
+            <a:r>
+              <a:t>| 직접 연결 | Live API WebSocket | WebRTC / WebSocket / SIP | provider adapter·세션 재연결·audio queue/취소 이벤트를 별도로 구현/계산 |</a:t>
+            </a:r>
+          </a:p>
+          <a:p xmlns:a="http://schemas.openxmlformats.org/drawingml/2006/main">
+            <a:r>
+              <a:t>| structured output | 미지원 | 미지원 | 함수 인자 JSON과 schema 제약 출력 보장을 구별, 의미 모델의 frame 검증은 별도 |</a:t>
+            </a:r>
+          </a:p>
+          <a:p xmlns:a="http://schemas.openxmlformats.org/drawingml/2006/main">
+            <a:r>
+              <a:t/>
+            </a:r>
+          </a:p>
+          <a:p xmlns:a="http://schemas.openxmlformats.org/drawingml/2006/main">
+            <a:r>
+              <a:t>근거: [Gemini Live 모델/제약](https://ai.google.dev/gemini-api/docs/models/gemini-3.1-flash-live-preview), [Live 도구의 동기 제한](https://ai.google.dev/gemini-api/docs/live-api/tools), [Live API 연결](https://ai.google.dev/gemini-api/docs/live-api), [Live VAD/중단](https://ai.google.dev/gemini-api/docs/live-api/capabilities), [OpenAI gpt-realtime](https://developers.openai.com/api/docs/models/gpt-realtime), [Realtime 대화/중단](https://developers.openai.com/api/docs/guides/realtime-conversations), [Realtime 도구](https://developers.openai.com/api/docs/guides/realtime-mcp), [GPT Realtime 비동기 함수 호출 설명](https://developers.openai.com/blog/realtime-api).</a:t>
+            </a:r>
+          </a:p>
+          <a:p xmlns:a="http://schemas.openxmlformats.org/drawingml/2006/main">
+            <a:r>
+              <a:t/>
+            </a:r>
+          </a:p>
+          <a:p xmlns:a="http://schemas.openxmlformats.org/drawingml/2006/main">
+            <a:r>
+              <a:t>VIA는 요청/Task의 권위를 갖고 음성 모델의 임시 session과 구별한다. 긴 업무는 로컬 VIA가 외부 Agent에 비동기로 위임하고, 음성 모델에는 유효한 접수·질문·결과를 제시할 입력을 따로 전달하는 방향으로 reference를 해석한다. 이것은 긴 Agent 결과를 Live 동기 함수 응답으로 기다리는 것과 다르다. 실제 provider의 forced response, cancel, 재연결, 출력 내용 준수와 local playback stop은 adapter/API 검증에서 확인해야 한다. 현재 GPT Realtime reference에서도 local playback stop·새 사용자 요청·동시에 도착한 Agent 질문/결과의 우선순위는 VIA가 관리하고, pending tool의 결과가 없는 동안 완료를 추측해 말하지 못하도록 실제 상태를 전달한다. 이전 Gemini 3.1 검토의 proactive audio/affective dialogue 미지원과 `turn_complete=true`의 활성 generation 중단은 기능 비교의 제한으로 보존한다. 모델 이름만으로 연속 입력/여러 Task 처리 계약이 충족됐다고 하지 않는다.</a:t>
             </a:r>
           </a:p>
           <a:p xmlns:a="http://schemas.openxmlformats.org/drawingml/2006/main">
@@ -24020,7 +25730,7 @@
   </p:cSld>
   <p:clrMap bg1="lt1" tx1="dk1" bg2="lt2" tx2="dk2" accent1="accent1" accent2="accent2" accent3="accent3" accent4="accent4" accent5="accent5" accent6="accent6" hlink="hlink" folHlink="folHlink"/>
   <p:sldLayoutIdLst>
-    <p:sldLayoutId xmlns:r="http://schemas.openxmlformats.org/officeDocument/2006/relationships" id="2147483649" r:id="R41eb6e39a7f14eb4"/>
+    <p:sldLayoutId xmlns:r="http://schemas.openxmlformats.org/officeDocument/2006/relationships" id="2147483649" r:id="R64b8399e10b24cde"/>
   </p:sldLayoutIdLst>
   <p:txStyles>
     <p:titleStyle>
@@ -24571,7 +26281,7 @@
           <p:cNvPr id="8" name="title">
             <a:extLst xmlns:a="http://schemas.openxmlformats.org/drawingml/2006/main">
               <a:ext uri="{FF2B5EF4-FFF2-40B4-BE49-F238E27FC236}">
-                <a16:creationId xmlns:a16="http://schemas.microsoft.com/office/drawing/2014/main" id="{7BED8959-5807-44DB-A739-92299D05645E}"/>
+                <a16:creationId xmlns:a16="http://schemas.microsoft.com/office/drawing/2014/main" id="{A908AAFE-7C2F-43D3-8C3E-6DB458AFA1FE}"/>
               </a:ext>
             </a:extLst>
           </p:cNvPr>
@@ -24628,7 +26338,7 @@
           <p:cNvPr id="2" name="header-rule">
             <a:extLst xmlns:a="http://schemas.openxmlformats.org/drawingml/2006/main">
               <a:ext uri="{FF2B5EF4-FFF2-40B4-BE49-F238E27FC236}">
-                <a16:creationId xmlns:a16="http://schemas.microsoft.com/office/drawing/2014/main" id="{2E27125D-60F2-4630-83D1-AF12C515B7B1}"/>
+                <a16:creationId xmlns:a16="http://schemas.microsoft.com/office/drawing/2014/main" id="{F7122FBF-146D-4BD9-8B55-330C11E3260F}"/>
               </a:ext>
             </a:extLst>
           </p:cNvPr>
@@ -24658,7 +26368,7 @@
           <p:cNvPr id="3" name="page">
             <a:extLst xmlns:a="http://schemas.openxmlformats.org/drawingml/2006/main">
               <a:ext uri="{FF2B5EF4-FFF2-40B4-BE49-F238E27FC236}">
-                <a16:creationId xmlns:a16="http://schemas.microsoft.com/office/drawing/2014/main" id="{3CC887C4-F6A3-4B42-A16A-8B7F1F05AB44}"/>
+                <a16:creationId xmlns:a16="http://schemas.microsoft.com/office/drawing/2014/main" id="{08556E0D-4101-483C-BFF2-735D7DDE932D}"/>
               </a:ext>
             </a:extLst>
           </p:cNvPr>
@@ -24715,7 +26425,7 @@
           <p:cNvPr id="4" name="headline">
             <a:extLst xmlns:a="http://schemas.openxmlformats.org/drawingml/2006/main">
               <a:ext uri="{FF2B5EF4-FFF2-40B4-BE49-F238E27FC236}">
-                <a16:creationId xmlns:a16="http://schemas.microsoft.com/office/drawing/2014/main" id="{E457B687-B381-462F-B87D-E6EC9526A3BB}"/>
+                <a16:creationId xmlns:a16="http://schemas.microsoft.com/office/drawing/2014/main" id="{C01472E1-663C-4793-BB19-6CF22FDF7482}"/>
               </a:ext>
             </a:extLst>
           </p:cNvPr>
@@ -24772,7 +26482,7 @@
           <p:cNvPr id="5" name="scope">
             <a:extLst xmlns:a="http://schemas.openxmlformats.org/drawingml/2006/main">
               <a:ext uri="{FF2B5EF4-FFF2-40B4-BE49-F238E27FC236}">
-                <a16:creationId xmlns:a16="http://schemas.microsoft.com/office/drawing/2014/main" id="{456CA4F3-A4AE-45E7-9963-3339E4795226}"/>
+                <a16:creationId xmlns:a16="http://schemas.microsoft.com/office/drawing/2014/main" id="{FE797CD4-627B-49E8-AA87-DD8C820DCAE7}"/>
               </a:ext>
             </a:extLst>
           </p:cNvPr>
@@ -25530,7 +27240,7 @@
           <p:cNvPr id="7" name="footer">
             <a:extLst xmlns:a="http://schemas.openxmlformats.org/drawingml/2006/main">
               <a:ext uri="{FF2B5EF4-FFF2-40B4-BE49-F238E27FC236}">
-                <a16:creationId xmlns:a16="http://schemas.microsoft.com/office/drawing/2014/main" id="{F918AF23-6A68-4CC6-B968-B6A7AA533A21}"/>
+                <a16:creationId xmlns:a16="http://schemas.microsoft.com/office/drawing/2014/main" id="{B06FF142-6B3F-4EAE-BF99-718776B5C9A7}"/>
               </a:ext>
             </a:extLst>
           </p:cNvPr>
@@ -25585,7 +27295,7 @@
     </p:spTree>
     <p:extLst>
       <p:ext uri="{BB962C8B-B14F-4D97-AF65-F5344CB8AC3E}">
-        <p14:creationId xmlns:p14="http://schemas.microsoft.com/office/powerpoint/2010/main" val="1504648296"/>
+        <p14:creationId xmlns:p14="http://schemas.microsoft.com/office/powerpoint/2010/main" val="488972711"/>
       </p:ext>
     </p:extLst>
   </p:cSld>
@@ -25616,7 +27326,7 @@
           <p:cNvPr id="8" name="title">
             <a:extLst xmlns:a="http://schemas.openxmlformats.org/drawingml/2006/main">
               <a:ext uri="{FF2B5EF4-FFF2-40B4-BE49-F238E27FC236}">
-                <a16:creationId xmlns:a16="http://schemas.microsoft.com/office/drawing/2014/main" id="{FF0F27ED-1ED9-47F0-9C62-31491C94CDBB}"/>
+                <a16:creationId xmlns:a16="http://schemas.microsoft.com/office/drawing/2014/main" id="{0ED29E3E-C849-478D-977B-B576CAF19E33}"/>
               </a:ext>
             </a:extLst>
           </p:cNvPr>
@@ -25673,7 +27383,7 @@
           <p:cNvPr id="2" name="header-rule">
             <a:extLst xmlns:a="http://schemas.openxmlformats.org/drawingml/2006/main">
               <a:ext uri="{FF2B5EF4-FFF2-40B4-BE49-F238E27FC236}">
-                <a16:creationId xmlns:a16="http://schemas.microsoft.com/office/drawing/2014/main" id="{CC50DD73-EDB4-4DEC-BD76-7D49ABBADA7B}"/>
+                <a16:creationId xmlns:a16="http://schemas.microsoft.com/office/drawing/2014/main" id="{ECAA7F52-8C18-4933-9957-878E2FA304DB}"/>
               </a:ext>
             </a:extLst>
           </p:cNvPr>
@@ -25703,7 +27413,7 @@
           <p:cNvPr id="3" name="page">
             <a:extLst xmlns:a="http://schemas.openxmlformats.org/drawingml/2006/main">
               <a:ext uri="{FF2B5EF4-FFF2-40B4-BE49-F238E27FC236}">
-                <a16:creationId xmlns:a16="http://schemas.microsoft.com/office/drawing/2014/main" id="{3F055C21-5283-40B7-9AB4-23F779DD8979}"/>
+                <a16:creationId xmlns:a16="http://schemas.microsoft.com/office/drawing/2014/main" id="{6FDB02AE-015E-4FDD-9C0E-FB1C18395502}"/>
               </a:ext>
             </a:extLst>
           </p:cNvPr>
@@ -25760,7 +27470,7 @@
           <p:cNvPr id="4" name="headline">
             <a:extLst xmlns:a="http://schemas.openxmlformats.org/drawingml/2006/main">
               <a:ext uri="{FF2B5EF4-FFF2-40B4-BE49-F238E27FC236}">
-                <a16:creationId xmlns:a16="http://schemas.microsoft.com/office/drawing/2014/main" id="{F82A499F-E210-47B5-8D9D-E99DA4C623C5}"/>
+                <a16:creationId xmlns:a16="http://schemas.microsoft.com/office/drawing/2014/main" id="{4E41AB00-DA25-4E87-BB54-062B2A742766}"/>
               </a:ext>
             </a:extLst>
           </p:cNvPr>
@@ -25817,7 +27527,7 @@
           <p:cNvPr id="5" name="scope">
             <a:extLst xmlns:a="http://schemas.openxmlformats.org/drawingml/2006/main">
               <a:ext uri="{FF2B5EF4-FFF2-40B4-BE49-F238E27FC236}">
-                <a16:creationId xmlns:a16="http://schemas.microsoft.com/office/drawing/2014/main" id="{16F27A96-B975-4D30-8520-93B0BAE53F69}"/>
+                <a16:creationId xmlns:a16="http://schemas.microsoft.com/office/drawing/2014/main" id="{5CAFAA28-BB8E-4223-95BB-19E7E9801014}"/>
               </a:ext>
             </a:extLst>
           </p:cNvPr>
@@ -26178,7 +27888,7 @@
                           <a:ea typeface="Apple SD Gothic Neo"/>
                           <a:cs typeface="Apple SD Gothic Neo"/>
                         </a:rPr>
-                        <a:t>근거: 신규 audio·Text 기본 $0.416320 + 추가 여유 $0.083680</a:t>
+                        <a:t>근거: 신규 audio·Text 기본 $0.351840 + 추가 여유 $0.148160</a:t>
                       </a:r>
                     </a:p>
                   </a:txBody>
@@ -26603,7 +28313,7 @@
           <p:cNvPr id="7" name="footer">
             <a:extLst xmlns:a="http://schemas.openxmlformats.org/drawingml/2006/main">
               <a:ext uri="{FF2B5EF4-FFF2-40B4-BE49-F238E27FC236}">
-                <a16:creationId xmlns:a16="http://schemas.microsoft.com/office/drawing/2014/main" id="{C4E82951-2C46-445E-BEA3-8E725A3B35EB}"/>
+                <a16:creationId xmlns:a16="http://schemas.microsoft.com/office/drawing/2014/main" id="{98CF56F0-633A-4E31-831E-3110F40F4424}"/>
               </a:ext>
             </a:extLst>
           </p:cNvPr>
@@ -26658,7 +28368,7 @@
     </p:spTree>
     <p:extLst>
       <p:ext uri="{BB962C8B-B14F-4D97-AF65-F5344CB8AC3E}">
-        <p14:creationId xmlns:p14="http://schemas.microsoft.com/office/powerpoint/2010/main" val="1776292606"/>
+        <p14:creationId xmlns:p14="http://schemas.microsoft.com/office/powerpoint/2010/main" val="340219924"/>
       </p:ext>
     </p:extLst>
   </p:cSld>
@@ -26689,7 +28399,7 @@
           <p:cNvPr id="8" name="title">
             <a:extLst xmlns:a="http://schemas.openxmlformats.org/drawingml/2006/main">
               <a:ext uri="{FF2B5EF4-FFF2-40B4-BE49-F238E27FC236}">
-                <a16:creationId xmlns:a16="http://schemas.microsoft.com/office/drawing/2014/main" id="{3624CFB2-432A-4515-B3C8-6B1CB8E500B5}"/>
+                <a16:creationId xmlns:a16="http://schemas.microsoft.com/office/drawing/2014/main" id="{E4AF6C37-55F4-4125-B57D-B26BE97A4310}"/>
               </a:ext>
             </a:extLst>
           </p:cNvPr>
@@ -26746,7 +28456,7 @@
           <p:cNvPr id="2" name="header-rule">
             <a:extLst xmlns:a="http://schemas.openxmlformats.org/drawingml/2006/main">
               <a:ext uri="{FF2B5EF4-FFF2-40B4-BE49-F238E27FC236}">
-                <a16:creationId xmlns:a16="http://schemas.microsoft.com/office/drawing/2014/main" id="{3FEA3865-F08A-49E9-8CFB-E494A8604EEF}"/>
+                <a16:creationId xmlns:a16="http://schemas.microsoft.com/office/drawing/2014/main" id="{AD6B1A54-43BB-4ACA-B8B2-64CA582334D5}"/>
               </a:ext>
             </a:extLst>
           </p:cNvPr>
@@ -26776,7 +28486,7 @@
           <p:cNvPr id="3" name="page">
             <a:extLst xmlns:a="http://schemas.openxmlformats.org/drawingml/2006/main">
               <a:ext uri="{FF2B5EF4-FFF2-40B4-BE49-F238E27FC236}">
-                <a16:creationId xmlns:a16="http://schemas.microsoft.com/office/drawing/2014/main" id="{C8E3AE3D-8CFC-4C45-9FD1-05DA56DDDEA7}"/>
+                <a16:creationId xmlns:a16="http://schemas.microsoft.com/office/drawing/2014/main" id="{30A708DD-AA56-4039-BF17-F6921BBF02A7}"/>
               </a:ext>
             </a:extLst>
           </p:cNvPr>
@@ -26833,7 +28543,7 @@
           <p:cNvPr id="4" name="headline">
             <a:extLst xmlns:a="http://schemas.openxmlformats.org/drawingml/2006/main">
               <a:ext uri="{FF2B5EF4-FFF2-40B4-BE49-F238E27FC236}">
-                <a16:creationId xmlns:a16="http://schemas.microsoft.com/office/drawing/2014/main" id="{BB5A805E-0C8E-42F9-8D63-EC2CFAE05EAD}"/>
+                <a16:creationId xmlns:a16="http://schemas.microsoft.com/office/drawing/2014/main" id="{8D8A6E69-CD7B-4FC1-9301-73B29C8C61FB}"/>
               </a:ext>
             </a:extLst>
           </p:cNvPr>
@@ -26890,7 +28600,7 @@
           <p:cNvPr id="5" name="scope">
             <a:extLst xmlns:a="http://schemas.openxmlformats.org/drawingml/2006/main">
               <a:ext uri="{FF2B5EF4-FFF2-40B4-BE49-F238E27FC236}">
-                <a16:creationId xmlns:a16="http://schemas.microsoft.com/office/drawing/2014/main" id="{8F1C644A-C225-4FD6-8EB9-048C86355532}"/>
+                <a16:creationId xmlns:a16="http://schemas.microsoft.com/office/drawing/2014/main" id="{1E7F64F9-28E8-4B51-979F-B0F3D78526EB}"/>
               </a:ext>
             </a:extLst>
           </p:cNvPr>
@@ -27677,7 +29387,7 @@
           <p:cNvPr id="7" name="footer">
             <a:extLst xmlns:a="http://schemas.openxmlformats.org/drawingml/2006/main">
               <a:ext uri="{FF2B5EF4-FFF2-40B4-BE49-F238E27FC236}">
-                <a16:creationId xmlns:a16="http://schemas.microsoft.com/office/drawing/2014/main" id="{4C361FAC-7CF2-4A80-ABF2-183B63C782ED}"/>
+                <a16:creationId xmlns:a16="http://schemas.microsoft.com/office/drawing/2014/main" id="{C343046D-2124-40AF-A097-FED64EE9E19E}"/>
               </a:ext>
             </a:extLst>
           </p:cNvPr>
@@ -27732,7 +29442,7 @@
     </p:spTree>
     <p:extLst>
       <p:ext uri="{BB962C8B-B14F-4D97-AF65-F5344CB8AC3E}">
-        <p14:creationId xmlns:p14="http://schemas.microsoft.com/office/powerpoint/2010/main" val="2048637843"/>
+        <p14:creationId xmlns:p14="http://schemas.microsoft.com/office/powerpoint/2010/main" val="186910980"/>
       </p:ext>
     </p:extLst>
   </p:cSld>
@@ -27763,7 +29473,7 @@
           <p:cNvPr id="8" name="title">
             <a:extLst xmlns:a="http://schemas.openxmlformats.org/drawingml/2006/main">
               <a:ext uri="{FF2B5EF4-FFF2-40B4-BE49-F238E27FC236}">
-                <a16:creationId xmlns:a16="http://schemas.microsoft.com/office/drawing/2014/main" id="{4B662A00-F331-4EBC-AAC3-45CC9F41C165}"/>
+                <a16:creationId xmlns:a16="http://schemas.microsoft.com/office/drawing/2014/main" id="{FFAE454F-A0D8-4F1F-9FFA-2D265442A2C3}"/>
               </a:ext>
             </a:extLst>
           </p:cNvPr>
@@ -27820,7 +29530,7 @@
           <p:cNvPr id="2" name="header-rule">
             <a:extLst xmlns:a="http://schemas.openxmlformats.org/drawingml/2006/main">
               <a:ext uri="{FF2B5EF4-FFF2-40B4-BE49-F238E27FC236}">
-                <a16:creationId xmlns:a16="http://schemas.microsoft.com/office/drawing/2014/main" id="{F70889D0-51B4-4E1D-8C7D-AA7442E4FD2C}"/>
+                <a16:creationId xmlns:a16="http://schemas.microsoft.com/office/drawing/2014/main" id="{F7EEED32-D36F-411F-A0BE-EC86DA937C69}"/>
               </a:ext>
             </a:extLst>
           </p:cNvPr>
@@ -27850,7 +29560,7 @@
           <p:cNvPr id="3" name="page">
             <a:extLst xmlns:a="http://schemas.openxmlformats.org/drawingml/2006/main">
               <a:ext uri="{FF2B5EF4-FFF2-40B4-BE49-F238E27FC236}">
-                <a16:creationId xmlns:a16="http://schemas.microsoft.com/office/drawing/2014/main" id="{1424BA80-9AE5-449D-B0D0-7E839ED19BBA}"/>
+                <a16:creationId xmlns:a16="http://schemas.microsoft.com/office/drawing/2014/main" id="{7105EEB2-7B88-43A6-A6DA-4B1FA72429B6}"/>
               </a:ext>
             </a:extLst>
           </p:cNvPr>
@@ -27907,7 +29617,7 @@
           <p:cNvPr id="4" name="headline">
             <a:extLst xmlns:a="http://schemas.openxmlformats.org/drawingml/2006/main">
               <a:ext uri="{FF2B5EF4-FFF2-40B4-BE49-F238E27FC236}">
-                <a16:creationId xmlns:a16="http://schemas.microsoft.com/office/drawing/2014/main" id="{1272F382-65DD-422A-8786-4C5FB00A7754}"/>
+                <a16:creationId xmlns:a16="http://schemas.microsoft.com/office/drawing/2014/main" id="{3AB1065A-D4A6-4A6E-9280-73A7A06B2599}"/>
               </a:ext>
             </a:extLst>
           </p:cNvPr>
@@ -27964,7 +29674,7 @@
           <p:cNvPr id="5" name="scope">
             <a:extLst xmlns:a="http://schemas.openxmlformats.org/drawingml/2006/main">
               <a:ext uri="{FF2B5EF4-FFF2-40B4-BE49-F238E27FC236}">
-                <a16:creationId xmlns:a16="http://schemas.microsoft.com/office/drawing/2014/main" id="{3C56BD69-5C1B-4AC5-BEDC-41E366C30CFE}"/>
+                <a16:creationId xmlns:a16="http://schemas.microsoft.com/office/drawing/2014/main" id="{94FFDB6A-3467-4A8A-AB92-00B55456FD74}"/>
               </a:ext>
             </a:extLst>
           </p:cNvPr>
@@ -29258,7 +30968,7 @@
           <p:cNvPr id="7" name="footer">
             <a:extLst xmlns:a="http://schemas.openxmlformats.org/drawingml/2006/main">
               <a:ext uri="{FF2B5EF4-FFF2-40B4-BE49-F238E27FC236}">
-                <a16:creationId xmlns:a16="http://schemas.microsoft.com/office/drawing/2014/main" id="{8E924A3F-8653-467A-BE8C-188FF3BBDA03}"/>
+                <a16:creationId xmlns:a16="http://schemas.microsoft.com/office/drawing/2014/main" id="{8813CE86-DDCD-4F86-8F07-C3B495496A5B}"/>
               </a:ext>
             </a:extLst>
           </p:cNvPr>
@@ -29313,7 +31023,7 @@
     </p:spTree>
     <p:extLst>
       <p:ext uri="{BB962C8B-B14F-4D97-AF65-F5344CB8AC3E}">
-        <p14:creationId xmlns:p14="http://schemas.microsoft.com/office/powerpoint/2010/main" val="1035022172"/>
+        <p14:creationId xmlns:p14="http://schemas.microsoft.com/office/powerpoint/2010/main" val="581484155"/>
       </p:ext>
     </p:extLst>
   </p:cSld>
@@ -29344,7 +31054,7 @@
           <p:cNvPr id="8" name="title">
             <a:extLst xmlns:a="http://schemas.openxmlformats.org/drawingml/2006/main">
               <a:ext uri="{FF2B5EF4-FFF2-40B4-BE49-F238E27FC236}">
-                <a16:creationId xmlns:a16="http://schemas.microsoft.com/office/drawing/2014/main" id="{A45DC734-68E2-4E8C-9341-AB22F83CB480}"/>
+                <a16:creationId xmlns:a16="http://schemas.microsoft.com/office/drawing/2014/main" id="{CD7BBC25-D59C-4BB5-B38D-8C324187E295}"/>
               </a:ext>
             </a:extLst>
           </p:cNvPr>
@@ -29401,7 +31111,7 @@
           <p:cNvPr id="2" name="header-rule">
             <a:extLst xmlns:a="http://schemas.openxmlformats.org/drawingml/2006/main">
               <a:ext uri="{FF2B5EF4-FFF2-40B4-BE49-F238E27FC236}">
-                <a16:creationId xmlns:a16="http://schemas.microsoft.com/office/drawing/2014/main" id="{99234F12-6E7E-465C-8DAF-F95D70EA65DA}"/>
+                <a16:creationId xmlns:a16="http://schemas.microsoft.com/office/drawing/2014/main" id="{E0C23B20-8093-49BB-84F4-FCBC29147B62}"/>
               </a:ext>
             </a:extLst>
           </p:cNvPr>
@@ -29431,7 +31141,7 @@
           <p:cNvPr id="3" name="page">
             <a:extLst xmlns:a="http://schemas.openxmlformats.org/drawingml/2006/main">
               <a:ext uri="{FF2B5EF4-FFF2-40B4-BE49-F238E27FC236}">
-                <a16:creationId xmlns:a16="http://schemas.microsoft.com/office/drawing/2014/main" id="{52EC775C-65B4-491B-A07B-D6D37D0BDEB1}"/>
+                <a16:creationId xmlns:a16="http://schemas.microsoft.com/office/drawing/2014/main" id="{40D72A60-B8E5-4E32-9729-CEE3F5BF9CDC}"/>
               </a:ext>
             </a:extLst>
           </p:cNvPr>
@@ -29488,7 +31198,7 @@
           <p:cNvPr id="4" name="headline">
             <a:extLst xmlns:a="http://schemas.openxmlformats.org/drawingml/2006/main">
               <a:ext uri="{FF2B5EF4-FFF2-40B4-BE49-F238E27FC236}">
-                <a16:creationId xmlns:a16="http://schemas.microsoft.com/office/drawing/2014/main" id="{7C85A454-97F5-450E-9AFF-AB0AB53AB2C0}"/>
+                <a16:creationId xmlns:a16="http://schemas.microsoft.com/office/drawing/2014/main" id="{9A108BD5-1ADC-4363-A92E-AC074757EF26}"/>
               </a:ext>
             </a:extLst>
           </p:cNvPr>
@@ -29545,7 +31255,7 @@
           <p:cNvPr id="5" name="scope">
             <a:extLst xmlns:a="http://schemas.openxmlformats.org/drawingml/2006/main">
               <a:ext uri="{FF2B5EF4-FFF2-40B4-BE49-F238E27FC236}">
-                <a16:creationId xmlns:a16="http://schemas.microsoft.com/office/drawing/2014/main" id="{8D4051D2-6029-4B21-9738-1A61D4217D2E}"/>
+                <a16:creationId xmlns:a16="http://schemas.microsoft.com/office/drawing/2014/main" id="{7840AC70-A82C-4F70-9E2D-6F3327653A21}"/>
               </a:ext>
             </a:extLst>
           </p:cNvPr>
@@ -30853,7 +32563,7 @@
           <p:cNvPr id="7" name="footer">
             <a:extLst xmlns:a="http://schemas.openxmlformats.org/drawingml/2006/main">
               <a:ext uri="{FF2B5EF4-FFF2-40B4-BE49-F238E27FC236}">
-                <a16:creationId xmlns:a16="http://schemas.microsoft.com/office/drawing/2014/main" id="{8B03BFE4-188A-4E07-AC4B-1D18DC0C1758}"/>
+                <a16:creationId xmlns:a16="http://schemas.microsoft.com/office/drawing/2014/main" id="{C70506EF-28B3-4EDA-8451-4912DE8792C7}"/>
               </a:ext>
             </a:extLst>
           </p:cNvPr>
@@ -30908,7 +32618,7 @@
     </p:spTree>
     <p:extLst>
       <p:ext uri="{BB962C8B-B14F-4D97-AF65-F5344CB8AC3E}">
-        <p14:creationId xmlns:p14="http://schemas.microsoft.com/office/powerpoint/2010/main" val="259028113"/>
+        <p14:creationId xmlns:p14="http://schemas.microsoft.com/office/powerpoint/2010/main" val="1192029404"/>
       </p:ext>
     </p:extLst>
   </p:cSld>
@@ -30939,7 +32649,7 @@
           <p:cNvPr id="8" name="title">
             <a:extLst xmlns:a="http://schemas.openxmlformats.org/drawingml/2006/main">
               <a:ext uri="{FF2B5EF4-FFF2-40B4-BE49-F238E27FC236}">
-                <a16:creationId xmlns:a16="http://schemas.microsoft.com/office/drawing/2014/main" id="{F7DAF67F-1175-4DBE-BB58-EA26F2912536}"/>
+                <a16:creationId xmlns:a16="http://schemas.microsoft.com/office/drawing/2014/main" id="{648C7643-4B6D-4D7A-A1E4-6871FDDD2DB4}"/>
               </a:ext>
             </a:extLst>
           </p:cNvPr>
@@ -30996,7 +32706,7 @@
           <p:cNvPr id="2" name="header-rule">
             <a:extLst xmlns:a="http://schemas.openxmlformats.org/drawingml/2006/main">
               <a:ext uri="{FF2B5EF4-FFF2-40B4-BE49-F238E27FC236}">
-                <a16:creationId xmlns:a16="http://schemas.microsoft.com/office/drawing/2014/main" id="{9470C8A2-8752-43AF-B6BF-C5C4E7A7C321}"/>
+                <a16:creationId xmlns:a16="http://schemas.microsoft.com/office/drawing/2014/main" id="{91D117A6-5F1F-464F-9126-E171A076D329}"/>
               </a:ext>
             </a:extLst>
           </p:cNvPr>
@@ -31026,7 +32736,7 @@
           <p:cNvPr id="3" name="page">
             <a:extLst xmlns:a="http://schemas.openxmlformats.org/drawingml/2006/main">
               <a:ext uri="{FF2B5EF4-FFF2-40B4-BE49-F238E27FC236}">
-                <a16:creationId xmlns:a16="http://schemas.microsoft.com/office/drawing/2014/main" id="{DD88009A-F035-4E63-876E-5603AB70211D}"/>
+                <a16:creationId xmlns:a16="http://schemas.microsoft.com/office/drawing/2014/main" id="{03F8EB59-B5A2-48EB-AD8F-C808CE5DC7CD}"/>
               </a:ext>
             </a:extLst>
           </p:cNvPr>
@@ -31083,7 +32793,7 @@
           <p:cNvPr id="4" name="headline">
             <a:extLst xmlns:a="http://schemas.openxmlformats.org/drawingml/2006/main">
               <a:ext uri="{FF2B5EF4-FFF2-40B4-BE49-F238E27FC236}">
-                <a16:creationId xmlns:a16="http://schemas.microsoft.com/office/drawing/2014/main" id="{4001907E-C726-4D4B-BE37-723239F49EC2}"/>
+                <a16:creationId xmlns:a16="http://schemas.microsoft.com/office/drawing/2014/main" id="{96E0266A-C121-4480-8359-91E1C3F7C13E}"/>
               </a:ext>
             </a:extLst>
           </p:cNvPr>
@@ -31140,7 +32850,7 @@
           <p:cNvPr id="5" name="scope">
             <a:extLst xmlns:a="http://schemas.openxmlformats.org/drawingml/2006/main">
               <a:ext uri="{FF2B5EF4-FFF2-40B4-BE49-F238E27FC236}">
-                <a16:creationId xmlns:a16="http://schemas.microsoft.com/office/drawing/2014/main" id="{862A8418-1031-4A5F-9B96-0803056FA4FC}"/>
+                <a16:creationId xmlns:a16="http://schemas.microsoft.com/office/drawing/2014/main" id="{E6596D5D-7F93-4978-85C1-3CF288E8EFEE}"/>
               </a:ext>
             </a:extLst>
           </p:cNvPr>
@@ -32476,7 +34186,7 @@
           <p:cNvPr id="7" name="footer">
             <a:extLst xmlns:a="http://schemas.openxmlformats.org/drawingml/2006/main">
               <a:ext uri="{FF2B5EF4-FFF2-40B4-BE49-F238E27FC236}">
-                <a16:creationId xmlns:a16="http://schemas.microsoft.com/office/drawing/2014/main" id="{FE29488F-569C-4E6F-B2AC-49EF16C5A5C8}"/>
+                <a16:creationId xmlns:a16="http://schemas.microsoft.com/office/drawing/2014/main" id="{AD714D4A-9B3E-4E05-B30F-7C4FE95D1138}"/>
               </a:ext>
             </a:extLst>
           </p:cNvPr>
@@ -32531,7 +34241,7 @@
     </p:spTree>
     <p:extLst>
       <p:ext uri="{BB962C8B-B14F-4D97-AF65-F5344CB8AC3E}">
-        <p14:creationId xmlns:p14="http://schemas.microsoft.com/office/powerpoint/2010/main" val="1280019452"/>
+        <p14:creationId xmlns:p14="http://schemas.microsoft.com/office/powerpoint/2010/main" val="1815268114"/>
       </p:ext>
     </p:extLst>
   </p:cSld>

</xml_diff>